<commit_message>
Update project overview presentation with sandbox execution direction
</commit_message>
<xml_diff>
--- a/docs/No_Trust_Me_Agentic_AI.pptx
+++ b/docs/No_Trust_Me_Agentic_AI.pptx
@@ -6,7 +6,7 @@
     <p:sldMasterId id="2147483672" r:id="rId2"/>
   </p:sldMasterIdLst>
   <p:notesMasterIdLst>
-    <p:notesMasterId r:id="rId10"/>
+    <p:notesMasterId r:id="rId11"/>
   </p:notesMasterIdLst>
   <p:sldIdLst>
     <p:sldId id="256" r:id="rId3"/>
@@ -16,6 +16,7 @@
     <p:sldId id="259" r:id="rId7"/>
     <p:sldId id="263" r:id="rId8"/>
     <p:sldId id="264" r:id="rId9"/>
+    <p:sldId id="265" r:id="rId10"/>
   </p:sldIdLst>
   <p:sldSz cx="43891200" cy="24688800"/>
   <p:notesSz cx="6858000" cy="9144000"/>
@@ -125,7 +126,7 @@
 <file path=ppt/revisionInfo.xml><?xml version="1.0" encoding="utf-8"?>
 <p1510:revInfo xmlns:a="http://schemas.openxmlformats.org/drawingml/2006/main" xmlns:r="http://schemas.openxmlformats.org/officeDocument/2006/relationships" xmlns:p1510="http://schemas.microsoft.com/office/powerpoint/2015/10/main">
   <p1510:revLst>
-    <p1510:client id="{365D465A-354D-4022-A33C-AF8F86656859}" v="19" dt="2026-10-06T03:53:52.977"/>
+    <p1510:client id="{365D465A-354D-4022-A33C-AF8F86656859}" v="21" dt="2026-10-09T16:54:40.319"/>
   </p1510:revLst>
 </p1510:revInfo>
 </file>
@@ -135,7 +136,7 @@
   <pc:docChgLst>
     <pc:chgData name="Simon Hong" userId="2f15200c-b3cf-4aef-8f69-ada819764841" providerId="ADAL" clId="{6AB89950-CF24-4538-93AF-1A20832D1772}"/>
     <pc:docChg chg="undo custSel addSld delSld modSld">
-      <pc:chgData name="Simon Hong" userId="2f15200c-b3cf-4aef-8f69-ada819764841" providerId="ADAL" clId="{6AB89950-CF24-4538-93AF-1A20832D1772}" dt="2026-10-06T03:57:58.280" v="452" actId="14100"/>
+      <pc:chgData name="Simon Hong" userId="2f15200c-b3cf-4aef-8f69-ada819764841" providerId="ADAL" clId="{6AB89950-CF24-4538-93AF-1A20832D1772}" dt="2026-10-09T16:54:45.668" v="464" actId="6549"/>
       <pc:docMkLst>
         <pc:docMk/>
       </pc:docMkLst>
@@ -207,20 +208,6 @@
             <ac:spMk id="7" creationId="{EAE19A95-131F-28B0-CB90-B469DC7B6136}"/>
           </ac:spMkLst>
         </pc:spChg>
-      </pc:sldChg>
-      <pc:sldChg chg="del">
-        <pc:chgData name="Simon Hong" userId="2f15200c-b3cf-4aef-8f69-ada819764841" providerId="ADAL" clId="{6AB89950-CF24-4538-93AF-1A20832D1772}" dt="2026-10-05T20:42:56.647" v="0" actId="47"/>
-        <pc:sldMkLst>
-          <pc:docMk/>
-          <pc:sldMk cId="4193351781" sldId="260"/>
-        </pc:sldMkLst>
-      </pc:sldChg>
-      <pc:sldChg chg="del">
-        <pc:chgData name="Simon Hong" userId="2f15200c-b3cf-4aef-8f69-ada819764841" providerId="ADAL" clId="{6AB89950-CF24-4538-93AF-1A20832D1772}" dt="2026-10-05T20:45:10.472" v="58" actId="47"/>
-        <pc:sldMkLst>
-          <pc:docMk/>
-          <pc:sldMk cId="1830838452" sldId="261"/>
-        </pc:sldMkLst>
       </pc:sldChg>
       <pc:sldChg chg="modSp mod">
         <pc:chgData name="Simon Hong" userId="2f15200c-b3cf-4aef-8f69-ada819764841" providerId="ADAL" clId="{6AB89950-CF24-4538-93AF-1A20832D1772}" dt="2026-10-05T21:54:22.673" v="195" actId="20577"/>
@@ -349,19 +336,11 @@
         </pc:cxnChg>
       </pc:sldChg>
       <pc:sldChg chg="addSp delSp modSp add mod">
-        <pc:chgData name="Simon Hong" userId="2f15200c-b3cf-4aef-8f69-ada819764841" providerId="ADAL" clId="{6AB89950-CF24-4538-93AF-1A20832D1772}" dt="2026-10-06T03:57:58.280" v="452" actId="14100"/>
+        <pc:chgData name="Simon Hong" userId="2f15200c-b3cf-4aef-8f69-ada819764841" providerId="ADAL" clId="{6AB89950-CF24-4538-93AF-1A20832D1772}" dt="2026-10-09T16:54:40.319" v="462"/>
         <pc:sldMkLst>
           <pc:docMk/>
           <pc:sldMk cId="0" sldId="264"/>
         </pc:sldMkLst>
-        <pc:spChg chg="del">
-          <ac:chgData name="Simon Hong" userId="2f15200c-b3cf-4aef-8f69-ada819764841" providerId="ADAL" clId="{6AB89950-CF24-4538-93AF-1A20832D1772}" dt="2026-10-06T03:45:18.124" v="284" actId="478"/>
-          <ac:spMkLst>
-            <pc:docMk/>
-            <pc:sldMk cId="0" sldId="264"/>
-            <ac:spMk id="2" creationId="{00000000-0000-0000-0000-000000000000}"/>
-          </ac:spMkLst>
-        </pc:spChg>
         <pc:spChg chg="mod">
           <ac:chgData name="Simon Hong" userId="2f15200c-b3cf-4aef-8f69-ada819764841" providerId="ADAL" clId="{6AB89950-CF24-4538-93AF-1A20832D1772}" dt="2026-10-06T03:55:56.543" v="369" actId="20577"/>
           <ac:spMkLst>
@@ -443,11 +422,26 @@
           </ac:spMkLst>
         </pc:spChg>
         <pc:spChg chg="add mod">
-          <ac:chgData name="Simon Hong" userId="2f15200c-b3cf-4aef-8f69-ada819764841" providerId="ADAL" clId="{6AB89950-CF24-4538-93AF-1A20832D1772}" dt="2026-10-06T03:45:14.586" v="283" actId="20577"/>
+          <ac:chgData name="Simon Hong" userId="2f15200c-b3cf-4aef-8f69-ada819764841" providerId="ADAL" clId="{6AB89950-CF24-4538-93AF-1A20832D1772}" dt="2026-10-09T16:54:40.319" v="462"/>
           <ac:spMkLst>
             <pc:docMk/>
             <pc:sldMk cId="0" sldId="264"/>
             <ac:spMk id="21" creationId="{EB52BBD8-5662-934C-E56F-1598C441506B}"/>
+          </ac:spMkLst>
+        </pc:spChg>
+      </pc:sldChg>
+      <pc:sldChg chg="modSp add mod setBg">
+        <pc:chgData name="Simon Hong" userId="2f15200c-b3cf-4aef-8f69-ada819764841" providerId="ADAL" clId="{6AB89950-CF24-4538-93AF-1A20832D1772}" dt="2026-10-09T16:54:45.668" v="464" actId="6549"/>
+        <pc:sldMkLst>
+          <pc:docMk/>
+          <pc:sldMk cId="0" sldId="265"/>
+        </pc:sldMkLst>
+        <pc:spChg chg="mod">
+          <ac:chgData name="Simon Hong" userId="2f15200c-b3cf-4aef-8f69-ada819764841" providerId="ADAL" clId="{6AB89950-CF24-4538-93AF-1A20832D1772}" dt="2026-10-09T16:54:45.668" v="464" actId="6549"/>
+          <ac:spMkLst>
+            <pc:docMk/>
+            <pc:sldMk cId="0" sldId="265"/>
+            <ac:spMk id="3" creationId="{00000000-0000-0000-0000-000000000000}"/>
           </ac:spMkLst>
         </pc:spChg>
       </pc:sldChg>
@@ -538,7 +532,7 @@
           <a:p>
             <a:fld id="{374A66AB-9790-4ABA-88B7-628CDEBB8E90}" type="datetimeFigureOut">
               <a:rPr lang="en-US" smtClean="0"/>
-              <a:t>10/5/2026</a:t>
+              <a:t>10/9/2026</a:t>
             </a:fld>
             <a:endParaRPr lang="en-US"/>
           </a:p>
@@ -1085,6 +1079,90 @@
 </p:notes>
 </file>
 
+<file path=ppt/notesSlides/notesSlide3.xml><?xml version="1.0" encoding="utf-8"?>
+<p:notes xmlns:a="http://schemas.openxmlformats.org/drawingml/2006/main" xmlns:r="http://schemas.openxmlformats.org/officeDocument/2006/relationships" xmlns:p="http://schemas.openxmlformats.org/presentationml/2006/main">
+  <p:cSld>
+    <p:spTree>
+      <p:nvGrpSpPr>
+        <p:cNvPr id="1" name=""/>
+        <p:cNvGrpSpPr/>
+        <p:nvPr/>
+      </p:nvGrpSpPr>
+      <p:grpSpPr>
+        <a:xfrm>
+          <a:off x="0" y="0"/>
+          <a:ext cx="0" cy="0"/>
+          <a:chOff x="0" y="0"/>
+          <a:chExt cx="0" cy="0"/>
+        </a:xfrm>
+      </p:grpSpPr>
+      <p:sp>
+        <p:nvSpPr>
+          <p:cNvPr id="2" name="Slide Image Placeholder 1"/>
+          <p:cNvSpPr>
+            <a:spLocks noGrp="1" noRot="1" noChangeAspect="1"/>
+          </p:cNvSpPr>
+          <p:nvPr>
+            <p:ph type="sldImg"/>
+          </p:nvPr>
+        </p:nvSpPr>
+        <p:spPr/>
+      </p:sp>
+      <p:sp>
+        <p:nvSpPr>
+          <p:cNvPr id="3" name="Notes Placeholder 2"/>
+          <p:cNvSpPr>
+            <a:spLocks noGrp="1"/>
+          </p:cNvSpPr>
+          <p:nvPr>
+            <p:ph type="body" idx="1"/>
+          </p:nvPr>
+        </p:nvSpPr>
+        <p:spPr/>
+        <p:txBody>
+          <a:bodyPr/>
+          <a:lstStyle/>
+          <a:p>
+            <a:endParaRPr lang="en-US" dirty="0"/>
+          </a:p>
+        </p:txBody>
+      </p:sp>
+      <p:sp>
+        <p:nvSpPr>
+          <p:cNvPr id="4" name="Slide Number Placeholder 3"/>
+          <p:cNvSpPr>
+            <a:spLocks noGrp="1"/>
+          </p:cNvSpPr>
+          <p:nvPr>
+            <p:ph type="sldNum" sz="quarter" idx="10"/>
+          </p:nvPr>
+        </p:nvSpPr>
+        <p:spPr/>
+        <p:txBody>
+          <a:bodyPr/>
+          <a:lstStyle/>
+          <a:p>
+            <a:fld id="{F7021451-1387-4CA6-816F-3879F97B5CBC}" type="slidenum">
+              <a:rPr lang="en-US"/>
+              <a:t>8</a:t>
+            </a:fld>
+            <a:endParaRPr lang="en-US"/>
+          </a:p>
+        </p:txBody>
+      </p:sp>
+    </p:spTree>
+    <p:extLst>
+      <p:ext uri="{BB962C8B-B14F-4D97-AF65-F5344CB8AC3E}">
+        <p14:creationId xmlns:p14="http://schemas.microsoft.com/office/powerpoint/2010/main" val="1024086991"/>
+      </p:ext>
+    </p:extLst>
+  </p:cSld>
+  <p:clrMapOvr>
+    <a:masterClrMapping/>
+  </p:clrMapOvr>
+</p:notes>
+</file>
+
 <file path=ppt/slideLayouts/slideLayout1.xml><?xml version="1.0" encoding="utf-8"?>
 <p:sldLayout xmlns:a="http://schemas.openxmlformats.org/drawingml/2006/main" xmlns:r="http://schemas.openxmlformats.org/officeDocument/2006/relationships" xmlns:p="http://schemas.openxmlformats.org/presentationml/2006/main" type="title" preserve="1">
   <p:cSld name="Title Slide">
@@ -1216,7 +1294,7 @@
           <a:p>
             <a:fld id="{B4BA138A-FC8D-465A-8B24-91162DC3A8EA}" type="datetimeFigureOut">
               <a:rPr lang="en-US" smtClean="0"/>
-              <a:t>10/5/2026</a:t>
+              <a:t>10/9/2026</a:t>
             </a:fld>
             <a:endParaRPr lang="en-US"/>
           </a:p>
@@ -1386,7 +1464,7 @@
           <a:p>
             <a:fld id="{B4BA138A-FC8D-465A-8B24-91162DC3A8EA}" type="datetimeFigureOut">
               <a:rPr lang="en-US" smtClean="0"/>
-              <a:t>10/5/2026</a:t>
+              <a:t>10/9/2026</a:t>
             </a:fld>
             <a:endParaRPr lang="en-US"/>
           </a:p>
@@ -1566,7 +1644,7 @@
           <a:p>
             <a:fld id="{B4BA138A-FC8D-465A-8B24-91162DC3A8EA}" type="datetimeFigureOut">
               <a:rPr lang="en-US" smtClean="0"/>
-              <a:t>10/5/2026</a:t>
+              <a:t>10/9/2026</a:t>
             </a:fld>
             <a:endParaRPr lang="en-US"/>
           </a:p>
@@ -1771,7 +1849,7 @@
           <a:p>
             <a:fld id="{B4BA138A-FC8D-465A-8B24-91162DC3A8EA}" type="datetimeFigureOut">
               <a:rPr lang="en-US" smtClean="0"/>
-              <a:t>10/5/2026</a:t>
+              <a:t>10/9/2026</a:t>
             </a:fld>
             <a:endParaRPr lang="en-US"/>
           </a:p>
@@ -2017,7 +2095,7 @@
           <a:p>
             <a:fld id="{B4BA138A-FC8D-465A-8B24-91162DC3A8EA}" type="datetimeFigureOut">
               <a:rPr lang="en-US" smtClean="0"/>
-              <a:t>10/5/2026</a:t>
+              <a:t>10/9/2026</a:t>
             </a:fld>
             <a:endParaRPr lang="en-US"/>
           </a:p>
@@ -2249,7 +2327,7 @@
           <a:p>
             <a:fld id="{B4BA138A-FC8D-465A-8B24-91162DC3A8EA}" type="datetimeFigureOut">
               <a:rPr lang="en-US" smtClean="0"/>
-              <a:t>10/5/2026</a:t>
+              <a:t>10/9/2026</a:t>
             </a:fld>
             <a:endParaRPr lang="en-US"/>
           </a:p>
@@ -2616,7 +2694,7 @@
           <a:p>
             <a:fld id="{B4BA138A-FC8D-465A-8B24-91162DC3A8EA}" type="datetimeFigureOut">
               <a:rPr lang="en-US" smtClean="0"/>
-              <a:t>10/5/2026</a:t>
+              <a:t>10/9/2026</a:t>
             </a:fld>
             <a:endParaRPr lang="en-US"/>
           </a:p>
@@ -2734,7 +2812,7 @@
           <a:p>
             <a:fld id="{B4BA138A-FC8D-465A-8B24-91162DC3A8EA}" type="datetimeFigureOut">
               <a:rPr lang="en-US" smtClean="0"/>
-              <a:t>10/5/2026</a:t>
+              <a:t>10/9/2026</a:t>
             </a:fld>
             <a:endParaRPr lang="en-US"/>
           </a:p>
@@ -2829,7 +2907,7 @@
           <a:p>
             <a:fld id="{B4BA138A-FC8D-465A-8B24-91162DC3A8EA}" type="datetimeFigureOut">
               <a:rPr lang="en-US" smtClean="0"/>
-              <a:t>10/5/2026</a:t>
+              <a:t>10/9/2026</a:t>
             </a:fld>
             <a:endParaRPr lang="en-US"/>
           </a:p>
@@ -3106,7 +3184,7 @@
           <a:p>
             <a:fld id="{B4BA138A-FC8D-465A-8B24-91162DC3A8EA}" type="datetimeFigureOut">
               <a:rPr lang="en-US" smtClean="0"/>
-              <a:t>10/5/2026</a:t>
+              <a:t>10/9/2026</a:t>
             </a:fld>
             <a:endParaRPr lang="en-US"/>
           </a:p>
@@ -3363,7 +3441,7 @@
           <a:p>
             <a:fld id="{B4BA138A-FC8D-465A-8B24-91162DC3A8EA}" type="datetimeFigureOut">
               <a:rPr lang="en-US" smtClean="0"/>
-              <a:t>10/5/2026</a:t>
+              <a:t>10/9/2026</a:t>
             </a:fld>
             <a:endParaRPr lang="en-US"/>
           </a:p>
@@ -3576,7 +3654,7 @@
           <a:p>
             <a:fld id="{B4BA138A-FC8D-465A-8B24-91162DC3A8EA}" type="datetimeFigureOut">
               <a:rPr lang="en-US" smtClean="0"/>
-              <a:t>10/5/2026</a:t>
+              <a:t>10/9/2026</a:t>
             </a:fld>
             <a:endParaRPr lang="en-US"/>
           </a:p>
@@ -31000,11 +31078,1540 @@
               </a:rPr>
               <a:t>Future implementation direction</a:t>
             </a:r>
+            <a:r>
+              <a:rPr lang="en-US" sz="8000" b="1" dirty="0">
+                <a:solidFill>
+                  <a:srgbClr val="2766EC"/>
+                </a:solidFill>
+                <a:latin typeface="Aptos" pitchFamily="34" charset="0"/>
+                <a:ea typeface="Aptos" pitchFamily="34" charset="-122"/>
+                <a:cs typeface="Aptos" pitchFamily="34" charset="-120"/>
+              </a:rPr>
+              <a:t> – 1</a:t>
+            </a:r>
             <a:endParaRPr lang="en-US" sz="8000" dirty="0">
               <a:solidFill>
                 <a:prstClr val="black"/>
               </a:solidFill>
             </a:endParaRPr>
+          </a:p>
+        </p:txBody>
+      </p:sp>
+    </p:spTree>
+  </p:cSld>
+  <p:clrMapOvr>
+    <a:masterClrMapping/>
+  </p:clrMapOvr>
+</p:sld>
+</file>
+
+<file path=ppt/slides/slide8.xml><?xml version="1.0" encoding="utf-8"?>
+<p:sld xmlns:a="http://schemas.openxmlformats.org/drawingml/2006/main" xmlns:r="http://schemas.openxmlformats.org/officeDocument/2006/relationships" xmlns:p="http://schemas.openxmlformats.org/presentationml/2006/main">
+  <p:cSld>
+    <p:spTree>
+      <p:nvGrpSpPr>
+        <p:cNvPr id="1" name=""/>
+        <p:cNvGrpSpPr/>
+        <p:nvPr/>
+      </p:nvGrpSpPr>
+      <p:grpSpPr>
+        <a:xfrm>
+          <a:off x="0" y="0"/>
+          <a:ext cx="0" cy="0"/>
+          <a:chOff x="0" y="0"/>
+          <a:chExt cx="0" cy="0"/>
+        </a:xfrm>
+      </p:grpSpPr>
+      <p:sp>
+        <p:nvSpPr>
+          <p:cNvPr id="2" name="Shape 0"/>
+          <p:cNvSpPr/>
+          <p:nvPr/>
+        </p:nvSpPr>
+        <p:spPr>
+          <a:xfrm>
+            <a:off x="0" y="0"/>
+            <a:ext cx="43891200" cy="1415491"/>
+          </a:xfrm>
+          <a:prstGeom prst="rect">
+            <a:avLst/>
+          </a:prstGeom>
+          <a:solidFill>
+            <a:srgbClr val="EDFAF7"/>
+          </a:solidFill>
+          <a:ln w="7620">
+            <a:solidFill>
+              <a:srgbClr val="A7B7BC"/>
+            </a:solidFill>
+            <a:prstDash val="solid"/>
+          </a:ln>
+        </p:spPr>
+        <p:txBody>
+          <a:bodyPr/>
+          <a:lstStyle/>
+          <a:p>
+            <a:endParaRPr lang="en-US" sz="6480"/>
+          </a:p>
+        </p:txBody>
+      </p:sp>
+      <p:sp>
+        <p:nvSpPr>
+          <p:cNvPr id="3" name="Text 1"/>
+          <p:cNvSpPr/>
+          <p:nvPr/>
+        </p:nvSpPr>
+        <p:spPr>
+          <a:xfrm>
+            <a:off x="1316736" y="49377"/>
+            <a:ext cx="41257728" cy="1283818"/>
+          </a:xfrm>
+          <a:prstGeom prst="rect">
+            <a:avLst/>
+          </a:prstGeom>
+          <a:noFill/>
+          <a:ln/>
+        </p:spPr>
+        <p:txBody>
+          <a:bodyPr wrap="square" lIns="0" tIns="0" rIns="0" bIns="0" rtlCol="0" anchor="ctr"/>
+          <a:lstStyle/>
+          <a:p>
+            <a:pPr algn="ctr"/>
+            <a:r>
+              <a:rPr lang="en-US" sz="5940" b="1" dirty="0">
+                <a:solidFill>
+                  <a:srgbClr val="2766EC"/>
+                </a:solidFill>
+                <a:latin typeface="Aptos" pitchFamily="34" charset="0"/>
+                <a:ea typeface="Aptos" pitchFamily="34" charset="-122"/>
+                <a:cs typeface="Aptos" pitchFamily="34" charset="-120"/>
+              </a:rPr>
+              <a:t>Future implementation direction </a:t>
+            </a:r>
+            <a:r>
+              <a:rPr lang="en-US" sz="5940" b="1">
+                <a:solidFill>
+                  <a:srgbClr val="2766EC"/>
+                </a:solidFill>
+                <a:latin typeface="Aptos" pitchFamily="34" charset="0"/>
+                <a:ea typeface="Aptos" pitchFamily="34" charset="-122"/>
+                <a:cs typeface="Aptos" pitchFamily="34" charset="-120"/>
+              </a:rPr>
+              <a:t>– 2</a:t>
+            </a:r>
+            <a:endParaRPr lang="en-US" sz="5940" b="1" dirty="0">
+              <a:solidFill>
+                <a:srgbClr val="2766EC"/>
+              </a:solidFill>
+              <a:latin typeface="Aptos" pitchFamily="34" charset="0"/>
+              <a:ea typeface="Aptos" pitchFamily="34" charset="-122"/>
+              <a:cs typeface="Aptos" pitchFamily="34" charset="-120"/>
+            </a:endParaRPr>
+          </a:p>
+        </p:txBody>
+      </p:sp>
+      <p:sp>
+        <p:nvSpPr>
+          <p:cNvPr id="4" name="Text 2"/>
+          <p:cNvSpPr/>
+          <p:nvPr/>
+        </p:nvSpPr>
+        <p:spPr>
+          <a:xfrm>
+            <a:off x="1909267" y="2337206"/>
+            <a:ext cx="40489632" cy="1645920"/>
+          </a:xfrm>
+          <a:prstGeom prst="rect">
+            <a:avLst/>
+          </a:prstGeom>
+          <a:noFill/>
+          <a:ln/>
+        </p:spPr>
+        <p:txBody>
+          <a:bodyPr wrap="square" lIns="0" tIns="0" rIns="0" bIns="0" rtlCol="0" anchor="ctr"/>
+          <a:lstStyle/>
+          <a:p>
+            <a:r>
+              <a:rPr lang="en-US" sz="9648" b="1" dirty="0">
+                <a:solidFill>
+                  <a:srgbClr val="10192D"/>
+                </a:solidFill>
+                <a:latin typeface="Aptos" pitchFamily="34" charset="0"/>
+                <a:ea typeface="Aptos" pitchFamily="34" charset="-122"/>
+                <a:cs typeface="Aptos" pitchFamily="34" charset="-120"/>
+              </a:rPr>
+              <a:t>Sandboxed execution of LLM-generated functions</a:t>
+            </a:r>
+            <a:endParaRPr lang="en-US" sz="9648" dirty="0"/>
+          </a:p>
+        </p:txBody>
+      </p:sp>
+      <p:sp>
+        <p:nvSpPr>
+          <p:cNvPr id="5" name="Text 3"/>
+          <p:cNvSpPr/>
+          <p:nvPr/>
+        </p:nvSpPr>
+        <p:spPr>
+          <a:xfrm>
+            <a:off x="1942186" y="4575657"/>
+            <a:ext cx="39502080" cy="954634"/>
+          </a:xfrm>
+          <a:prstGeom prst="rect">
+            <a:avLst/>
+          </a:prstGeom>
+          <a:noFill/>
+          <a:ln/>
+        </p:spPr>
+        <p:txBody>
+          <a:bodyPr wrap="square" lIns="0" tIns="0" rIns="0" bIns="0" rtlCol="0" anchor="ctr"/>
+          <a:lstStyle/>
+          <a:p>
+            <a:r>
+              <a:rPr lang="en-US" sz="4500" dirty="0">
+                <a:solidFill>
+                  <a:srgbClr val="475569"/>
+                </a:solidFill>
+                <a:latin typeface="Aptos" pitchFamily="34" charset="0"/>
+                <a:ea typeface="Aptos" pitchFamily="34" charset="-122"/>
+                <a:cs typeface="Aptos" pitchFamily="34" charset="-120"/>
+              </a:rPr>
+              <a:t>BRD permissions define what code may request; isolation limits what untrusted code can actually do.</a:t>
+            </a:r>
+            <a:endParaRPr lang="en-US" sz="4500" dirty="0"/>
+          </a:p>
+        </p:txBody>
+      </p:sp>
+      <p:sp>
+        <p:nvSpPr>
+          <p:cNvPr id="6" name="Shape 4"/>
+          <p:cNvSpPr/>
+          <p:nvPr/>
+        </p:nvSpPr>
+        <p:spPr>
+          <a:xfrm>
+            <a:off x="1942186" y="6024067"/>
+            <a:ext cx="39995856" cy="1119226"/>
+          </a:xfrm>
+          <a:prstGeom prst="rect">
+            <a:avLst/>
+          </a:prstGeom>
+          <a:solidFill>
+            <a:srgbClr val="F0F4F8"/>
+          </a:solidFill>
+          <a:ln w="10160">
+            <a:solidFill>
+              <a:srgbClr val="DEE5EB"/>
+            </a:solidFill>
+            <a:prstDash val="solid"/>
+          </a:ln>
+        </p:spPr>
+        <p:txBody>
+          <a:bodyPr/>
+          <a:lstStyle/>
+          <a:p>
+            <a:endParaRPr lang="en-US" sz="6480"/>
+          </a:p>
+        </p:txBody>
+      </p:sp>
+      <p:sp>
+        <p:nvSpPr>
+          <p:cNvPr id="7" name="Text 5"/>
+          <p:cNvSpPr/>
+          <p:nvPr/>
+        </p:nvSpPr>
+        <p:spPr>
+          <a:xfrm>
+            <a:off x="2468880" y="6155741"/>
+            <a:ext cx="38843712" cy="757123"/>
+          </a:xfrm>
+          <a:prstGeom prst="rect">
+            <a:avLst/>
+          </a:prstGeom>
+          <a:noFill/>
+          <a:ln/>
+        </p:spPr>
+        <p:txBody>
+          <a:bodyPr wrap="square" lIns="0" tIns="0" rIns="0" bIns="0" rtlCol="0" anchor="ctr"/>
+          <a:lstStyle/>
+          <a:p>
+            <a:r>
+              <a:rPr lang="en-US" sz="3852" dirty="0">
+                <a:solidFill>
+                  <a:srgbClr val="263248"/>
+                </a:solidFill>
+                <a:latin typeface="Aptos" pitchFamily="34" charset="0"/>
+                <a:ea typeface="Aptos" pitchFamily="34" charset="-122"/>
+                <a:cs typeface="Aptos" pitchFamily="34" charset="-120"/>
+              </a:rPr>
+              <a:t>CURRENT GAP  Generated code runs via exec() in the BRD worker; static checks are not a security boundary.</a:t>
+            </a:r>
+            <a:endParaRPr lang="en-US" sz="3852" dirty="0"/>
+          </a:p>
+        </p:txBody>
+      </p:sp>
+      <p:sp>
+        <p:nvSpPr>
+          <p:cNvPr id="8" name="Text 6"/>
+          <p:cNvSpPr/>
+          <p:nvPr/>
+        </p:nvSpPr>
+        <p:spPr>
+          <a:xfrm>
+            <a:off x="1876349" y="7505395"/>
+            <a:ext cx="39502080" cy="954634"/>
+          </a:xfrm>
+          <a:prstGeom prst="rect">
+            <a:avLst/>
+          </a:prstGeom>
+          <a:noFill/>
+          <a:ln/>
+        </p:spPr>
+        <p:txBody>
+          <a:bodyPr wrap="square" lIns="0" tIns="0" rIns="0" bIns="0" rtlCol="0" anchor="ctr"/>
+          <a:lstStyle/>
+          <a:p>
+            <a:r>
+              <a:rPr lang="en-US" sz="5040" b="1" dirty="0">
+                <a:solidFill>
+                  <a:srgbClr val="2766EC"/>
+                </a:solidFill>
+                <a:latin typeface="Aptos" pitchFamily="34" charset="0"/>
+                <a:ea typeface="Aptos" pitchFamily="34" charset="-122"/>
+                <a:cs typeface="Aptos" pitchFamily="34" charset="-120"/>
+              </a:rPr>
+              <a:t>Proposed execution flow</a:t>
+            </a:r>
+            <a:endParaRPr lang="en-US" sz="5040" dirty="0"/>
+          </a:p>
+        </p:txBody>
+      </p:sp>
+      <p:sp>
+        <p:nvSpPr>
+          <p:cNvPr id="9" name="Shape 7"/>
+          <p:cNvSpPr/>
+          <p:nvPr/>
+        </p:nvSpPr>
+        <p:spPr>
+          <a:xfrm>
+            <a:off x="1909267" y="8822131"/>
+            <a:ext cx="8460029" cy="5036515"/>
+          </a:xfrm>
+          <a:prstGeom prst="rect">
+            <a:avLst/>
+          </a:prstGeom>
+          <a:solidFill>
+            <a:srgbClr val="DBEAFE"/>
+          </a:solidFill>
+          <a:ln w="13335">
+            <a:solidFill>
+              <a:srgbClr val="3977FF"/>
+            </a:solidFill>
+            <a:prstDash val="solid"/>
+          </a:ln>
+        </p:spPr>
+        <p:txBody>
+          <a:bodyPr/>
+          <a:lstStyle/>
+          <a:p>
+            <a:endParaRPr lang="en-US" sz="6480"/>
+          </a:p>
+        </p:txBody>
+      </p:sp>
+      <p:sp>
+        <p:nvSpPr>
+          <p:cNvPr id="10" name="Text 8"/>
+          <p:cNvSpPr/>
+          <p:nvPr/>
+        </p:nvSpPr>
+        <p:spPr>
+          <a:xfrm>
+            <a:off x="2304288" y="9282989"/>
+            <a:ext cx="7669987" cy="921715"/>
+          </a:xfrm>
+          <a:prstGeom prst="rect">
+            <a:avLst/>
+          </a:prstGeom>
+          <a:noFill/>
+          <a:ln/>
+        </p:spPr>
+        <p:txBody>
+          <a:bodyPr wrap="square" lIns="0" tIns="0" rIns="0" bIns="0" rtlCol="0" anchor="ctr"/>
+          <a:lstStyle/>
+          <a:p>
+            <a:pPr algn="ctr"/>
+            <a:r>
+              <a:rPr lang="en-US" sz="5472" dirty="0">
+                <a:solidFill>
+                  <a:srgbClr val="10192D"/>
+                </a:solidFill>
+                <a:latin typeface="Aptos" pitchFamily="34" charset="0"/>
+                <a:ea typeface="Aptos" pitchFamily="34" charset="-122"/>
+                <a:cs typeface="Aptos" pitchFamily="34" charset="-120"/>
+              </a:rPr>
+              <a:t>1</a:t>
+            </a:r>
+            <a:endParaRPr lang="en-US" sz="5472" dirty="0"/>
+          </a:p>
+        </p:txBody>
+      </p:sp>
+      <p:sp>
+        <p:nvSpPr>
+          <p:cNvPr id="11" name="Text 9"/>
+          <p:cNvSpPr/>
+          <p:nvPr/>
+        </p:nvSpPr>
+        <p:spPr>
+          <a:xfrm>
+            <a:off x="2337207" y="10500969"/>
+            <a:ext cx="7604150" cy="954634"/>
+          </a:xfrm>
+          <a:prstGeom prst="rect">
+            <a:avLst/>
+          </a:prstGeom>
+          <a:noFill/>
+          <a:ln/>
+        </p:spPr>
+        <p:txBody>
+          <a:bodyPr wrap="square" lIns="0" tIns="0" rIns="0" bIns="0" rtlCol="0" anchor="ctr"/>
+          <a:lstStyle/>
+          <a:p>
+            <a:pPr algn="ctr"/>
+            <a:r>
+              <a:rPr lang="en-US" sz="5400" b="1" dirty="0">
+                <a:solidFill>
+                  <a:srgbClr val="10192D"/>
+                </a:solidFill>
+                <a:latin typeface="Aptos" pitchFamily="34" charset="0"/>
+                <a:ea typeface="Aptos" pitchFamily="34" charset="-122"/>
+                <a:cs typeface="Aptos" pitchFamily="34" charset="-120"/>
+              </a:rPr>
+              <a:t>Python supervisor</a:t>
+            </a:r>
+            <a:endParaRPr lang="en-US" sz="5400" dirty="0"/>
+          </a:p>
+        </p:txBody>
+      </p:sp>
+      <p:sp>
+        <p:nvSpPr>
+          <p:cNvPr id="12" name="Text 10"/>
+          <p:cNvSpPr/>
+          <p:nvPr/>
+        </p:nvSpPr>
+        <p:spPr>
+          <a:xfrm>
+            <a:off x="2337207" y="11718951"/>
+            <a:ext cx="7604150" cy="1580083"/>
+          </a:xfrm>
+          <a:prstGeom prst="rect">
+            <a:avLst/>
+          </a:prstGeom>
+          <a:noFill/>
+          <a:ln/>
+        </p:spPr>
+        <p:txBody>
+          <a:bodyPr wrap="square" lIns="0" tIns="0" rIns="0" bIns="0" rtlCol="0" anchor="ctr"/>
+          <a:lstStyle/>
+          <a:p>
+            <a:pPr algn="ctr"/>
+            <a:r>
+              <a:rPr lang="en-US" sz="4572" dirty="0">
+                <a:solidFill>
+                  <a:srgbClr val="10192D"/>
+                </a:solidFill>
+                <a:latin typeface="Aptos" pitchFamily="34" charset="0"/>
+                <a:ea typeface="Aptos" pitchFamily="34" charset="-122"/>
+                <a:cs typeface="Aptos" pitchFamily="34" charset="-120"/>
+              </a:rPr>
+              <a:t>Validates and starts a</a:t>
+            </a:r>
+            <a:endParaRPr lang="en-US" sz="4572" dirty="0"/>
+          </a:p>
+          <a:p>
+            <a:pPr algn="ctr"/>
+            <a:r>
+              <a:rPr lang="en-US" sz="4572" dirty="0">
+                <a:solidFill>
+                  <a:srgbClr val="10192D"/>
+                </a:solidFill>
+                <a:latin typeface="Aptos" pitchFamily="34" charset="0"/>
+                <a:ea typeface="Aptos" pitchFamily="34" charset="-122"/>
+                <a:cs typeface="Aptos" pitchFamily="34" charset="-120"/>
+              </a:rPr>
+              <a:t>restricted execution worker</a:t>
+            </a:r>
+            <a:endParaRPr lang="en-US" sz="4572" dirty="0"/>
+          </a:p>
+        </p:txBody>
+      </p:sp>
+      <p:sp>
+        <p:nvSpPr>
+          <p:cNvPr id="13" name="Shape 11"/>
+          <p:cNvSpPr/>
+          <p:nvPr/>
+        </p:nvSpPr>
+        <p:spPr>
+          <a:xfrm>
+            <a:off x="10451592" y="11340389"/>
+            <a:ext cx="1761134" cy="0"/>
+          </a:xfrm>
+          <a:prstGeom prst="line">
+            <a:avLst/>
+          </a:prstGeom>
+          <a:noFill/>
+          <a:ln w="17780">
+            <a:solidFill>
+              <a:srgbClr val="98A4B7"/>
+            </a:solidFill>
+            <a:prstDash val="solid"/>
+            <a:headEnd type="none"/>
+            <a:tailEnd type="triangle"/>
+          </a:ln>
+        </p:spPr>
+        <p:txBody>
+          <a:bodyPr/>
+          <a:lstStyle/>
+          <a:p>
+            <a:endParaRPr lang="en-US" sz="6480"/>
+          </a:p>
+        </p:txBody>
+      </p:sp>
+      <p:sp>
+        <p:nvSpPr>
+          <p:cNvPr id="14" name="Shape 12"/>
+          <p:cNvSpPr/>
+          <p:nvPr/>
+        </p:nvSpPr>
+        <p:spPr>
+          <a:xfrm>
+            <a:off x="12410237" y="8822131"/>
+            <a:ext cx="8460029" cy="5036515"/>
+          </a:xfrm>
+          <a:prstGeom prst="rect">
+            <a:avLst/>
+          </a:prstGeom>
+          <a:solidFill>
+            <a:srgbClr val="D3F7E5"/>
+          </a:solidFill>
+          <a:ln w="13335">
+            <a:solidFill>
+              <a:srgbClr val="17AD79"/>
+            </a:solidFill>
+            <a:prstDash val="solid"/>
+          </a:ln>
+        </p:spPr>
+        <p:txBody>
+          <a:bodyPr/>
+          <a:lstStyle/>
+          <a:p>
+            <a:endParaRPr lang="en-US" sz="6480"/>
+          </a:p>
+        </p:txBody>
+      </p:sp>
+      <p:sp>
+        <p:nvSpPr>
+          <p:cNvPr id="15" name="Text 13"/>
+          <p:cNvSpPr/>
+          <p:nvPr/>
+        </p:nvSpPr>
+        <p:spPr>
+          <a:xfrm>
+            <a:off x="12805258" y="9282989"/>
+            <a:ext cx="7669987" cy="921715"/>
+          </a:xfrm>
+          <a:prstGeom prst="rect">
+            <a:avLst/>
+          </a:prstGeom>
+          <a:noFill/>
+          <a:ln/>
+        </p:spPr>
+        <p:txBody>
+          <a:bodyPr wrap="square" lIns="0" tIns="0" rIns="0" bIns="0" rtlCol="0" anchor="ctr"/>
+          <a:lstStyle/>
+          <a:p>
+            <a:pPr algn="ctr"/>
+            <a:r>
+              <a:rPr lang="en-US" sz="5472" dirty="0">
+                <a:solidFill>
+                  <a:srgbClr val="10192D"/>
+                </a:solidFill>
+                <a:latin typeface="Aptos" pitchFamily="34" charset="0"/>
+                <a:ea typeface="Aptos" pitchFamily="34" charset="-122"/>
+                <a:cs typeface="Aptos" pitchFamily="34" charset="-120"/>
+              </a:rPr>
+              <a:t>2</a:t>
+            </a:r>
+            <a:endParaRPr lang="en-US" sz="5472" dirty="0"/>
+          </a:p>
+        </p:txBody>
+      </p:sp>
+      <p:sp>
+        <p:nvSpPr>
+          <p:cNvPr id="16" name="Text 14"/>
+          <p:cNvSpPr/>
+          <p:nvPr/>
+        </p:nvSpPr>
+        <p:spPr>
+          <a:xfrm>
+            <a:off x="12838176" y="10500969"/>
+            <a:ext cx="7604150" cy="954634"/>
+          </a:xfrm>
+          <a:prstGeom prst="rect">
+            <a:avLst/>
+          </a:prstGeom>
+          <a:noFill/>
+          <a:ln/>
+        </p:spPr>
+        <p:txBody>
+          <a:bodyPr wrap="square" lIns="0" tIns="0" rIns="0" bIns="0" rtlCol="0" anchor="ctr"/>
+          <a:lstStyle/>
+          <a:p>
+            <a:pPr algn="ctr"/>
+            <a:r>
+              <a:rPr lang="en-US" sz="5400" b="1" dirty="0">
+                <a:solidFill>
+                  <a:srgbClr val="10192D"/>
+                </a:solidFill>
+                <a:latin typeface="Aptos" pitchFamily="34" charset="0"/>
+                <a:ea typeface="Aptos" pitchFamily="34" charset="-122"/>
+                <a:cs typeface="Aptos" pitchFamily="34" charset="-120"/>
+              </a:rPr>
+              <a:t>Isolated sandbox</a:t>
+            </a:r>
+            <a:endParaRPr lang="en-US" sz="5400" dirty="0"/>
+          </a:p>
+        </p:txBody>
+      </p:sp>
+      <p:sp>
+        <p:nvSpPr>
+          <p:cNvPr id="17" name="Text 15"/>
+          <p:cNvSpPr/>
+          <p:nvPr/>
+        </p:nvSpPr>
+        <p:spPr>
+          <a:xfrm>
+            <a:off x="12838176" y="11718951"/>
+            <a:ext cx="7604150" cy="1580083"/>
+          </a:xfrm>
+          <a:prstGeom prst="rect">
+            <a:avLst/>
+          </a:prstGeom>
+          <a:noFill/>
+          <a:ln/>
+        </p:spPr>
+        <p:txBody>
+          <a:bodyPr wrap="square" lIns="0" tIns="0" rIns="0" bIns="0" rtlCol="0" anchor="ctr"/>
+          <a:lstStyle/>
+          <a:p>
+            <a:pPr algn="ctr"/>
+            <a:r>
+              <a:rPr lang="en-US" sz="4572" dirty="0">
+                <a:solidFill>
+                  <a:srgbClr val="10192D"/>
+                </a:solidFill>
+                <a:latin typeface="Aptos" pitchFamily="34" charset="0"/>
+                <a:ea typeface="Aptos" pitchFamily="34" charset="-122"/>
+                <a:cs typeface="Aptos" pitchFamily="34" charset="-120"/>
+              </a:rPr>
+              <a:t>Runs the generated</a:t>
+            </a:r>
+            <a:endParaRPr lang="en-US" sz="4572" dirty="0"/>
+          </a:p>
+          <a:p>
+            <a:pPr algn="ctr"/>
+            <a:r>
+              <a:rPr lang="en-US" sz="4572" dirty="0">
+                <a:solidFill>
+                  <a:srgbClr val="10192D"/>
+                </a:solidFill>
+                <a:latin typeface="Aptos" pitchFamily="34" charset="0"/>
+                <a:ea typeface="Aptos" pitchFamily="34" charset="-122"/>
+                <a:cs typeface="Aptos" pitchFamily="34" charset="-120"/>
+              </a:rPr>
+              <a:t>function as untrusted code</a:t>
+            </a:r>
+            <a:endParaRPr lang="en-US" sz="4572" dirty="0"/>
+          </a:p>
+        </p:txBody>
+      </p:sp>
+      <p:sp>
+        <p:nvSpPr>
+          <p:cNvPr id="18" name="Shape 16"/>
+          <p:cNvSpPr/>
+          <p:nvPr/>
+        </p:nvSpPr>
+        <p:spPr>
+          <a:xfrm>
+            <a:off x="20952562" y="11340389"/>
+            <a:ext cx="1761134" cy="0"/>
+          </a:xfrm>
+          <a:prstGeom prst="line">
+            <a:avLst/>
+          </a:prstGeom>
+          <a:noFill/>
+          <a:ln w="17780">
+            <a:solidFill>
+              <a:srgbClr val="98A4B7"/>
+            </a:solidFill>
+            <a:prstDash val="solid"/>
+            <a:headEnd type="none"/>
+            <a:tailEnd type="triangle"/>
+          </a:ln>
+        </p:spPr>
+        <p:txBody>
+          <a:bodyPr/>
+          <a:lstStyle/>
+          <a:p>
+            <a:endParaRPr lang="en-US" sz="6480"/>
+          </a:p>
+        </p:txBody>
+      </p:sp>
+      <p:sp>
+        <p:nvSpPr>
+          <p:cNvPr id="19" name="Shape 17"/>
+          <p:cNvSpPr/>
+          <p:nvPr/>
+        </p:nvSpPr>
+        <p:spPr>
+          <a:xfrm>
+            <a:off x="22911206" y="8822131"/>
+            <a:ext cx="8460029" cy="5036515"/>
+          </a:xfrm>
+          <a:prstGeom prst="rect">
+            <a:avLst/>
+          </a:prstGeom>
+          <a:solidFill>
+            <a:srgbClr val="FFF2C5"/>
+          </a:solidFill>
+          <a:ln w="13335">
+            <a:solidFill>
+              <a:srgbClr val="F59A15"/>
+            </a:solidFill>
+            <a:prstDash val="solid"/>
+          </a:ln>
+        </p:spPr>
+        <p:txBody>
+          <a:bodyPr/>
+          <a:lstStyle/>
+          <a:p>
+            <a:endParaRPr lang="en-US" sz="6480"/>
+          </a:p>
+        </p:txBody>
+      </p:sp>
+      <p:sp>
+        <p:nvSpPr>
+          <p:cNvPr id="20" name="Text 18"/>
+          <p:cNvSpPr/>
+          <p:nvPr/>
+        </p:nvSpPr>
+        <p:spPr>
+          <a:xfrm>
+            <a:off x="23306227" y="9282989"/>
+            <a:ext cx="7669987" cy="921715"/>
+          </a:xfrm>
+          <a:prstGeom prst="rect">
+            <a:avLst/>
+          </a:prstGeom>
+          <a:noFill/>
+          <a:ln/>
+        </p:spPr>
+        <p:txBody>
+          <a:bodyPr wrap="square" lIns="0" tIns="0" rIns="0" bIns="0" rtlCol="0" anchor="ctr"/>
+          <a:lstStyle/>
+          <a:p>
+            <a:pPr algn="ctr"/>
+            <a:r>
+              <a:rPr lang="en-US" sz="5472" dirty="0">
+                <a:solidFill>
+                  <a:srgbClr val="10192D"/>
+                </a:solidFill>
+                <a:latin typeface="Aptos" pitchFamily="34" charset="0"/>
+                <a:ea typeface="Aptos" pitchFamily="34" charset="-122"/>
+                <a:cs typeface="Aptos" pitchFamily="34" charset="-120"/>
+              </a:rPr>
+              <a:t>3</a:t>
+            </a:r>
+            <a:endParaRPr lang="en-US" sz="5472" dirty="0"/>
+          </a:p>
+        </p:txBody>
+      </p:sp>
+      <p:sp>
+        <p:nvSpPr>
+          <p:cNvPr id="21" name="Text 19"/>
+          <p:cNvSpPr/>
+          <p:nvPr/>
+        </p:nvSpPr>
+        <p:spPr>
+          <a:xfrm>
+            <a:off x="23339146" y="10500969"/>
+            <a:ext cx="7604150" cy="954634"/>
+          </a:xfrm>
+          <a:prstGeom prst="rect">
+            <a:avLst/>
+          </a:prstGeom>
+          <a:noFill/>
+          <a:ln/>
+        </p:spPr>
+        <p:txBody>
+          <a:bodyPr wrap="square" lIns="0" tIns="0" rIns="0" bIns="0" rtlCol="0" anchor="ctr"/>
+          <a:lstStyle/>
+          <a:p>
+            <a:pPr algn="ctr"/>
+            <a:r>
+              <a:rPr lang="en-US" sz="5400" b="1" dirty="0">
+                <a:solidFill>
+                  <a:srgbClr val="10192D"/>
+                </a:solidFill>
+                <a:latin typeface="Aptos" pitchFamily="34" charset="0"/>
+                <a:ea typeface="Aptos" pitchFamily="34" charset="-122"/>
+                <a:cs typeface="Aptos" pitchFamily="34" charset="-120"/>
+              </a:rPr>
+              <a:t>Trusted tool broker</a:t>
+            </a:r>
+            <a:endParaRPr lang="en-US" sz="5400" dirty="0"/>
+          </a:p>
+        </p:txBody>
+      </p:sp>
+      <p:sp>
+        <p:nvSpPr>
+          <p:cNvPr id="22" name="Text 20"/>
+          <p:cNvSpPr/>
+          <p:nvPr/>
+        </p:nvSpPr>
+        <p:spPr>
+          <a:xfrm>
+            <a:off x="23339146" y="11718951"/>
+            <a:ext cx="7604150" cy="1580083"/>
+          </a:xfrm>
+          <a:prstGeom prst="rect">
+            <a:avLst/>
+          </a:prstGeom>
+          <a:noFill/>
+          <a:ln/>
+        </p:spPr>
+        <p:txBody>
+          <a:bodyPr wrap="square" lIns="0" tIns="0" rIns="0" bIns="0" rtlCol="0" anchor="ctr"/>
+          <a:lstStyle/>
+          <a:p>
+            <a:pPr algn="ctr"/>
+            <a:r>
+              <a:rPr lang="en-US" sz="4572" dirty="0">
+                <a:solidFill>
+                  <a:srgbClr val="10192D"/>
+                </a:solidFill>
+                <a:latin typeface="Aptos" pitchFamily="34" charset="0"/>
+                <a:ea typeface="Aptos" pitchFamily="34" charset="-122"/>
+                <a:cs typeface="Aptos" pitchFamily="34" charset="-120"/>
+              </a:rPr>
+              <a:t>Mediates only BRD-</a:t>
+            </a:r>
+            <a:endParaRPr lang="en-US" sz="4572" dirty="0"/>
+          </a:p>
+          <a:p>
+            <a:pPr algn="ctr"/>
+            <a:r>
+              <a:rPr lang="en-US" sz="4572" dirty="0">
+                <a:solidFill>
+                  <a:srgbClr val="10192D"/>
+                </a:solidFill>
+                <a:latin typeface="Aptos" pitchFamily="34" charset="0"/>
+                <a:ea typeface="Aptos" pitchFamily="34" charset="-122"/>
+                <a:cs typeface="Aptos" pitchFamily="34" charset="-120"/>
+              </a:rPr>
+              <a:t>approved external actions</a:t>
+            </a:r>
+            <a:endParaRPr lang="en-US" sz="4572" dirty="0"/>
+          </a:p>
+        </p:txBody>
+      </p:sp>
+      <p:sp>
+        <p:nvSpPr>
+          <p:cNvPr id="23" name="Shape 21"/>
+          <p:cNvSpPr/>
+          <p:nvPr/>
+        </p:nvSpPr>
+        <p:spPr>
+          <a:xfrm>
+            <a:off x="31453531" y="11340389"/>
+            <a:ext cx="1761134" cy="0"/>
+          </a:xfrm>
+          <a:prstGeom prst="line">
+            <a:avLst/>
+          </a:prstGeom>
+          <a:noFill/>
+          <a:ln w="17780">
+            <a:solidFill>
+              <a:srgbClr val="98A4B7"/>
+            </a:solidFill>
+            <a:prstDash val="solid"/>
+            <a:headEnd type="none"/>
+            <a:tailEnd type="triangle"/>
+          </a:ln>
+        </p:spPr>
+        <p:txBody>
+          <a:bodyPr/>
+          <a:lstStyle/>
+          <a:p>
+            <a:endParaRPr lang="en-US" sz="6480"/>
+          </a:p>
+        </p:txBody>
+      </p:sp>
+      <p:sp>
+        <p:nvSpPr>
+          <p:cNvPr id="24" name="Shape 22"/>
+          <p:cNvSpPr/>
+          <p:nvPr/>
+        </p:nvSpPr>
+        <p:spPr>
+          <a:xfrm>
+            <a:off x="33412176" y="8822131"/>
+            <a:ext cx="8460029" cy="5036515"/>
+          </a:xfrm>
+          <a:prstGeom prst="rect">
+            <a:avLst/>
+          </a:prstGeom>
+          <a:solidFill>
+            <a:srgbClr val="FFE3E2"/>
+          </a:solidFill>
+          <a:ln w="13335">
+            <a:solidFill>
+              <a:srgbClr val="F05252"/>
+            </a:solidFill>
+            <a:prstDash val="solid"/>
+          </a:ln>
+        </p:spPr>
+        <p:txBody>
+          <a:bodyPr/>
+          <a:lstStyle/>
+          <a:p>
+            <a:endParaRPr lang="en-US" sz="6480"/>
+          </a:p>
+        </p:txBody>
+      </p:sp>
+      <p:sp>
+        <p:nvSpPr>
+          <p:cNvPr id="25" name="Text 23"/>
+          <p:cNvSpPr/>
+          <p:nvPr/>
+        </p:nvSpPr>
+        <p:spPr>
+          <a:xfrm>
+            <a:off x="33807197" y="9282989"/>
+            <a:ext cx="7669987" cy="921715"/>
+          </a:xfrm>
+          <a:prstGeom prst="rect">
+            <a:avLst/>
+          </a:prstGeom>
+          <a:noFill/>
+          <a:ln/>
+        </p:spPr>
+        <p:txBody>
+          <a:bodyPr wrap="square" lIns="0" tIns="0" rIns="0" bIns="0" rtlCol="0" anchor="ctr"/>
+          <a:lstStyle/>
+          <a:p>
+            <a:pPr algn="ctr"/>
+            <a:r>
+              <a:rPr lang="en-US" sz="5472" dirty="0">
+                <a:solidFill>
+                  <a:srgbClr val="10192D"/>
+                </a:solidFill>
+                <a:latin typeface="Aptos" pitchFamily="34" charset="0"/>
+                <a:ea typeface="Aptos" pitchFamily="34" charset="-122"/>
+                <a:cs typeface="Aptos" pitchFamily="34" charset="-120"/>
+              </a:rPr>
+              <a:t>4</a:t>
+            </a:r>
+            <a:endParaRPr lang="en-US" sz="5472" dirty="0"/>
+          </a:p>
+        </p:txBody>
+      </p:sp>
+      <p:sp>
+        <p:nvSpPr>
+          <p:cNvPr id="26" name="Text 24"/>
+          <p:cNvSpPr/>
+          <p:nvPr/>
+        </p:nvSpPr>
+        <p:spPr>
+          <a:xfrm>
+            <a:off x="33840115" y="10500969"/>
+            <a:ext cx="7604150" cy="954634"/>
+          </a:xfrm>
+          <a:prstGeom prst="rect">
+            <a:avLst/>
+          </a:prstGeom>
+          <a:noFill/>
+          <a:ln/>
+        </p:spPr>
+        <p:txBody>
+          <a:bodyPr wrap="square" lIns="0" tIns="0" rIns="0" bIns="0" rtlCol="0" anchor="ctr"/>
+          <a:lstStyle/>
+          <a:p>
+            <a:pPr algn="ctr"/>
+            <a:r>
+              <a:rPr lang="en-US" sz="5400" b="1" dirty="0">
+                <a:solidFill>
+                  <a:srgbClr val="10192D"/>
+                </a:solidFill>
+                <a:latin typeface="Aptos" pitchFamily="34" charset="0"/>
+                <a:ea typeface="Aptos" pitchFamily="34" charset="-122"/>
+                <a:cs typeface="Aptos" pitchFamily="34" charset="-120"/>
+              </a:rPr>
+              <a:t>Python validation</a:t>
+            </a:r>
+            <a:endParaRPr lang="en-US" sz="5400" dirty="0"/>
+          </a:p>
+        </p:txBody>
+      </p:sp>
+      <p:sp>
+        <p:nvSpPr>
+          <p:cNvPr id="27" name="Text 25"/>
+          <p:cNvSpPr/>
+          <p:nvPr/>
+        </p:nvSpPr>
+        <p:spPr>
+          <a:xfrm>
+            <a:off x="33840115" y="11718951"/>
+            <a:ext cx="7604150" cy="1580083"/>
+          </a:xfrm>
+          <a:prstGeom prst="rect">
+            <a:avLst/>
+          </a:prstGeom>
+          <a:noFill/>
+          <a:ln/>
+        </p:spPr>
+        <p:txBody>
+          <a:bodyPr wrap="square" lIns="0" tIns="0" rIns="0" bIns="0" rtlCol="0" anchor="ctr"/>
+          <a:lstStyle/>
+          <a:p>
+            <a:pPr algn="ctr"/>
+            <a:r>
+              <a:rPr lang="en-US" sz="4572" dirty="0">
+                <a:solidFill>
+                  <a:srgbClr val="10192D"/>
+                </a:solidFill>
+                <a:latin typeface="Aptos" pitchFamily="34" charset="0"/>
+                <a:ea typeface="Aptos" pitchFamily="34" charset="-122"/>
+                <a:cs typeface="Aptos" pitchFamily="34" charset="-120"/>
+              </a:rPr>
+              <a:t>Checks outputs; logs or</a:t>
+            </a:r>
+            <a:endParaRPr lang="en-US" sz="4572" dirty="0"/>
+          </a:p>
+          <a:p>
+            <a:pPr algn="ctr"/>
+            <a:r>
+              <a:rPr lang="en-US" sz="4572" dirty="0">
+                <a:solidFill>
+                  <a:srgbClr val="10192D"/>
+                </a:solidFill>
+                <a:latin typeface="Aptos" pitchFamily="34" charset="0"/>
+                <a:ea typeface="Aptos" pitchFamily="34" charset="-122"/>
+                <a:cs typeface="Aptos" pitchFamily="34" charset="-120"/>
+              </a:rPr>
+              <a:t>terminates failures</a:t>
+            </a:r>
+            <a:endParaRPr lang="en-US" sz="4572" dirty="0"/>
+          </a:p>
+        </p:txBody>
+      </p:sp>
+      <p:sp>
+        <p:nvSpPr>
+          <p:cNvPr id="28" name="Text 26"/>
+          <p:cNvSpPr/>
+          <p:nvPr/>
+        </p:nvSpPr>
+        <p:spPr>
+          <a:xfrm>
+            <a:off x="1909267" y="15372893"/>
+            <a:ext cx="12508992" cy="987552"/>
+          </a:xfrm>
+          <a:prstGeom prst="rect">
+            <a:avLst/>
+          </a:prstGeom>
+          <a:noFill/>
+          <a:ln/>
+        </p:spPr>
+        <p:txBody>
+          <a:bodyPr wrap="square" lIns="0" tIns="0" rIns="0" bIns="0" rtlCol="0" anchor="ctr"/>
+          <a:lstStyle/>
+          <a:p>
+            <a:r>
+              <a:rPr lang="en-US" sz="5940" b="1" dirty="0">
+                <a:solidFill>
+                  <a:srgbClr val="2766EC"/>
+                </a:solidFill>
+                <a:latin typeface="Aptos" pitchFamily="34" charset="0"/>
+                <a:ea typeface="Aptos" pitchFamily="34" charset="-122"/>
+                <a:cs typeface="Aptos" pitchFamily="34" charset="-120"/>
+              </a:rPr>
+              <a:t>Sandbox isolation</a:t>
+            </a:r>
+            <a:endParaRPr lang="en-US" sz="5940" dirty="0"/>
+          </a:p>
+        </p:txBody>
+      </p:sp>
+      <p:sp>
+        <p:nvSpPr>
+          <p:cNvPr id="29" name="Text 27"/>
+          <p:cNvSpPr/>
+          <p:nvPr/>
+        </p:nvSpPr>
+        <p:spPr>
+          <a:xfrm>
+            <a:off x="1909267" y="16854221"/>
+            <a:ext cx="13002768" cy="1020470"/>
+          </a:xfrm>
+          <a:prstGeom prst="rect">
+            <a:avLst/>
+          </a:prstGeom>
+          <a:noFill/>
+          <a:ln/>
+        </p:spPr>
+        <p:txBody>
+          <a:bodyPr wrap="square" lIns="0" tIns="0" rIns="0" bIns="0" rtlCol="0" anchor="ctr"/>
+          <a:lstStyle/>
+          <a:p>
+            <a:r>
+              <a:rPr lang="en-US" sz="4446" dirty="0">
+                <a:solidFill>
+                  <a:srgbClr val="10192D"/>
+                </a:solidFill>
+                <a:latin typeface="Aptos" pitchFamily="34" charset="0"/>
+                <a:ea typeface="Aptos" pitchFamily="34" charset="-122"/>
+                <a:cs typeface="Aptos" pitchFamily="34" charset="-120"/>
+              </a:rPr>
+              <a:t>•  Separate restricted process / container</a:t>
+            </a:r>
+            <a:endParaRPr lang="en-US" sz="4446" dirty="0"/>
+          </a:p>
+        </p:txBody>
+      </p:sp>
+      <p:sp>
+        <p:nvSpPr>
+          <p:cNvPr id="30" name="Text 28"/>
+          <p:cNvSpPr/>
+          <p:nvPr/>
+        </p:nvSpPr>
+        <p:spPr>
+          <a:xfrm>
+            <a:off x="1909267" y="18039283"/>
+            <a:ext cx="13002768" cy="1020470"/>
+          </a:xfrm>
+          <a:prstGeom prst="rect">
+            <a:avLst/>
+          </a:prstGeom>
+          <a:noFill/>
+          <a:ln/>
+        </p:spPr>
+        <p:txBody>
+          <a:bodyPr wrap="square" lIns="0" tIns="0" rIns="0" bIns="0" rtlCol="0" anchor="ctr"/>
+          <a:lstStyle/>
+          <a:p>
+            <a:r>
+              <a:rPr lang="en-US" sz="4446" dirty="0">
+                <a:solidFill>
+                  <a:srgbClr val="10192D"/>
+                </a:solidFill>
+                <a:latin typeface="Aptos" pitchFamily="34" charset="0"/>
+                <a:ea typeface="Aptos" pitchFamily="34" charset="-122"/>
+                <a:cs typeface="Aptos" pitchFamily="34" charset="-120"/>
+              </a:rPr>
+              <a:t>•  No direct access to host files or secrets</a:t>
+            </a:r>
+            <a:endParaRPr lang="en-US" sz="4446" dirty="0"/>
+          </a:p>
+        </p:txBody>
+      </p:sp>
+      <p:sp>
+        <p:nvSpPr>
+          <p:cNvPr id="31" name="Text 29"/>
+          <p:cNvSpPr/>
+          <p:nvPr/>
+        </p:nvSpPr>
+        <p:spPr>
+          <a:xfrm>
+            <a:off x="1909267" y="19224346"/>
+            <a:ext cx="13002768" cy="1020470"/>
+          </a:xfrm>
+          <a:prstGeom prst="rect">
+            <a:avLst/>
+          </a:prstGeom>
+          <a:noFill/>
+          <a:ln/>
+        </p:spPr>
+        <p:txBody>
+          <a:bodyPr wrap="square" lIns="0" tIns="0" rIns="0" bIns="0" rtlCol="0" anchor="ctr"/>
+          <a:lstStyle/>
+          <a:p>
+            <a:r>
+              <a:rPr lang="en-US" sz="4446" dirty="0">
+                <a:solidFill>
+                  <a:srgbClr val="10192D"/>
+                </a:solidFill>
+                <a:latin typeface="Aptos" pitchFamily="34" charset="0"/>
+                <a:ea typeface="Aptos" pitchFamily="34" charset="-122"/>
+                <a:cs typeface="Aptos" pitchFamily="34" charset="-120"/>
+              </a:rPr>
+              <a:t>•  Network and OS permissions denied by default</a:t>
+            </a:r>
+            <a:endParaRPr lang="en-US" sz="4446" dirty="0"/>
+          </a:p>
+        </p:txBody>
+      </p:sp>
+      <p:sp>
+        <p:nvSpPr>
+          <p:cNvPr id="32" name="Text 30"/>
+          <p:cNvSpPr/>
+          <p:nvPr/>
+        </p:nvSpPr>
+        <p:spPr>
+          <a:xfrm>
+            <a:off x="15504566" y="15372893"/>
+            <a:ext cx="13167360" cy="987552"/>
+          </a:xfrm>
+          <a:prstGeom prst="rect">
+            <a:avLst/>
+          </a:prstGeom>
+          <a:noFill/>
+          <a:ln/>
+        </p:spPr>
+        <p:txBody>
+          <a:bodyPr wrap="square" lIns="0" tIns="0" rIns="0" bIns="0" rtlCol="0" anchor="ctr"/>
+          <a:lstStyle/>
+          <a:p>
+            <a:r>
+              <a:rPr lang="en-US" sz="5940" b="1" dirty="0">
+                <a:solidFill>
+                  <a:srgbClr val="0A9B73"/>
+                </a:solidFill>
+                <a:latin typeface="Aptos" pitchFamily="34" charset="0"/>
+                <a:ea typeface="Aptos" pitchFamily="34" charset="-122"/>
+                <a:cs typeface="Aptos" pitchFamily="34" charset="-120"/>
+              </a:rPr>
+              <a:t>Python-owned tool gateway</a:t>
+            </a:r>
+            <a:endParaRPr lang="en-US" sz="5940" dirty="0"/>
+          </a:p>
+        </p:txBody>
+      </p:sp>
+      <p:sp>
+        <p:nvSpPr>
+          <p:cNvPr id="33" name="Text 31"/>
+          <p:cNvSpPr/>
+          <p:nvPr/>
+        </p:nvSpPr>
+        <p:spPr>
+          <a:xfrm>
+            <a:off x="15504566" y="16854221"/>
+            <a:ext cx="13002768" cy="1020470"/>
+          </a:xfrm>
+          <a:prstGeom prst="rect">
+            <a:avLst/>
+          </a:prstGeom>
+          <a:noFill/>
+          <a:ln/>
+        </p:spPr>
+        <p:txBody>
+          <a:bodyPr wrap="square" lIns="0" tIns="0" rIns="0" bIns="0" rtlCol="0" anchor="ctr"/>
+          <a:lstStyle/>
+          <a:p>
+            <a:r>
+              <a:rPr lang="en-US" sz="4446" dirty="0">
+                <a:solidFill>
+                  <a:srgbClr val="10192D"/>
+                </a:solidFill>
+                <a:latin typeface="Aptos" pitchFamily="34" charset="0"/>
+                <a:ea typeface="Aptos" pitchFamily="34" charset="-122"/>
+                <a:cs typeface="Aptos" pitchFamily="34" charset="-120"/>
+              </a:rPr>
+              <a:t>•  Only BRD-authorized tools and resources</a:t>
+            </a:r>
+            <a:endParaRPr lang="en-US" sz="4446" dirty="0"/>
+          </a:p>
+        </p:txBody>
+      </p:sp>
+      <p:sp>
+        <p:nvSpPr>
+          <p:cNvPr id="34" name="Text 32"/>
+          <p:cNvSpPr/>
+          <p:nvPr/>
+        </p:nvSpPr>
+        <p:spPr>
+          <a:xfrm>
+            <a:off x="15504566" y="18039283"/>
+            <a:ext cx="13002768" cy="1020470"/>
+          </a:xfrm>
+          <a:prstGeom prst="rect">
+            <a:avLst/>
+          </a:prstGeom>
+          <a:noFill/>
+          <a:ln/>
+        </p:spPr>
+        <p:txBody>
+          <a:bodyPr wrap="square" lIns="0" tIns="0" rIns="0" bIns="0" rtlCol="0" anchor="ctr"/>
+          <a:lstStyle/>
+          <a:p>
+            <a:r>
+              <a:rPr lang="en-US" sz="4446" dirty="0">
+                <a:solidFill>
+                  <a:srgbClr val="10192D"/>
+                </a:solidFill>
+                <a:latin typeface="Aptos" pitchFamily="34" charset="0"/>
+                <a:ea typeface="Aptos" pitchFamily="34" charset="-122"/>
+                <a:cs typeface="Aptos" pitchFamily="34" charset="-120"/>
+              </a:rPr>
+              <a:t>•  Calls mediated by a trusted broker</a:t>
+            </a:r>
+            <a:endParaRPr lang="en-US" sz="4446" dirty="0"/>
+          </a:p>
+        </p:txBody>
+      </p:sp>
+      <p:sp>
+        <p:nvSpPr>
+          <p:cNvPr id="35" name="Text 33"/>
+          <p:cNvSpPr/>
+          <p:nvPr/>
+        </p:nvSpPr>
+        <p:spPr>
+          <a:xfrm>
+            <a:off x="15504566" y="19224346"/>
+            <a:ext cx="13002768" cy="1020470"/>
+          </a:xfrm>
+          <a:prstGeom prst="rect">
+            <a:avLst/>
+          </a:prstGeom>
+          <a:noFill/>
+          <a:ln/>
+        </p:spPr>
+        <p:txBody>
+          <a:bodyPr wrap="square" lIns="0" tIns="0" rIns="0" bIns="0" rtlCol="0" anchor="ctr"/>
+          <a:lstStyle/>
+          <a:p>
+            <a:r>
+              <a:rPr lang="en-US" sz="4446" dirty="0">
+                <a:solidFill>
+                  <a:srgbClr val="10192D"/>
+                </a:solidFill>
+                <a:latin typeface="Aptos" pitchFamily="34" charset="0"/>
+                <a:ea typeface="Aptos" pitchFamily="34" charset="-122"/>
+                <a:cs typeface="Aptos" pitchFamily="34" charset="-120"/>
+              </a:rPr>
+              <a:t>•  Credentials remain outside the sandbox</a:t>
+            </a:r>
+            <a:endParaRPr lang="en-US" sz="4446" dirty="0"/>
+          </a:p>
+        </p:txBody>
+      </p:sp>
+      <p:sp>
+        <p:nvSpPr>
+          <p:cNvPr id="36" name="Text 34"/>
+          <p:cNvSpPr/>
+          <p:nvPr/>
+        </p:nvSpPr>
+        <p:spPr>
+          <a:xfrm>
+            <a:off x="28770682" y="15372893"/>
+            <a:ext cx="13167360" cy="987552"/>
+          </a:xfrm>
+          <a:prstGeom prst="rect">
+            <a:avLst/>
+          </a:prstGeom>
+          <a:noFill/>
+          <a:ln/>
+        </p:spPr>
+        <p:txBody>
+          <a:bodyPr wrap="square" lIns="0" tIns="0" rIns="0" bIns="0" rtlCol="0" anchor="ctr"/>
+          <a:lstStyle/>
+          <a:p>
+            <a:r>
+              <a:rPr lang="en-US" sz="5940" b="1" dirty="0">
+                <a:solidFill>
+                  <a:srgbClr val="D88404"/>
+                </a:solidFill>
+                <a:latin typeface="Aptos" pitchFamily="34" charset="0"/>
+                <a:ea typeface="Aptos" pitchFamily="34" charset="-122"/>
+                <a:cs typeface="Aptos" pitchFamily="34" charset="-120"/>
+              </a:rPr>
+              <a:t>Failure containment</a:t>
+            </a:r>
+            <a:endParaRPr lang="en-US" sz="5940" dirty="0"/>
+          </a:p>
+        </p:txBody>
+      </p:sp>
+      <p:sp>
+        <p:nvSpPr>
+          <p:cNvPr id="37" name="Text 35"/>
+          <p:cNvSpPr/>
+          <p:nvPr/>
+        </p:nvSpPr>
+        <p:spPr>
+          <a:xfrm>
+            <a:off x="28770682" y="16854221"/>
+            <a:ext cx="13002768" cy="1020470"/>
+          </a:xfrm>
+          <a:prstGeom prst="rect">
+            <a:avLst/>
+          </a:prstGeom>
+          <a:noFill/>
+          <a:ln/>
+        </p:spPr>
+        <p:txBody>
+          <a:bodyPr wrap="square" lIns="0" tIns="0" rIns="0" bIns="0" rtlCol="0" anchor="ctr"/>
+          <a:lstStyle/>
+          <a:p>
+            <a:r>
+              <a:rPr lang="en-US" sz="4446" dirty="0">
+                <a:solidFill>
+                  <a:srgbClr val="10192D"/>
+                </a:solidFill>
+                <a:latin typeface="Aptos" pitchFamily="34" charset="0"/>
+                <a:ea typeface="Aptos" pitchFamily="34" charset="-122"/>
+                <a:cs typeface="Aptos" pitchFamily="34" charset="-120"/>
+              </a:rPr>
+              <a:t>•  Enforce time, CPU and memory ceilings</a:t>
+            </a:r>
+            <a:endParaRPr lang="en-US" sz="4446" dirty="0"/>
+          </a:p>
+        </p:txBody>
+      </p:sp>
+      <p:sp>
+        <p:nvSpPr>
+          <p:cNvPr id="38" name="Text 36"/>
+          <p:cNvSpPr/>
+          <p:nvPr/>
+        </p:nvSpPr>
+        <p:spPr>
+          <a:xfrm>
+            <a:off x="28770682" y="18039283"/>
+            <a:ext cx="13002768" cy="1020470"/>
+          </a:xfrm>
+          <a:prstGeom prst="rect">
+            <a:avLst/>
+          </a:prstGeom>
+          <a:noFill/>
+          <a:ln/>
+        </p:spPr>
+        <p:txBody>
+          <a:bodyPr wrap="square" lIns="0" tIns="0" rIns="0" bIns="0" rtlCol="0" anchor="ctr"/>
+          <a:lstStyle/>
+          <a:p>
+            <a:r>
+              <a:rPr lang="en-US" sz="4446" dirty="0">
+                <a:solidFill>
+                  <a:srgbClr val="10192D"/>
+                </a:solidFill>
+                <a:latin typeface="Aptos" pitchFamily="34" charset="0"/>
+                <a:ea typeface="Aptos" pitchFamily="34" charset="-122"/>
+                <a:cs typeface="Aptos" pitchFamily="34" charset="-120"/>
+              </a:rPr>
+              <a:t>•  Stop hanging or misbehaving executions</a:t>
+            </a:r>
+            <a:endParaRPr lang="en-US" sz="4446" dirty="0"/>
+          </a:p>
+        </p:txBody>
+      </p:sp>
+      <p:sp>
+        <p:nvSpPr>
+          <p:cNvPr id="39" name="Text 37"/>
+          <p:cNvSpPr/>
+          <p:nvPr/>
+        </p:nvSpPr>
+        <p:spPr>
+          <a:xfrm>
+            <a:off x="28770682" y="19224346"/>
+            <a:ext cx="13002768" cy="1020470"/>
+          </a:xfrm>
+          <a:prstGeom prst="rect">
+            <a:avLst/>
+          </a:prstGeom>
+          <a:noFill/>
+          <a:ln/>
+        </p:spPr>
+        <p:txBody>
+          <a:bodyPr wrap="square" lIns="0" tIns="0" rIns="0" bIns="0" rtlCol="0" anchor="ctr"/>
+          <a:lstStyle/>
+          <a:p>
+            <a:r>
+              <a:rPr lang="en-US" sz="4446" dirty="0">
+                <a:solidFill>
+                  <a:srgbClr val="10192D"/>
+                </a:solidFill>
+                <a:latin typeface="Aptos" pitchFamily="34" charset="0"/>
+                <a:ea typeface="Aptos" pitchFamily="34" charset="-122"/>
+                <a:cs typeface="Aptos" pitchFamily="34" charset="-120"/>
+              </a:rPr>
+              <a:t>•  Audit requests, results and violations</a:t>
+            </a:r>
+            <a:endParaRPr lang="en-US" sz="4446" dirty="0"/>
+          </a:p>
+        </p:txBody>
+      </p:sp>
+      <p:sp>
+        <p:nvSpPr>
+          <p:cNvPr id="40" name="Shape 38"/>
+          <p:cNvSpPr/>
+          <p:nvPr/>
+        </p:nvSpPr>
+        <p:spPr>
+          <a:xfrm>
+            <a:off x="1909267" y="22318675"/>
+            <a:ext cx="40028774" cy="1448410"/>
+          </a:xfrm>
+          <a:prstGeom prst="rect">
+            <a:avLst/>
+          </a:prstGeom>
+          <a:solidFill>
+            <a:srgbClr val="10192F"/>
+          </a:solidFill>
+          <a:ln w="12700">
+            <a:solidFill>
+              <a:srgbClr val="10192F">
+                <a:alpha val="0"/>
+              </a:srgbClr>
+            </a:solidFill>
+            <a:prstDash val="solid"/>
+          </a:ln>
+        </p:spPr>
+        <p:txBody>
+          <a:bodyPr/>
+          <a:lstStyle/>
+          <a:p>
+            <a:endParaRPr lang="en-US" sz="6480"/>
+          </a:p>
+        </p:txBody>
+      </p:sp>
+      <p:sp>
+        <p:nvSpPr>
+          <p:cNvPr id="41" name="Text 39"/>
+          <p:cNvSpPr/>
+          <p:nvPr/>
+        </p:nvSpPr>
+        <p:spPr>
+          <a:xfrm>
+            <a:off x="2435962" y="22549104"/>
+            <a:ext cx="39107059" cy="888797"/>
+          </a:xfrm>
+          <a:prstGeom prst="rect">
+            <a:avLst/>
+          </a:prstGeom>
+          <a:noFill/>
+          <a:ln/>
+        </p:spPr>
+        <p:txBody>
+          <a:bodyPr wrap="square" lIns="0" tIns="0" rIns="0" bIns="0" rtlCol="0" anchor="ctr"/>
+          <a:lstStyle/>
+          <a:p>
+            <a:r>
+              <a:rPr lang="en-US" sz="4158" b="1" dirty="0">
+                <a:solidFill>
+                  <a:srgbClr val="FFFFFF"/>
+                </a:solidFill>
+                <a:latin typeface="Aptos" pitchFamily="34" charset="0"/>
+                <a:ea typeface="Aptos" pitchFamily="34" charset="-122"/>
+                <a:cs typeface="Aptos" pitchFamily="34" charset="-120"/>
+              </a:rPr>
+              <a:t>Design rule: BRD-scoped tools control permissions; sandbox isolation contains unexpected code behavior. Both are needed.</a:t>
+            </a:r>
+            <a:endParaRPr lang="en-US" sz="4158" dirty="0"/>
           </a:p>
         </p:txBody>
       </p:sp>

</xml_diff>

<commit_message>
Update presentation with reliability-aligned BRD documentation
</commit_message>
<xml_diff>
--- a/docs/No_Trust_Me_Agentic_AI.pptx
+++ b/docs/No_Trust_Me_Agentic_AI.pptx
@@ -6,7 +6,7 @@
     <p:sldMasterId id="2147483672" r:id="rId2"/>
   </p:sldMasterIdLst>
   <p:notesMasterIdLst>
-    <p:notesMasterId r:id="rId11"/>
+    <p:notesMasterId r:id="rId12"/>
   </p:notesMasterIdLst>
   <p:sldIdLst>
     <p:sldId id="256" r:id="rId3"/>
@@ -17,6 +17,7 @@
     <p:sldId id="263" r:id="rId8"/>
     <p:sldId id="264" r:id="rId9"/>
     <p:sldId id="265" r:id="rId10"/>
+    <p:sldId id="266" r:id="rId11"/>
   </p:sldIdLst>
   <p:sldSz cx="43891200" cy="24688800"/>
   <p:notesSz cx="6858000" cy="9144000"/>
@@ -126,7 +127,7 @@
 <file path=ppt/revisionInfo.xml><?xml version="1.0" encoding="utf-8"?>
 <p1510:revInfo xmlns:a="http://schemas.openxmlformats.org/drawingml/2006/main" xmlns:r="http://schemas.openxmlformats.org/officeDocument/2006/relationships" xmlns:p1510="http://schemas.microsoft.com/office/powerpoint/2015/10/main">
   <p1510:revLst>
-    <p1510:client id="{365D465A-354D-4022-A33C-AF8F86656859}" v="21" dt="2026-10-09T16:54:40.319"/>
+    <p1510:client id="{365D465A-354D-4022-A33C-AF8F86656859}" v="66" dt="2026-10-09T19:17:00.791"/>
   </p1510:revLst>
 </p1510:revInfo>
 </file>
@@ -135,11 +136,26 @@
 <pc:chgInfo xmlns:a="http://schemas.openxmlformats.org/drawingml/2006/main" xmlns:r="http://schemas.openxmlformats.org/officeDocument/2006/relationships" xmlns:ac="http://schemas.microsoft.com/office/drawing/2013/main/command" xmlns:pc="http://schemas.microsoft.com/office/powerpoint/2013/main/command">
   <pc:docChgLst>
     <pc:chgData name="Simon Hong" userId="2f15200c-b3cf-4aef-8f69-ada819764841" providerId="ADAL" clId="{6AB89950-CF24-4538-93AF-1A20832D1772}"/>
-    <pc:docChg chg="undo custSel addSld delSld modSld">
-      <pc:chgData name="Simon Hong" userId="2f15200c-b3cf-4aef-8f69-ada819764841" providerId="ADAL" clId="{6AB89950-CF24-4538-93AF-1A20832D1772}" dt="2026-10-09T16:54:45.668" v="464" actId="6549"/>
+    <pc:docChg chg="undo redo custSel addSld delSld modSld">
+      <pc:chgData name="Simon Hong" userId="2f15200c-b3cf-4aef-8f69-ada819764841" providerId="ADAL" clId="{6AB89950-CF24-4538-93AF-1A20832D1772}" dt="2026-10-09T19:17:00.791" v="981" actId="1037"/>
       <pc:docMkLst>
         <pc:docMk/>
       </pc:docMkLst>
+      <pc:sldChg chg="modSp mod">
+        <pc:chgData name="Simon Hong" userId="2f15200c-b3cf-4aef-8f69-ada819764841" providerId="ADAL" clId="{6AB89950-CF24-4538-93AF-1A20832D1772}" dt="2026-10-09T18:53:48.851" v="783" actId="6549"/>
+        <pc:sldMkLst>
+          <pc:docMk/>
+          <pc:sldMk cId="1674887463" sldId="256"/>
+        </pc:sldMkLst>
+        <pc:spChg chg="mod">
+          <ac:chgData name="Simon Hong" userId="2f15200c-b3cf-4aef-8f69-ada819764841" providerId="ADAL" clId="{6AB89950-CF24-4538-93AF-1A20832D1772}" dt="2026-10-09T18:53:48.851" v="783" actId="6549"/>
+          <ac:spMkLst>
+            <pc:docMk/>
+            <pc:sldMk cId="1674887463" sldId="256"/>
+            <ac:spMk id="43" creationId="{BD46BBD1-38CB-19B8-67F2-EECC9C57D83F}"/>
+          </ac:spMkLst>
+        </pc:spChg>
+      </pc:sldChg>
       <pc:sldChg chg="modSp mod">
         <pc:chgData name="Simon Hong" userId="2f15200c-b3cf-4aef-8f69-ada819764841" providerId="ADAL" clId="{6AB89950-CF24-4538-93AF-1A20832D1772}" dt="2026-10-05T22:46:19.432" v="259" actId="13926"/>
         <pc:sldMkLst>
@@ -232,18 +248,154 @@
           </ac:spMkLst>
         </pc:spChg>
       </pc:sldChg>
-      <pc:sldChg chg="modSp mod">
-        <pc:chgData name="Simon Hong" userId="2f15200c-b3cf-4aef-8f69-ada819764841" providerId="ADAL" clId="{6AB89950-CF24-4538-93AF-1A20832D1772}" dt="2026-10-05T22:05:44.250" v="256" actId="20577"/>
+      <pc:sldChg chg="addSp delSp modSp mod">
+        <pc:chgData name="Simon Hong" userId="2f15200c-b3cf-4aef-8f69-ada819764841" providerId="ADAL" clId="{6AB89950-CF24-4538-93AF-1A20832D1772}" dt="2026-10-09T19:17:00.791" v="981" actId="1037"/>
         <pc:sldMkLst>
           <pc:docMk/>
           <pc:sldMk cId="2475521724" sldId="263"/>
         </pc:sldMkLst>
+        <pc:spChg chg="mod">
+          <ac:chgData name="Simon Hong" userId="2f15200c-b3cf-4aef-8f69-ada819764841" providerId="ADAL" clId="{6AB89950-CF24-4538-93AF-1A20832D1772}" dt="2026-10-09T19:12:56.982" v="965" actId="14100"/>
+          <ac:spMkLst>
+            <pc:docMk/>
+            <pc:sldMk cId="2475521724" sldId="263"/>
+            <ac:spMk id="2" creationId="{FB177F57-5024-AAC3-EAA9-97F19B2BFE68}"/>
+          </ac:spMkLst>
+        </pc:spChg>
         <pc:spChg chg="mod">
           <ac:chgData name="Simon Hong" userId="2f15200c-b3cf-4aef-8f69-ada819764841" providerId="ADAL" clId="{6AB89950-CF24-4538-93AF-1A20832D1772}" dt="2026-10-05T20:44:35.931" v="57" actId="6549"/>
           <ac:spMkLst>
             <pc:docMk/>
             <pc:sldMk cId="2475521724" sldId="263"/>
             <ac:spMk id="3" creationId="{44C82B57-F564-6280-53E1-EF53DD92F1C9}"/>
+          </ac:spMkLst>
+        </pc:spChg>
+        <pc:spChg chg="mod">
+          <ac:chgData name="Simon Hong" userId="2f15200c-b3cf-4aef-8f69-ada819764841" providerId="ADAL" clId="{6AB89950-CF24-4538-93AF-1A20832D1772}" dt="2026-10-09T17:48:07.767" v="522" actId="1076"/>
+          <ac:spMkLst>
+            <pc:docMk/>
+            <pc:sldMk cId="2475521724" sldId="263"/>
+            <ac:spMk id="10" creationId="{62811AE6-0830-4C40-F1BF-97EAB74EF60A}"/>
+          </ac:spMkLst>
+        </pc:spChg>
+        <pc:spChg chg="mod">
+          <ac:chgData name="Simon Hong" userId="2f15200c-b3cf-4aef-8f69-ada819764841" providerId="ADAL" clId="{6AB89950-CF24-4538-93AF-1A20832D1772}" dt="2026-10-09T17:47:25.573" v="502" actId="1035"/>
+          <ac:spMkLst>
+            <pc:docMk/>
+            <pc:sldMk cId="2475521724" sldId="263"/>
+            <ac:spMk id="13" creationId="{46C1BE4D-947F-F5CF-775E-D8E7CE94FB66}"/>
+          </ac:spMkLst>
+        </pc:spChg>
+        <pc:spChg chg="mod">
+          <ac:chgData name="Simon Hong" userId="2f15200c-b3cf-4aef-8f69-ada819764841" providerId="ADAL" clId="{6AB89950-CF24-4538-93AF-1A20832D1772}" dt="2026-10-09T17:50:07.614" v="538" actId="1076"/>
+          <ac:spMkLst>
+            <pc:docMk/>
+            <pc:sldMk cId="2475521724" sldId="263"/>
+            <ac:spMk id="14" creationId="{54D69334-E05C-B19C-C3F6-3351A743AA55}"/>
+          </ac:spMkLst>
+        </pc:spChg>
+        <pc:spChg chg="mod">
+          <ac:chgData name="Simon Hong" userId="2f15200c-b3cf-4aef-8f69-ada819764841" providerId="ADAL" clId="{6AB89950-CF24-4538-93AF-1A20832D1772}" dt="2026-10-09T17:47:30.528" v="503" actId="14100"/>
+          <ac:spMkLst>
+            <pc:docMk/>
+            <pc:sldMk cId="2475521724" sldId="263"/>
+            <ac:spMk id="16" creationId="{B593D06A-1FFF-7164-3186-B2D1D361BF79}"/>
+          </ac:spMkLst>
+        </pc:spChg>
+        <pc:spChg chg="mod">
+          <ac:chgData name="Simon Hong" userId="2f15200c-b3cf-4aef-8f69-ada819764841" providerId="ADAL" clId="{6AB89950-CF24-4538-93AF-1A20832D1772}" dt="2026-10-09T17:50:42.807" v="545" actId="1076"/>
+          <ac:spMkLst>
+            <pc:docMk/>
+            <pc:sldMk cId="2475521724" sldId="263"/>
+            <ac:spMk id="21" creationId="{657FAB87-4161-2538-7D14-E8E2AA3CF49B}"/>
+          </ac:spMkLst>
+        </pc:spChg>
+        <pc:spChg chg="mod">
+          <ac:chgData name="Simon Hong" userId="2f15200c-b3cf-4aef-8f69-ada819764841" providerId="ADAL" clId="{6AB89950-CF24-4538-93AF-1A20832D1772}" dt="2026-10-09T19:17:00.791" v="981" actId="1037"/>
+          <ac:spMkLst>
+            <pc:docMk/>
+            <pc:sldMk cId="2475521724" sldId="263"/>
+            <ac:spMk id="23" creationId="{C6F18763-A9E1-2B43-4016-F07FD12298C5}"/>
+          </ac:spMkLst>
+        </pc:spChg>
+        <pc:spChg chg="mod">
+          <ac:chgData name="Simon Hong" userId="2f15200c-b3cf-4aef-8f69-ada819764841" providerId="ADAL" clId="{6AB89950-CF24-4538-93AF-1A20832D1772}" dt="2026-10-09T19:17:00.791" v="981" actId="1037"/>
+          <ac:spMkLst>
+            <pc:docMk/>
+            <pc:sldMk cId="2475521724" sldId="263"/>
+            <ac:spMk id="34" creationId="{188936F9-B80A-90A8-3573-845E348D005D}"/>
+          </ac:spMkLst>
+        </pc:spChg>
+        <pc:spChg chg="mod">
+          <ac:chgData name="Simon Hong" userId="2f15200c-b3cf-4aef-8f69-ada819764841" providerId="ADAL" clId="{6AB89950-CF24-4538-93AF-1A20832D1772}" dt="2026-10-09T19:17:00.791" v="981" actId="1037"/>
+          <ac:spMkLst>
+            <pc:docMk/>
+            <pc:sldMk cId="2475521724" sldId="263"/>
+            <ac:spMk id="38" creationId="{43621672-E1BE-E0FF-1C63-7B694986EFED}"/>
+          </ac:spMkLst>
+        </pc:spChg>
+        <pc:spChg chg="mod">
+          <ac:chgData name="Simon Hong" userId="2f15200c-b3cf-4aef-8f69-ada819764841" providerId="ADAL" clId="{6AB89950-CF24-4538-93AF-1A20832D1772}" dt="2026-10-09T17:46:59.124" v="483" actId="1036"/>
+          <ac:spMkLst>
+            <pc:docMk/>
+            <pc:sldMk cId="2475521724" sldId="263"/>
+            <ac:spMk id="44" creationId="{ED27EE2C-F2B7-4259-E54C-0C0100B2E02D}"/>
+          </ac:spMkLst>
+        </pc:spChg>
+        <pc:spChg chg="mod">
+          <ac:chgData name="Simon Hong" userId="2f15200c-b3cf-4aef-8f69-ada819764841" providerId="ADAL" clId="{6AB89950-CF24-4538-93AF-1A20832D1772}" dt="2026-10-09T17:46:59.124" v="483" actId="1036"/>
+          <ac:spMkLst>
+            <pc:docMk/>
+            <pc:sldMk cId="2475521724" sldId="263"/>
+            <ac:spMk id="46" creationId="{1C110048-5D99-9B4F-7B5E-3CA9E964CD81}"/>
+          </ac:spMkLst>
+        </pc:spChg>
+        <pc:spChg chg="mod">
+          <ac:chgData name="Simon Hong" userId="2f15200c-b3cf-4aef-8f69-ada819764841" providerId="ADAL" clId="{6AB89950-CF24-4538-93AF-1A20832D1772}" dt="2026-10-09T19:17:00.791" v="981" actId="1037"/>
+          <ac:spMkLst>
+            <pc:docMk/>
+            <pc:sldMk cId="2475521724" sldId="263"/>
+            <ac:spMk id="63" creationId="{43F406F2-8E94-5E30-F1DE-72C08D605038}"/>
+          </ac:spMkLst>
+        </pc:spChg>
+        <pc:spChg chg="mod">
+          <ac:chgData name="Simon Hong" userId="2f15200c-b3cf-4aef-8f69-ada819764841" providerId="ADAL" clId="{6AB89950-CF24-4538-93AF-1A20832D1772}" dt="2026-10-09T19:17:00.791" v="981" actId="1037"/>
+          <ac:spMkLst>
+            <pc:docMk/>
+            <pc:sldMk cId="2475521724" sldId="263"/>
+            <ac:spMk id="72" creationId="{5106D71A-0BEC-13B3-392C-694A475A003A}"/>
+          </ac:spMkLst>
+        </pc:spChg>
+        <pc:spChg chg="mod">
+          <ac:chgData name="Simon Hong" userId="2f15200c-b3cf-4aef-8f69-ada819764841" providerId="ADAL" clId="{6AB89950-CF24-4538-93AF-1A20832D1772}" dt="2026-10-09T17:46:59.124" v="483" actId="1036"/>
+          <ac:spMkLst>
+            <pc:docMk/>
+            <pc:sldMk cId="2475521724" sldId="263"/>
+            <ac:spMk id="73" creationId="{38C6028C-2E54-585C-15FD-19C638FD1AE3}"/>
+          </ac:spMkLst>
+        </pc:spChg>
+        <pc:spChg chg="mod">
+          <ac:chgData name="Simon Hong" userId="2f15200c-b3cf-4aef-8f69-ada819764841" providerId="ADAL" clId="{6AB89950-CF24-4538-93AF-1A20832D1772}" dt="2026-10-09T17:46:59.124" v="483" actId="1036"/>
+          <ac:spMkLst>
+            <pc:docMk/>
+            <pc:sldMk cId="2475521724" sldId="263"/>
+            <ac:spMk id="74" creationId="{A092B615-58A0-6761-FD45-BFCD684B1D6E}"/>
+          </ac:spMkLst>
+        </pc:spChg>
+        <pc:spChg chg="mod">
+          <ac:chgData name="Simon Hong" userId="2f15200c-b3cf-4aef-8f69-ada819764841" providerId="ADAL" clId="{6AB89950-CF24-4538-93AF-1A20832D1772}" dt="2026-10-09T19:17:00.791" v="981" actId="1037"/>
+          <ac:spMkLst>
+            <pc:docMk/>
+            <pc:sldMk cId="2475521724" sldId="263"/>
+            <ac:spMk id="90" creationId="{C0BB03E8-0D67-32A2-5433-8CAA7A7697C8}"/>
+          </ac:spMkLst>
+        </pc:spChg>
+        <pc:spChg chg="mod">
+          <ac:chgData name="Simon Hong" userId="2f15200c-b3cf-4aef-8f69-ada819764841" providerId="ADAL" clId="{6AB89950-CF24-4538-93AF-1A20832D1772}" dt="2026-10-09T19:17:00.791" v="981" actId="1037"/>
+          <ac:spMkLst>
+            <pc:docMk/>
+            <pc:sldMk cId="2475521724" sldId="263"/>
+            <ac:spMk id="91" creationId="{D8CE48DB-F0FC-0E8B-DEAF-BE699DCF8D49}"/>
           </ac:spMkLst>
         </pc:spChg>
         <pc:spChg chg="mod">
@@ -255,6 +407,30 @@
           </ac:spMkLst>
         </pc:spChg>
         <pc:spChg chg="mod">
+          <ac:chgData name="Simon Hong" userId="2f15200c-b3cf-4aef-8f69-ada819764841" providerId="ADAL" clId="{6AB89950-CF24-4538-93AF-1A20832D1772}" dt="2026-10-09T19:17:00.791" v="981" actId="1037"/>
+          <ac:spMkLst>
+            <pc:docMk/>
+            <pc:sldMk cId="2475521724" sldId="263"/>
+            <ac:spMk id="97" creationId="{965DC3F9-0AB2-A42E-02DC-C2DD60611F65}"/>
+          </ac:spMkLst>
+        </pc:spChg>
+        <pc:spChg chg="mod">
+          <ac:chgData name="Simon Hong" userId="2f15200c-b3cf-4aef-8f69-ada819764841" providerId="ADAL" clId="{6AB89950-CF24-4538-93AF-1A20832D1772}" dt="2026-10-09T17:46:59.124" v="483" actId="1036"/>
+          <ac:spMkLst>
+            <pc:docMk/>
+            <pc:sldMk cId="2475521724" sldId="263"/>
+            <ac:spMk id="108" creationId="{0ECD30BB-30A6-AB49-10A3-FBBFE805BA89}"/>
+          </ac:spMkLst>
+        </pc:spChg>
+        <pc:spChg chg="mod">
+          <ac:chgData name="Simon Hong" userId="2f15200c-b3cf-4aef-8f69-ada819764841" providerId="ADAL" clId="{6AB89950-CF24-4538-93AF-1A20832D1772}" dt="2026-10-09T17:46:59.124" v="483" actId="1036"/>
+          <ac:spMkLst>
+            <pc:docMk/>
+            <pc:sldMk cId="2475521724" sldId="263"/>
+            <ac:spMk id="110" creationId="{2AAD4B30-23DB-BE04-7E18-E090DBCF22EC}"/>
+          </ac:spMkLst>
+        </pc:spChg>
+        <pc:spChg chg="mod">
           <ac:chgData name="Simon Hong" userId="2f15200c-b3cf-4aef-8f69-ada819764841" providerId="ADAL" clId="{6AB89950-CF24-4538-93AF-1A20832D1772}" dt="2026-10-05T21:44:24.683" v="132" actId="113"/>
           <ac:spMkLst>
             <pc:docMk/>
@@ -262,8 +438,8 @@
             <ac:spMk id="113" creationId="{C9560F2E-B965-2C39-CFF6-2CE892DE4C5C}"/>
           </ac:spMkLst>
         </pc:spChg>
-        <pc:spChg chg="mod">
-          <ac:chgData name="Simon Hong" userId="2f15200c-b3cf-4aef-8f69-ada819764841" providerId="ADAL" clId="{6AB89950-CF24-4538-93AF-1A20832D1772}" dt="2026-10-05T22:02:15.738" v="244" actId="6549"/>
+        <pc:spChg chg="mod ord">
+          <ac:chgData name="Simon Hong" userId="2f15200c-b3cf-4aef-8f69-ada819764841" providerId="ADAL" clId="{6AB89950-CF24-4538-93AF-1A20832D1772}" dt="2026-10-09T19:13:36.076" v="968" actId="14100"/>
           <ac:spMkLst>
             <pc:docMk/>
             <pc:sldMk cId="2475521724" sldId="263"/>
@@ -271,7 +447,23 @@
           </ac:spMkLst>
         </pc:spChg>
         <pc:spChg chg="mod">
-          <ac:chgData name="Simon Hong" userId="2f15200c-b3cf-4aef-8f69-ada819764841" providerId="ADAL" clId="{6AB89950-CF24-4538-93AF-1A20832D1772}" dt="2026-10-05T22:05:44.250" v="256" actId="20577"/>
+          <ac:chgData name="Simon Hong" userId="2f15200c-b3cf-4aef-8f69-ada819764841" providerId="ADAL" clId="{6AB89950-CF24-4538-93AF-1A20832D1772}" dt="2026-10-09T17:46:59.124" v="483" actId="1036"/>
+          <ac:spMkLst>
+            <pc:docMk/>
+            <pc:sldMk cId="2475521724" sldId="263"/>
+            <ac:spMk id="122" creationId="{C5617F28-5962-DD22-71E0-2DB551477752}"/>
+          </ac:spMkLst>
+        </pc:spChg>
+        <pc:spChg chg="mod">
+          <ac:chgData name="Simon Hong" userId="2f15200c-b3cf-4aef-8f69-ada819764841" providerId="ADAL" clId="{6AB89950-CF24-4538-93AF-1A20832D1772}" dt="2026-10-09T17:46:59.124" v="483" actId="1036"/>
+          <ac:spMkLst>
+            <pc:docMk/>
+            <pc:sldMk cId="2475521724" sldId="263"/>
+            <ac:spMk id="124" creationId="{53DA67CD-86CF-7C6C-34BD-6C7F76498A29}"/>
+          </ac:spMkLst>
+        </pc:spChg>
+        <pc:spChg chg="mod">
+          <ac:chgData name="Simon Hong" userId="2f15200c-b3cf-4aef-8f69-ada819764841" providerId="ADAL" clId="{6AB89950-CF24-4538-93AF-1A20832D1772}" dt="2026-10-09T17:46:59.124" v="483" actId="1036"/>
           <ac:spMkLst>
             <pc:docMk/>
             <pc:sldMk cId="2475521724" sldId="263"/>
@@ -279,7 +471,7 @@
           </ac:spMkLst>
         </pc:spChg>
         <pc:spChg chg="mod">
-          <ac:chgData name="Simon Hong" userId="2f15200c-b3cf-4aef-8f69-ada819764841" providerId="ADAL" clId="{6AB89950-CF24-4538-93AF-1A20832D1772}" dt="2026-10-05T22:02:47.792" v="248" actId="20577"/>
+          <ac:chgData name="Simon Hong" userId="2f15200c-b3cf-4aef-8f69-ada819764841" providerId="ADAL" clId="{6AB89950-CF24-4538-93AF-1A20832D1772}" dt="2026-10-09T19:17:00.791" v="981" actId="1037"/>
           <ac:spMkLst>
             <pc:docMk/>
             <pc:sldMk cId="2475521724" sldId="263"/>
@@ -287,13 +479,125 @@
           </ac:spMkLst>
         </pc:spChg>
         <pc:spChg chg="mod">
-          <ac:chgData name="Simon Hong" userId="2f15200c-b3cf-4aef-8f69-ada819764841" providerId="ADAL" clId="{6AB89950-CF24-4538-93AF-1A20832D1772}" dt="2026-10-05T22:04:52.248" v="254" actId="6549"/>
+          <ac:chgData name="Simon Hong" userId="2f15200c-b3cf-4aef-8f69-ada819764841" providerId="ADAL" clId="{6AB89950-CF24-4538-93AF-1A20832D1772}" dt="2026-10-09T19:17:00.791" v="981" actId="1037"/>
           <ac:spMkLst>
             <pc:docMk/>
             <pc:sldMk cId="2475521724" sldId="263"/>
             <ac:spMk id="132" creationId="{0D77CCE7-1645-D03F-9FDF-9718737ED569}"/>
           </ac:spMkLst>
         </pc:spChg>
+        <pc:spChg chg="mod">
+          <ac:chgData name="Simon Hong" userId="2f15200c-b3cf-4aef-8f69-ada819764841" providerId="ADAL" clId="{6AB89950-CF24-4538-93AF-1A20832D1772}" dt="2026-10-09T17:50:01.805" v="537" actId="14100"/>
+          <ac:spMkLst>
+            <pc:docMk/>
+            <pc:sldMk cId="2475521724" sldId="263"/>
+            <ac:spMk id="136" creationId="{7DD72A52-D7D1-8454-9E09-E454031BA21D}"/>
+          </ac:spMkLst>
+        </pc:spChg>
+        <pc:spChg chg="mod">
+          <ac:chgData name="Simon Hong" userId="2f15200c-b3cf-4aef-8f69-ada819764841" providerId="ADAL" clId="{6AB89950-CF24-4538-93AF-1A20832D1772}" dt="2026-10-09T17:52:49.442" v="775" actId="20577"/>
+          <ac:spMkLst>
+            <pc:docMk/>
+            <pc:sldMk cId="2475521724" sldId="263"/>
+            <ac:spMk id="146" creationId="{2DB6D99C-D67E-4DB8-802A-D1D2FDC211A3}"/>
+          </ac:spMkLst>
+        </pc:spChg>
+        <pc:spChg chg="add mod">
+          <ac:chgData name="Simon Hong" userId="2f15200c-b3cf-4aef-8f69-ada819764841" providerId="ADAL" clId="{6AB89950-CF24-4538-93AF-1A20832D1772}" dt="2026-10-09T17:49:36.480" v="534" actId="20577"/>
+          <ac:spMkLst>
+            <pc:docMk/>
+            <pc:sldMk cId="2475521724" sldId="263"/>
+            <ac:spMk id="169" creationId="{45B5BACE-5E75-DB60-BB3C-CEFD60FA53CF}"/>
+          </ac:spMkLst>
+        </pc:spChg>
+        <pc:spChg chg="add mod">
+          <ac:chgData name="Simon Hong" userId="2f15200c-b3cf-4aef-8f69-ada819764841" providerId="ADAL" clId="{6AB89950-CF24-4538-93AF-1A20832D1772}" dt="2026-10-09T17:48:05.408" v="520" actId="571"/>
+          <ac:spMkLst>
+            <pc:docMk/>
+            <pc:sldMk cId="2475521724" sldId="263"/>
+            <ac:spMk id="171" creationId="{48432214-1A91-D5AB-DC05-26F93358FB0B}"/>
+          </ac:spMkLst>
+        </pc:spChg>
+        <pc:spChg chg="add mod">
+          <ac:chgData name="Simon Hong" userId="2f15200c-b3cf-4aef-8f69-ada819764841" providerId="ADAL" clId="{6AB89950-CF24-4538-93AF-1A20832D1772}" dt="2026-10-09T17:48:14.639" v="524" actId="571"/>
+          <ac:spMkLst>
+            <pc:docMk/>
+            <pc:sldMk cId="2475521724" sldId="263"/>
+            <ac:spMk id="172" creationId="{16715D96-15CD-2B13-D578-54E2633BF4CF}"/>
+          </ac:spMkLst>
+        </pc:spChg>
+        <pc:spChg chg="add mod">
+          <ac:chgData name="Simon Hong" userId="2f15200c-b3cf-4aef-8f69-ada819764841" providerId="ADAL" clId="{6AB89950-CF24-4538-93AF-1A20832D1772}" dt="2026-10-09T17:50:11.346" v="539" actId="571"/>
+          <ac:spMkLst>
+            <pc:docMk/>
+            <pc:sldMk cId="2475521724" sldId="263"/>
+            <ac:spMk id="178" creationId="{F836A25F-ECCB-CADD-A312-90E74D438996}"/>
+          </ac:spMkLst>
+        </pc:spChg>
+        <pc:spChg chg="add mod">
+          <ac:chgData name="Simon Hong" userId="2f15200c-b3cf-4aef-8f69-ada819764841" providerId="ADAL" clId="{6AB89950-CF24-4538-93AF-1A20832D1772}" dt="2026-10-09T17:53:49.145" v="778" actId="6549"/>
+          <ac:spMkLst>
+            <pc:docMk/>
+            <pc:sldMk cId="2475521724" sldId="263"/>
+            <ac:spMk id="183" creationId="{173415F7-DF5F-69E6-5E0A-FE99A5D5C93E}"/>
+          </ac:spMkLst>
+        </pc:spChg>
+        <pc:spChg chg="add mod">
+          <ac:chgData name="Simon Hong" userId="2f15200c-b3cf-4aef-8f69-ada819764841" providerId="ADAL" clId="{6AB89950-CF24-4538-93AF-1A20832D1772}" dt="2026-10-09T17:53:06.446" v="776" actId="571"/>
+          <ac:spMkLst>
+            <pc:docMk/>
+            <pc:sldMk cId="2475521724" sldId="263"/>
+            <ac:spMk id="184" creationId="{44B30D09-1C01-3CCA-4C85-1801DD1D151F}"/>
+          </ac:spMkLst>
+        </pc:spChg>
+        <pc:grpChg chg="mod">
+          <ac:chgData name="Simon Hong" userId="2f15200c-b3cf-4aef-8f69-ada819764841" providerId="ADAL" clId="{6AB89950-CF24-4538-93AF-1A20832D1772}" dt="2026-10-09T19:13:41.351" v="969" actId="14100"/>
+          <ac:grpSpMkLst>
+            <pc:docMk/>
+            <pc:sldMk cId="2475521724" sldId="263"/>
+            <ac:grpSpMk id="40" creationId="{3B9F416B-9ECD-9F7F-7184-A871F2493A26}"/>
+          </ac:grpSpMkLst>
+        </pc:grpChg>
+        <pc:cxnChg chg="mod">
+          <ac:chgData name="Simon Hong" userId="2f15200c-b3cf-4aef-8f69-ada819764841" providerId="ADAL" clId="{6AB89950-CF24-4538-93AF-1A20832D1772}" dt="2026-10-09T17:49:27.774" v="529" actId="14100"/>
+          <ac:cxnSpMkLst>
+            <pc:docMk/>
+            <pc:sldMk cId="2475521724" sldId="263"/>
+            <ac:cxnSpMk id="12" creationId="{FF772285-D127-0495-87FD-D16B17880798}"/>
+          </ac:cxnSpMkLst>
+        </pc:cxnChg>
+        <pc:cxnChg chg="mod">
+          <ac:chgData name="Simon Hong" userId="2f15200c-b3cf-4aef-8f69-ada819764841" providerId="ADAL" clId="{6AB89950-CF24-4538-93AF-1A20832D1772}" dt="2026-10-09T17:47:30.528" v="503" actId="14100"/>
+          <ac:cxnSpMkLst>
+            <pc:docMk/>
+            <pc:sldMk cId="2475521724" sldId="263"/>
+            <ac:cxnSpMk id="17" creationId="{8868319C-E4D0-6162-113D-4B5C03B105BF}"/>
+          </ac:cxnSpMkLst>
+        </pc:cxnChg>
+        <pc:cxnChg chg="mod">
+          <ac:chgData name="Simon Hong" userId="2f15200c-b3cf-4aef-8f69-ada819764841" providerId="ADAL" clId="{6AB89950-CF24-4538-93AF-1A20832D1772}" dt="2026-10-09T19:13:41.351" v="969" actId="14100"/>
+          <ac:cxnSpMkLst>
+            <pc:docMk/>
+            <pc:sldMk cId="2475521724" sldId="263"/>
+            <ac:cxnSpMk id="19" creationId="{A48D1EAD-4473-D33D-055D-F1EE8D39E577}"/>
+          </ac:cxnSpMkLst>
+        </pc:cxnChg>
+        <pc:cxnChg chg="mod">
+          <ac:chgData name="Simon Hong" userId="2f15200c-b3cf-4aef-8f69-ada819764841" providerId="ADAL" clId="{6AB89950-CF24-4538-93AF-1A20832D1772}" dt="2026-10-09T17:47:30.528" v="503" actId="14100"/>
+          <ac:cxnSpMkLst>
+            <pc:docMk/>
+            <pc:sldMk cId="2475521724" sldId="263"/>
+            <ac:cxnSpMk id="27" creationId="{7AB95253-F988-AF50-58D0-FA2FDA4A4A4B}"/>
+          </ac:cxnSpMkLst>
+        </pc:cxnChg>
+        <pc:cxnChg chg="mod">
+          <ac:chgData name="Simon Hong" userId="2f15200c-b3cf-4aef-8f69-ada819764841" providerId="ADAL" clId="{6AB89950-CF24-4538-93AF-1A20832D1772}" dt="2026-10-09T17:47:25.573" v="502" actId="1035"/>
+          <ac:cxnSpMkLst>
+            <pc:docMk/>
+            <pc:sldMk cId="2475521724" sldId="263"/>
+            <ac:cxnSpMk id="28" creationId="{71A64148-BF6A-F42D-4A5B-2146B1AA03D5}"/>
+          </ac:cxnSpMkLst>
+        </pc:cxnChg>
         <pc:cxnChg chg="mod">
           <ac:chgData name="Simon Hong" userId="2f15200c-b3cf-4aef-8f69-ada819764841" providerId="ADAL" clId="{6AB89950-CF24-4538-93AF-1A20832D1772}" dt="2026-10-05T22:04:37.659" v="253" actId="14100"/>
           <ac:cxnSpMkLst>
@@ -303,11 +607,59 @@
           </ac:cxnSpMkLst>
         </pc:cxnChg>
         <pc:cxnChg chg="mod">
+          <ac:chgData name="Simon Hong" userId="2f15200c-b3cf-4aef-8f69-ada819764841" providerId="ADAL" clId="{6AB89950-CF24-4538-93AF-1A20832D1772}" dt="2026-10-09T19:13:41.351" v="969" actId="14100"/>
+          <ac:cxnSpMkLst>
+            <pc:docMk/>
+            <pc:sldMk cId="2475521724" sldId="263"/>
+            <ac:cxnSpMk id="69" creationId="{4303B419-E5B6-B3F4-877A-E555DC5CEAE6}"/>
+          </ac:cxnSpMkLst>
+        </pc:cxnChg>
+        <pc:cxnChg chg="mod">
+          <ac:chgData name="Simon Hong" userId="2f15200c-b3cf-4aef-8f69-ada819764841" providerId="ADAL" clId="{6AB89950-CF24-4538-93AF-1A20832D1772}" dt="2026-10-09T17:53:24.206" v="777" actId="14100"/>
+          <ac:cxnSpMkLst>
+            <pc:docMk/>
+            <pc:sldMk cId="2475521724" sldId="263"/>
+            <ac:cxnSpMk id="77" creationId="{1E61221B-F371-4C45-109F-71CEEE07AD58}"/>
+          </ac:cxnSpMkLst>
+        </pc:cxnChg>
+        <pc:cxnChg chg="mod">
+          <ac:chgData name="Simon Hong" userId="2f15200c-b3cf-4aef-8f69-ada819764841" providerId="ADAL" clId="{6AB89950-CF24-4538-93AF-1A20832D1772}" dt="2026-10-09T19:13:41.351" v="969" actId="14100"/>
+          <ac:cxnSpMkLst>
+            <pc:docMk/>
+            <pc:sldMk cId="2475521724" sldId="263"/>
+            <ac:cxnSpMk id="79" creationId="{76E23DB5-63B1-93EE-7F8A-014F3358B88F}"/>
+          </ac:cxnSpMkLst>
+        </pc:cxnChg>
+        <pc:cxnChg chg="mod">
           <ac:chgData name="Simon Hong" userId="2f15200c-b3cf-4aef-8f69-ada819764841" providerId="ADAL" clId="{6AB89950-CF24-4538-93AF-1A20832D1772}" dt="2026-10-05T22:04:37.659" v="253" actId="14100"/>
           <ac:cxnSpMkLst>
             <pc:docMk/>
             <pc:sldMk cId="2475521724" sldId="263"/>
             <ac:cxnSpMk id="106" creationId="{F0F0C8A2-87A9-8555-5D6D-5F1E44F2C393}"/>
+          </ac:cxnSpMkLst>
+        </pc:cxnChg>
+        <pc:cxnChg chg="mod">
+          <ac:chgData name="Simon Hong" userId="2f15200c-b3cf-4aef-8f69-ada819764841" providerId="ADAL" clId="{6AB89950-CF24-4538-93AF-1A20832D1772}" dt="2026-10-09T19:13:41.351" v="969" actId="14100"/>
+          <ac:cxnSpMkLst>
+            <pc:docMk/>
+            <pc:sldMk cId="2475521724" sldId="263"/>
+            <ac:cxnSpMk id="119" creationId="{31C64937-85AA-EB52-B850-82E723854C69}"/>
+          </ac:cxnSpMkLst>
+        </pc:cxnChg>
+        <pc:cxnChg chg="del mod">
+          <ac:chgData name="Simon Hong" userId="2f15200c-b3cf-4aef-8f69-ada819764841" providerId="ADAL" clId="{6AB89950-CF24-4538-93AF-1A20832D1772}" dt="2026-10-09T19:10:16.295" v="913" actId="478"/>
+          <ac:cxnSpMkLst>
+            <pc:docMk/>
+            <pc:sldMk cId="2475521724" sldId="263"/>
+            <ac:cxnSpMk id="121" creationId="{1D5C3394-70DE-0F89-EC59-E822C95878F7}"/>
+          </ac:cxnSpMkLst>
+        </pc:cxnChg>
+        <pc:cxnChg chg="add del mod">
+          <ac:chgData name="Simon Hong" userId="2f15200c-b3cf-4aef-8f69-ada819764841" providerId="ADAL" clId="{6AB89950-CF24-4538-93AF-1A20832D1772}" dt="2026-10-09T19:10:08.654" v="912" actId="478"/>
+          <ac:cxnSpMkLst>
+            <pc:docMk/>
+            <pc:sldMk cId="2475521724" sldId="263"/>
+            <ac:cxnSpMk id="126" creationId="{D36CCBE3-55A9-2EC9-358E-0E114B9FAA65}"/>
           </ac:cxnSpMkLst>
         </pc:cxnChg>
         <pc:cxnChg chg="mod">
@@ -332,6 +684,46 @@
             <pc:docMk/>
             <pc:sldMk cId="2475521724" sldId="263"/>
             <ac:cxnSpMk id="156" creationId="{31DAFEF0-D002-428A-5E10-87B66E1AB213}"/>
+          </ac:cxnSpMkLst>
+        </pc:cxnChg>
+        <pc:cxnChg chg="add del mod">
+          <ac:chgData name="Simon Hong" userId="2f15200c-b3cf-4aef-8f69-ada819764841" providerId="ADAL" clId="{6AB89950-CF24-4538-93AF-1A20832D1772}" dt="2026-10-09T19:11:18.256" v="924" actId="478"/>
+          <ac:cxnSpMkLst>
+            <pc:docMk/>
+            <pc:sldMk cId="2475521724" sldId="263"/>
+            <ac:cxnSpMk id="162" creationId="{2556571A-BC8C-D379-7E03-1AF7BD5C6F14}"/>
+          </ac:cxnSpMkLst>
+        </pc:cxnChg>
+        <pc:cxnChg chg="add mod">
+          <ac:chgData name="Simon Hong" userId="2f15200c-b3cf-4aef-8f69-ada819764841" providerId="ADAL" clId="{6AB89950-CF24-4538-93AF-1A20832D1772}" dt="2026-10-09T19:13:36.076" v="968" actId="14100"/>
+          <ac:cxnSpMkLst>
+            <pc:docMk/>
+            <pc:sldMk cId="2475521724" sldId="263"/>
+            <ac:cxnSpMk id="166" creationId="{29BDAEC3-B0F1-2AD5-D395-42FF5665ADAB}"/>
+          </ac:cxnSpMkLst>
+        </pc:cxnChg>
+        <pc:cxnChg chg="add mod">
+          <ac:chgData name="Simon Hong" userId="2f15200c-b3cf-4aef-8f69-ada819764841" providerId="ADAL" clId="{6AB89950-CF24-4538-93AF-1A20832D1772}" dt="2026-10-09T17:49:27.774" v="529" actId="14100"/>
+          <ac:cxnSpMkLst>
+            <pc:docMk/>
+            <pc:sldMk cId="2475521724" sldId="263"/>
+            <ac:cxnSpMk id="173" creationId="{D84BBED4-F848-E6B6-AA6F-C6419EA0C04A}"/>
+          </ac:cxnSpMkLst>
+        </pc:cxnChg>
+        <pc:cxnChg chg="add del mod">
+          <ac:chgData name="Simon Hong" userId="2f15200c-b3cf-4aef-8f69-ada819764841" providerId="ADAL" clId="{6AB89950-CF24-4538-93AF-1A20832D1772}" dt="2026-10-09T17:50:19.577" v="541" actId="478"/>
+          <ac:cxnSpMkLst>
+            <pc:docMk/>
+            <pc:sldMk cId="2475521724" sldId="263"/>
+            <ac:cxnSpMk id="179" creationId="{26D48696-37F1-9C7D-B222-200C3DA4BBF1}"/>
+          </ac:cxnSpMkLst>
+        </pc:cxnChg>
+        <pc:cxnChg chg="add mod">
+          <ac:chgData name="Simon Hong" userId="2f15200c-b3cf-4aef-8f69-ada819764841" providerId="ADAL" clId="{6AB89950-CF24-4538-93AF-1A20832D1772}" dt="2026-10-09T19:13:41.351" v="969" actId="14100"/>
+          <ac:cxnSpMkLst>
+            <pc:docMk/>
+            <pc:sldMk cId="2475521724" sldId="263"/>
+            <ac:cxnSpMk id="180" creationId="{F963A72C-4A8E-BBFE-0674-5EA1411A3275}"/>
           </ac:cxnSpMkLst>
         </pc:cxnChg>
       </pc:sldChg>
@@ -431,17 +823,192 @@
         </pc:spChg>
       </pc:sldChg>
       <pc:sldChg chg="modSp add mod setBg">
-        <pc:chgData name="Simon Hong" userId="2f15200c-b3cf-4aef-8f69-ada819764841" providerId="ADAL" clId="{6AB89950-CF24-4538-93AF-1A20832D1772}" dt="2026-10-09T16:54:45.668" v="464" actId="6549"/>
+        <pc:chgData name="Simon Hong" userId="2f15200c-b3cf-4aef-8f69-ada819764841" providerId="ADAL" clId="{6AB89950-CF24-4538-93AF-1A20832D1772}" dt="2026-10-09T17:22:29.848" v="465" actId="108"/>
         <pc:sldMkLst>
           <pc:docMk/>
           <pc:sldMk cId="0" sldId="265"/>
         </pc:sldMkLst>
         <pc:spChg chg="mod">
-          <ac:chgData name="Simon Hong" userId="2f15200c-b3cf-4aef-8f69-ada819764841" providerId="ADAL" clId="{6AB89950-CF24-4538-93AF-1A20832D1772}" dt="2026-10-09T16:54:45.668" v="464" actId="6549"/>
+          <ac:chgData name="Simon Hong" userId="2f15200c-b3cf-4aef-8f69-ada819764841" providerId="ADAL" clId="{6AB89950-CF24-4538-93AF-1A20832D1772}" dt="2026-10-09T17:22:29.848" v="465" actId="108"/>
           <ac:spMkLst>
             <pc:docMk/>
             <pc:sldMk cId="0" sldId="265"/>
             <ac:spMk id="3" creationId="{00000000-0000-0000-0000-000000000000}"/>
+          </ac:spMkLst>
+        </pc:spChg>
+      </pc:sldChg>
+      <pc:sldChg chg="addSp delSp modSp add mod">
+        <pc:chgData name="Simon Hong" userId="2f15200c-b3cf-4aef-8f69-ada819764841" providerId="ADAL" clId="{6AB89950-CF24-4538-93AF-1A20832D1772}" dt="2026-10-09T18:59:46.581" v="908" actId="1035"/>
+        <pc:sldMkLst>
+          <pc:docMk/>
+          <pc:sldMk cId="0" sldId="266"/>
+        </pc:sldMkLst>
+        <pc:spChg chg="mod">
+          <ac:chgData name="Simon Hong" userId="2f15200c-b3cf-4aef-8f69-ada819764841" providerId="ADAL" clId="{6AB89950-CF24-4538-93AF-1A20832D1772}" dt="2026-10-09T18:52:05.716" v="780" actId="108"/>
+          <ac:spMkLst>
+            <pc:docMk/>
+            <pc:sldMk cId="0" sldId="266"/>
+            <ac:spMk id="3" creationId="{00000000-0000-0000-0000-000000000000}"/>
+          </ac:spMkLst>
+        </pc:spChg>
+        <pc:spChg chg="add del mod">
+          <ac:chgData name="Simon Hong" userId="2f15200c-b3cf-4aef-8f69-ada819764841" providerId="ADAL" clId="{6AB89950-CF24-4538-93AF-1A20832D1772}" dt="2026-10-09T18:58:06.344" v="866" actId="6549"/>
+          <ac:spMkLst>
+            <pc:docMk/>
+            <pc:sldMk cId="0" sldId="266"/>
+            <ac:spMk id="5" creationId="{00000000-0000-0000-0000-000000000000}"/>
+          </ac:spMkLst>
+        </pc:spChg>
+        <pc:spChg chg="del mod">
+          <ac:chgData name="Simon Hong" userId="2f15200c-b3cf-4aef-8f69-ada819764841" providerId="ADAL" clId="{6AB89950-CF24-4538-93AF-1A20832D1772}" dt="2026-10-09T18:58:25.981" v="867" actId="478"/>
+          <ac:spMkLst>
+            <pc:docMk/>
+            <pc:sldMk cId="0" sldId="266"/>
+            <ac:spMk id="6" creationId="{00000000-0000-0000-0000-000000000000}"/>
+          </ac:spMkLst>
+        </pc:spChg>
+        <pc:spChg chg="del">
+          <ac:chgData name="Simon Hong" userId="2f15200c-b3cf-4aef-8f69-ada819764841" providerId="ADAL" clId="{6AB89950-CF24-4538-93AF-1A20832D1772}" dt="2026-10-09T18:58:29.248" v="868" actId="478"/>
+          <ac:spMkLst>
+            <pc:docMk/>
+            <pc:sldMk cId="0" sldId="266"/>
+            <ac:spMk id="7" creationId="{00000000-0000-0000-0000-000000000000}"/>
+          </ac:spMkLst>
+        </pc:spChg>
+        <pc:spChg chg="mod">
+          <ac:chgData name="Simon Hong" userId="2f15200c-b3cf-4aef-8f69-ada819764841" providerId="ADAL" clId="{6AB89950-CF24-4538-93AF-1A20832D1772}" dt="2026-10-09T18:59:24.301" v="884" actId="20577"/>
+          <ac:spMkLst>
+            <pc:docMk/>
+            <pc:sldMk cId="0" sldId="266"/>
+            <ac:spMk id="8" creationId="{00000000-0000-0000-0000-000000000000}"/>
+          </ac:spMkLst>
+        </pc:spChg>
+        <pc:spChg chg="mod">
+          <ac:chgData name="Simon Hong" userId="2f15200c-b3cf-4aef-8f69-ada819764841" providerId="ADAL" clId="{6AB89950-CF24-4538-93AF-1A20832D1772}" dt="2026-10-09T18:56:44.785" v="823" actId="1036"/>
+          <ac:spMkLst>
+            <pc:docMk/>
+            <pc:sldMk cId="0" sldId="266"/>
+            <ac:spMk id="10" creationId="{00000000-0000-0000-0000-000000000000}"/>
+          </ac:spMkLst>
+        </pc:spChg>
+        <pc:spChg chg="mod">
+          <ac:chgData name="Simon Hong" userId="2f15200c-b3cf-4aef-8f69-ada819764841" providerId="ADAL" clId="{6AB89950-CF24-4538-93AF-1A20832D1772}" dt="2026-10-09T18:59:46.581" v="908" actId="1035"/>
+          <ac:spMkLst>
+            <pc:docMk/>
+            <pc:sldMk cId="0" sldId="266"/>
+            <ac:spMk id="11" creationId="{00000000-0000-0000-0000-000000000000}"/>
+          </ac:spMkLst>
+        </pc:spChg>
+        <pc:spChg chg="mod">
+          <ac:chgData name="Simon Hong" userId="2f15200c-b3cf-4aef-8f69-ada819764841" providerId="ADAL" clId="{6AB89950-CF24-4538-93AF-1A20832D1772}" dt="2026-10-09T18:59:46.581" v="908" actId="1035"/>
+          <ac:spMkLst>
+            <pc:docMk/>
+            <pc:sldMk cId="0" sldId="266"/>
+            <ac:spMk id="12" creationId="{00000000-0000-0000-0000-000000000000}"/>
+          </ac:spMkLst>
+        </pc:spChg>
+        <pc:spChg chg="mod">
+          <ac:chgData name="Simon Hong" userId="2f15200c-b3cf-4aef-8f69-ada819764841" providerId="ADAL" clId="{6AB89950-CF24-4538-93AF-1A20832D1772}" dt="2026-10-09T18:59:46.581" v="908" actId="1035"/>
+          <ac:spMkLst>
+            <pc:docMk/>
+            <pc:sldMk cId="0" sldId="266"/>
+            <ac:spMk id="15" creationId="{00000000-0000-0000-0000-000000000000}"/>
+          </ac:spMkLst>
+        </pc:spChg>
+        <pc:spChg chg="mod">
+          <ac:chgData name="Simon Hong" userId="2f15200c-b3cf-4aef-8f69-ada819764841" providerId="ADAL" clId="{6AB89950-CF24-4538-93AF-1A20832D1772}" dt="2026-10-09T18:59:46.581" v="908" actId="1035"/>
+          <ac:spMkLst>
+            <pc:docMk/>
+            <pc:sldMk cId="0" sldId="266"/>
+            <ac:spMk id="16" creationId="{00000000-0000-0000-0000-000000000000}"/>
+          </ac:spMkLst>
+        </pc:spChg>
+        <pc:spChg chg="mod">
+          <ac:chgData name="Simon Hong" userId="2f15200c-b3cf-4aef-8f69-ada819764841" providerId="ADAL" clId="{6AB89950-CF24-4538-93AF-1A20832D1772}" dt="2026-10-09T18:59:46.581" v="908" actId="1035"/>
+          <ac:spMkLst>
+            <pc:docMk/>
+            <pc:sldMk cId="0" sldId="266"/>
+            <ac:spMk id="17" creationId="{00000000-0000-0000-0000-000000000000}"/>
+          </ac:spMkLst>
+        </pc:spChg>
+        <pc:spChg chg="mod">
+          <ac:chgData name="Simon Hong" userId="2f15200c-b3cf-4aef-8f69-ada819764841" providerId="ADAL" clId="{6AB89950-CF24-4538-93AF-1A20832D1772}" dt="2026-10-09T18:56:44.785" v="823" actId="1036"/>
+          <ac:spMkLst>
+            <pc:docMk/>
+            <pc:sldMk cId="0" sldId="266"/>
+            <ac:spMk id="18" creationId="{00000000-0000-0000-0000-000000000000}"/>
+          </ac:spMkLst>
+        </pc:spChg>
+        <pc:spChg chg="mod">
+          <ac:chgData name="Simon Hong" userId="2f15200c-b3cf-4aef-8f69-ada819764841" providerId="ADAL" clId="{6AB89950-CF24-4538-93AF-1A20832D1772}" dt="2026-10-09T18:59:46.581" v="908" actId="1035"/>
+          <ac:spMkLst>
+            <pc:docMk/>
+            <pc:sldMk cId="0" sldId="266"/>
+            <ac:spMk id="19" creationId="{00000000-0000-0000-0000-000000000000}"/>
+          </ac:spMkLst>
+        </pc:spChg>
+        <pc:spChg chg="mod">
+          <ac:chgData name="Simon Hong" userId="2f15200c-b3cf-4aef-8f69-ada819764841" providerId="ADAL" clId="{6AB89950-CF24-4538-93AF-1A20832D1772}" dt="2026-10-09T18:59:46.581" v="908" actId="1035"/>
+          <ac:spMkLst>
+            <pc:docMk/>
+            <pc:sldMk cId="0" sldId="266"/>
+            <ac:spMk id="20" creationId="{00000000-0000-0000-0000-000000000000}"/>
+          </ac:spMkLst>
+        </pc:spChg>
+        <pc:spChg chg="mod">
+          <ac:chgData name="Simon Hong" userId="2f15200c-b3cf-4aef-8f69-ada819764841" providerId="ADAL" clId="{6AB89950-CF24-4538-93AF-1A20832D1772}" dt="2026-10-09T18:56:44.785" v="823" actId="1036"/>
+          <ac:spMkLst>
+            <pc:docMk/>
+            <pc:sldMk cId="0" sldId="266"/>
+            <ac:spMk id="22" creationId="{00000000-0000-0000-0000-000000000000}"/>
+          </ac:spMkLst>
+        </pc:spChg>
+        <pc:spChg chg="mod">
+          <ac:chgData name="Simon Hong" userId="2f15200c-b3cf-4aef-8f69-ada819764841" providerId="ADAL" clId="{6AB89950-CF24-4538-93AF-1A20832D1772}" dt="2026-10-09T18:59:46.581" v="908" actId="1035"/>
+          <ac:spMkLst>
+            <pc:docMk/>
+            <pc:sldMk cId="0" sldId="266"/>
+            <ac:spMk id="23" creationId="{00000000-0000-0000-0000-000000000000}"/>
+          </ac:spMkLst>
+        </pc:spChg>
+        <pc:spChg chg="mod">
+          <ac:chgData name="Simon Hong" userId="2f15200c-b3cf-4aef-8f69-ada819764841" providerId="ADAL" clId="{6AB89950-CF24-4538-93AF-1A20832D1772}" dt="2026-10-09T18:59:46.581" v="908" actId="1035"/>
+          <ac:spMkLst>
+            <pc:docMk/>
+            <pc:sldMk cId="0" sldId="266"/>
+            <ac:spMk id="24" creationId="{00000000-0000-0000-0000-000000000000}"/>
+          </ac:spMkLst>
+        </pc:spChg>
+        <pc:spChg chg="mod">
+          <ac:chgData name="Simon Hong" userId="2f15200c-b3cf-4aef-8f69-ada819764841" providerId="ADAL" clId="{6AB89950-CF24-4538-93AF-1A20832D1772}" dt="2026-10-09T18:59:46.581" v="908" actId="1035"/>
+          <ac:spMkLst>
+            <pc:docMk/>
+            <pc:sldMk cId="0" sldId="266"/>
+            <ac:spMk id="25" creationId="{00000000-0000-0000-0000-000000000000}"/>
+          </ac:spMkLst>
+        </pc:spChg>
+        <pc:spChg chg="mod">
+          <ac:chgData name="Simon Hong" userId="2f15200c-b3cf-4aef-8f69-ada819764841" providerId="ADAL" clId="{6AB89950-CF24-4538-93AF-1A20832D1772}" dt="2026-10-09T18:56:44.785" v="823" actId="1036"/>
+          <ac:spMkLst>
+            <pc:docMk/>
+            <pc:sldMk cId="0" sldId="266"/>
+            <ac:spMk id="31" creationId="{00000000-0000-0000-0000-000000000000}"/>
+          </ac:spMkLst>
+        </pc:spChg>
+        <pc:spChg chg="mod">
+          <ac:chgData name="Simon Hong" userId="2f15200c-b3cf-4aef-8f69-ada819764841" providerId="ADAL" clId="{6AB89950-CF24-4538-93AF-1A20832D1772}" dt="2026-10-09T18:56:44.785" v="823" actId="1036"/>
+          <ac:spMkLst>
+            <pc:docMk/>
+            <pc:sldMk cId="0" sldId="266"/>
+            <ac:spMk id="37" creationId="{00000000-0000-0000-0000-000000000000}"/>
+          </ac:spMkLst>
+        </pc:spChg>
+        <pc:spChg chg="del">
+          <ac:chgData name="Simon Hong" userId="2f15200c-b3cf-4aef-8f69-ada819764841" providerId="ADAL" clId="{6AB89950-CF24-4538-93AF-1A20832D1772}" dt="2026-10-09T18:56:34.167" v="797" actId="478"/>
+          <ac:spMkLst>
+            <pc:docMk/>
+            <pc:sldMk cId="0" sldId="266"/>
+            <ac:spMk id="41" creationId="{00000000-0000-0000-0000-000000000000}"/>
           </ac:spMkLst>
         </pc:spChg>
       </pc:sldChg>
@@ -5167,7 +5734,7 @@
                 <a:latin typeface="Calibri" panose="020F0502020204030204" pitchFamily="34" charset="0"/>
                 <a:cs typeface="Calibri" panose="020F0502020204030204" pitchFamily="34" charset="0"/>
               </a:rPr>
-              <a:t>(A bad LLM can make a function just to pass the test items in BRD)</a:t>
+              <a:t>(A LLM can make a function just to pass the test items in BRD)</a:t>
             </a:r>
           </a:p>
           <a:p>
@@ -8869,7 +9436,7 @@
                 <a:ea typeface="+mn-ea"/>
                 <a:cs typeface="Courier New" panose="02070309020205020404" pitchFamily="49" charset="0"/>
               </a:rPr>
-              <a:t>  },</a:t>
+              <a:t>  }</a:t>
             </a:r>
           </a:p>
           <a:p>
@@ -9651,7 +10218,9 @@
                 <a:ea typeface="+mn-ea"/>
                 <a:cs typeface="Courier New" panose="02070309020205020404" pitchFamily="49" charset="0"/>
               </a:rPr>
-              <a:t>N_ITEMS_TO_PASS=15</a:t>
+              <a:t>ID_FIELD=incident_id
+EXPECTED_FIELD=expected_word_count
+N_ITEMS_TO_PASS=15</a:t>
             </a:r>
           </a:p>
           <a:p>
@@ -10825,7 +11394,9 @@
                 <a:ea typeface="+mn-ea"/>
                 <a:cs typeface="Courier New" panose="02070309020205020404" pitchFamily="49" charset="0"/>
               </a:rPr>
-              <a:t>N_ITEMS_TO_PASS=15</a:t>
+              <a:t>ID_FIELD=incident_id
+EXPECTED_FIELD=expected_word_count
+N_ITEMS_TO_PASS=15</a:t>
             </a:r>
           </a:p>
           <a:p>
@@ -15381,7 +15952,7 @@
                 <a:latin typeface="Calibri"/>
                 <a:sym typeface="Wingdings" panose="05000000000000000000" pitchFamily="2" charset="2"/>
               </a:rPr>
-              <a:t>function failure (anomaly </a:t>
+              <a:t>correction of failed BRD examples before deployment</a:t>
             </a:r>
             <a:r>
               <a:rPr lang="en-US" sz="4000" dirty="0">
@@ -15391,7 +15962,7 @@
                 <a:latin typeface="Calibri"/>
                 <a:sym typeface="Wingdings" panose="05000000000000000000" pitchFamily="2" charset="2"/>
               </a:rPr>
-              <a:t>monitoring and fixing</a:t>
+              <a:t/>
             </a:r>
             <a:r>
               <a:rPr lang="en-US" sz="4000" dirty="0">
@@ -15401,7 +15972,7 @@
                 <a:latin typeface="Calibri"/>
                 <a:sym typeface="Wingdings" panose="05000000000000000000" pitchFamily="2" charset="2"/>
               </a:rPr>
-              <a:t>)</a:t>
+              <a:t/>
             </a:r>
           </a:p>
           <a:p>
@@ -18256,34 +18827,15 @@
         </p:nvSpPr>
         <p:spPr>
           <a:xfrm>
-            <a:off x="10763735" y="8039100"/>
-            <a:ext cx="14306065" cy="16550376"/>
+            <a:off x="11178657" y="8039100"/>
+            <a:ext cx="13891143" cy="16550376"/>
           </a:xfrm>
           <a:prstGeom prst="roundRect">
             <a:avLst>
               <a:gd name="adj" fmla="val 3647"/>
             </a:avLst>
           </a:prstGeom>
-          <a:gradFill flip="none" rotWithShape="1">
-            <a:gsLst>
-              <a:gs pos="0">
-                <a:srgbClr val="FFFFFF"/>
-              </a:gs>
-              <a:gs pos="92000">
-                <a:srgbClr val="FFFFFF"/>
-              </a:gs>
-              <a:gs pos="100000">
-                <a:srgbClr val="B6D2E3">
-                  <a:lumMod val="20000"/>
-                  <a:lumOff val="80000"/>
-                </a:srgbClr>
-              </a:gs>
-            </a:gsLst>
-            <a:path path="rect">
-              <a:fillToRect l="50000" t="50000" r="50000" b="50000"/>
-            </a:path>
-            <a:tileRect/>
-          </a:gradFill>
+          <a:noFill/>
           <a:ln w="28575" cap="sq" cmpd="sng" algn="ctr">
             <a:solidFill>
               <a:srgbClr val="0000FF"/>
@@ -18750,7 +19302,7 @@
         </p:nvCxnSpPr>
         <p:spPr>
           <a:xfrm>
-            <a:off x="6750990" y="3972742"/>
+            <a:off x="5928030" y="3972742"/>
             <a:ext cx="5334" cy="319298"/>
           </a:xfrm>
           <a:prstGeom prst="straightConnector1">
@@ -18782,7 +19334,7 @@
         <p:spPr>
           <a:xfrm>
             <a:off x="15497248" y="14114340"/>
-            <a:ext cx="8851911" cy="2829646"/>
+            <a:ext cx="8851911" cy="2537689"/>
           </a:xfrm>
           <a:prstGeom prst="roundRect">
             <a:avLst>
@@ -18954,14 +19506,14 @@
           <p:cNvCxnSpPr>
             <a:cxnSpLocks/>
             <a:stCxn id="146" idx="2"/>
-            <a:endCxn id="110" idx="0"/>
+            <a:endCxn id="169" idx="0"/>
           </p:cNvCxnSpPr>
           <p:nvPr/>
         </p:nvCxnSpPr>
         <p:spPr>
           <a:xfrm>
-            <a:off x="18313289" y="16333303"/>
-            <a:ext cx="635" cy="926521"/>
+            <a:off x="18313289" y="16203763"/>
+            <a:ext cx="6240" cy="614475"/>
           </a:xfrm>
           <a:prstGeom prst="straightConnector1">
             <a:avLst/>
@@ -18991,7 +19543,7 @@
         </p:nvSpPr>
         <p:spPr>
           <a:xfrm>
-            <a:off x="20467712" y="15813350"/>
+            <a:off x="20467712" y="15683810"/>
             <a:ext cx="820736" cy="338554"/>
           </a:xfrm>
           <a:prstGeom prst="rect">
@@ -19042,8 +19594,8 @@
         </p:nvSpPr>
         <p:spPr>
           <a:xfrm>
-            <a:off x="17512454" y="16464647"/>
-            <a:ext cx="820736" cy="338554"/>
+            <a:off x="17790024" y="16235804"/>
+            <a:ext cx="529505" cy="276999"/>
           </a:xfrm>
           <a:prstGeom prst="rect">
             <a:avLst/>
@@ -19060,7 +19612,7 @@
               <a:defRPr/>
             </a:pPr>
             <a:r>
-              <a:rPr lang="en-US" sz="1600" dirty="0">
+              <a:rPr lang="en-US" sz="1200" dirty="0">
                 <a:solidFill>
                   <a:prstClr val="black">
                     <a:lumMod val="50000"/>
@@ -19070,7 +19622,7 @@
               </a:rPr>
               <a:t>Yes</a:t>
             </a:r>
-            <a:endParaRPr lang="en-US" sz="1600" dirty="0">
+            <a:endParaRPr lang="en-US" sz="1200" dirty="0">
               <a:solidFill>
                 <a:prstClr val="black"/>
               </a:solidFill>
@@ -19128,8 +19680,8 @@
         </p:nvSpPr>
         <p:spPr>
           <a:xfrm>
-            <a:off x="21324012" y="15636861"/>
-            <a:ext cx="2691924" cy="1066800"/>
+            <a:off x="21324012" y="15654201"/>
+            <a:ext cx="2691924" cy="773040"/>
           </a:xfrm>
           <a:prstGeom prst="diamond">
             <a:avLst/>
@@ -19206,7 +19758,7 @@
         </p:nvCxnSpPr>
         <p:spPr>
           <a:xfrm>
-            <a:off x="19622809" y="16167652"/>
+            <a:off x="19622809" y="16038112"/>
             <a:ext cx="1701203" cy="2609"/>
           </a:xfrm>
           <a:prstGeom prst="straightConnector1">
@@ -19292,8 +19844,8 @@
         </p:nvCxnSpPr>
         <p:spPr>
           <a:xfrm rot="16200000" flipH="1">
-            <a:off x="19646903" y="19726731"/>
-            <a:ext cx="6048085" cy="1943"/>
+            <a:off x="19449624" y="19647590"/>
+            <a:ext cx="6442643" cy="1943"/>
           </a:xfrm>
           <a:prstGeom prst="bentConnector3">
             <a:avLst>
@@ -19329,7 +19881,7 @@
         </p:nvCxnSpPr>
         <p:spPr>
           <a:xfrm flipH="1">
-            <a:off x="6750990" y="8084464"/>
+            <a:off x="5928030" y="8084464"/>
             <a:ext cx="5440" cy="1112107"/>
           </a:xfrm>
           <a:prstGeom prst="straightConnector1">
@@ -19360,7 +19912,7 @@
         </p:nvSpPr>
         <p:spPr>
           <a:xfrm>
-            <a:off x="21945311" y="16591474"/>
+            <a:off x="22329484" y="16325444"/>
             <a:ext cx="2138851" cy="500137"/>
           </a:xfrm>
           <a:prstGeom prst="rect">
@@ -19427,7 +19979,7 @@
         </p:nvGrpSpPr>
         <p:grpSpPr>
           <a:xfrm>
-            <a:off x="4387107" y="12516871"/>
+            <a:off x="3564147" y="12516871"/>
             <a:ext cx="4746562" cy="670280"/>
             <a:chOff x="12799260" y="4501979"/>
             <a:chExt cx="18288000" cy="670280"/>
@@ -19596,7 +20148,7 @@
         </p:nvCxnSpPr>
         <p:spPr>
           <a:xfrm>
-            <a:off x="6759499" y="12161085"/>
+            <a:off x="5936539" y="12161085"/>
             <a:ext cx="889" cy="561274"/>
           </a:xfrm>
           <a:prstGeom prst="straightConnector1">
@@ -19720,7 +20272,7 @@
         <p:spPr>
           <a:xfrm flipH="1" flipV="1">
             <a:off x="22660656" y="15255861"/>
-            <a:ext cx="9318" cy="381000"/>
+            <a:ext cx="9318" cy="398340"/>
           </a:xfrm>
           <a:prstGeom prst="straightConnector1">
             <a:avLst/>
@@ -19755,7 +20307,7 @@
         <p:spPr>
           <a:xfrm flipH="1">
             <a:off x="18313289" y="15207206"/>
-            <a:ext cx="388" cy="794794"/>
+            <a:ext cx="388" cy="665254"/>
           </a:xfrm>
           <a:prstGeom prst="straightConnector1">
             <a:avLst/>
@@ -19785,7 +20337,7 @@
         </p:nvSpPr>
         <p:spPr>
           <a:xfrm>
-            <a:off x="4590855" y="5137538"/>
+            <a:off x="3767895" y="5137538"/>
             <a:ext cx="4330938" cy="449561"/>
           </a:xfrm>
           <a:prstGeom prst="roundRect">
@@ -19951,7 +20503,7 @@
         </p:nvCxnSpPr>
         <p:spPr>
           <a:xfrm>
-            <a:off x="6756324" y="5587099"/>
+            <a:off x="5933364" y="5587099"/>
             <a:ext cx="3174" cy="374528"/>
           </a:xfrm>
           <a:prstGeom prst="straightConnector1">
@@ -20037,8 +20589,8 @@
         </p:nvCxnSpPr>
         <p:spPr>
           <a:xfrm rot="5400000" flipH="1" flipV="1">
-            <a:off x="11475850" y="11430845"/>
-            <a:ext cx="7152810" cy="6341204"/>
+            <a:off x="11351155" y="11555540"/>
+            <a:ext cx="7402200" cy="6341204"/>
           </a:xfrm>
           <a:prstGeom prst="bentConnector2">
             <a:avLst/>
@@ -20068,7 +20620,7 @@
         </p:nvSpPr>
         <p:spPr>
           <a:xfrm>
-            <a:off x="4590855" y="4292040"/>
+            <a:off x="3767895" y="4292040"/>
             <a:ext cx="4330938" cy="449561"/>
           </a:xfrm>
           <a:prstGeom prst="roundRect">
@@ -20160,7 +20712,7 @@
         </p:nvCxnSpPr>
         <p:spPr>
           <a:xfrm>
-            <a:off x="6756324" y="4741601"/>
+            <a:off x="5933364" y="4741601"/>
             <a:ext cx="0" cy="395937"/>
           </a:xfrm>
           <a:prstGeom prst="straightConnector1">
@@ -20191,7 +20743,7 @@
         </p:nvSpPr>
         <p:spPr>
           <a:xfrm>
-            <a:off x="2998794" y="10213852"/>
+            <a:off x="2175834" y="10213852"/>
             <a:ext cx="7525058" cy="593471"/>
           </a:xfrm>
           <a:prstGeom prst="diamond">
@@ -20269,7 +20821,7 @@
         </p:nvCxnSpPr>
         <p:spPr>
           <a:xfrm rot="10800000" flipH="1">
-            <a:off x="2998793" y="4516822"/>
+            <a:off x="2175833" y="4516822"/>
             <a:ext cx="1592061" cy="5993767"/>
           </a:xfrm>
           <a:prstGeom prst="bentConnector3">
@@ -20302,7 +20854,7 @@
         </p:nvSpPr>
         <p:spPr>
           <a:xfrm>
-            <a:off x="6924943" y="12279276"/>
+            <a:off x="6101983" y="12279276"/>
             <a:ext cx="820736" cy="400110"/>
           </a:xfrm>
           <a:prstGeom prst="rect">
@@ -20396,8 +20948,8 @@
         </p:nvGrpSpPr>
         <p:grpSpPr>
           <a:xfrm>
-            <a:off x="20896404" y="22729444"/>
-            <a:ext cx="3551026" cy="1019037"/>
+            <a:off x="20896404" y="22852990"/>
+            <a:ext cx="3551026" cy="771946"/>
             <a:chOff x="39533526" y="17475131"/>
             <a:chExt cx="4330938" cy="1019037"/>
           </a:xfrm>
@@ -20592,7 +21144,7 @@
         </p:nvSpPr>
         <p:spPr>
           <a:xfrm>
-            <a:off x="17060294" y="21174415"/>
+            <a:off x="17060294" y="21423805"/>
             <a:ext cx="2505124" cy="263061"/>
           </a:xfrm>
           <a:prstGeom prst="roundRect">
@@ -20680,7 +21232,7 @@
         </p:nvSpPr>
         <p:spPr>
           <a:xfrm>
-            <a:off x="16786662" y="21831642"/>
+            <a:off x="16786662" y="22081032"/>
             <a:ext cx="3054928" cy="494958"/>
           </a:xfrm>
           <a:prstGeom prst="diamond">
@@ -20758,7 +21310,7 @@
         </p:nvCxnSpPr>
         <p:spPr>
           <a:xfrm>
-            <a:off x="18312856" y="21437476"/>
+            <a:off x="18312856" y="21686866"/>
             <a:ext cx="1270" cy="394166"/>
           </a:xfrm>
           <a:prstGeom prst="straightConnector1">
@@ -20789,7 +21341,7 @@
         </p:nvSpPr>
         <p:spPr>
           <a:xfrm>
-            <a:off x="16522104" y="21788837"/>
+            <a:off x="16522104" y="22038227"/>
             <a:ext cx="463575" cy="276999"/>
           </a:xfrm>
           <a:prstGeom prst="rect">
@@ -20926,8 +21478,8 @@
         </p:nvCxnSpPr>
         <p:spPr>
           <a:xfrm flipH="1" flipV="1">
-            <a:off x="19841590" y="18057413"/>
-            <a:ext cx="135136" cy="5216941"/>
+            <a:off x="19841590" y="18306803"/>
+            <a:ext cx="135136" cy="4967551"/>
           </a:xfrm>
           <a:prstGeom prst="bentConnector3">
             <a:avLst>
@@ -21340,8 +21892,8 @@
         </p:nvCxnSpPr>
         <p:spPr>
           <a:xfrm>
-            <a:off x="10501026" y="7833284"/>
-            <a:ext cx="7812538" cy="332181"/>
+            <a:off x="9678066" y="7833284"/>
+            <a:ext cx="8635498" cy="332181"/>
           </a:xfrm>
           <a:prstGeom prst="bentConnector2">
             <a:avLst/>
@@ -21371,7 +21923,7 @@
         </p:nvGrpSpPr>
         <p:grpSpPr>
           <a:xfrm>
-            <a:off x="5536082" y="7585146"/>
+            <a:off x="4713122" y="7585146"/>
             <a:ext cx="2440696" cy="499318"/>
             <a:chOff x="19780736" y="18469318"/>
             <a:chExt cx="2440696" cy="499318"/>
@@ -21552,7 +22104,7 @@
         </p:nvCxnSpPr>
         <p:spPr>
           <a:xfrm flipH="1">
-            <a:off x="6759499" y="10807323"/>
+            <a:off x="5936539" y="10807323"/>
             <a:ext cx="1824" cy="632155"/>
           </a:xfrm>
           <a:prstGeom prst="straightConnector1">
@@ -21583,7 +22135,7 @@
         </p:nvSpPr>
         <p:spPr>
           <a:xfrm>
-            <a:off x="4808221" y="11439478"/>
+            <a:off x="3985261" y="11439478"/>
             <a:ext cx="3902556" cy="721607"/>
           </a:xfrm>
           <a:prstGeom prst="diamond">
@@ -21675,7 +22227,7 @@
         </p:nvCxnSpPr>
         <p:spPr>
           <a:xfrm rot="10800000">
-            <a:off x="4585521" y="2908636"/>
+            <a:off x="3762561" y="2908636"/>
             <a:ext cx="222700" cy="8891647"/>
           </a:xfrm>
           <a:prstGeom prst="bentConnector3">
@@ -21708,7 +22260,7 @@
         </p:nvSpPr>
         <p:spPr>
           <a:xfrm>
-            <a:off x="3941048" y="11437693"/>
+            <a:off x="3118088" y="11437693"/>
             <a:ext cx="820736" cy="400110"/>
           </a:xfrm>
           <a:prstGeom prst="rect">
@@ -21759,7 +22311,7 @@
         </p:nvSpPr>
         <p:spPr>
           <a:xfrm>
-            <a:off x="3721621" y="5961627"/>
+            <a:off x="2898661" y="5961627"/>
             <a:ext cx="6075754" cy="743086"/>
           </a:xfrm>
           <a:prstGeom prst="diamond">
@@ -21837,7 +22389,7 @@
         </p:nvCxnSpPr>
         <p:spPr>
           <a:xfrm flipH="1">
-            <a:off x="6756430" y="6704713"/>
+            <a:off x="5933470" y="6704713"/>
             <a:ext cx="3068" cy="880433"/>
           </a:xfrm>
           <a:prstGeom prst="straightConnector1">
@@ -21868,7 +22420,7 @@
         </p:nvSpPr>
         <p:spPr>
           <a:xfrm>
-            <a:off x="6842806" y="6801083"/>
+            <a:off x="6019846" y="6801083"/>
             <a:ext cx="820736" cy="400110"/>
           </a:xfrm>
           <a:prstGeom prst="rect">
@@ -21919,7 +22471,7 @@
         </p:nvSpPr>
         <p:spPr>
           <a:xfrm>
-            <a:off x="8915400" y="7162802"/>
+            <a:off x="8092440" y="7162802"/>
             <a:ext cx="1585626" cy="1340964"/>
           </a:xfrm>
           <a:prstGeom prst="roundRect">
@@ -22049,7 +22601,7 @@
         </p:nvCxnSpPr>
         <p:spPr>
           <a:xfrm flipV="1">
-            <a:off x="7976778" y="7833284"/>
+            <a:off x="7153818" y="7833284"/>
             <a:ext cx="938622" cy="1521"/>
           </a:xfrm>
           <a:prstGeom prst="straightConnector1">
@@ -22157,9 +22709,9 @@
           <p:nvPr/>
         </p:nvCxnSpPr>
         <p:spPr>
-          <a:xfrm flipV="1">
-            <a:off x="24447430" y="23250113"/>
-            <a:ext cx="3332397" cy="1"/>
+          <a:xfrm>
+            <a:off x="24447430" y="23247410"/>
+            <a:ext cx="3332397" cy="2703"/>
           </a:xfrm>
           <a:prstGeom prst="straightConnector1">
             <a:avLst/>
@@ -22230,7 +22782,7 @@
         </p:nvCxnSpPr>
         <p:spPr>
           <a:xfrm rot="10800000" flipH="1" flipV="1">
-            <a:off x="3721620" y="6333169"/>
+            <a:off x="2898660" y="6333169"/>
             <a:ext cx="2936195" cy="2956575"/>
           </a:xfrm>
           <a:prstGeom prst="bentConnector3">
@@ -22263,7 +22815,7 @@
         </p:nvSpPr>
         <p:spPr>
           <a:xfrm>
-            <a:off x="3164871" y="5769178"/>
+            <a:off x="2341911" y="5769178"/>
             <a:ext cx="1398261" cy="400110"/>
           </a:xfrm>
           <a:prstGeom prst="rect">
@@ -22314,7 +22866,7 @@
         </p:nvSpPr>
         <p:spPr>
           <a:xfrm>
-            <a:off x="18292969" y="22326600"/>
+            <a:off x="18292969" y="22575990"/>
             <a:ext cx="574900" cy="276999"/>
           </a:xfrm>
           <a:prstGeom prst="rect">
@@ -22365,7 +22917,7 @@
         </p:nvSpPr>
         <p:spPr>
           <a:xfrm>
-            <a:off x="18458252" y="20102959"/>
+            <a:off x="18458252" y="20352349"/>
             <a:ext cx="563717" cy="276999"/>
           </a:xfrm>
           <a:prstGeom prst="rect">
@@ -22420,7 +22972,7 @@
         </p:nvCxnSpPr>
         <p:spPr>
           <a:xfrm flipH="1">
-            <a:off x="18312856" y="20724923"/>
+            <a:off x="18312856" y="20974313"/>
             <a:ext cx="1808" cy="449492"/>
           </a:xfrm>
           <a:prstGeom prst="straightConnector1">
@@ -22451,7 +23003,7 @@
         </p:nvSpPr>
         <p:spPr>
           <a:xfrm>
-            <a:off x="16434418" y="19385918"/>
+            <a:off x="16434418" y="19635308"/>
             <a:ext cx="820736" cy="276999"/>
           </a:xfrm>
           <a:prstGeom prst="rect">
@@ -22506,12 +23058,12 @@
         </p:nvCxnSpPr>
         <p:spPr>
           <a:xfrm rot="10800000" flipV="1">
-            <a:off x="16655336" y="19691670"/>
-            <a:ext cx="431344" cy="3582684"/>
+            <a:off x="16655336" y="19941060"/>
+            <a:ext cx="431344" cy="3333294"/>
           </a:xfrm>
           <a:prstGeom prst="bentConnector3">
             <a:avLst>
-              <a:gd name="adj1" fmla="val 210812"/>
+              <a:gd name="adj1" fmla="val 188328"/>
             </a:avLst>
           </a:prstGeom>
           <a:noFill/>
@@ -22580,8 +23132,8 @@
         </p:nvCxnSpPr>
         <p:spPr>
           <a:xfrm rot="5400000">
-            <a:off x="22518482" y="23890656"/>
-            <a:ext cx="295610" cy="11261"/>
+            <a:off x="22456710" y="23828883"/>
+            <a:ext cx="419155" cy="11261"/>
           </a:xfrm>
           <a:prstGeom prst="bentConnector3">
             <a:avLst>
@@ -23013,7 +23565,7 @@
         </p:nvSpPr>
         <p:spPr>
           <a:xfrm>
-            <a:off x="7610981" y="7097887"/>
+            <a:off x="6788021" y="7097887"/>
             <a:ext cx="1661050" cy="523220"/>
           </a:xfrm>
           <a:prstGeom prst="rect">
@@ -23080,7 +23632,7 @@
         </p:nvSpPr>
         <p:spPr>
           <a:xfrm>
-            <a:off x="2819401" y="10053799"/>
+            <a:off x="1996441" y="10053799"/>
             <a:ext cx="820736" cy="400110"/>
           </a:xfrm>
           <a:prstGeom prst="rect">
@@ -23131,7 +23683,7 @@
         </p:nvSpPr>
         <p:spPr>
           <a:xfrm>
-            <a:off x="6790245" y="10967376"/>
+            <a:off x="5967285" y="10967376"/>
             <a:ext cx="820736" cy="400110"/>
           </a:xfrm>
           <a:prstGeom prst="rect">
@@ -23333,7 +23885,7 @@
                 </a:solidFill>
                 <a:latin typeface="Arial"/>
               </a:rPr>
-              <a:t>Shared runtime tools such as </a:t>
+              <a:t>Generated functions receive narrow wrappers through my_tools; raw GPT client, semaphore, and shared state are not exposed.</a:t>
             </a:r>
             <a:r>
               <a:rPr lang="en-US" sz="1100" kern="0" dirty="0" err="1">
@@ -23344,7 +23896,7 @@
                 </a:solidFill>
                 <a:latin typeface="Arial"/>
               </a:rPr>
-              <a:t>gpt_client</a:t>
+              <a:t/>
             </a:r>
             <a:r>
               <a:rPr lang="en-US" sz="1100" kern="0" dirty="0">
@@ -23355,7 +23907,7 @@
                 </a:solidFill>
                 <a:latin typeface="Arial"/>
               </a:rPr>
-              <a:t>, </a:t>
+              <a:t/>
             </a:r>
             <a:r>
               <a:rPr lang="en-US" sz="1100" kern="0" dirty="0" err="1">
@@ -23366,7 +23918,7 @@
                 </a:solidFill>
                 <a:latin typeface="Arial"/>
               </a:rPr>
-              <a:t>gpt_semaphore</a:t>
+              <a:t/>
             </a:r>
             <a:r>
               <a:rPr lang="en-US" sz="1100" kern="0" dirty="0">
@@ -23377,7 +23929,7 @@
                 </a:solidFill>
                 <a:latin typeface="Arial"/>
               </a:rPr>
-              <a:t>, logging, and shared state are made available through the global </a:t>
+              <a:t/>
             </a:r>
             <a:r>
               <a:rPr lang="en-US" sz="1100" kern="0" dirty="0" err="1">
@@ -23388,7 +23940,7 @@
                 </a:solidFill>
                 <a:latin typeface="Arial"/>
               </a:rPr>
-              <a:t>my_tools</a:t>
+              <a:t/>
             </a:r>
             <a:r>
               <a:rPr lang="en-US" sz="1100" kern="0" dirty="0">
@@ -23399,7 +23951,7 @@
                 </a:solidFill>
                 <a:latin typeface="Arial"/>
               </a:rPr>
-              <a:t> module.  </a:t>
+              <a:t/>
             </a:r>
           </a:p>
           <a:p>
@@ -23842,7 +24394,7 @@
         </p:nvSpPr>
         <p:spPr bwMode="auto">
           <a:xfrm>
-            <a:off x="6657816" y="9196571"/>
+            <a:off x="5834856" y="9196571"/>
             <a:ext cx="186348" cy="186348"/>
           </a:xfrm>
           <a:prstGeom prst="ellipse">
@@ -23936,7 +24488,7 @@
         </p:nvCxnSpPr>
         <p:spPr>
           <a:xfrm>
-            <a:off x="6750990" y="9382919"/>
+            <a:off x="5928030" y="9382919"/>
             <a:ext cx="10333" cy="830933"/>
           </a:xfrm>
           <a:prstGeom prst="straightConnector1">
@@ -24430,7 +24982,7 @@
         </p:nvCxnSpPr>
         <p:spPr>
           <a:xfrm flipH="1">
-            <a:off x="18313394" y="18223064"/>
+            <a:off x="18313394" y="18472454"/>
             <a:ext cx="997" cy="401107"/>
           </a:xfrm>
           <a:prstGeom prst="straightConnector1">
@@ -24461,7 +25013,7 @@
         </p:nvSpPr>
         <p:spPr>
           <a:xfrm>
-            <a:off x="17086680" y="19446443"/>
+            <a:off x="17086680" y="19695833"/>
             <a:ext cx="2453396" cy="490454"/>
           </a:xfrm>
           <a:prstGeom prst="diamond">
@@ -24535,7 +25087,7 @@
         </p:nvSpPr>
         <p:spPr>
           <a:xfrm>
-            <a:off x="17094316" y="20393620"/>
+            <a:off x="17094316" y="20643010"/>
             <a:ext cx="2440696" cy="331303"/>
           </a:xfrm>
           <a:prstGeom prst="roundRect">
@@ -25917,7 +26469,7 @@
         </p:nvSpPr>
         <p:spPr>
           <a:xfrm>
-            <a:off x="17351193" y="17259824"/>
+            <a:off x="17351193" y="17509214"/>
             <a:ext cx="1925462" cy="323814"/>
           </a:xfrm>
           <a:prstGeom prst="roundRect">
@@ -26009,8 +26561,8 @@
         </p:nvCxnSpPr>
         <p:spPr>
           <a:xfrm>
-            <a:off x="18314126" y="22326600"/>
-            <a:ext cx="1905" cy="586950"/>
+            <a:off x="18314126" y="22575990"/>
+            <a:ext cx="1905" cy="337560"/>
           </a:xfrm>
           <a:prstGeom prst="straightConnector1">
             <a:avLst/>
@@ -26922,94 +27474,6 @@
           </a:p>
         </p:txBody>
       </p:sp>
-      <p:sp>
-        <p:nvSpPr>
-          <p:cNvPr id="118" name="Rectangle: Rounded Corners 117">
-            <a:extLst>
-              <a:ext uri="{FF2B5EF4-FFF2-40B4-BE49-F238E27FC236}">
-                <a16:creationId xmlns:a16="http://schemas.microsoft.com/office/drawing/2014/main" id="{EA6F7C5F-6F23-F607-F50F-0828F4266A53}"/>
-              </a:ext>
-            </a:extLst>
-          </p:cNvPr>
-          <p:cNvSpPr/>
-          <p:nvPr/>
-        </p:nvSpPr>
-        <p:spPr>
-          <a:xfrm>
-            <a:off x="10889214" y="20279358"/>
-            <a:ext cx="1988585" cy="741695"/>
-          </a:xfrm>
-          <a:prstGeom prst="roundRect">
-            <a:avLst/>
-          </a:prstGeom>
-          <a:noFill/>
-          <a:ln w="12700" cap="sq" cmpd="sng" algn="ctr">
-            <a:solidFill>
-              <a:srgbClr val="4F5759">
-                <a:lumMod val="50000"/>
-              </a:srgbClr>
-            </a:solidFill>
-            <a:prstDash val="solid"/>
-          </a:ln>
-          <a:effectLst/>
-        </p:spPr>
-        <p:txBody>
-          <a:bodyPr rtlCol="0" anchor="ctr"/>
-          <a:lstStyle/>
-          <a:p>
-            <a:pPr marL="0" marR="0" lvl="0" indent="0" algn="ctr" defTabSz="914400" eaLnBrk="1" fontAlgn="auto" latinLnBrk="0" hangingPunct="1">
-              <a:lnSpc>
-                <a:spcPct val="100000"/>
-              </a:lnSpc>
-              <a:spcBef>
-                <a:spcPts val="0"/>
-              </a:spcBef>
-              <a:spcAft>
-                <a:spcPts val="0"/>
-              </a:spcAft>
-              <a:buClrTx/>
-              <a:buSzTx/>
-              <a:buFontTx/>
-              <a:buNone/>
-              <a:tabLst/>
-              <a:defRPr/>
-            </a:pPr>
-            <a:r>
-              <a:rPr kumimoji="0" lang="en-US" sz="1050" b="0" i="0" u="none" strike="noStrike" kern="0" cap="none" spc="0" normalizeH="0" baseline="0" noProof="0" dirty="0">
-                <a:ln>
-                  <a:noFill/>
-                </a:ln>
-                <a:solidFill>
-                  <a:prstClr val="black">
-                    <a:lumMod val="50000"/>
-                  </a:prstClr>
-                </a:solidFill>
-                <a:effectLst/>
-                <a:uLnTx/>
-                <a:uFillTx/>
-                <a:latin typeface="Arial"/>
-                <a:ea typeface="+mn-ea"/>
-                <a:cs typeface="+mn-cs"/>
-              </a:rPr>
-              <a:t>Make a quarantine note in memory and registry for this crash-causing function for the BRD</a:t>
-            </a:r>
-            <a:endParaRPr kumimoji="0" lang="en-US" sz="1050" b="0" i="0" u="none" strike="noStrike" kern="0" cap="none" spc="0" normalizeH="0" baseline="0" noProof="0" dirty="0">
-              <a:ln>
-                <a:noFill/>
-              </a:ln>
-              <a:solidFill>
-                <a:prstClr val="white"/>
-              </a:solidFill>
-              <a:effectLst/>
-              <a:uLnTx/>
-              <a:uFillTx/>
-              <a:latin typeface="Arial"/>
-              <a:ea typeface="+mn-ea"/>
-              <a:cs typeface="+mn-cs"/>
-            </a:endParaRPr>
-          </a:p>
-        </p:txBody>
-      </p:sp>
       <p:cxnSp>
         <p:nvCxnSpPr>
           <p:cNvPr id="119" name="Connector: Elbow 118">
@@ -27021,15 +27485,15 @@
           </p:cNvPr>
           <p:cNvCxnSpPr>
             <a:cxnSpLocks/>
-            <a:stCxn id="44" idx="1"/>
-            <a:endCxn id="118" idx="2"/>
+            <a:stCxn id="118" idx="3"/>
+            <a:endCxn id="41" idx="0"/>
           </p:cNvCxnSpPr>
           <p:nvPr/>
         </p:nvCxnSpPr>
         <p:spPr>
-          <a:xfrm rot="10800000">
-            <a:off x="11883508" y="21021053"/>
-            <a:ext cx="4903155" cy="1058068"/>
+          <a:xfrm>
+            <a:off x="22300847" y="22327926"/>
+            <a:ext cx="371070" cy="541958"/>
           </a:xfrm>
           <a:prstGeom prst="bentConnector2">
             <a:avLst/>
@@ -27059,7 +27523,7 @@
         </p:nvSpPr>
         <p:spPr bwMode="auto">
           <a:xfrm>
-            <a:off x="11788479" y="18177852"/>
+            <a:off x="11788479" y="18427242"/>
             <a:ext cx="186348" cy="186348"/>
           </a:xfrm>
           <a:prstGeom prst="ellipse">
@@ -27135,41 +27599,6 @@
           </a:p>
         </p:txBody>
       </p:sp>
-      <p:cxnSp>
-        <p:nvCxnSpPr>
-          <p:cNvPr id="121" name="Connector: Elbow 200">
-            <a:extLst>
-              <a:ext uri="{FF2B5EF4-FFF2-40B4-BE49-F238E27FC236}">
-                <a16:creationId xmlns:a16="http://schemas.microsoft.com/office/drawing/2014/main" id="{1D5C3394-70DE-0F89-EC59-E822C95878F7}"/>
-              </a:ext>
-            </a:extLst>
-          </p:cNvPr>
-          <p:cNvCxnSpPr>
-            <a:cxnSpLocks/>
-            <a:stCxn id="118" idx="0"/>
-            <a:endCxn id="120" idx="4"/>
-          </p:cNvCxnSpPr>
-          <p:nvPr/>
-        </p:nvCxnSpPr>
-        <p:spPr>
-          <a:xfrm flipH="1" flipV="1">
-            <a:off x="11881653" y="18364200"/>
-            <a:ext cx="1854" cy="1915158"/>
-          </a:xfrm>
-          <a:prstGeom prst="straightConnector1">
-            <a:avLst/>
-          </a:prstGeom>
-          <a:noFill/>
-          <a:ln w="76200" cap="sq" cmpd="sng" algn="ctr">
-            <a:solidFill>
-              <a:srgbClr val="006297"/>
-            </a:solidFill>
-            <a:prstDash val="solid"/>
-            <a:tailEnd type="triangle"/>
-          </a:ln>
-          <a:effectLst/>
-        </p:spPr>
-      </p:cxnSp>
       <p:sp>
         <p:nvSpPr>
           <p:cNvPr id="122" name="Diamond 121">
@@ -27184,7 +27613,7 @@
         </p:nvSpPr>
         <p:spPr>
           <a:xfrm>
-            <a:off x="17086696" y="18624171"/>
+            <a:off x="17086696" y="18873561"/>
             <a:ext cx="2453396" cy="490454"/>
           </a:xfrm>
           <a:prstGeom prst="diamond">
@@ -27262,7 +27691,7 @@
         </p:nvCxnSpPr>
         <p:spPr>
           <a:xfrm>
-            <a:off x="18313378" y="19936897"/>
+            <a:off x="18313378" y="20186287"/>
             <a:ext cx="1286" cy="456723"/>
           </a:xfrm>
           <a:prstGeom prst="straightConnector1">
@@ -27293,7 +27722,7 @@
         </p:nvSpPr>
         <p:spPr>
           <a:xfrm>
-            <a:off x="18346551" y="19084788"/>
+            <a:off x="18346551" y="19334178"/>
             <a:ext cx="563717" cy="276999"/>
           </a:xfrm>
           <a:prstGeom prst="rect">
@@ -27348,7 +27777,7 @@
         </p:nvCxnSpPr>
         <p:spPr>
           <a:xfrm flipH="1">
-            <a:off x="18313378" y="19114625"/>
+            <a:off x="18313378" y="19364015"/>
             <a:ext cx="16" cy="331818"/>
           </a:xfrm>
           <a:prstGeom prst="straightConnector1">
@@ -27383,7 +27812,7 @@
         </p:nvCxnSpPr>
         <p:spPr>
           <a:xfrm rot="10800000">
-            <a:off x="11881654" y="18364200"/>
+            <a:off x="11881654" y="18613590"/>
             <a:ext cx="5205043" cy="505198"/>
           </a:xfrm>
           <a:prstGeom prst="bentConnector2">
@@ -27414,7 +27843,7 @@
         </p:nvSpPr>
         <p:spPr bwMode="auto">
           <a:xfrm>
-            <a:off x="16787192" y="17891761"/>
+            <a:off x="16787192" y="18141151"/>
             <a:ext cx="3054398" cy="331303"/>
           </a:xfrm>
           <a:prstGeom prst="flowChartPreparation">
@@ -27583,7 +28012,7 @@
         </p:nvSpPr>
         <p:spPr>
           <a:xfrm>
-            <a:off x="16434418" y="18560072"/>
+            <a:off x="16434418" y="18809462"/>
             <a:ext cx="820736" cy="276999"/>
           </a:xfrm>
           <a:prstGeom prst="rect">
@@ -27634,7 +28063,7 @@
         </p:nvSpPr>
         <p:spPr>
           <a:xfrm>
-            <a:off x="4465082" y="1605230"/>
+            <a:off x="3642122" y="1605230"/>
             <a:ext cx="4574118" cy="676459"/>
           </a:xfrm>
           <a:prstGeom prst="roundRect">
@@ -27784,7 +28213,7 @@
         </p:nvSpPr>
         <p:spPr>
           <a:xfrm>
-            <a:off x="4585521" y="3523181"/>
+            <a:off x="3762561" y="3523181"/>
             <a:ext cx="4330938" cy="449561"/>
           </a:xfrm>
           <a:prstGeom prst="roundRect">
@@ -27876,7 +28305,7 @@
         </p:nvCxnSpPr>
         <p:spPr>
           <a:xfrm>
-            <a:off x="6750990" y="3222566"/>
+            <a:off x="5928030" y="3222566"/>
             <a:ext cx="0" cy="300615"/>
           </a:xfrm>
           <a:prstGeom prst="straightConnector1">
@@ -27907,7 +28336,7 @@
         </p:nvSpPr>
         <p:spPr>
           <a:xfrm>
-            <a:off x="4585521" y="2594703"/>
+            <a:off x="3762561" y="2594703"/>
             <a:ext cx="4330938" cy="627863"/>
           </a:xfrm>
           <a:prstGeom prst="roundRect">
@@ -28039,7 +28468,7 @@
         </p:nvCxnSpPr>
         <p:spPr>
           <a:xfrm flipH="1">
-            <a:off x="6750990" y="2281689"/>
+            <a:off x="5928030" y="2281689"/>
             <a:ext cx="1151" cy="313014"/>
           </a:xfrm>
           <a:prstGeom prst="straightConnector1">
@@ -28160,8 +28589,8 @@
         </p:nvSpPr>
         <p:spPr>
           <a:xfrm>
-            <a:off x="17330564" y="15333306"/>
-            <a:ext cx="820736" cy="338554"/>
+            <a:off x="17621794" y="15333306"/>
+            <a:ext cx="529505" cy="276999"/>
           </a:xfrm>
           <a:prstGeom prst="rect">
             <a:avLst/>
@@ -28178,7 +28607,7 @@
               <a:defRPr/>
             </a:pPr>
             <a:r>
-              <a:rPr lang="en-US" sz="1600" dirty="0">
+              <a:rPr lang="en-US" sz="1200" dirty="0">
                 <a:solidFill>
                   <a:prstClr val="black">
                     <a:lumMod val="50000"/>
@@ -28188,7 +28617,7 @@
               </a:rPr>
               <a:t>Yes</a:t>
             </a:r>
-            <a:endParaRPr lang="en-US" sz="1600" dirty="0">
+            <a:endParaRPr lang="en-US" sz="1200" dirty="0">
               <a:solidFill>
                 <a:prstClr val="black"/>
               </a:solidFill>
@@ -28380,7 +28809,7 @@
                 <a:ea typeface="+mn-ea"/>
                 <a:cs typeface="+mn-cs"/>
               </a:rPr>
-              <a:t>  N_ITEMS_TO_PASS</a:t>
+              <a:t>  ID_FIELD, EXPECTED_FIELD, N_ITEMS_TO_PASS</a:t>
             </a:r>
           </a:p>
           <a:p>
@@ -28564,7 +28993,7 @@
         </p:nvCxnSpPr>
         <p:spPr>
           <a:xfrm>
-            <a:off x="18313924" y="17583638"/>
+            <a:off x="18313924" y="17833028"/>
             <a:ext cx="467" cy="308123"/>
           </a:xfrm>
           <a:prstGeom prst="straightConnector1">
@@ -28853,7 +29282,7 @@
         </p:nvSpPr>
         <p:spPr bwMode="auto">
           <a:xfrm>
-            <a:off x="17003769" y="16002000"/>
+            <a:off x="17003769" y="15872460"/>
             <a:ext cx="2619040" cy="331303"/>
           </a:xfrm>
           <a:prstGeom prst="flowChartPreparation">
@@ -28927,7 +29356,7 @@
                 <a:ea typeface="+mn-ea"/>
                 <a:cs typeface="+mn-cs"/>
               </a:rPr>
-              <a:t>: Does it pass the examples + N tests?</a:t>
+              <a:t>: Does it pass the BRD examples test?</a:t>
             </a:r>
           </a:p>
         </p:txBody>
@@ -29377,7 +29806,7 @@
         <p:spPr>
           <a:xfrm rot="10800000" flipH="1" flipV="1">
             <a:off x="12420598" y="11746725"/>
-            <a:ext cx="4366593" cy="6310687"/>
+            <a:ext cx="4366593" cy="6560077"/>
           </a:xfrm>
           <a:prstGeom prst="bentConnector3">
             <a:avLst>
@@ -29504,7 +29933,7 @@
         <p:spPr>
           <a:xfrm rot="10800000" flipH="1" flipV="1">
             <a:off x="13200044" y="13014073"/>
-            <a:ext cx="3587148" cy="5043339"/>
+            <a:ext cx="3587148" cy="5292729"/>
           </a:xfrm>
           <a:prstGeom prst="bentConnector3">
             <a:avLst>
@@ -29700,6 +30129,482 @@
           <a:effectLst/>
         </p:spPr>
       </p:cxnSp>
+      <p:sp>
+        <p:nvSpPr>
+          <p:cNvPr id="169" name="Flowchart: Preparation 168">
+            <a:extLst>
+              <a:ext uri="{FF2B5EF4-FFF2-40B4-BE49-F238E27FC236}">
+                <a16:creationId xmlns:a16="http://schemas.microsoft.com/office/drawing/2014/main" id="{45B5BACE-5E75-DB60-BB3C-CEFD60FA53CF}"/>
+              </a:ext>
+            </a:extLst>
+          </p:cNvPr>
+          <p:cNvSpPr/>
+          <p:nvPr/>
+        </p:nvSpPr>
+        <p:spPr bwMode="auto">
+          <a:xfrm>
+            <a:off x="16786662" y="16818238"/>
+            <a:ext cx="3065734" cy="331303"/>
+          </a:xfrm>
+          <a:prstGeom prst="flowChartPreparation">
+            <a:avLst/>
+          </a:prstGeom>
+          <a:noFill/>
+          <a:ln w="12700" cap="sq" cmpd="sng" algn="ctr">
+            <a:solidFill>
+              <a:srgbClr val="4F5759">
+                <a:lumMod val="50000"/>
+              </a:srgbClr>
+            </a:solidFill>
+            <a:prstDash val="solid"/>
+          </a:ln>
+          <a:effectLst/>
+        </p:spPr>
+        <p:txBody>
+          <a:bodyPr rtlCol="0" anchor="ctr"/>
+          <a:lstStyle/>
+          <a:p>
+            <a:pPr lvl="0" algn="ctr" defTabSz="914400">
+              <a:defRPr/>
+            </a:pPr>
+            <a:r>
+              <a:rPr kumimoji="0" lang="en-US" sz="1000" b="0" i="0" u="none" strike="noStrike" kern="0" cap="none" spc="0" normalizeH="0" baseline="0" noProof="0" dirty="0" err="1">
+                <a:ln>
+                  <a:noFill/>
+                </a:ln>
+                <a:solidFill>
+                  <a:prstClr val="black">
+                    <a:lumMod val="50000"/>
+                  </a:prstClr>
+                </a:solidFill>
+                <a:effectLst/>
+                <a:uLnTx/>
+                <a:uFillTx/>
+                <a:latin typeface="Arial"/>
+                <a:ea typeface="+mn-ea"/>
+                <a:cs typeface="+mn-cs"/>
+              </a:rPr>
+              <a:t>Test_Run</a:t>
+            </a:r>
+            <a:r>
+              <a:rPr kumimoji="0" lang="en-US" sz="1000" b="0" i="0" u="none" strike="noStrike" kern="0" cap="none" spc="0" normalizeH="0" baseline="0" noProof="0" dirty="0">
+                <a:ln>
+                  <a:noFill/>
+                </a:ln>
+                <a:solidFill>
+                  <a:prstClr val="black">
+                    <a:lumMod val="50000"/>
+                  </a:prstClr>
+                </a:solidFill>
+                <a:effectLst/>
+                <a:uLnTx/>
+                <a:uFillTx/>
+                <a:latin typeface="Arial"/>
+                <a:ea typeface="+mn-ea"/>
+                <a:cs typeface="+mn-cs"/>
+              </a:rPr>
+              <a:t>: Does it pass the </a:t>
+            </a:r>
+            <a:r>
+              <a:rPr lang="en-US" sz="1000" kern="0" dirty="0">
+                <a:solidFill>
+                  <a:prstClr val="black">
+                    <a:lumMod val="50000"/>
+                  </a:prstClr>
+                </a:solidFill>
+                <a:latin typeface="Arial"/>
+              </a:rPr>
+              <a:t>N_ITEMS_TO_PASS</a:t>
+            </a:r>
+            <a:r>
+              <a:rPr kumimoji="0" lang="en-US" sz="1000" b="0" i="0" u="none" strike="noStrike" kern="0" cap="none" spc="0" normalizeH="0" baseline="0" noProof="0" dirty="0">
+                <a:ln>
+                  <a:noFill/>
+                </a:ln>
+                <a:solidFill>
+                  <a:prstClr val="black">
+                    <a:lumMod val="50000"/>
+                  </a:prstClr>
+                </a:solidFill>
+                <a:effectLst/>
+                <a:uLnTx/>
+                <a:uFillTx/>
+                <a:latin typeface="Arial"/>
+                <a:ea typeface="+mn-ea"/>
+                <a:cs typeface="+mn-cs"/>
+              </a:rPr>
+              <a:t> test?</a:t>
+            </a:r>
+          </a:p>
+        </p:txBody>
+      </p:sp>
+      <p:cxnSp>
+        <p:nvCxnSpPr>
+          <p:cNvPr id="173" name="Connector: Elbow 87">
+            <a:extLst>
+              <a:ext uri="{FF2B5EF4-FFF2-40B4-BE49-F238E27FC236}">
+                <a16:creationId xmlns:a16="http://schemas.microsoft.com/office/drawing/2014/main" id="{D84BBED4-F848-E6B6-AA6F-C6419EA0C04A}"/>
+              </a:ext>
+            </a:extLst>
+          </p:cNvPr>
+          <p:cNvCxnSpPr>
+            <a:cxnSpLocks/>
+            <a:stCxn id="169" idx="2"/>
+          </p:cNvCxnSpPr>
+          <p:nvPr/>
+        </p:nvCxnSpPr>
+        <p:spPr>
+          <a:xfrm flipH="1">
+            <a:off x="18312856" y="17149541"/>
+            <a:ext cx="6673" cy="392482"/>
+          </a:xfrm>
+          <a:prstGeom prst="straightConnector1">
+            <a:avLst/>
+          </a:prstGeom>
+          <a:noFill/>
+          <a:ln w="76200" cap="sq" cmpd="sng" algn="ctr">
+            <a:solidFill>
+              <a:srgbClr val="006297"/>
+            </a:solidFill>
+            <a:prstDash val="solid"/>
+            <a:tailEnd type="triangle"/>
+          </a:ln>
+          <a:effectLst/>
+        </p:spPr>
+      </p:cxnSp>
+      <p:sp>
+        <p:nvSpPr>
+          <p:cNvPr id="178" name="TextBox 177">
+            <a:extLst>
+              <a:ext uri="{FF2B5EF4-FFF2-40B4-BE49-F238E27FC236}">
+                <a16:creationId xmlns:a16="http://schemas.microsoft.com/office/drawing/2014/main" id="{F836A25F-ECCB-CADD-A312-90E74D438996}"/>
+              </a:ext>
+            </a:extLst>
+          </p:cNvPr>
+          <p:cNvSpPr txBox="1"/>
+          <p:nvPr/>
+        </p:nvSpPr>
+        <p:spPr>
+          <a:xfrm>
+            <a:off x="17738568" y="17171153"/>
+            <a:ext cx="529505" cy="276999"/>
+          </a:xfrm>
+          <a:prstGeom prst="rect">
+            <a:avLst/>
+          </a:prstGeom>
+          <a:noFill/>
+        </p:spPr>
+        <p:txBody>
+          <a:bodyPr wrap="square">
+            <a:spAutoFit/>
+          </a:bodyPr>
+          <a:lstStyle/>
+          <a:p>
+            <a:pPr algn="ctr" defTabSz="914400">
+              <a:defRPr/>
+            </a:pPr>
+            <a:r>
+              <a:rPr lang="en-US" sz="1200" dirty="0">
+                <a:solidFill>
+                  <a:prstClr val="black">
+                    <a:lumMod val="50000"/>
+                  </a:prstClr>
+                </a:solidFill>
+                <a:latin typeface="Arial"/>
+              </a:rPr>
+              <a:t>Yes</a:t>
+            </a:r>
+            <a:endParaRPr lang="en-US" sz="1200" dirty="0">
+              <a:solidFill>
+                <a:prstClr val="black"/>
+              </a:solidFill>
+              <a:latin typeface="Arial"/>
+            </a:endParaRPr>
+          </a:p>
+        </p:txBody>
+      </p:sp>
+      <p:cxnSp>
+        <p:nvCxnSpPr>
+          <p:cNvPr id="180" name="Connector: Elbow 179">
+            <a:extLst>
+              <a:ext uri="{FF2B5EF4-FFF2-40B4-BE49-F238E27FC236}">
+                <a16:creationId xmlns:a16="http://schemas.microsoft.com/office/drawing/2014/main" id="{F963A72C-4A8E-BBFE-0674-5EA1411A3275}"/>
+              </a:ext>
+            </a:extLst>
+          </p:cNvPr>
+          <p:cNvCxnSpPr>
+            <a:cxnSpLocks/>
+            <a:stCxn id="169" idx="3"/>
+            <a:endCxn id="41" idx="0"/>
+          </p:cNvCxnSpPr>
+          <p:nvPr/>
+        </p:nvCxnSpPr>
+        <p:spPr>
+          <a:xfrm>
+            <a:off x="19852396" y="16983890"/>
+            <a:ext cx="2819521" cy="5885994"/>
+          </a:xfrm>
+          <a:prstGeom prst="bentConnector2">
+            <a:avLst/>
+          </a:prstGeom>
+          <a:noFill/>
+          <a:ln w="76200" cap="sq" cmpd="sng" algn="ctr">
+            <a:solidFill>
+              <a:srgbClr val="006297"/>
+            </a:solidFill>
+            <a:prstDash val="solid"/>
+            <a:tailEnd type="triangle"/>
+          </a:ln>
+          <a:effectLst/>
+        </p:spPr>
+      </p:cxnSp>
+      <p:sp>
+        <p:nvSpPr>
+          <p:cNvPr id="183" name="TextBox 182">
+            <a:extLst>
+              <a:ext uri="{FF2B5EF4-FFF2-40B4-BE49-F238E27FC236}">
+                <a16:creationId xmlns:a16="http://schemas.microsoft.com/office/drawing/2014/main" id="{173415F7-DF5F-69E6-5E0A-FE99A5D5C93E}"/>
+              </a:ext>
+            </a:extLst>
+          </p:cNvPr>
+          <p:cNvSpPr txBox="1"/>
+          <p:nvPr/>
+        </p:nvSpPr>
+        <p:spPr>
+          <a:xfrm>
+            <a:off x="19668870" y="16982208"/>
+            <a:ext cx="2487894" cy="830997"/>
+          </a:xfrm>
+          <a:prstGeom prst="rect">
+            <a:avLst/>
+          </a:prstGeom>
+          <a:noFill/>
+        </p:spPr>
+        <p:txBody>
+          <a:bodyPr wrap="square">
+            <a:spAutoFit/>
+          </a:bodyPr>
+          <a:lstStyle/>
+          <a:p>
+            <a:pPr algn="ctr" defTabSz="914400">
+              <a:defRPr/>
+            </a:pPr>
+            <a:r>
+              <a:rPr lang="en-US" sz="1200" dirty="0">
+                <a:solidFill>
+                  <a:prstClr val="black">
+                    <a:lumMod val="50000"/>
+                  </a:prstClr>
+                </a:solidFill>
+                <a:latin typeface="Arial"/>
+              </a:rPr>
+              <a:t>This goes to </a:t>
+            </a:r>
+            <a:r>
+              <a:rPr lang="en-US" sz="1200" dirty="0" err="1">
+                <a:solidFill>
+                  <a:prstClr val="black">
+                    <a:lumMod val="50000"/>
+                  </a:prstClr>
+                </a:solidFill>
+                <a:latin typeface="Arial"/>
+              </a:rPr>
+              <a:t>humnan</a:t>
+            </a:r>
+            <a:r>
+              <a:rPr lang="en-US" sz="1200" dirty="0">
+                <a:solidFill>
+                  <a:prstClr val="black">
+                    <a:lumMod val="50000"/>
+                  </a:prstClr>
+                </a:solidFill>
+                <a:latin typeface="Arial"/>
+              </a:rPr>
+              <a:t> escalation, since either the LLM is cheating or the examples in BRD is not covering all real job cases.</a:t>
+            </a:r>
+            <a:endParaRPr lang="en-US" sz="1200" dirty="0">
+              <a:solidFill>
+                <a:prstClr val="black"/>
+              </a:solidFill>
+              <a:latin typeface="Arial"/>
+            </a:endParaRPr>
+          </a:p>
+        </p:txBody>
+      </p:sp>
+      <p:sp>
+        <p:nvSpPr>
+          <p:cNvPr id="184" name="TextBox 183">
+            <a:extLst>
+              <a:ext uri="{FF2B5EF4-FFF2-40B4-BE49-F238E27FC236}">
+                <a16:creationId xmlns:a16="http://schemas.microsoft.com/office/drawing/2014/main" id="{44B30D09-1C01-3CCA-4C85-1801DD1D151F}"/>
+              </a:ext>
+            </a:extLst>
+          </p:cNvPr>
+          <p:cNvSpPr txBox="1"/>
+          <p:nvPr/>
+        </p:nvSpPr>
+        <p:spPr>
+          <a:xfrm>
+            <a:off x="19751756" y="16682315"/>
+            <a:ext cx="820736" cy="338554"/>
+          </a:xfrm>
+          <a:prstGeom prst="rect">
+            <a:avLst/>
+          </a:prstGeom>
+          <a:noFill/>
+        </p:spPr>
+        <p:txBody>
+          <a:bodyPr wrap="square">
+            <a:spAutoFit/>
+          </a:bodyPr>
+          <a:lstStyle/>
+          <a:p>
+            <a:pPr algn="ctr" defTabSz="914400">
+              <a:defRPr/>
+            </a:pPr>
+            <a:r>
+              <a:rPr lang="en-US" sz="1600" dirty="0">
+                <a:solidFill>
+                  <a:prstClr val="black">
+                    <a:lumMod val="50000"/>
+                  </a:prstClr>
+                </a:solidFill>
+                <a:latin typeface="Arial"/>
+              </a:rPr>
+              <a:t>No</a:t>
+            </a:r>
+            <a:endParaRPr lang="en-US" sz="1600" dirty="0">
+              <a:solidFill>
+                <a:prstClr val="black"/>
+              </a:solidFill>
+              <a:latin typeface="Arial"/>
+            </a:endParaRPr>
+          </a:p>
+        </p:txBody>
+      </p:sp>
+      <p:cxnSp>
+        <p:nvCxnSpPr>
+          <p:cNvPr id="166" name="Connector: Elbow 87">
+            <a:extLst>
+              <a:ext uri="{FF2B5EF4-FFF2-40B4-BE49-F238E27FC236}">
+                <a16:creationId xmlns:a16="http://schemas.microsoft.com/office/drawing/2014/main" id="{29BDAEC3-B0F1-2AD5-D395-42FF5665ADAB}"/>
+              </a:ext>
+            </a:extLst>
+          </p:cNvPr>
+          <p:cNvCxnSpPr>
+            <a:cxnSpLocks/>
+            <a:stCxn id="44" idx="3"/>
+            <a:endCxn id="118" idx="1"/>
+          </p:cNvCxnSpPr>
+          <p:nvPr/>
+        </p:nvCxnSpPr>
+        <p:spPr>
+          <a:xfrm flipV="1">
+            <a:off x="19841590" y="22327926"/>
+            <a:ext cx="696949" cy="585"/>
+          </a:xfrm>
+          <a:prstGeom prst="straightConnector1">
+            <a:avLst/>
+          </a:prstGeom>
+          <a:noFill/>
+          <a:ln w="76200" cap="sq" cmpd="sng" algn="ctr">
+            <a:solidFill>
+              <a:srgbClr val="006297"/>
+            </a:solidFill>
+            <a:prstDash val="solid"/>
+            <a:tailEnd type="triangle"/>
+          </a:ln>
+          <a:effectLst/>
+        </p:spPr>
+      </p:cxnSp>
+      <p:sp>
+        <p:nvSpPr>
+          <p:cNvPr id="118" name="Rectangle: Rounded Corners 117">
+            <a:extLst>
+              <a:ext uri="{FF2B5EF4-FFF2-40B4-BE49-F238E27FC236}">
+                <a16:creationId xmlns:a16="http://schemas.microsoft.com/office/drawing/2014/main" id="{EA6F7C5F-6F23-F607-F50F-0828F4266A53}"/>
+              </a:ext>
+            </a:extLst>
+          </p:cNvPr>
+          <p:cNvSpPr/>
+          <p:nvPr/>
+        </p:nvSpPr>
+        <p:spPr>
+          <a:xfrm>
+            <a:off x="20538539" y="21957078"/>
+            <a:ext cx="1762308" cy="741695"/>
+          </a:xfrm>
+          <a:prstGeom prst="roundRect">
+            <a:avLst/>
+          </a:prstGeom>
+          <a:noFill/>
+          <a:ln w="12700" cap="sq" cmpd="sng" algn="ctr">
+            <a:solidFill>
+              <a:srgbClr val="4F5759">
+                <a:lumMod val="50000"/>
+              </a:srgbClr>
+            </a:solidFill>
+            <a:prstDash val="solid"/>
+          </a:ln>
+          <a:effectLst/>
+        </p:spPr>
+        <p:txBody>
+          <a:bodyPr rtlCol="0" anchor="ctr"/>
+          <a:lstStyle/>
+          <a:p>
+            <a:pPr marL="0" marR="0" lvl="0" indent="0" algn="ctr" defTabSz="914400" eaLnBrk="1" fontAlgn="auto" latinLnBrk="0" hangingPunct="1">
+              <a:lnSpc>
+                <a:spcPct val="100000"/>
+              </a:lnSpc>
+              <a:spcBef>
+                <a:spcPts val="0"/>
+              </a:spcBef>
+              <a:spcAft>
+                <a:spcPts val="0"/>
+              </a:spcAft>
+              <a:buClrTx/>
+              <a:buSzTx/>
+              <a:buFontTx/>
+              <a:buNone/>
+              <a:tabLst/>
+              <a:defRPr/>
+            </a:pPr>
+            <a:r>
+              <a:rPr kumimoji="0" lang="en-US" sz="1050" b="0" i="0" u="none" strike="noStrike" kern="0" cap="none" spc="0" normalizeH="0" baseline="0" noProof="0" dirty="0">
+                <a:ln>
+                  <a:noFill/>
+                </a:ln>
+                <a:solidFill>
+                  <a:prstClr val="black">
+                    <a:lumMod val="50000"/>
+                  </a:prstClr>
+                </a:solidFill>
+                <a:effectLst/>
+                <a:uLnTx/>
+                <a:uFillTx/>
+                <a:latin typeface="Arial"/>
+                <a:ea typeface="+mn-ea"/>
+                <a:cs typeface="+mn-cs"/>
+              </a:rPr>
+              <a:t>Make a quarantine note in memory and registry for this function</a:t>
+            </a:r>
+            <a:endParaRPr kumimoji="0" lang="en-US" sz="1050" b="0" i="0" u="none" strike="noStrike" kern="0" cap="none" spc="0" normalizeH="0" baseline="0" noProof="0" dirty="0">
+              <a:ln>
+                <a:noFill/>
+              </a:ln>
+              <a:solidFill>
+                <a:prstClr val="white"/>
+              </a:solidFill>
+              <a:effectLst/>
+              <a:uLnTx/>
+              <a:uFillTx/>
+              <a:latin typeface="Arial"/>
+              <a:ea typeface="+mn-ea"/>
+              <a:cs typeface="+mn-cs"/>
+            </a:endParaRPr>
+          </a:p>
+        </p:txBody>
+      </p:sp>
     </p:spTree>
     <p:extLst>
       <p:ext uri="{BB962C8B-B14F-4D97-AF65-F5344CB8AC3E}">
@@ -31177,35 +32082,14 @@
           <a:p>
             <a:pPr algn="ctr"/>
             <a:r>
-              <a:rPr lang="en-US" sz="5940" b="1" dirty="0">
-                <a:solidFill>
-                  <a:srgbClr val="2766EC"/>
+              <a:rPr lang="en-US" sz="8000" b="1" dirty="0">
+                <a:solidFill>
+                  <a:srgbClr val="2563EB"/>
                 </a:solidFill>
                 <a:latin typeface="Aptos" pitchFamily="34" charset="0"/>
-                <a:ea typeface="Aptos" pitchFamily="34" charset="-122"/>
-                <a:cs typeface="Aptos" pitchFamily="34" charset="-120"/>
-              </a:rPr>
-              <a:t>Future implementation direction </a:t>
-            </a:r>
-            <a:r>
-              <a:rPr lang="en-US" sz="5940" b="1">
-                <a:solidFill>
-                  <a:srgbClr val="2766EC"/>
-                </a:solidFill>
-                <a:latin typeface="Aptos" pitchFamily="34" charset="0"/>
-                <a:ea typeface="Aptos" pitchFamily="34" charset="-122"/>
-                <a:cs typeface="Aptos" pitchFamily="34" charset="-120"/>
-              </a:rPr>
-              <a:t>– 2</a:t>
-            </a:r>
-            <a:endParaRPr lang="en-US" sz="5940" b="1" dirty="0">
-              <a:solidFill>
-                <a:srgbClr val="2766EC"/>
-              </a:solidFill>
-              <a:latin typeface="Aptos" pitchFamily="34" charset="0"/>
-              <a:ea typeface="Aptos" pitchFamily="34" charset="-122"/>
-              <a:cs typeface="Aptos" pitchFamily="34" charset="-120"/>
-            </a:endParaRPr>
+              </a:rPr>
+              <a:t>Future implementation direction – 2</a:t>
+            </a:r>
           </a:p>
         </p:txBody>
       </p:sp>
@@ -32612,6 +33496,1424 @@
               <a:t>Design rule: BRD-scoped tools control permissions; sandbox isolation contains unexpected code behavior. Both are needed.</a:t>
             </a:r>
             <a:endParaRPr lang="en-US" sz="4158" dirty="0"/>
+          </a:p>
+        </p:txBody>
+      </p:sp>
+    </p:spTree>
+  </p:cSld>
+  <p:clrMapOvr>
+    <a:masterClrMapping/>
+  </p:clrMapOvr>
+</p:sld>
+</file>
+
+<file path=ppt/slides/slide9.xml><?xml version="1.0" encoding="utf-8"?>
+<p:sld xmlns:a="http://schemas.openxmlformats.org/drawingml/2006/main" xmlns:r="http://schemas.openxmlformats.org/officeDocument/2006/relationships" xmlns:p="http://schemas.openxmlformats.org/presentationml/2006/main">
+  <p:cSld>
+    <p:spTree>
+      <p:nvGrpSpPr>
+        <p:cNvPr id="1" name=""/>
+        <p:cNvGrpSpPr/>
+        <p:nvPr/>
+      </p:nvGrpSpPr>
+      <p:grpSpPr>
+        <a:xfrm>
+          <a:off x="0" y="0"/>
+          <a:ext cx="0" cy="0"/>
+          <a:chOff x="0" y="0"/>
+          <a:chExt cx="0" cy="0"/>
+        </a:xfrm>
+      </p:grpSpPr>
+      <p:sp>
+        <p:nvSpPr>
+          <p:cNvPr id="2" name="Shape 0"/>
+          <p:cNvSpPr/>
+          <p:nvPr/>
+        </p:nvSpPr>
+        <p:spPr>
+          <a:xfrm>
+            <a:off x="0" y="0"/>
+            <a:ext cx="43891200" cy="1415491"/>
+          </a:xfrm>
+          <a:prstGeom prst="rect">
+            <a:avLst/>
+          </a:prstGeom>
+          <a:solidFill>
+            <a:srgbClr val="EDFAF7"/>
+          </a:solidFill>
+          <a:ln w="7620">
+            <a:solidFill>
+              <a:srgbClr val="A7B7BC"/>
+            </a:solidFill>
+            <a:prstDash val="solid"/>
+          </a:ln>
+        </p:spPr>
+        <p:txBody>
+          <a:bodyPr/>
+          <a:lstStyle/>
+          <a:p>
+            <a:endParaRPr lang="en-US" sz="6480"/>
+          </a:p>
+        </p:txBody>
+      </p:sp>
+      <p:sp>
+        <p:nvSpPr>
+          <p:cNvPr id="3" name="Text 1"/>
+          <p:cNvSpPr/>
+          <p:nvPr/>
+        </p:nvSpPr>
+        <p:spPr>
+          <a:xfrm>
+            <a:off x="1316736" y="49377"/>
+            <a:ext cx="41257728" cy="1283818"/>
+          </a:xfrm>
+          <a:prstGeom prst="rect">
+            <a:avLst/>
+          </a:prstGeom>
+          <a:noFill/>
+          <a:ln/>
+        </p:spPr>
+        <p:txBody>
+          <a:bodyPr wrap="square" lIns="0" tIns="0" rIns="0" bIns="0" rtlCol="0" anchor="ctr"/>
+          <a:lstStyle/>
+          <a:p>
+            <a:pPr algn="ctr"/>
+            <a:r>
+              <a:rPr lang="en-US" sz="8000" b="1" dirty="0">
+                <a:solidFill>
+                  <a:srgbClr val="2563EB"/>
+                </a:solidFill>
+                <a:latin typeface="Aptos" pitchFamily="34" charset="0"/>
+              </a:rPr>
+              <a:t>Future implementation direction – 3</a:t>
+            </a:r>
+          </a:p>
+        </p:txBody>
+      </p:sp>
+      <p:sp>
+        <p:nvSpPr>
+          <p:cNvPr id="4" name="Text 2"/>
+          <p:cNvSpPr/>
+          <p:nvPr/>
+        </p:nvSpPr>
+        <p:spPr>
+          <a:xfrm>
+            <a:off x="1909267" y="2337206"/>
+            <a:ext cx="40489632" cy="1645920"/>
+          </a:xfrm>
+          <a:prstGeom prst="rect">
+            <a:avLst/>
+          </a:prstGeom>
+          <a:noFill/>
+          <a:ln/>
+        </p:spPr>
+        <p:txBody>
+          <a:bodyPr wrap="square" lIns="0" tIns="0" rIns="0" bIns="0" rtlCol="0" anchor="ctr"/>
+          <a:lstStyle/>
+          <a:p>
+            <a:r>
+              <a:rPr lang="en-US" sz="9648" b="1" dirty="0">
+                <a:solidFill>
+                  <a:srgbClr val="10192D"/>
+                </a:solidFill>
+                <a:latin typeface="Aptos" pitchFamily="34" charset="0"/>
+                <a:ea typeface="Aptos" pitchFamily="34" charset="-122"/>
+                <a:cs typeface="Aptos" pitchFamily="34" charset="-120"/>
+              </a:rPr>
+              <a:t>Defending against deliberately deceptive generated functions</a:t>
+            </a:r>
+            <a:endParaRPr lang="en-US" sz="9648" dirty="0"/>
+          </a:p>
+        </p:txBody>
+      </p:sp>
+      <p:sp>
+        <p:nvSpPr>
+          <p:cNvPr id="5" name="Text 3"/>
+          <p:cNvSpPr/>
+          <p:nvPr/>
+        </p:nvSpPr>
+        <p:spPr>
+          <a:xfrm>
+            <a:off x="1942186" y="4575656"/>
+            <a:ext cx="23340974" cy="1840383"/>
+          </a:xfrm>
+          <a:prstGeom prst="rect">
+            <a:avLst/>
+          </a:prstGeom>
+          <a:noFill/>
+          <a:ln/>
+        </p:spPr>
+        <p:txBody>
+          <a:bodyPr wrap="square" lIns="0" tIns="0" rIns="0" bIns="0" rtlCol="0" anchor="ctr"/>
+          <a:lstStyle/>
+          <a:p>
+            <a:pPr marL="685800" indent="-685800">
+              <a:buFont typeface="Arial" panose="020B0604020202020204" pitchFamily="34" charset="0"/>
+              <a:buChar char="•"/>
+            </a:pPr>
+            <a:r>
+              <a:rPr lang="en-US" sz="4500" dirty="0">
+                <a:solidFill>
+                  <a:srgbClr val="475569"/>
+                </a:solidFill>
+                <a:highlight>
+                  <a:srgbClr val="FFFF00"/>
+                </a:highlight>
+                <a:latin typeface="Aptos" pitchFamily="34" charset="0"/>
+                <a:ea typeface="Aptos" pitchFamily="34" charset="-122"/>
+                <a:cs typeface="Aptos" pitchFamily="34" charset="-120"/>
+              </a:rPr>
+              <a:t>Current program prevents ordinary LLM coding mistakes. </a:t>
+            </a:r>
+          </a:p>
+          <a:p>
+            <a:pPr marL="685800" indent="-685800">
+              <a:buFont typeface="Arial" panose="020B0604020202020204" pitchFamily="34" charset="0"/>
+              <a:buChar char="•"/>
+            </a:pPr>
+            <a:r>
+              <a:rPr lang="en-US" sz="4500" dirty="0">
+                <a:solidFill>
+                  <a:srgbClr val="475569"/>
+                </a:solidFill>
+                <a:highlight>
+                  <a:srgbClr val="FFFF00"/>
+                </a:highlight>
+                <a:latin typeface="Aptos" pitchFamily="34" charset="0"/>
+                <a:ea typeface="Aptos" pitchFamily="34" charset="-122"/>
+                <a:cs typeface="Aptos" pitchFamily="34" charset="-120"/>
+              </a:rPr>
+              <a:t>A future </a:t>
+            </a:r>
+            <a:r>
+              <a:rPr lang="en-US" sz="4500" b="1" dirty="0">
+                <a:solidFill>
+                  <a:srgbClr val="475569"/>
+                </a:solidFill>
+                <a:highlight>
+                  <a:srgbClr val="FFFF00"/>
+                </a:highlight>
+                <a:latin typeface="Aptos" pitchFamily="34" charset="0"/>
+                <a:ea typeface="Aptos" pitchFamily="34" charset="-122"/>
+                <a:cs typeface="Aptos" pitchFamily="34" charset="-120"/>
+              </a:rPr>
+              <a:t>adversarial</a:t>
+            </a:r>
+            <a:r>
+              <a:rPr lang="en-US" sz="4500" dirty="0">
+                <a:solidFill>
+                  <a:srgbClr val="475569"/>
+                </a:solidFill>
+                <a:highlight>
+                  <a:srgbClr val="FFFF00"/>
+                </a:highlight>
+                <a:latin typeface="Aptos" pitchFamily="34" charset="0"/>
+                <a:ea typeface="Aptos" pitchFamily="34" charset="-122"/>
+                <a:cs typeface="Aptos" pitchFamily="34" charset="-120"/>
+              </a:rPr>
+              <a:t> defense must also prevent intentional cheating.</a:t>
+            </a:r>
+            <a:endParaRPr lang="en-US" sz="4500" dirty="0">
+              <a:highlight>
+                <a:srgbClr val="FFFF00"/>
+              </a:highlight>
+            </a:endParaRPr>
+          </a:p>
+        </p:txBody>
+      </p:sp>
+      <p:sp>
+        <p:nvSpPr>
+          <p:cNvPr id="8" name="Text 6"/>
+          <p:cNvSpPr/>
+          <p:nvPr/>
+        </p:nvSpPr>
+        <p:spPr>
+          <a:xfrm>
+            <a:off x="1889760" y="8574634"/>
+            <a:ext cx="39502080" cy="954634"/>
+          </a:xfrm>
+          <a:prstGeom prst="rect">
+            <a:avLst/>
+          </a:prstGeom>
+          <a:noFill/>
+          <a:ln/>
+        </p:spPr>
+        <p:txBody>
+          <a:bodyPr wrap="square" lIns="0" tIns="0" rIns="0" bIns="0" rtlCol="0" anchor="ctr"/>
+          <a:lstStyle/>
+          <a:p>
+            <a:r>
+              <a:rPr lang="en-US" sz="6000" b="1" dirty="0">
+                <a:solidFill>
+                  <a:srgbClr val="2766EC"/>
+                </a:solidFill>
+                <a:latin typeface="Aptos" pitchFamily="34" charset="0"/>
+                <a:ea typeface="Aptos" pitchFamily="34" charset="-122"/>
+                <a:cs typeface="Aptos" pitchFamily="34" charset="-120"/>
+              </a:rPr>
+              <a:t>Hypothetical Cheating Path</a:t>
+            </a:r>
+            <a:endParaRPr lang="en-US" sz="6000" dirty="0"/>
+          </a:p>
+        </p:txBody>
+      </p:sp>
+      <p:sp>
+        <p:nvSpPr>
+          <p:cNvPr id="9" name="Shape 7"/>
+          <p:cNvSpPr/>
+          <p:nvPr/>
+        </p:nvSpPr>
+        <p:spPr>
+          <a:xfrm>
+            <a:off x="1909267" y="10269931"/>
+            <a:ext cx="8460029" cy="5036515"/>
+          </a:xfrm>
+          <a:prstGeom prst="rect">
+            <a:avLst/>
+          </a:prstGeom>
+          <a:solidFill>
+            <a:srgbClr val="DBEAFE"/>
+          </a:solidFill>
+          <a:ln w="13335">
+            <a:solidFill>
+              <a:srgbClr val="3977FF"/>
+            </a:solidFill>
+            <a:prstDash val="solid"/>
+          </a:ln>
+        </p:spPr>
+        <p:txBody>
+          <a:bodyPr/>
+          <a:lstStyle/>
+          <a:p>
+            <a:endParaRPr lang="en-US" sz="6480"/>
+          </a:p>
+        </p:txBody>
+      </p:sp>
+      <p:sp>
+        <p:nvSpPr>
+          <p:cNvPr id="10" name="Text 8"/>
+          <p:cNvSpPr/>
+          <p:nvPr/>
+        </p:nvSpPr>
+        <p:spPr>
+          <a:xfrm>
+            <a:off x="2304288" y="10730789"/>
+            <a:ext cx="7669987" cy="921715"/>
+          </a:xfrm>
+          <a:prstGeom prst="rect">
+            <a:avLst/>
+          </a:prstGeom>
+          <a:noFill/>
+          <a:ln/>
+        </p:spPr>
+        <p:txBody>
+          <a:bodyPr wrap="square" lIns="0" tIns="0" rIns="0" bIns="0" rtlCol="0" anchor="ctr"/>
+          <a:lstStyle/>
+          <a:p>
+            <a:pPr algn="ctr"/>
+            <a:r>
+              <a:rPr lang="en-US" sz="5472" dirty="0">
+                <a:solidFill>
+                  <a:srgbClr val="10192D"/>
+                </a:solidFill>
+                <a:latin typeface="Aptos" pitchFamily="34" charset="0"/>
+                <a:ea typeface="Aptos" pitchFamily="34" charset="-122"/>
+                <a:cs typeface="Aptos" pitchFamily="34" charset="-120"/>
+              </a:rPr>
+              <a:t>1</a:t>
+            </a:r>
+            <a:endParaRPr lang="en-US" sz="5472" dirty="0"/>
+          </a:p>
+        </p:txBody>
+      </p:sp>
+      <p:sp>
+        <p:nvSpPr>
+          <p:cNvPr id="11" name="Text 9"/>
+          <p:cNvSpPr/>
+          <p:nvPr/>
+        </p:nvSpPr>
+        <p:spPr>
+          <a:xfrm>
+            <a:off x="2337207" y="11948769"/>
+            <a:ext cx="7604150" cy="954634"/>
+          </a:xfrm>
+          <a:prstGeom prst="rect">
+            <a:avLst/>
+          </a:prstGeom>
+          <a:noFill/>
+          <a:ln/>
+        </p:spPr>
+        <p:txBody>
+          <a:bodyPr wrap="square" lIns="0" tIns="0" rIns="0" bIns="0" rtlCol="0" anchor="ctr"/>
+          <a:lstStyle/>
+          <a:p>
+            <a:pPr algn="ctr"/>
+            <a:r>
+              <a:rPr lang="en-US" sz="5400" b="1" dirty="0">
+                <a:solidFill>
+                  <a:srgbClr val="10192D"/>
+                </a:solidFill>
+                <a:latin typeface="Aptos" pitchFamily="34" charset="0"/>
+                <a:ea typeface="Aptos" pitchFamily="34" charset="-122"/>
+                <a:cs typeface="Aptos" pitchFamily="34" charset="-120"/>
+              </a:rPr>
+              <a:t>Deceptive code</a:t>
+            </a:r>
+            <a:endParaRPr lang="en-US" sz="5400" dirty="0"/>
+          </a:p>
+        </p:txBody>
+      </p:sp>
+      <p:sp>
+        <p:nvSpPr>
+          <p:cNvPr id="12" name="Text 10"/>
+          <p:cNvSpPr/>
+          <p:nvPr/>
+        </p:nvSpPr>
+        <p:spPr>
+          <a:xfrm>
+            <a:off x="2337207" y="13166751"/>
+            <a:ext cx="7604150" cy="1580083"/>
+          </a:xfrm>
+          <a:prstGeom prst="rect">
+            <a:avLst/>
+          </a:prstGeom>
+          <a:noFill/>
+          <a:ln/>
+        </p:spPr>
+        <p:txBody>
+          <a:bodyPr wrap="square" lIns="0" tIns="0" rIns="0" bIns="0" rtlCol="0" anchor="ctr"/>
+          <a:lstStyle/>
+          <a:p>
+            <a:pPr algn="ctr"/>
+            <a:r>
+              <a:rPr lang="en-US" sz="4572" dirty="0">
+                <a:solidFill>
+                  <a:srgbClr val="10192D"/>
+                </a:solidFill>
+                <a:latin typeface="Aptos" pitchFamily="34" charset="0"/>
+                <a:ea typeface="Aptos" pitchFamily="34" charset="-122"/>
+                <a:cs typeface="Aptos" pitchFamily="34" charset="-120"/>
+              </a:rPr>
+              <a:t>Generated function aims</a:t>
+            </a:r>
+            <a:endParaRPr lang="en-US" sz="4572" dirty="0"/>
+          </a:p>
+          <a:p>
+            <a:pPr algn="ctr"/>
+            <a:r>
+              <a:rPr lang="en-US" sz="4572" dirty="0">
+                <a:solidFill>
+                  <a:srgbClr val="10192D"/>
+                </a:solidFill>
+                <a:latin typeface="Aptos" pitchFamily="34" charset="0"/>
+                <a:ea typeface="Aptos" pitchFamily="34" charset="-122"/>
+                <a:cs typeface="Aptos" pitchFamily="34" charset="-120"/>
+              </a:rPr>
+              <a:t>to game the tests</a:t>
+            </a:r>
+            <a:endParaRPr lang="en-US" sz="4572" dirty="0"/>
+          </a:p>
+        </p:txBody>
+      </p:sp>
+      <p:sp>
+        <p:nvSpPr>
+          <p:cNvPr id="13" name="Shape 11"/>
+          <p:cNvSpPr/>
+          <p:nvPr/>
+        </p:nvSpPr>
+        <p:spPr>
+          <a:xfrm>
+            <a:off x="10451592" y="12788189"/>
+            <a:ext cx="1761134" cy="0"/>
+          </a:xfrm>
+          <a:prstGeom prst="line">
+            <a:avLst/>
+          </a:prstGeom>
+          <a:noFill/>
+          <a:ln w="17780">
+            <a:solidFill>
+              <a:srgbClr val="98A4B7"/>
+            </a:solidFill>
+            <a:prstDash val="solid"/>
+            <a:headEnd type="none"/>
+            <a:tailEnd type="triangle"/>
+          </a:ln>
+        </p:spPr>
+        <p:txBody>
+          <a:bodyPr/>
+          <a:lstStyle/>
+          <a:p>
+            <a:endParaRPr lang="en-US" sz="6480"/>
+          </a:p>
+        </p:txBody>
+      </p:sp>
+      <p:sp>
+        <p:nvSpPr>
+          <p:cNvPr id="14" name="Shape 12"/>
+          <p:cNvSpPr/>
+          <p:nvPr/>
+        </p:nvSpPr>
+        <p:spPr>
+          <a:xfrm>
+            <a:off x="12410237" y="10269931"/>
+            <a:ext cx="8460029" cy="5036515"/>
+          </a:xfrm>
+          <a:prstGeom prst="rect">
+            <a:avLst/>
+          </a:prstGeom>
+          <a:solidFill>
+            <a:srgbClr val="D3F7E5"/>
+          </a:solidFill>
+          <a:ln w="13335">
+            <a:solidFill>
+              <a:srgbClr val="17AD79"/>
+            </a:solidFill>
+            <a:prstDash val="solid"/>
+          </a:ln>
+        </p:spPr>
+        <p:txBody>
+          <a:bodyPr/>
+          <a:lstStyle/>
+          <a:p>
+            <a:endParaRPr lang="en-US" sz="6480"/>
+          </a:p>
+        </p:txBody>
+      </p:sp>
+      <p:sp>
+        <p:nvSpPr>
+          <p:cNvPr id="15" name="Text 13"/>
+          <p:cNvSpPr/>
+          <p:nvPr/>
+        </p:nvSpPr>
+        <p:spPr>
+          <a:xfrm>
+            <a:off x="12805258" y="10730789"/>
+            <a:ext cx="7669987" cy="921715"/>
+          </a:xfrm>
+          <a:prstGeom prst="rect">
+            <a:avLst/>
+          </a:prstGeom>
+          <a:noFill/>
+          <a:ln/>
+        </p:spPr>
+        <p:txBody>
+          <a:bodyPr wrap="square" lIns="0" tIns="0" rIns="0" bIns="0" rtlCol="0" anchor="ctr"/>
+          <a:lstStyle/>
+          <a:p>
+            <a:pPr algn="ctr"/>
+            <a:r>
+              <a:rPr lang="en-US" sz="5472" dirty="0">
+                <a:solidFill>
+                  <a:srgbClr val="10192D"/>
+                </a:solidFill>
+                <a:latin typeface="Aptos" pitchFamily="34" charset="0"/>
+                <a:ea typeface="Aptos" pitchFamily="34" charset="-122"/>
+                <a:cs typeface="Aptos" pitchFamily="34" charset="-120"/>
+              </a:rPr>
+              <a:t>2</a:t>
+            </a:r>
+            <a:endParaRPr lang="en-US" sz="5472" dirty="0"/>
+          </a:p>
+        </p:txBody>
+      </p:sp>
+      <p:sp>
+        <p:nvSpPr>
+          <p:cNvPr id="16" name="Text 14"/>
+          <p:cNvSpPr/>
+          <p:nvPr/>
+        </p:nvSpPr>
+        <p:spPr>
+          <a:xfrm>
+            <a:off x="12838176" y="11948769"/>
+            <a:ext cx="7604150" cy="954634"/>
+          </a:xfrm>
+          <a:prstGeom prst="rect">
+            <a:avLst/>
+          </a:prstGeom>
+          <a:noFill/>
+          <a:ln/>
+        </p:spPr>
+        <p:txBody>
+          <a:bodyPr wrap="square" lIns="0" tIns="0" rIns="0" bIns="0" rtlCol="0" anchor="ctr"/>
+          <a:lstStyle/>
+          <a:p>
+            <a:pPr algn="ctr"/>
+            <a:r>
+              <a:rPr lang="en-US" sz="5400" b="1" dirty="0">
+                <a:solidFill>
+                  <a:srgbClr val="10192D"/>
+                </a:solidFill>
+                <a:latin typeface="Aptos" pitchFamily="34" charset="0"/>
+                <a:ea typeface="Aptos" pitchFamily="34" charset="-122"/>
+                <a:cs typeface="Aptos" pitchFamily="34" charset="-120"/>
+              </a:rPr>
+              <a:t>Answer-key access</a:t>
+            </a:r>
+            <a:endParaRPr lang="en-US" sz="5400" dirty="0"/>
+          </a:p>
+        </p:txBody>
+      </p:sp>
+      <p:sp>
+        <p:nvSpPr>
+          <p:cNvPr id="17" name="Text 15"/>
+          <p:cNvSpPr/>
+          <p:nvPr/>
+        </p:nvSpPr>
+        <p:spPr>
+          <a:xfrm>
+            <a:off x="12838176" y="13166751"/>
+            <a:ext cx="7604150" cy="1580083"/>
+          </a:xfrm>
+          <a:prstGeom prst="rect">
+            <a:avLst/>
+          </a:prstGeom>
+          <a:noFill/>
+          <a:ln/>
+        </p:spPr>
+        <p:txBody>
+          <a:bodyPr wrap="square" lIns="0" tIns="0" rIns="0" bIns="0" rtlCol="0" anchor="ctr"/>
+          <a:lstStyle/>
+          <a:p>
+            <a:pPr algn="ctr"/>
+            <a:r>
+              <a:rPr lang="en-US" sz="4572" dirty="0">
+                <a:solidFill>
+                  <a:srgbClr val="10192D"/>
+                </a:solidFill>
+                <a:latin typeface="Aptos" pitchFamily="34" charset="0"/>
+                <a:ea typeface="Aptos" pitchFamily="34" charset="-122"/>
+                <a:cs typeface="Aptos" pitchFamily="34" charset="-120"/>
+              </a:rPr>
+              <a:t>Uses worker privileges</a:t>
+            </a:r>
+            <a:endParaRPr lang="en-US" sz="4572" dirty="0"/>
+          </a:p>
+          <a:p>
+            <a:pPr algn="ctr"/>
+            <a:r>
+              <a:rPr lang="en-US" sz="4572" dirty="0">
+                <a:solidFill>
+                  <a:srgbClr val="10192D"/>
+                </a:solidFill>
+                <a:latin typeface="Aptos" pitchFamily="34" charset="0"/>
+                <a:ea typeface="Aptos" pitchFamily="34" charset="-122"/>
+                <a:cs typeface="Aptos" pitchFamily="34" charset="-120"/>
+              </a:rPr>
+              <a:t>to read hidden labels</a:t>
+            </a:r>
+            <a:endParaRPr lang="en-US" sz="4572" dirty="0"/>
+          </a:p>
+        </p:txBody>
+      </p:sp>
+      <p:sp>
+        <p:nvSpPr>
+          <p:cNvPr id="18" name="Shape 16"/>
+          <p:cNvSpPr/>
+          <p:nvPr/>
+        </p:nvSpPr>
+        <p:spPr>
+          <a:xfrm>
+            <a:off x="20952562" y="12788189"/>
+            <a:ext cx="1761134" cy="0"/>
+          </a:xfrm>
+          <a:prstGeom prst="line">
+            <a:avLst/>
+          </a:prstGeom>
+          <a:noFill/>
+          <a:ln w="17780">
+            <a:solidFill>
+              <a:srgbClr val="98A4B7"/>
+            </a:solidFill>
+            <a:prstDash val="solid"/>
+            <a:headEnd type="none"/>
+            <a:tailEnd type="triangle"/>
+          </a:ln>
+        </p:spPr>
+        <p:txBody>
+          <a:bodyPr/>
+          <a:lstStyle/>
+          <a:p>
+            <a:endParaRPr lang="en-US" sz="6480"/>
+          </a:p>
+        </p:txBody>
+      </p:sp>
+      <p:sp>
+        <p:nvSpPr>
+          <p:cNvPr id="19" name="Shape 17"/>
+          <p:cNvSpPr/>
+          <p:nvPr/>
+        </p:nvSpPr>
+        <p:spPr>
+          <a:xfrm>
+            <a:off x="22911206" y="10269931"/>
+            <a:ext cx="8460029" cy="5036515"/>
+          </a:xfrm>
+          <a:prstGeom prst="rect">
+            <a:avLst/>
+          </a:prstGeom>
+          <a:solidFill>
+            <a:srgbClr val="FFF2C5"/>
+          </a:solidFill>
+          <a:ln w="13335">
+            <a:solidFill>
+              <a:srgbClr val="F59A15"/>
+            </a:solidFill>
+            <a:prstDash val="solid"/>
+          </a:ln>
+        </p:spPr>
+        <p:txBody>
+          <a:bodyPr/>
+          <a:lstStyle/>
+          <a:p>
+            <a:endParaRPr lang="en-US" sz="6480"/>
+          </a:p>
+        </p:txBody>
+      </p:sp>
+      <p:sp>
+        <p:nvSpPr>
+          <p:cNvPr id="20" name="Text 18"/>
+          <p:cNvSpPr/>
+          <p:nvPr/>
+        </p:nvSpPr>
+        <p:spPr>
+          <a:xfrm>
+            <a:off x="23306227" y="10730789"/>
+            <a:ext cx="7669987" cy="921715"/>
+          </a:xfrm>
+          <a:prstGeom prst="rect">
+            <a:avLst/>
+          </a:prstGeom>
+          <a:noFill/>
+          <a:ln/>
+        </p:spPr>
+        <p:txBody>
+          <a:bodyPr wrap="square" lIns="0" tIns="0" rIns="0" bIns="0" rtlCol="0" anchor="ctr"/>
+          <a:lstStyle/>
+          <a:p>
+            <a:pPr algn="ctr"/>
+            <a:r>
+              <a:rPr lang="en-US" sz="5472" dirty="0">
+                <a:solidFill>
+                  <a:srgbClr val="10192D"/>
+                </a:solidFill>
+                <a:latin typeface="Aptos" pitchFamily="34" charset="0"/>
+                <a:ea typeface="Aptos" pitchFamily="34" charset="-122"/>
+                <a:cs typeface="Aptos" pitchFamily="34" charset="-120"/>
+              </a:rPr>
+              <a:t>3</a:t>
+            </a:r>
+            <a:endParaRPr lang="en-US" sz="5472" dirty="0"/>
+          </a:p>
+        </p:txBody>
+      </p:sp>
+      <p:sp>
+        <p:nvSpPr>
+          <p:cNvPr id="21" name="Text 19"/>
+          <p:cNvSpPr/>
+          <p:nvPr/>
+        </p:nvSpPr>
+        <p:spPr>
+          <a:xfrm>
+            <a:off x="23339146" y="11948769"/>
+            <a:ext cx="7604150" cy="954634"/>
+          </a:xfrm>
+          <a:prstGeom prst="rect">
+            <a:avLst/>
+          </a:prstGeom>
+          <a:noFill/>
+          <a:ln/>
+        </p:spPr>
+        <p:txBody>
+          <a:bodyPr wrap="square" lIns="0" tIns="0" rIns="0" bIns="0" rtlCol="0" anchor="ctr"/>
+          <a:lstStyle/>
+          <a:p>
+            <a:pPr algn="ctr"/>
+            <a:r>
+              <a:rPr lang="en-US" sz="5400" b="1" dirty="0">
+                <a:solidFill>
+                  <a:srgbClr val="10192D"/>
+                </a:solidFill>
+                <a:latin typeface="Aptos" pitchFamily="34" charset="0"/>
+                <a:ea typeface="Aptos" pitchFamily="34" charset="-122"/>
+                <a:cs typeface="Aptos" pitchFamily="34" charset="-120"/>
+              </a:rPr>
+              <a:t>Memorized outputs</a:t>
+            </a:r>
+            <a:endParaRPr lang="en-US" sz="5400" dirty="0"/>
+          </a:p>
+        </p:txBody>
+      </p:sp>
+      <p:sp>
+        <p:nvSpPr>
+          <p:cNvPr id="22" name="Text 20"/>
+          <p:cNvSpPr/>
+          <p:nvPr/>
+        </p:nvSpPr>
+        <p:spPr>
+          <a:xfrm>
+            <a:off x="23339146" y="13166751"/>
+            <a:ext cx="7604150" cy="1580083"/>
+          </a:xfrm>
+          <a:prstGeom prst="rect">
+            <a:avLst/>
+          </a:prstGeom>
+          <a:noFill/>
+          <a:ln/>
+        </p:spPr>
+        <p:txBody>
+          <a:bodyPr wrap="square" lIns="0" tIns="0" rIns="0" bIns="0" rtlCol="0" anchor="ctr"/>
+          <a:lstStyle/>
+          <a:p>
+            <a:pPr algn="ctr"/>
+            <a:r>
+              <a:rPr lang="en-US" sz="4572" dirty="0">
+                <a:solidFill>
+                  <a:srgbClr val="10192D"/>
+                </a:solidFill>
+                <a:latin typeface="Aptos" pitchFamily="34" charset="0"/>
+                <a:ea typeface="Aptos" pitchFamily="34" charset="-122"/>
+                <a:cs typeface="Aptos" pitchFamily="34" charset="-120"/>
+              </a:rPr>
+              <a:t>Returns stored answers</a:t>
+            </a:r>
+            <a:endParaRPr lang="en-US" sz="4572" dirty="0"/>
+          </a:p>
+          <a:p>
+            <a:pPr algn="ctr"/>
+            <a:r>
+              <a:rPr lang="en-US" sz="4572" dirty="0">
+                <a:solidFill>
+                  <a:srgbClr val="10192D"/>
+                </a:solidFill>
+                <a:latin typeface="Aptos" pitchFamily="34" charset="0"/>
+                <a:ea typeface="Aptos" pitchFamily="34" charset="-122"/>
+                <a:cs typeface="Aptos" pitchFamily="34" charset="-120"/>
+              </a:rPr>
+              <a:t>instead of business logic</a:t>
+            </a:r>
+            <a:endParaRPr lang="en-US" sz="4572" dirty="0"/>
+          </a:p>
+        </p:txBody>
+      </p:sp>
+      <p:sp>
+        <p:nvSpPr>
+          <p:cNvPr id="23" name="Shape 21"/>
+          <p:cNvSpPr/>
+          <p:nvPr/>
+        </p:nvSpPr>
+        <p:spPr>
+          <a:xfrm>
+            <a:off x="31453531" y="12788189"/>
+            <a:ext cx="1761134" cy="0"/>
+          </a:xfrm>
+          <a:prstGeom prst="line">
+            <a:avLst/>
+          </a:prstGeom>
+          <a:noFill/>
+          <a:ln w="17780">
+            <a:solidFill>
+              <a:srgbClr val="98A4B7"/>
+            </a:solidFill>
+            <a:prstDash val="solid"/>
+            <a:headEnd type="none"/>
+            <a:tailEnd type="triangle"/>
+          </a:ln>
+        </p:spPr>
+        <p:txBody>
+          <a:bodyPr/>
+          <a:lstStyle/>
+          <a:p>
+            <a:endParaRPr lang="en-US" sz="6480"/>
+          </a:p>
+        </p:txBody>
+      </p:sp>
+      <p:sp>
+        <p:nvSpPr>
+          <p:cNvPr id="24" name="Shape 22"/>
+          <p:cNvSpPr/>
+          <p:nvPr/>
+        </p:nvSpPr>
+        <p:spPr>
+          <a:xfrm>
+            <a:off x="33412176" y="10269931"/>
+            <a:ext cx="8460029" cy="5036515"/>
+          </a:xfrm>
+          <a:prstGeom prst="rect">
+            <a:avLst/>
+          </a:prstGeom>
+          <a:solidFill>
+            <a:srgbClr val="FFE3E2"/>
+          </a:solidFill>
+          <a:ln w="13335">
+            <a:solidFill>
+              <a:srgbClr val="F05252"/>
+            </a:solidFill>
+            <a:prstDash val="solid"/>
+          </a:ln>
+        </p:spPr>
+        <p:txBody>
+          <a:bodyPr/>
+          <a:lstStyle/>
+          <a:p>
+            <a:endParaRPr lang="en-US" sz="6480"/>
+          </a:p>
+        </p:txBody>
+      </p:sp>
+      <p:sp>
+        <p:nvSpPr>
+          <p:cNvPr id="25" name="Text 23"/>
+          <p:cNvSpPr/>
+          <p:nvPr/>
+        </p:nvSpPr>
+        <p:spPr>
+          <a:xfrm>
+            <a:off x="33807197" y="10730789"/>
+            <a:ext cx="7669987" cy="921715"/>
+          </a:xfrm>
+          <a:prstGeom prst="rect">
+            <a:avLst/>
+          </a:prstGeom>
+          <a:noFill/>
+          <a:ln/>
+        </p:spPr>
+        <p:txBody>
+          <a:bodyPr wrap="square" lIns="0" tIns="0" rIns="0" bIns="0" rtlCol="0" anchor="ctr"/>
+          <a:lstStyle/>
+          <a:p>
+            <a:pPr algn="ctr"/>
+            <a:r>
+              <a:rPr lang="en-US" sz="5472" dirty="0">
+                <a:solidFill>
+                  <a:srgbClr val="10192D"/>
+                </a:solidFill>
+                <a:latin typeface="Aptos" pitchFamily="34" charset="0"/>
+                <a:ea typeface="Aptos" pitchFamily="34" charset="-122"/>
+                <a:cs typeface="Aptos" pitchFamily="34" charset="-120"/>
+              </a:rPr>
+              <a:t>4</a:t>
+            </a:r>
+            <a:endParaRPr lang="en-US" sz="5472" dirty="0"/>
+          </a:p>
+        </p:txBody>
+      </p:sp>
+      <p:sp>
+        <p:nvSpPr>
+          <p:cNvPr id="26" name="Text 24"/>
+          <p:cNvSpPr/>
+          <p:nvPr/>
+        </p:nvSpPr>
+        <p:spPr>
+          <a:xfrm>
+            <a:off x="33840115" y="11948769"/>
+            <a:ext cx="7604150" cy="954634"/>
+          </a:xfrm>
+          <a:prstGeom prst="rect">
+            <a:avLst/>
+          </a:prstGeom>
+          <a:noFill/>
+          <a:ln/>
+        </p:spPr>
+        <p:txBody>
+          <a:bodyPr wrap="square" lIns="0" tIns="0" rIns="0" bIns="0" rtlCol="0" anchor="ctr"/>
+          <a:lstStyle/>
+          <a:p>
+            <a:pPr algn="ctr"/>
+            <a:r>
+              <a:rPr lang="en-US" sz="5400" b="1" dirty="0">
+                <a:solidFill>
+                  <a:srgbClr val="10192D"/>
+                </a:solidFill>
+                <a:latin typeface="Aptos" pitchFamily="34" charset="0"/>
+                <a:ea typeface="Aptos" pitchFamily="34" charset="-122"/>
+                <a:cs typeface="Aptos" pitchFamily="34" charset="-120"/>
+              </a:rPr>
+              <a:t>False approval</a:t>
+            </a:r>
+            <a:endParaRPr lang="en-US" sz="5400" dirty="0"/>
+          </a:p>
+        </p:txBody>
+      </p:sp>
+      <p:sp>
+        <p:nvSpPr>
+          <p:cNvPr id="27" name="Text 25"/>
+          <p:cNvSpPr/>
+          <p:nvPr/>
+        </p:nvSpPr>
+        <p:spPr>
+          <a:xfrm>
+            <a:off x="33840115" y="13166751"/>
+            <a:ext cx="7604150" cy="1580083"/>
+          </a:xfrm>
+          <a:prstGeom prst="rect">
+            <a:avLst/>
+          </a:prstGeom>
+          <a:noFill/>
+          <a:ln/>
+        </p:spPr>
+        <p:txBody>
+          <a:bodyPr wrap="square" lIns="0" tIns="0" rIns="0" bIns="0" rtlCol="0" anchor="ctr"/>
+          <a:lstStyle/>
+          <a:p>
+            <a:pPr algn="ctr"/>
+            <a:r>
+              <a:rPr lang="en-US" sz="4572" dirty="0">
+                <a:solidFill>
+                  <a:srgbClr val="10192D"/>
+                </a:solidFill>
+                <a:latin typeface="Aptos" pitchFamily="34" charset="0"/>
+                <a:ea typeface="Aptos" pitchFamily="34" charset="-122"/>
+                <a:cs typeface="Aptos" pitchFamily="34" charset="-120"/>
+              </a:rPr>
+              <a:t>Python sees a match;</a:t>
+            </a:r>
+            <a:endParaRPr lang="en-US" sz="4572" dirty="0"/>
+          </a:p>
+          <a:p>
+            <a:pPr algn="ctr"/>
+            <a:r>
+              <a:rPr lang="en-US" sz="4572" dirty="0">
+                <a:solidFill>
+                  <a:srgbClr val="10192D"/>
+                </a:solidFill>
+                <a:latin typeface="Aptos" pitchFamily="34" charset="0"/>
+                <a:ea typeface="Aptos" pitchFamily="34" charset="-122"/>
+                <a:cs typeface="Aptos" pitchFamily="34" charset="-120"/>
+              </a:rPr>
+              <a:t>the candidate is unsound</a:t>
+            </a:r>
+            <a:endParaRPr lang="en-US" sz="4572" dirty="0"/>
+          </a:p>
+        </p:txBody>
+      </p:sp>
+      <p:sp>
+        <p:nvSpPr>
+          <p:cNvPr id="28" name="Text 26"/>
+          <p:cNvSpPr/>
+          <p:nvPr/>
+        </p:nvSpPr>
+        <p:spPr>
+          <a:xfrm>
+            <a:off x="1909267" y="17643653"/>
+            <a:ext cx="12508992" cy="987552"/>
+          </a:xfrm>
+          <a:prstGeom prst="rect">
+            <a:avLst/>
+          </a:prstGeom>
+          <a:noFill/>
+          <a:ln/>
+        </p:spPr>
+        <p:txBody>
+          <a:bodyPr wrap="square" lIns="0" tIns="0" rIns="0" bIns="0" rtlCol="0" anchor="ctr"/>
+          <a:lstStyle/>
+          <a:p>
+            <a:r>
+              <a:rPr lang="en-US" sz="5940" b="1" dirty="0">
+                <a:solidFill>
+                  <a:srgbClr val="2766EC"/>
+                </a:solidFill>
+                <a:latin typeface="Aptos" pitchFamily="34" charset="0"/>
+                <a:ea typeface="Aptos" pitchFamily="34" charset="-122"/>
+                <a:cs typeface="Aptos" pitchFamily="34" charset="-120"/>
+              </a:rPr>
+              <a:t>Threat model</a:t>
+            </a:r>
+            <a:endParaRPr lang="en-US" sz="5940" dirty="0"/>
+          </a:p>
+        </p:txBody>
+      </p:sp>
+      <p:sp>
+        <p:nvSpPr>
+          <p:cNvPr id="29" name="Text 27"/>
+          <p:cNvSpPr/>
+          <p:nvPr/>
+        </p:nvSpPr>
+        <p:spPr>
+          <a:xfrm>
+            <a:off x="1909267" y="19124981"/>
+            <a:ext cx="13002768" cy="1020470"/>
+          </a:xfrm>
+          <a:prstGeom prst="rect">
+            <a:avLst/>
+          </a:prstGeom>
+          <a:noFill/>
+          <a:ln/>
+        </p:spPr>
+        <p:txBody>
+          <a:bodyPr wrap="square" lIns="0" tIns="0" rIns="0" bIns="0" rtlCol="0" anchor="ctr"/>
+          <a:lstStyle/>
+          <a:p>
+            <a:r>
+              <a:rPr lang="en-US" sz="4446" dirty="0">
+                <a:solidFill>
+                  <a:srgbClr val="10192D"/>
+                </a:solidFill>
+                <a:latin typeface="Aptos" pitchFamily="34" charset="0"/>
+                <a:ea typeface="Aptos" pitchFamily="34" charset="-122"/>
+                <a:cs typeface="Aptos" pitchFamily="34" charset="-120"/>
+              </a:rPr>
+              <a:t>•  Hidden job files or answers are reachable</a:t>
+            </a:r>
+            <a:endParaRPr lang="en-US" sz="4446" dirty="0"/>
+          </a:p>
+        </p:txBody>
+      </p:sp>
+      <p:sp>
+        <p:nvSpPr>
+          <p:cNvPr id="30" name="Text 28"/>
+          <p:cNvSpPr/>
+          <p:nvPr/>
+        </p:nvSpPr>
+        <p:spPr>
+          <a:xfrm>
+            <a:off x="1909267" y="20310043"/>
+            <a:ext cx="13002768" cy="1020470"/>
+          </a:xfrm>
+          <a:prstGeom prst="rect">
+            <a:avLst/>
+          </a:prstGeom>
+          <a:noFill/>
+          <a:ln/>
+        </p:spPr>
+        <p:txBody>
+          <a:bodyPr wrap="square" lIns="0" tIns="0" rIns="0" bIns="0" rtlCol="0" anchor="ctr"/>
+          <a:lstStyle/>
+          <a:p>
+            <a:r>
+              <a:rPr lang="en-US" sz="4446" dirty="0">
+                <a:solidFill>
+                  <a:srgbClr val="10192D"/>
+                </a:solidFill>
+                <a:latin typeface="Aptos" pitchFamily="34" charset="0"/>
+                <a:ea typeface="Aptos" pitchFamily="34" charset="-122"/>
+                <a:cs typeface="Aptos" pitchFamily="34" charset="-120"/>
+              </a:rPr>
+              <a:t>•  Static allowlists can have escape paths</a:t>
+            </a:r>
+            <a:endParaRPr lang="en-US" sz="4446" dirty="0"/>
+          </a:p>
+        </p:txBody>
+      </p:sp>
+      <p:sp>
+        <p:nvSpPr>
+          <p:cNvPr id="31" name="Text 29"/>
+          <p:cNvSpPr/>
+          <p:nvPr/>
+        </p:nvSpPr>
+        <p:spPr>
+          <a:xfrm>
+            <a:off x="1909267" y="21495106"/>
+            <a:ext cx="13002768" cy="1020470"/>
+          </a:xfrm>
+          <a:prstGeom prst="rect">
+            <a:avLst/>
+          </a:prstGeom>
+          <a:noFill/>
+          <a:ln/>
+        </p:spPr>
+        <p:txBody>
+          <a:bodyPr wrap="square" lIns="0" tIns="0" rIns="0" bIns="0" rtlCol="0" anchor="ctr"/>
+          <a:lstStyle/>
+          <a:p>
+            <a:r>
+              <a:rPr lang="en-US" sz="4446" dirty="0">
+                <a:solidFill>
+                  <a:srgbClr val="10192D"/>
+                </a:solidFill>
+                <a:latin typeface="Aptos" pitchFamily="34" charset="0"/>
+                <a:ea typeface="Aptos" pitchFamily="34" charset="-122"/>
+                <a:cs typeface="Aptos" pitchFamily="34" charset="-120"/>
+              </a:rPr>
+              <a:t>•  Passing N jobs does not prove generality</a:t>
+            </a:r>
+            <a:endParaRPr lang="en-US" sz="4446" dirty="0"/>
+          </a:p>
+        </p:txBody>
+      </p:sp>
+      <p:sp>
+        <p:nvSpPr>
+          <p:cNvPr id="32" name="Text 30"/>
+          <p:cNvSpPr/>
+          <p:nvPr/>
+        </p:nvSpPr>
+        <p:spPr>
+          <a:xfrm>
+            <a:off x="15504566" y="17643653"/>
+            <a:ext cx="13167360" cy="987552"/>
+          </a:xfrm>
+          <a:prstGeom prst="rect">
+            <a:avLst/>
+          </a:prstGeom>
+          <a:noFill/>
+          <a:ln/>
+        </p:spPr>
+        <p:txBody>
+          <a:bodyPr wrap="square" lIns="0" tIns="0" rIns="0" bIns="0" rtlCol="0" anchor="ctr"/>
+          <a:lstStyle/>
+          <a:p>
+            <a:r>
+              <a:rPr lang="en-US" sz="5940" b="1" dirty="0">
+                <a:solidFill>
+                  <a:srgbClr val="0A9B73"/>
+                </a:solidFill>
+                <a:latin typeface="Aptos" pitchFamily="34" charset="0"/>
+                <a:ea typeface="Aptos" pitchFamily="34" charset="-122"/>
+                <a:cs typeface="Aptos" pitchFamily="34" charset="-120"/>
+              </a:rPr>
+              <a:t>Future countermeasures</a:t>
+            </a:r>
+            <a:endParaRPr lang="en-US" sz="5940" dirty="0"/>
+          </a:p>
+        </p:txBody>
+      </p:sp>
+      <p:sp>
+        <p:nvSpPr>
+          <p:cNvPr id="33" name="Text 31"/>
+          <p:cNvSpPr/>
+          <p:nvPr/>
+        </p:nvSpPr>
+        <p:spPr>
+          <a:xfrm>
+            <a:off x="15504566" y="19124981"/>
+            <a:ext cx="13002768" cy="1020470"/>
+          </a:xfrm>
+          <a:prstGeom prst="rect">
+            <a:avLst/>
+          </a:prstGeom>
+          <a:noFill/>
+          <a:ln/>
+        </p:spPr>
+        <p:txBody>
+          <a:bodyPr wrap="square" lIns="0" tIns="0" rIns="0" bIns="0" rtlCol="0" anchor="ctr"/>
+          <a:lstStyle/>
+          <a:p>
+            <a:r>
+              <a:rPr lang="en-US" sz="4446" dirty="0">
+                <a:solidFill>
+                  <a:srgbClr val="10192D"/>
+                </a:solidFill>
+                <a:latin typeface="Aptos" pitchFamily="34" charset="0"/>
+                <a:ea typeface="Aptos" pitchFamily="34" charset="-122"/>
+                <a:cs typeface="Aptos" pitchFamily="34" charset="-120"/>
+              </a:rPr>
+              <a:t>•  Sandbox cannot read answers or secrets</a:t>
+            </a:r>
+            <a:endParaRPr lang="en-US" sz="4446" dirty="0"/>
+          </a:p>
+        </p:txBody>
+      </p:sp>
+      <p:sp>
+        <p:nvSpPr>
+          <p:cNvPr id="34" name="Text 32"/>
+          <p:cNvSpPr/>
+          <p:nvPr/>
+        </p:nvSpPr>
+        <p:spPr>
+          <a:xfrm>
+            <a:off x="15504566" y="20310043"/>
+            <a:ext cx="13002768" cy="1020470"/>
+          </a:xfrm>
+          <a:prstGeom prst="rect">
+            <a:avLst/>
+          </a:prstGeom>
+          <a:noFill/>
+          <a:ln/>
+        </p:spPr>
+        <p:txBody>
+          <a:bodyPr wrap="square" lIns="0" tIns="0" rIns="0" bIns="0" rtlCol="0" anchor="ctr"/>
+          <a:lstStyle/>
+          <a:p>
+            <a:r>
+              <a:rPr lang="en-US" sz="4446" dirty="0">
+                <a:solidFill>
+                  <a:srgbClr val="10192D"/>
+                </a:solidFill>
+                <a:latin typeface="Aptos" pitchFamily="34" charset="0"/>
+                <a:ea typeface="Aptos" pitchFamily="34" charset="-122"/>
+                <a:cs typeface="Aptos" pitchFamily="34" charset="-120"/>
+              </a:rPr>
+              <a:t>•  Parent alone compares expected outputs</a:t>
+            </a:r>
+            <a:endParaRPr lang="en-US" sz="4446" dirty="0"/>
+          </a:p>
+        </p:txBody>
+      </p:sp>
+      <p:sp>
+        <p:nvSpPr>
+          <p:cNvPr id="35" name="Text 33"/>
+          <p:cNvSpPr/>
+          <p:nvPr/>
+        </p:nvSpPr>
+        <p:spPr>
+          <a:xfrm>
+            <a:off x="15504566" y="21495106"/>
+            <a:ext cx="13002768" cy="1020470"/>
+          </a:xfrm>
+          <a:prstGeom prst="rect">
+            <a:avLst/>
+          </a:prstGeom>
+          <a:noFill/>
+          <a:ln/>
+        </p:spPr>
+        <p:txBody>
+          <a:bodyPr wrap="square" lIns="0" tIns="0" rIns="0" bIns="0" rtlCol="0" anchor="ctr"/>
+          <a:lstStyle/>
+          <a:p>
+            <a:r>
+              <a:rPr lang="en-US" sz="4446" dirty="0">
+                <a:solidFill>
+                  <a:srgbClr val="10192D"/>
+                </a:solidFill>
+                <a:latin typeface="Aptos" pitchFamily="34" charset="0"/>
+                <a:ea typeface="Aptos" pitchFamily="34" charset="-122"/>
+                <a:cs typeface="Aptos" pitchFamily="34" charset="-120"/>
+              </a:rPr>
+              <a:t>•  BRD-scoped broker limits external tools</a:t>
+            </a:r>
+            <a:endParaRPr lang="en-US" sz="4446" dirty="0"/>
+          </a:p>
+        </p:txBody>
+      </p:sp>
+      <p:sp>
+        <p:nvSpPr>
+          <p:cNvPr id="36" name="Text 34"/>
+          <p:cNvSpPr/>
+          <p:nvPr/>
+        </p:nvSpPr>
+        <p:spPr>
+          <a:xfrm>
+            <a:off x="28770682" y="17643653"/>
+            <a:ext cx="13167360" cy="987552"/>
+          </a:xfrm>
+          <a:prstGeom prst="rect">
+            <a:avLst/>
+          </a:prstGeom>
+          <a:noFill/>
+          <a:ln/>
+        </p:spPr>
+        <p:txBody>
+          <a:bodyPr wrap="square" lIns="0" tIns="0" rIns="0" bIns="0" rtlCol="0" anchor="ctr"/>
+          <a:lstStyle/>
+          <a:p>
+            <a:r>
+              <a:rPr lang="en-US" sz="5940" b="1" dirty="0">
+                <a:solidFill>
+                  <a:srgbClr val="D88404"/>
+                </a:solidFill>
+                <a:latin typeface="Aptos" pitchFamily="34" charset="0"/>
+                <a:ea typeface="Aptos" pitchFamily="34" charset="-122"/>
+                <a:cs typeface="Aptos" pitchFamily="34" charset="-120"/>
+              </a:rPr>
+              <a:t>Adversarial verification</a:t>
+            </a:r>
+            <a:endParaRPr lang="en-US" sz="5940" dirty="0"/>
+          </a:p>
+        </p:txBody>
+      </p:sp>
+      <p:sp>
+        <p:nvSpPr>
+          <p:cNvPr id="37" name="Text 35"/>
+          <p:cNvSpPr/>
+          <p:nvPr/>
+        </p:nvSpPr>
+        <p:spPr>
+          <a:xfrm>
+            <a:off x="28770682" y="19124981"/>
+            <a:ext cx="13002768" cy="1020470"/>
+          </a:xfrm>
+          <a:prstGeom prst="rect">
+            <a:avLst/>
+          </a:prstGeom>
+          <a:noFill/>
+          <a:ln/>
+        </p:spPr>
+        <p:txBody>
+          <a:bodyPr wrap="square" lIns="0" tIns="0" rIns="0" bIns="0" rtlCol="0" anchor="ctr"/>
+          <a:lstStyle/>
+          <a:p>
+            <a:r>
+              <a:rPr lang="en-US" sz="4446" dirty="0">
+                <a:solidFill>
+                  <a:srgbClr val="10192D"/>
+                </a:solidFill>
+                <a:latin typeface="Aptos" pitchFamily="34" charset="0"/>
+                <a:ea typeface="Aptos" pitchFamily="34" charset="-122"/>
+                <a:cs typeface="Aptos" pitchFamily="34" charset="-120"/>
+              </a:rPr>
+              <a:t>•  Test honest and cheating implementations</a:t>
+            </a:r>
+            <a:endParaRPr lang="en-US" sz="4446" dirty="0"/>
+          </a:p>
+        </p:txBody>
+      </p:sp>
+      <p:sp>
+        <p:nvSpPr>
+          <p:cNvPr id="38" name="Text 36"/>
+          <p:cNvSpPr/>
+          <p:nvPr/>
+        </p:nvSpPr>
+        <p:spPr>
+          <a:xfrm>
+            <a:off x="28770682" y="20310043"/>
+            <a:ext cx="13002768" cy="1020470"/>
+          </a:xfrm>
+          <a:prstGeom prst="rect">
+            <a:avLst/>
+          </a:prstGeom>
+          <a:noFill/>
+          <a:ln/>
+        </p:spPr>
+        <p:txBody>
+          <a:bodyPr wrap="square" lIns="0" tIns="0" rIns="0" bIns="0" rtlCol="0" anchor="ctr"/>
+          <a:lstStyle/>
+          <a:p>
+            <a:r>
+              <a:rPr lang="en-US" sz="4446" dirty="0">
+                <a:solidFill>
+                  <a:srgbClr val="10192D"/>
+                </a:solidFill>
+                <a:latin typeface="Aptos" pitchFamily="34" charset="0"/>
+                <a:ea typeface="Aptos" pitchFamily="34" charset="-122"/>
+                <a:cs typeface="Aptos" pitchFamily="34" charset="-120"/>
+              </a:rPr>
+              <a:t>•  Assert holdout data remains inaccessible</a:t>
+            </a:r>
+            <a:endParaRPr lang="en-US" sz="4446" dirty="0"/>
+          </a:p>
+        </p:txBody>
+      </p:sp>
+      <p:sp>
+        <p:nvSpPr>
+          <p:cNvPr id="39" name="Text 37"/>
+          <p:cNvSpPr/>
+          <p:nvPr/>
+        </p:nvSpPr>
+        <p:spPr>
+          <a:xfrm>
+            <a:off x="28770682" y="21495106"/>
+            <a:ext cx="13002768" cy="1020470"/>
+          </a:xfrm>
+          <a:prstGeom prst="rect">
+            <a:avLst/>
+          </a:prstGeom>
+          <a:noFill/>
+          <a:ln/>
+        </p:spPr>
+        <p:txBody>
+          <a:bodyPr wrap="square" lIns="0" tIns="0" rIns="0" bIns="0" rtlCol="0" anchor="ctr"/>
+          <a:lstStyle/>
+          <a:p>
+            <a:r>
+              <a:rPr lang="en-US" sz="4446" dirty="0">
+                <a:solidFill>
+                  <a:srgbClr val="10192D"/>
+                </a:solidFill>
+                <a:latin typeface="Aptos" pitchFamily="34" charset="0"/>
+                <a:ea typeface="Aptos" pitchFamily="34" charset="-122"/>
+                <a:cs typeface="Aptos" pitchFamily="34" charset="-120"/>
+              </a:rPr>
+              <a:t>•  Enforce timeouts; persist blocked hashes</a:t>
+            </a:r>
+            <a:endParaRPr lang="en-US" sz="4446" dirty="0"/>
           </a:p>
         </p:txBody>
       </p:sp>

</xml_diff>

<commit_message>
Improve worker fault isolation, retries and watchdog
* Classify temporary job data errors and monitor function invocations

* Isolate worker logging and enforce function-call watchdog

* Restore full processor source in reliability update

* Complete full processor source after paginated upload

* Update presentation with reliability-aligned BRD documentation

* Document jobs-file retries, private logging and function watchdog

* Expose function-call watchdog timeout in env template

* Temporarily validate reliability changes on Linux and Windows

* Remove temporary cross-platform reliability workflow
</commit_message>
<xml_diff>
--- a/docs/No_Trust_Me_Agentic_AI.pptx
+++ b/docs/No_Trust_Me_Agentic_AI.pptx
@@ -6,7 +6,7 @@
     <p:sldMasterId id="2147483672" r:id="rId2"/>
   </p:sldMasterIdLst>
   <p:notesMasterIdLst>
-    <p:notesMasterId r:id="rId11"/>
+    <p:notesMasterId r:id="rId12"/>
   </p:notesMasterIdLst>
   <p:sldIdLst>
     <p:sldId id="256" r:id="rId3"/>
@@ -17,6 +17,7 @@
     <p:sldId id="263" r:id="rId8"/>
     <p:sldId id="264" r:id="rId9"/>
     <p:sldId id="265" r:id="rId10"/>
+    <p:sldId id="266" r:id="rId11"/>
   </p:sldIdLst>
   <p:sldSz cx="43891200" cy="24688800"/>
   <p:notesSz cx="6858000" cy="9144000"/>
@@ -126,7 +127,7 @@
 <file path=ppt/revisionInfo.xml><?xml version="1.0" encoding="utf-8"?>
 <p1510:revInfo xmlns:a="http://schemas.openxmlformats.org/drawingml/2006/main" xmlns:r="http://schemas.openxmlformats.org/officeDocument/2006/relationships" xmlns:p1510="http://schemas.microsoft.com/office/powerpoint/2015/10/main">
   <p1510:revLst>
-    <p1510:client id="{365D465A-354D-4022-A33C-AF8F86656859}" v="21" dt="2026-10-09T16:54:40.319"/>
+    <p1510:client id="{365D465A-354D-4022-A33C-AF8F86656859}" v="66" dt="2026-10-09T19:17:00.791"/>
   </p1510:revLst>
 </p1510:revInfo>
 </file>
@@ -135,11 +136,26 @@
 <pc:chgInfo xmlns:a="http://schemas.openxmlformats.org/drawingml/2006/main" xmlns:r="http://schemas.openxmlformats.org/officeDocument/2006/relationships" xmlns:ac="http://schemas.microsoft.com/office/drawing/2013/main/command" xmlns:pc="http://schemas.microsoft.com/office/powerpoint/2013/main/command">
   <pc:docChgLst>
     <pc:chgData name="Simon Hong" userId="2f15200c-b3cf-4aef-8f69-ada819764841" providerId="ADAL" clId="{6AB89950-CF24-4538-93AF-1A20832D1772}"/>
-    <pc:docChg chg="undo custSel addSld delSld modSld">
-      <pc:chgData name="Simon Hong" userId="2f15200c-b3cf-4aef-8f69-ada819764841" providerId="ADAL" clId="{6AB89950-CF24-4538-93AF-1A20832D1772}" dt="2026-10-09T16:54:45.668" v="464" actId="6549"/>
+    <pc:docChg chg="undo redo custSel addSld delSld modSld">
+      <pc:chgData name="Simon Hong" userId="2f15200c-b3cf-4aef-8f69-ada819764841" providerId="ADAL" clId="{6AB89950-CF24-4538-93AF-1A20832D1772}" dt="2026-10-09T19:17:00.791" v="981" actId="1037"/>
       <pc:docMkLst>
         <pc:docMk/>
       </pc:docMkLst>
+      <pc:sldChg chg="modSp mod">
+        <pc:chgData name="Simon Hong" userId="2f15200c-b3cf-4aef-8f69-ada819764841" providerId="ADAL" clId="{6AB89950-CF24-4538-93AF-1A20832D1772}" dt="2026-10-09T18:53:48.851" v="783" actId="6549"/>
+        <pc:sldMkLst>
+          <pc:docMk/>
+          <pc:sldMk cId="1674887463" sldId="256"/>
+        </pc:sldMkLst>
+        <pc:spChg chg="mod">
+          <ac:chgData name="Simon Hong" userId="2f15200c-b3cf-4aef-8f69-ada819764841" providerId="ADAL" clId="{6AB89950-CF24-4538-93AF-1A20832D1772}" dt="2026-10-09T18:53:48.851" v="783" actId="6549"/>
+          <ac:spMkLst>
+            <pc:docMk/>
+            <pc:sldMk cId="1674887463" sldId="256"/>
+            <ac:spMk id="43" creationId="{BD46BBD1-38CB-19B8-67F2-EECC9C57D83F}"/>
+          </ac:spMkLst>
+        </pc:spChg>
+      </pc:sldChg>
       <pc:sldChg chg="modSp mod">
         <pc:chgData name="Simon Hong" userId="2f15200c-b3cf-4aef-8f69-ada819764841" providerId="ADAL" clId="{6AB89950-CF24-4538-93AF-1A20832D1772}" dt="2026-10-05T22:46:19.432" v="259" actId="13926"/>
         <pc:sldMkLst>
@@ -232,18 +248,154 @@
           </ac:spMkLst>
         </pc:spChg>
       </pc:sldChg>
-      <pc:sldChg chg="modSp mod">
-        <pc:chgData name="Simon Hong" userId="2f15200c-b3cf-4aef-8f69-ada819764841" providerId="ADAL" clId="{6AB89950-CF24-4538-93AF-1A20832D1772}" dt="2026-10-05T22:05:44.250" v="256" actId="20577"/>
+      <pc:sldChg chg="addSp delSp modSp mod">
+        <pc:chgData name="Simon Hong" userId="2f15200c-b3cf-4aef-8f69-ada819764841" providerId="ADAL" clId="{6AB89950-CF24-4538-93AF-1A20832D1772}" dt="2026-10-09T19:17:00.791" v="981" actId="1037"/>
         <pc:sldMkLst>
           <pc:docMk/>
           <pc:sldMk cId="2475521724" sldId="263"/>
         </pc:sldMkLst>
+        <pc:spChg chg="mod">
+          <ac:chgData name="Simon Hong" userId="2f15200c-b3cf-4aef-8f69-ada819764841" providerId="ADAL" clId="{6AB89950-CF24-4538-93AF-1A20832D1772}" dt="2026-10-09T19:12:56.982" v="965" actId="14100"/>
+          <ac:spMkLst>
+            <pc:docMk/>
+            <pc:sldMk cId="2475521724" sldId="263"/>
+            <ac:spMk id="2" creationId="{FB177F57-5024-AAC3-EAA9-97F19B2BFE68}"/>
+          </ac:spMkLst>
+        </pc:spChg>
         <pc:spChg chg="mod">
           <ac:chgData name="Simon Hong" userId="2f15200c-b3cf-4aef-8f69-ada819764841" providerId="ADAL" clId="{6AB89950-CF24-4538-93AF-1A20832D1772}" dt="2026-10-05T20:44:35.931" v="57" actId="6549"/>
           <ac:spMkLst>
             <pc:docMk/>
             <pc:sldMk cId="2475521724" sldId="263"/>
             <ac:spMk id="3" creationId="{44C82B57-F564-6280-53E1-EF53DD92F1C9}"/>
+          </ac:spMkLst>
+        </pc:spChg>
+        <pc:spChg chg="mod">
+          <ac:chgData name="Simon Hong" userId="2f15200c-b3cf-4aef-8f69-ada819764841" providerId="ADAL" clId="{6AB89950-CF24-4538-93AF-1A20832D1772}" dt="2026-10-09T17:48:07.767" v="522" actId="1076"/>
+          <ac:spMkLst>
+            <pc:docMk/>
+            <pc:sldMk cId="2475521724" sldId="263"/>
+            <ac:spMk id="10" creationId="{62811AE6-0830-4C40-F1BF-97EAB74EF60A}"/>
+          </ac:spMkLst>
+        </pc:spChg>
+        <pc:spChg chg="mod">
+          <ac:chgData name="Simon Hong" userId="2f15200c-b3cf-4aef-8f69-ada819764841" providerId="ADAL" clId="{6AB89950-CF24-4538-93AF-1A20832D1772}" dt="2026-10-09T17:47:25.573" v="502" actId="1035"/>
+          <ac:spMkLst>
+            <pc:docMk/>
+            <pc:sldMk cId="2475521724" sldId="263"/>
+            <ac:spMk id="13" creationId="{46C1BE4D-947F-F5CF-775E-D8E7CE94FB66}"/>
+          </ac:spMkLst>
+        </pc:spChg>
+        <pc:spChg chg="mod">
+          <ac:chgData name="Simon Hong" userId="2f15200c-b3cf-4aef-8f69-ada819764841" providerId="ADAL" clId="{6AB89950-CF24-4538-93AF-1A20832D1772}" dt="2026-10-09T17:50:07.614" v="538" actId="1076"/>
+          <ac:spMkLst>
+            <pc:docMk/>
+            <pc:sldMk cId="2475521724" sldId="263"/>
+            <ac:spMk id="14" creationId="{54D69334-E05C-B19C-C3F6-3351A743AA55}"/>
+          </ac:spMkLst>
+        </pc:spChg>
+        <pc:spChg chg="mod">
+          <ac:chgData name="Simon Hong" userId="2f15200c-b3cf-4aef-8f69-ada819764841" providerId="ADAL" clId="{6AB89950-CF24-4538-93AF-1A20832D1772}" dt="2026-10-09T17:47:30.528" v="503" actId="14100"/>
+          <ac:spMkLst>
+            <pc:docMk/>
+            <pc:sldMk cId="2475521724" sldId="263"/>
+            <ac:spMk id="16" creationId="{B593D06A-1FFF-7164-3186-B2D1D361BF79}"/>
+          </ac:spMkLst>
+        </pc:spChg>
+        <pc:spChg chg="mod">
+          <ac:chgData name="Simon Hong" userId="2f15200c-b3cf-4aef-8f69-ada819764841" providerId="ADAL" clId="{6AB89950-CF24-4538-93AF-1A20832D1772}" dt="2026-10-09T17:50:42.807" v="545" actId="1076"/>
+          <ac:spMkLst>
+            <pc:docMk/>
+            <pc:sldMk cId="2475521724" sldId="263"/>
+            <ac:spMk id="21" creationId="{657FAB87-4161-2538-7D14-E8E2AA3CF49B}"/>
+          </ac:spMkLst>
+        </pc:spChg>
+        <pc:spChg chg="mod">
+          <ac:chgData name="Simon Hong" userId="2f15200c-b3cf-4aef-8f69-ada819764841" providerId="ADAL" clId="{6AB89950-CF24-4538-93AF-1A20832D1772}" dt="2026-10-09T19:17:00.791" v="981" actId="1037"/>
+          <ac:spMkLst>
+            <pc:docMk/>
+            <pc:sldMk cId="2475521724" sldId="263"/>
+            <ac:spMk id="23" creationId="{C6F18763-A9E1-2B43-4016-F07FD12298C5}"/>
+          </ac:spMkLst>
+        </pc:spChg>
+        <pc:spChg chg="mod">
+          <ac:chgData name="Simon Hong" userId="2f15200c-b3cf-4aef-8f69-ada819764841" providerId="ADAL" clId="{6AB89950-CF24-4538-93AF-1A20832D1772}" dt="2026-10-09T19:17:00.791" v="981" actId="1037"/>
+          <ac:spMkLst>
+            <pc:docMk/>
+            <pc:sldMk cId="2475521724" sldId="263"/>
+            <ac:spMk id="34" creationId="{188936F9-B80A-90A8-3573-845E348D005D}"/>
+          </ac:spMkLst>
+        </pc:spChg>
+        <pc:spChg chg="mod">
+          <ac:chgData name="Simon Hong" userId="2f15200c-b3cf-4aef-8f69-ada819764841" providerId="ADAL" clId="{6AB89950-CF24-4538-93AF-1A20832D1772}" dt="2026-10-09T19:17:00.791" v="981" actId="1037"/>
+          <ac:spMkLst>
+            <pc:docMk/>
+            <pc:sldMk cId="2475521724" sldId="263"/>
+            <ac:spMk id="38" creationId="{43621672-E1BE-E0FF-1C63-7B694986EFED}"/>
+          </ac:spMkLst>
+        </pc:spChg>
+        <pc:spChg chg="mod">
+          <ac:chgData name="Simon Hong" userId="2f15200c-b3cf-4aef-8f69-ada819764841" providerId="ADAL" clId="{6AB89950-CF24-4538-93AF-1A20832D1772}" dt="2026-10-09T17:46:59.124" v="483" actId="1036"/>
+          <ac:spMkLst>
+            <pc:docMk/>
+            <pc:sldMk cId="2475521724" sldId="263"/>
+            <ac:spMk id="44" creationId="{ED27EE2C-F2B7-4259-E54C-0C0100B2E02D}"/>
+          </ac:spMkLst>
+        </pc:spChg>
+        <pc:spChg chg="mod">
+          <ac:chgData name="Simon Hong" userId="2f15200c-b3cf-4aef-8f69-ada819764841" providerId="ADAL" clId="{6AB89950-CF24-4538-93AF-1A20832D1772}" dt="2026-10-09T17:46:59.124" v="483" actId="1036"/>
+          <ac:spMkLst>
+            <pc:docMk/>
+            <pc:sldMk cId="2475521724" sldId="263"/>
+            <ac:spMk id="46" creationId="{1C110048-5D99-9B4F-7B5E-3CA9E964CD81}"/>
+          </ac:spMkLst>
+        </pc:spChg>
+        <pc:spChg chg="mod">
+          <ac:chgData name="Simon Hong" userId="2f15200c-b3cf-4aef-8f69-ada819764841" providerId="ADAL" clId="{6AB89950-CF24-4538-93AF-1A20832D1772}" dt="2026-10-09T19:17:00.791" v="981" actId="1037"/>
+          <ac:spMkLst>
+            <pc:docMk/>
+            <pc:sldMk cId="2475521724" sldId="263"/>
+            <ac:spMk id="63" creationId="{43F406F2-8E94-5E30-F1DE-72C08D605038}"/>
+          </ac:spMkLst>
+        </pc:spChg>
+        <pc:spChg chg="mod">
+          <ac:chgData name="Simon Hong" userId="2f15200c-b3cf-4aef-8f69-ada819764841" providerId="ADAL" clId="{6AB89950-CF24-4538-93AF-1A20832D1772}" dt="2026-10-09T19:17:00.791" v="981" actId="1037"/>
+          <ac:spMkLst>
+            <pc:docMk/>
+            <pc:sldMk cId="2475521724" sldId="263"/>
+            <ac:spMk id="72" creationId="{5106D71A-0BEC-13B3-392C-694A475A003A}"/>
+          </ac:spMkLst>
+        </pc:spChg>
+        <pc:spChg chg="mod">
+          <ac:chgData name="Simon Hong" userId="2f15200c-b3cf-4aef-8f69-ada819764841" providerId="ADAL" clId="{6AB89950-CF24-4538-93AF-1A20832D1772}" dt="2026-10-09T17:46:59.124" v="483" actId="1036"/>
+          <ac:spMkLst>
+            <pc:docMk/>
+            <pc:sldMk cId="2475521724" sldId="263"/>
+            <ac:spMk id="73" creationId="{38C6028C-2E54-585C-15FD-19C638FD1AE3}"/>
+          </ac:spMkLst>
+        </pc:spChg>
+        <pc:spChg chg="mod">
+          <ac:chgData name="Simon Hong" userId="2f15200c-b3cf-4aef-8f69-ada819764841" providerId="ADAL" clId="{6AB89950-CF24-4538-93AF-1A20832D1772}" dt="2026-10-09T17:46:59.124" v="483" actId="1036"/>
+          <ac:spMkLst>
+            <pc:docMk/>
+            <pc:sldMk cId="2475521724" sldId="263"/>
+            <ac:spMk id="74" creationId="{A092B615-58A0-6761-FD45-BFCD684B1D6E}"/>
+          </ac:spMkLst>
+        </pc:spChg>
+        <pc:spChg chg="mod">
+          <ac:chgData name="Simon Hong" userId="2f15200c-b3cf-4aef-8f69-ada819764841" providerId="ADAL" clId="{6AB89950-CF24-4538-93AF-1A20832D1772}" dt="2026-10-09T19:17:00.791" v="981" actId="1037"/>
+          <ac:spMkLst>
+            <pc:docMk/>
+            <pc:sldMk cId="2475521724" sldId="263"/>
+            <ac:spMk id="90" creationId="{C0BB03E8-0D67-32A2-5433-8CAA7A7697C8}"/>
+          </ac:spMkLst>
+        </pc:spChg>
+        <pc:spChg chg="mod">
+          <ac:chgData name="Simon Hong" userId="2f15200c-b3cf-4aef-8f69-ada819764841" providerId="ADAL" clId="{6AB89950-CF24-4538-93AF-1A20832D1772}" dt="2026-10-09T19:17:00.791" v="981" actId="1037"/>
+          <ac:spMkLst>
+            <pc:docMk/>
+            <pc:sldMk cId="2475521724" sldId="263"/>
+            <ac:spMk id="91" creationId="{D8CE48DB-F0FC-0E8B-DEAF-BE699DCF8D49}"/>
           </ac:spMkLst>
         </pc:spChg>
         <pc:spChg chg="mod">
@@ -255,6 +407,30 @@
           </ac:spMkLst>
         </pc:spChg>
         <pc:spChg chg="mod">
+          <ac:chgData name="Simon Hong" userId="2f15200c-b3cf-4aef-8f69-ada819764841" providerId="ADAL" clId="{6AB89950-CF24-4538-93AF-1A20832D1772}" dt="2026-10-09T19:17:00.791" v="981" actId="1037"/>
+          <ac:spMkLst>
+            <pc:docMk/>
+            <pc:sldMk cId="2475521724" sldId="263"/>
+            <ac:spMk id="97" creationId="{965DC3F9-0AB2-A42E-02DC-C2DD60611F65}"/>
+          </ac:spMkLst>
+        </pc:spChg>
+        <pc:spChg chg="mod">
+          <ac:chgData name="Simon Hong" userId="2f15200c-b3cf-4aef-8f69-ada819764841" providerId="ADAL" clId="{6AB89950-CF24-4538-93AF-1A20832D1772}" dt="2026-10-09T17:46:59.124" v="483" actId="1036"/>
+          <ac:spMkLst>
+            <pc:docMk/>
+            <pc:sldMk cId="2475521724" sldId="263"/>
+            <ac:spMk id="108" creationId="{0ECD30BB-30A6-AB49-10A3-FBBFE805BA89}"/>
+          </ac:spMkLst>
+        </pc:spChg>
+        <pc:spChg chg="mod">
+          <ac:chgData name="Simon Hong" userId="2f15200c-b3cf-4aef-8f69-ada819764841" providerId="ADAL" clId="{6AB89950-CF24-4538-93AF-1A20832D1772}" dt="2026-10-09T17:46:59.124" v="483" actId="1036"/>
+          <ac:spMkLst>
+            <pc:docMk/>
+            <pc:sldMk cId="2475521724" sldId="263"/>
+            <ac:spMk id="110" creationId="{2AAD4B30-23DB-BE04-7E18-E090DBCF22EC}"/>
+          </ac:spMkLst>
+        </pc:spChg>
+        <pc:spChg chg="mod">
           <ac:chgData name="Simon Hong" userId="2f15200c-b3cf-4aef-8f69-ada819764841" providerId="ADAL" clId="{6AB89950-CF24-4538-93AF-1A20832D1772}" dt="2026-10-05T21:44:24.683" v="132" actId="113"/>
           <ac:spMkLst>
             <pc:docMk/>
@@ -262,8 +438,8 @@
             <ac:spMk id="113" creationId="{C9560F2E-B965-2C39-CFF6-2CE892DE4C5C}"/>
           </ac:spMkLst>
         </pc:spChg>
-        <pc:spChg chg="mod">
-          <ac:chgData name="Simon Hong" userId="2f15200c-b3cf-4aef-8f69-ada819764841" providerId="ADAL" clId="{6AB89950-CF24-4538-93AF-1A20832D1772}" dt="2026-10-05T22:02:15.738" v="244" actId="6549"/>
+        <pc:spChg chg="mod ord">
+          <ac:chgData name="Simon Hong" userId="2f15200c-b3cf-4aef-8f69-ada819764841" providerId="ADAL" clId="{6AB89950-CF24-4538-93AF-1A20832D1772}" dt="2026-10-09T19:13:36.076" v="968" actId="14100"/>
           <ac:spMkLst>
             <pc:docMk/>
             <pc:sldMk cId="2475521724" sldId="263"/>
@@ -271,7 +447,23 @@
           </ac:spMkLst>
         </pc:spChg>
         <pc:spChg chg="mod">
-          <ac:chgData name="Simon Hong" userId="2f15200c-b3cf-4aef-8f69-ada819764841" providerId="ADAL" clId="{6AB89950-CF24-4538-93AF-1A20832D1772}" dt="2026-10-05T22:05:44.250" v="256" actId="20577"/>
+          <ac:chgData name="Simon Hong" userId="2f15200c-b3cf-4aef-8f69-ada819764841" providerId="ADAL" clId="{6AB89950-CF24-4538-93AF-1A20832D1772}" dt="2026-10-09T17:46:59.124" v="483" actId="1036"/>
+          <ac:spMkLst>
+            <pc:docMk/>
+            <pc:sldMk cId="2475521724" sldId="263"/>
+            <ac:spMk id="122" creationId="{C5617F28-5962-DD22-71E0-2DB551477752}"/>
+          </ac:spMkLst>
+        </pc:spChg>
+        <pc:spChg chg="mod">
+          <ac:chgData name="Simon Hong" userId="2f15200c-b3cf-4aef-8f69-ada819764841" providerId="ADAL" clId="{6AB89950-CF24-4538-93AF-1A20832D1772}" dt="2026-10-09T17:46:59.124" v="483" actId="1036"/>
+          <ac:spMkLst>
+            <pc:docMk/>
+            <pc:sldMk cId="2475521724" sldId="263"/>
+            <ac:spMk id="124" creationId="{53DA67CD-86CF-7C6C-34BD-6C7F76498A29}"/>
+          </ac:spMkLst>
+        </pc:spChg>
+        <pc:spChg chg="mod">
+          <ac:chgData name="Simon Hong" userId="2f15200c-b3cf-4aef-8f69-ada819764841" providerId="ADAL" clId="{6AB89950-CF24-4538-93AF-1A20832D1772}" dt="2026-10-09T17:46:59.124" v="483" actId="1036"/>
           <ac:spMkLst>
             <pc:docMk/>
             <pc:sldMk cId="2475521724" sldId="263"/>
@@ -279,7 +471,7 @@
           </ac:spMkLst>
         </pc:spChg>
         <pc:spChg chg="mod">
-          <ac:chgData name="Simon Hong" userId="2f15200c-b3cf-4aef-8f69-ada819764841" providerId="ADAL" clId="{6AB89950-CF24-4538-93AF-1A20832D1772}" dt="2026-10-05T22:02:47.792" v="248" actId="20577"/>
+          <ac:chgData name="Simon Hong" userId="2f15200c-b3cf-4aef-8f69-ada819764841" providerId="ADAL" clId="{6AB89950-CF24-4538-93AF-1A20832D1772}" dt="2026-10-09T19:17:00.791" v="981" actId="1037"/>
           <ac:spMkLst>
             <pc:docMk/>
             <pc:sldMk cId="2475521724" sldId="263"/>
@@ -287,13 +479,125 @@
           </ac:spMkLst>
         </pc:spChg>
         <pc:spChg chg="mod">
-          <ac:chgData name="Simon Hong" userId="2f15200c-b3cf-4aef-8f69-ada819764841" providerId="ADAL" clId="{6AB89950-CF24-4538-93AF-1A20832D1772}" dt="2026-10-05T22:04:52.248" v="254" actId="6549"/>
+          <ac:chgData name="Simon Hong" userId="2f15200c-b3cf-4aef-8f69-ada819764841" providerId="ADAL" clId="{6AB89950-CF24-4538-93AF-1A20832D1772}" dt="2026-10-09T19:17:00.791" v="981" actId="1037"/>
           <ac:spMkLst>
             <pc:docMk/>
             <pc:sldMk cId="2475521724" sldId="263"/>
             <ac:spMk id="132" creationId="{0D77CCE7-1645-D03F-9FDF-9718737ED569}"/>
           </ac:spMkLst>
         </pc:spChg>
+        <pc:spChg chg="mod">
+          <ac:chgData name="Simon Hong" userId="2f15200c-b3cf-4aef-8f69-ada819764841" providerId="ADAL" clId="{6AB89950-CF24-4538-93AF-1A20832D1772}" dt="2026-10-09T17:50:01.805" v="537" actId="14100"/>
+          <ac:spMkLst>
+            <pc:docMk/>
+            <pc:sldMk cId="2475521724" sldId="263"/>
+            <ac:spMk id="136" creationId="{7DD72A52-D7D1-8454-9E09-E454031BA21D}"/>
+          </ac:spMkLst>
+        </pc:spChg>
+        <pc:spChg chg="mod">
+          <ac:chgData name="Simon Hong" userId="2f15200c-b3cf-4aef-8f69-ada819764841" providerId="ADAL" clId="{6AB89950-CF24-4538-93AF-1A20832D1772}" dt="2026-10-09T17:52:49.442" v="775" actId="20577"/>
+          <ac:spMkLst>
+            <pc:docMk/>
+            <pc:sldMk cId="2475521724" sldId="263"/>
+            <ac:spMk id="146" creationId="{2DB6D99C-D67E-4DB8-802A-D1D2FDC211A3}"/>
+          </ac:spMkLst>
+        </pc:spChg>
+        <pc:spChg chg="add mod">
+          <ac:chgData name="Simon Hong" userId="2f15200c-b3cf-4aef-8f69-ada819764841" providerId="ADAL" clId="{6AB89950-CF24-4538-93AF-1A20832D1772}" dt="2026-10-09T17:49:36.480" v="534" actId="20577"/>
+          <ac:spMkLst>
+            <pc:docMk/>
+            <pc:sldMk cId="2475521724" sldId="263"/>
+            <ac:spMk id="169" creationId="{45B5BACE-5E75-DB60-BB3C-CEFD60FA53CF}"/>
+          </ac:spMkLst>
+        </pc:spChg>
+        <pc:spChg chg="add mod">
+          <ac:chgData name="Simon Hong" userId="2f15200c-b3cf-4aef-8f69-ada819764841" providerId="ADAL" clId="{6AB89950-CF24-4538-93AF-1A20832D1772}" dt="2026-10-09T17:48:05.408" v="520" actId="571"/>
+          <ac:spMkLst>
+            <pc:docMk/>
+            <pc:sldMk cId="2475521724" sldId="263"/>
+            <ac:spMk id="171" creationId="{48432214-1A91-D5AB-DC05-26F93358FB0B}"/>
+          </ac:spMkLst>
+        </pc:spChg>
+        <pc:spChg chg="add mod">
+          <ac:chgData name="Simon Hong" userId="2f15200c-b3cf-4aef-8f69-ada819764841" providerId="ADAL" clId="{6AB89950-CF24-4538-93AF-1A20832D1772}" dt="2026-10-09T17:48:14.639" v="524" actId="571"/>
+          <ac:spMkLst>
+            <pc:docMk/>
+            <pc:sldMk cId="2475521724" sldId="263"/>
+            <ac:spMk id="172" creationId="{16715D96-15CD-2B13-D578-54E2633BF4CF}"/>
+          </ac:spMkLst>
+        </pc:spChg>
+        <pc:spChg chg="add mod">
+          <ac:chgData name="Simon Hong" userId="2f15200c-b3cf-4aef-8f69-ada819764841" providerId="ADAL" clId="{6AB89950-CF24-4538-93AF-1A20832D1772}" dt="2026-10-09T17:50:11.346" v="539" actId="571"/>
+          <ac:spMkLst>
+            <pc:docMk/>
+            <pc:sldMk cId="2475521724" sldId="263"/>
+            <ac:spMk id="178" creationId="{F836A25F-ECCB-CADD-A312-90E74D438996}"/>
+          </ac:spMkLst>
+        </pc:spChg>
+        <pc:spChg chg="add mod">
+          <ac:chgData name="Simon Hong" userId="2f15200c-b3cf-4aef-8f69-ada819764841" providerId="ADAL" clId="{6AB89950-CF24-4538-93AF-1A20832D1772}" dt="2026-10-09T17:53:49.145" v="778" actId="6549"/>
+          <ac:spMkLst>
+            <pc:docMk/>
+            <pc:sldMk cId="2475521724" sldId="263"/>
+            <ac:spMk id="183" creationId="{173415F7-DF5F-69E6-5E0A-FE99A5D5C93E}"/>
+          </ac:spMkLst>
+        </pc:spChg>
+        <pc:spChg chg="add mod">
+          <ac:chgData name="Simon Hong" userId="2f15200c-b3cf-4aef-8f69-ada819764841" providerId="ADAL" clId="{6AB89950-CF24-4538-93AF-1A20832D1772}" dt="2026-10-09T17:53:06.446" v="776" actId="571"/>
+          <ac:spMkLst>
+            <pc:docMk/>
+            <pc:sldMk cId="2475521724" sldId="263"/>
+            <ac:spMk id="184" creationId="{44B30D09-1C01-3CCA-4C85-1801DD1D151F}"/>
+          </ac:spMkLst>
+        </pc:spChg>
+        <pc:grpChg chg="mod">
+          <ac:chgData name="Simon Hong" userId="2f15200c-b3cf-4aef-8f69-ada819764841" providerId="ADAL" clId="{6AB89950-CF24-4538-93AF-1A20832D1772}" dt="2026-10-09T19:13:41.351" v="969" actId="14100"/>
+          <ac:grpSpMkLst>
+            <pc:docMk/>
+            <pc:sldMk cId="2475521724" sldId="263"/>
+            <ac:grpSpMk id="40" creationId="{3B9F416B-9ECD-9F7F-7184-A871F2493A26}"/>
+          </ac:grpSpMkLst>
+        </pc:grpChg>
+        <pc:cxnChg chg="mod">
+          <ac:chgData name="Simon Hong" userId="2f15200c-b3cf-4aef-8f69-ada819764841" providerId="ADAL" clId="{6AB89950-CF24-4538-93AF-1A20832D1772}" dt="2026-10-09T17:49:27.774" v="529" actId="14100"/>
+          <ac:cxnSpMkLst>
+            <pc:docMk/>
+            <pc:sldMk cId="2475521724" sldId="263"/>
+            <ac:cxnSpMk id="12" creationId="{FF772285-D127-0495-87FD-D16B17880798}"/>
+          </ac:cxnSpMkLst>
+        </pc:cxnChg>
+        <pc:cxnChg chg="mod">
+          <ac:chgData name="Simon Hong" userId="2f15200c-b3cf-4aef-8f69-ada819764841" providerId="ADAL" clId="{6AB89950-CF24-4538-93AF-1A20832D1772}" dt="2026-10-09T17:47:30.528" v="503" actId="14100"/>
+          <ac:cxnSpMkLst>
+            <pc:docMk/>
+            <pc:sldMk cId="2475521724" sldId="263"/>
+            <ac:cxnSpMk id="17" creationId="{8868319C-E4D0-6162-113D-4B5C03B105BF}"/>
+          </ac:cxnSpMkLst>
+        </pc:cxnChg>
+        <pc:cxnChg chg="mod">
+          <ac:chgData name="Simon Hong" userId="2f15200c-b3cf-4aef-8f69-ada819764841" providerId="ADAL" clId="{6AB89950-CF24-4538-93AF-1A20832D1772}" dt="2026-10-09T19:13:41.351" v="969" actId="14100"/>
+          <ac:cxnSpMkLst>
+            <pc:docMk/>
+            <pc:sldMk cId="2475521724" sldId="263"/>
+            <ac:cxnSpMk id="19" creationId="{A48D1EAD-4473-D33D-055D-F1EE8D39E577}"/>
+          </ac:cxnSpMkLst>
+        </pc:cxnChg>
+        <pc:cxnChg chg="mod">
+          <ac:chgData name="Simon Hong" userId="2f15200c-b3cf-4aef-8f69-ada819764841" providerId="ADAL" clId="{6AB89950-CF24-4538-93AF-1A20832D1772}" dt="2026-10-09T17:47:30.528" v="503" actId="14100"/>
+          <ac:cxnSpMkLst>
+            <pc:docMk/>
+            <pc:sldMk cId="2475521724" sldId="263"/>
+            <ac:cxnSpMk id="27" creationId="{7AB95253-F988-AF50-58D0-FA2FDA4A4A4B}"/>
+          </ac:cxnSpMkLst>
+        </pc:cxnChg>
+        <pc:cxnChg chg="mod">
+          <ac:chgData name="Simon Hong" userId="2f15200c-b3cf-4aef-8f69-ada819764841" providerId="ADAL" clId="{6AB89950-CF24-4538-93AF-1A20832D1772}" dt="2026-10-09T17:47:25.573" v="502" actId="1035"/>
+          <ac:cxnSpMkLst>
+            <pc:docMk/>
+            <pc:sldMk cId="2475521724" sldId="263"/>
+            <ac:cxnSpMk id="28" creationId="{71A64148-BF6A-F42D-4A5B-2146B1AA03D5}"/>
+          </ac:cxnSpMkLst>
+        </pc:cxnChg>
         <pc:cxnChg chg="mod">
           <ac:chgData name="Simon Hong" userId="2f15200c-b3cf-4aef-8f69-ada819764841" providerId="ADAL" clId="{6AB89950-CF24-4538-93AF-1A20832D1772}" dt="2026-10-05T22:04:37.659" v="253" actId="14100"/>
           <ac:cxnSpMkLst>
@@ -303,11 +607,59 @@
           </ac:cxnSpMkLst>
         </pc:cxnChg>
         <pc:cxnChg chg="mod">
+          <ac:chgData name="Simon Hong" userId="2f15200c-b3cf-4aef-8f69-ada819764841" providerId="ADAL" clId="{6AB89950-CF24-4538-93AF-1A20832D1772}" dt="2026-10-09T19:13:41.351" v="969" actId="14100"/>
+          <ac:cxnSpMkLst>
+            <pc:docMk/>
+            <pc:sldMk cId="2475521724" sldId="263"/>
+            <ac:cxnSpMk id="69" creationId="{4303B419-E5B6-B3F4-877A-E555DC5CEAE6}"/>
+          </ac:cxnSpMkLst>
+        </pc:cxnChg>
+        <pc:cxnChg chg="mod">
+          <ac:chgData name="Simon Hong" userId="2f15200c-b3cf-4aef-8f69-ada819764841" providerId="ADAL" clId="{6AB89950-CF24-4538-93AF-1A20832D1772}" dt="2026-10-09T17:53:24.206" v="777" actId="14100"/>
+          <ac:cxnSpMkLst>
+            <pc:docMk/>
+            <pc:sldMk cId="2475521724" sldId="263"/>
+            <ac:cxnSpMk id="77" creationId="{1E61221B-F371-4C45-109F-71CEEE07AD58}"/>
+          </ac:cxnSpMkLst>
+        </pc:cxnChg>
+        <pc:cxnChg chg="mod">
+          <ac:chgData name="Simon Hong" userId="2f15200c-b3cf-4aef-8f69-ada819764841" providerId="ADAL" clId="{6AB89950-CF24-4538-93AF-1A20832D1772}" dt="2026-10-09T19:13:41.351" v="969" actId="14100"/>
+          <ac:cxnSpMkLst>
+            <pc:docMk/>
+            <pc:sldMk cId="2475521724" sldId="263"/>
+            <ac:cxnSpMk id="79" creationId="{76E23DB5-63B1-93EE-7F8A-014F3358B88F}"/>
+          </ac:cxnSpMkLst>
+        </pc:cxnChg>
+        <pc:cxnChg chg="mod">
           <ac:chgData name="Simon Hong" userId="2f15200c-b3cf-4aef-8f69-ada819764841" providerId="ADAL" clId="{6AB89950-CF24-4538-93AF-1A20832D1772}" dt="2026-10-05T22:04:37.659" v="253" actId="14100"/>
           <ac:cxnSpMkLst>
             <pc:docMk/>
             <pc:sldMk cId="2475521724" sldId="263"/>
             <ac:cxnSpMk id="106" creationId="{F0F0C8A2-87A9-8555-5D6D-5F1E44F2C393}"/>
+          </ac:cxnSpMkLst>
+        </pc:cxnChg>
+        <pc:cxnChg chg="mod">
+          <ac:chgData name="Simon Hong" userId="2f15200c-b3cf-4aef-8f69-ada819764841" providerId="ADAL" clId="{6AB89950-CF24-4538-93AF-1A20832D1772}" dt="2026-10-09T19:13:41.351" v="969" actId="14100"/>
+          <ac:cxnSpMkLst>
+            <pc:docMk/>
+            <pc:sldMk cId="2475521724" sldId="263"/>
+            <ac:cxnSpMk id="119" creationId="{31C64937-85AA-EB52-B850-82E723854C69}"/>
+          </ac:cxnSpMkLst>
+        </pc:cxnChg>
+        <pc:cxnChg chg="del mod">
+          <ac:chgData name="Simon Hong" userId="2f15200c-b3cf-4aef-8f69-ada819764841" providerId="ADAL" clId="{6AB89950-CF24-4538-93AF-1A20832D1772}" dt="2026-10-09T19:10:16.295" v="913" actId="478"/>
+          <ac:cxnSpMkLst>
+            <pc:docMk/>
+            <pc:sldMk cId="2475521724" sldId="263"/>
+            <ac:cxnSpMk id="121" creationId="{1D5C3394-70DE-0F89-EC59-E822C95878F7}"/>
+          </ac:cxnSpMkLst>
+        </pc:cxnChg>
+        <pc:cxnChg chg="add del mod">
+          <ac:chgData name="Simon Hong" userId="2f15200c-b3cf-4aef-8f69-ada819764841" providerId="ADAL" clId="{6AB89950-CF24-4538-93AF-1A20832D1772}" dt="2026-10-09T19:10:08.654" v="912" actId="478"/>
+          <ac:cxnSpMkLst>
+            <pc:docMk/>
+            <pc:sldMk cId="2475521724" sldId="263"/>
+            <ac:cxnSpMk id="126" creationId="{D36CCBE3-55A9-2EC9-358E-0E114B9FAA65}"/>
           </ac:cxnSpMkLst>
         </pc:cxnChg>
         <pc:cxnChg chg="mod">
@@ -332,6 +684,46 @@
             <pc:docMk/>
             <pc:sldMk cId="2475521724" sldId="263"/>
             <ac:cxnSpMk id="156" creationId="{31DAFEF0-D002-428A-5E10-87B66E1AB213}"/>
+          </ac:cxnSpMkLst>
+        </pc:cxnChg>
+        <pc:cxnChg chg="add del mod">
+          <ac:chgData name="Simon Hong" userId="2f15200c-b3cf-4aef-8f69-ada819764841" providerId="ADAL" clId="{6AB89950-CF24-4538-93AF-1A20832D1772}" dt="2026-10-09T19:11:18.256" v="924" actId="478"/>
+          <ac:cxnSpMkLst>
+            <pc:docMk/>
+            <pc:sldMk cId="2475521724" sldId="263"/>
+            <ac:cxnSpMk id="162" creationId="{2556571A-BC8C-D379-7E03-1AF7BD5C6F14}"/>
+          </ac:cxnSpMkLst>
+        </pc:cxnChg>
+        <pc:cxnChg chg="add mod">
+          <ac:chgData name="Simon Hong" userId="2f15200c-b3cf-4aef-8f69-ada819764841" providerId="ADAL" clId="{6AB89950-CF24-4538-93AF-1A20832D1772}" dt="2026-10-09T19:13:36.076" v="968" actId="14100"/>
+          <ac:cxnSpMkLst>
+            <pc:docMk/>
+            <pc:sldMk cId="2475521724" sldId="263"/>
+            <ac:cxnSpMk id="166" creationId="{29BDAEC3-B0F1-2AD5-D395-42FF5665ADAB}"/>
+          </ac:cxnSpMkLst>
+        </pc:cxnChg>
+        <pc:cxnChg chg="add mod">
+          <ac:chgData name="Simon Hong" userId="2f15200c-b3cf-4aef-8f69-ada819764841" providerId="ADAL" clId="{6AB89950-CF24-4538-93AF-1A20832D1772}" dt="2026-10-09T17:49:27.774" v="529" actId="14100"/>
+          <ac:cxnSpMkLst>
+            <pc:docMk/>
+            <pc:sldMk cId="2475521724" sldId="263"/>
+            <ac:cxnSpMk id="173" creationId="{D84BBED4-F848-E6B6-AA6F-C6419EA0C04A}"/>
+          </ac:cxnSpMkLst>
+        </pc:cxnChg>
+        <pc:cxnChg chg="add del mod">
+          <ac:chgData name="Simon Hong" userId="2f15200c-b3cf-4aef-8f69-ada819764841" providerId="ADAL" clId="{6AB89950-CF24-4538-93AF-1A20832D1772}" dt="2026-10-09T17:50:19.577" v="541" actId="478"/>
+          <ac:cxnSpMkLst>
+            <pc:docMk/>
+            <pc:sldMk cId="2475521724" sldId="263"/>
+            <ac:cxnSpMk id="179" creationId="{26D48696-37F1-9C7D-B222-200C3DA4BBF1}"/>
+          </ac:cxnSpMkLst>
+        </pc:cxnChg>
+        <pc:cxnChg chg="add mod">
+          <ac:chgData name="Simon Hong" userId="2f15200c-b3cf-4aef-8f69-ada819764841" providerId="ADAL" clId="{6AB89950-CF24-4538-93AF-1A20832D1772}" dt="2026-10-09T19:13:41.351" v="969" actId="14100"/>
+          <ac:cxnSpMkLst>
+            <pc:docMk/>
+            <pc:sldMk cId="2475521724" sldId="263"/>
+            <ac:cxnSpMk id="180" creationId="{F963A72C-4A8E-BBFE-0674-5EA1411A3275}"/>
           </ac:cxnSpMkLst>
         </pc:cxnChg>
       </pc:sldChg>
@@ -431,17 +823,192 @@
         </pc:spChg>
       </pc:sldChg>
       <pc:sldChg chg="modSp add mod setBg">
-        <pc:chgData name="Simon Hong" userId="2f15200c-b3cf-4aef-8f69-ada819764841" providerId="ADAL" clId="{6AB89950-CF24-4538-93AF-1A20832D1772}" dt="2026-10-09T16:54:45.668" v="464" actId="6549"/>
+        <pc:chgData name="Simon Hong" userId="2f15200c-b3cf-4aef-8f69-ada819764841" providerId="ADAL" clId="{6AB89950-CF24-4538-93AF-1A20832D1772}" dt="2026-10-09T17:22:29.848" v="465" actId="108"/>
         <pc:sldMkLst>
           <pc:docMk/>
           <pc:sldMk cId="0" sldId="265"/>
         </pc:sldMkLst>
         <pc:spChg chg="mod">
-          <ac:chgData name="Simon Hong" userId="2f15200c-b3cf-4aef-8f69-ada819764841" providerId="ADAL" clId="{6AB89950-CF24-4538-93AF-1A20832D1772}" dt="2026-10-09T16:54:45.668" v="464" actId="6549"/>
+          <ac:chgData name="Simon Hong" userId="2f15200c-b3cf-4aef-8f69-ada819764841" providerId="ADAL" clId="{6AB89950-CF24-4538-93AF-1A20832D1772}" dt="2026-10-09T17:22:29.848" v="465" actId="108"/>
           <ac:spMkLst>
             <pc:docMk/>
             <pc:sldMk cId="0" sldId="265"/>
             <ac:spMk id="3" creationId="{00000000-0000-0000-0000-000000000000}"/>
+          </ac:spMkLst>
+        </pc:spChg>
+      </pc:sldChg>
+      <pc:sldChg chg="addSp delSp modSp add mod">
+        <pc:chgData name="Simon Hong" userId="2f15200c-b3cf-4aef-8f69-ada819764841" providerId="ADAL" clId="{6AB89950-CF24-4538-93AF-1A20832D1772}" dt="2026-10-09T18:59:46.581" v="908" actId="1035"/>
+        <pc:sldMkLst>
+          <pc:docMk/>
+          <pc:sldMk cId="0" sldId="266"/>
+        </pc:sldMkLst>
+        <pc:spChg chg="mod">
+          <ac:chgData name="Simon Hong" userId="2f15200c-b3cf-4aef-8f69-ada819764841" providerId="ADAL" clId="{6AB89950-CF24-4538-93AF-1A20832D1772}" dt="2026-10-09T18:52:05.716" v="780" actId="108"/>
+          <ac:spMkLst>
+            <pc:docMk/>
+            <pc:sldMk cId="0" sldId="266"/>
+            <ac:spMk id="3" creationId="{00000000-0000-0000-0000-000000000000}"/>
+          </ac:spMkLst>
+        </pc:spChg>
+        <pc:spChg chg="add del mod">
+          <ac:chgData name="Simon Hong" userId="2f15200c-b3cf-4aef-8f69-ada819764841" providerId="ADAL" clId="{6AB89950-CF24-4538-93AF-1A20832D1772}" dt="2026-10-09T18:58:06.344" v="866" actId="6549"/>
+          <ac:spMkLst>
+            <pc:docMk/>
+            <pc:sldMk cId="0" sldId="266"/>
+            <ac:spMk id="5" creationId="{00000000-0000-0000-0000-000000000000}"/>
+          </ac:spMkLst>
+        </pc:spChg>
+        <pc:spChg chg="del mod">
+          <ac:chgData name="Simon Hong" userId="2f15200c-b3cf-4aef-8f69-ada819764841" providerId="ADAL" clId="{6AB89950-CF24-4538-93AF-1A20832D1772}" dt="2026-10-09T18:58:25.981" v="867" actId="478"/>
+          <ac:spMkLst>
+            <pc:docMk/>
+            <pc:sldMk cId="0" sldId="266"/>
+            <ac:spMk id="6" creationId="{00000000-0000-0000-0000-000000000000}"/>
+          </ac:spMkLst>
+        </pc:spChg>
+        <pc:spChg chg="del">
+          <ac:chgData name="Simon Hong" userId="2f15200c-b3cf-4aef-8f69-ada819764841" providerId="ADAL" clId="{6AB89950-CF24-4538-93AF-1A20832D1772}" dt="2026-10-09T18:58:29.248" v="868" actId="478"/>
+          <ac:spMkLst>
+            <pc:docMk/>
+            <pc:sldMk cId="0" sldId="266"/>
+            <ac:spMk id="7" creationId="{00000000-0000-0000-0000-000000000000}"/>
+          </ac:spMkLst>
+        </pc:spChg>
+        <pc:spChg chg="mod">
+          <ac:chgData name="Simon Hong" userId="2f15200c-b3cf-4aef-8f69-ada819764841" providerId="ADAL" clId="{6AB89950-CF24-4538-93AF-1A20832D1772}" dt="2026-10-09T18:59:24.301" v="884" actId="20577"/>
+          <ac:spMkLst>
+            <pc:docMk/>
+            <pc:sldMk cId="0" sldId="266"/>
+            <ac:spMk id="8" creationId="{00000000-0000-0000-0000-000000000000}"/>
+          </ac:spMkLst>
+        </pc:spChg>
+        <pc:spChg chg="mod">
+          <ac:chgData name="Simon Hong" userId="2f15200c-b3cf-4aef-8f69-ada819764841" providerId="ADAL" clId="{6AB89950-CF24-4538-93AF-1A20832D1772}" dt="2026-10-09T18:56:44.785" v="823" actId="1036"/>
+          <ac:spMkLst>
+            <pc:docMk/>
+            <pc:sldMk cId="0" sldId="266"/>
+            <ac:spMk id="10" creationId="{00000000-0000-0000-0000-000000000000}"/>
+          </ac:spMkLst>
+        </pc:spChg>
+        <pc:spChg chg="mod">
+          <ac:chgData name="Simon Hong" userId="2f15200c-b3cf-4aef-8f69-ada819764841" providerId="ADAL" clId="{6AB89950-CF24-4538-93AF-1A20832D1772}" dt="2026-10-09T18:59:46.581" v="908" actId="1035"/>
+          <ac:spMkLst>
+            <pc:docMk/>
+            <pc:sldMk cId="0" sldId="266"/>
+            <ac:spMk id="11" creationId="{00000000-0000-0000-0000-000000000000}"/>
+          </ac:spMkLst>
+        </pc:spChg>
+        <pc:spChg chg="mod">
+          <ac:chgData name="Simon Hong" userId="2f15200c-b3cf-4aef-8f69-ada819764841" providerId="ADAL" clId="{6AB89950-CF24-4538-93AF-1A20832D1772}" dt="2026-10-09T18:59:46.581" v="908" actId="1035"/>
+          <ac:spMkLst>
+            <pc:docMk/>
+            <pc:sldMk cId="0" sldId="266"/>
+            <ac:spMk id="12" creationId="{00000000-0000-0000-0000-000000000000}"/>
+          </ac:spMkLst>
+        </pc:spChg>
+        <pc:spChg chg="mod">
+          <ac:chgData name="Simon Hong" userId="2f15200c-b3cf-4aef-8f69-ada819764841" providerId="ADAL" clId="{6AB89950-CF24-4538-93AF-1A20832D1772}" dt="2026-10-09T18:59:46.581" v="908" actId="1035"/>
+          <ac:spMkLst>
+            <pc:docMk/>
+            <pc:sldMk cId="0" sldId="266"/>
+            <ac:spMk id="15" creationId="{00000000-0000-0000-0000-000000000000}"/>
+          </ac:spMkLst>
+        </pc:spChg>
+        <pc:spChg chg="mod">
+          <ac:chgData name="Simon Hong" userId="2f15200c-b3cf-4aef-8f69-ada819764841" providerId="ADAL" clId="{6AB89950-CF24-4538-93AF-1A20832D1772}" dt="2026-10-09T18:59:46.581" v="908" actId="1035"/>
+          <ac:spMkLst>
+            <pc:docMk/>
+            <pc:sldMk cId="0" sldId="266"/>
+            <ac:spMk id="16" creationId="{00000000-0000-0000-0000-000000000000}"/>
+          </ac:spMkLst>
+        </pc:spChg>
+        <pc:spChg chg="mod">
+          <ac:chgData name="Simon Hong" userId="2f15200c-b3cf-4aef-8f69-ada819764841" providerId="ADAL" clId="{6AB89950-CF24-4538-93AF-1A20832D1772}" dt="2026-10-09T18:59:46.581" v="908" actId="1035"/>
+          <ac:spMkLst>
+            <pc:docMk/>
+            <pc:sldMk cId="0" sldId="266"/>
+            <ac:spMk id="17" creationId="{00000000-0000-0000-0000-000000000000}"/>
+          </ac:spMkLst>
+        </pc:spChg>
+        <pc:spChg chg="mod">
+          <ac:chgData name="Simon Hong" userId="2f15200c-b3cf-4aef-8f69-ada819764841" providerId="ADAL" clId="{6AB89950-CF24-4538-93AF-1A20832D1772}" dt="2026-10-09T18:56:44.785" v="823" actId="1036"/>
+          <ac:spMkLst>
+            <pc:docMk/>
+            <pc:sldMk cId="0" sldId="266"/>
+            <ac:spMk id="18" creationId="{00000000-0000-0000-0000-000000000000}"/>
+          </ac:spMkLst>
+        </pc:spChg>
+        <pc:spChg chg="mod">
+          <ac:chgData name="Simon Hong" userId="2f15200c-b3cf-4aef-8f69-ada819764841" providerId="ADAL" clId="{6AB89950-CF24-4538-93AF-1A20832D1772}" dt="2026-10-09T18:59:46.581" v="908" actId="1035"/>
+          <ac:spMkLst>
+            <pc:docMk/>
+            <pc:sldMk cId="0" sldId="266"/>
+            <ac:spMk id="19" creationId="{00000000-0000-0000-0000-000000000000}"/>
+          </ac:spMkLst>
+        </pc:spChg>
+        <pc:spChg chg="mod">
+          <ac:chgData name="Simon Hong" userId="2f15200c-b3cf-4aef-8f69-ada819764841" providerId="ADAL" clId="{6AB89950-CF24-4538-93AF-1A20832D1772}" dt="2026-10-09T18:59:46.581" v="908" actId="1035"/>
+          <ac:spMkLst>
+            <pc:docMk/>
+            <pc:sldMk cId="0" sldId="266"/>
+            <ac:spMk id="20" creationId="{00000000-0000-0000-0000-000000000000}"/>
+          </ac:spMkLst>
+        </pc:spChg>
+        <pc:spChg chg="mod">
+          <ac:chgData name="Simon Hong" userId="2f15200c-b3cf-4aef-8f69-ada819764841" providerId="ADAL" clId="{6AB89950-CF24-4538-93AF-1A20832D1772}" dt="2026-10-09T18:56:44.785" v="823" actId="1036"/>
+          <ac:spMkLst>
+            <pc:docMk/>
+            <pc:sldMk cId="0" sldId="266"/>
+            <ac:spMk id="22" creationId="{00000000-0000-0000-0000-000000000000}"/>
+          </ac:spMkLst>
+        </pc:spChg>
+        <pc:spChg chg="mod">
+          <ac:chgData name="Simon Hong" userId="2f15200c-b3cf-4aef-8f69-ada819764841" providerId="ADAL" clId="{6AB89950-CF24-4538-93AF-1A20832D1772}" dt="2026-10-09T18:59:46.581" v="908" actId="1035"/>
+          <ac:spMkLst>
+            <pc:docMk/>
+            <pc:sldMk cId="0" sldId="266"/>
+            <ac:spMk id="23" creationId="{00000000-0000-0000-0000-000000000000}"/>
+          </ac:spMkLst>
+        </pc:spChg>
+        <pc:spChg chg="mod">
+          <ac:chgData name="Simon Hong" userId="2f15200c-b3cf-4aef-8f69-ada819764841" providerId="ADAL" clId="{6AB89950-CF24-4538-93AF-1A20832D1772}" dt="2026-10-09T18:59:46.581" v="908" actId="1035"/>
+          <ac:spMkLst>
+            <pc:docMk/>
+            <pc:sldMk cId="0" sldId="266"/>
+            <ac:spMk id="24" creationId="{00000000-0000-0000-0000-000000000000}"/>
+          </ac:spMkLst>
+        </pc:spChg>
+        <pc:spChg chg="mod">
+          <ac:chgData name="Simon Hong" userId="2f15200c-b3cf-4aef-8f69-ada819764841" providerId="ADAL" clId="{6AB89950-CF24-4538-93AF-1A20832D1772}" dt="2026-10-09T18:59:46.581" v="908" actId="1035"/>
+          <ac:spMkLst>
+            <pc:docMk/>
+            <pc:sldMk cId="0" sldId="266"/>
+            <ac:spMk id="25" creationId="{00000000-0000-0000-0000-000000000000}"/>
+          </ac:spMkLst>
+        </pc:spChg>
+        <pc:spChg chg="mod">
+          <ac:chgData name="Simon Hong" userId="2f15200c-b3cf-4aef-8f69-ada819764841" providerId="ADAL" clId="{6AB89950-CF24-4538-93AF-1A20832D1772}" dt="2026-10-09T18:56:44.785" v="823" actId="1036"/>
+          <ac:spMkLst>
+            <pc:docMk/>
+            <pc:sldMk cId="0" sldId="266"/>
+            <ac:spMk id="31" creationId="{00000000-0000-0000-0000-000000000000}"/>
+          </ac:spMkLst>
+        </pc:spChg>
+        <pc:spChg chg="mod">
+          <ac:chgData name="Simon Hong" userId="2f15200c-b3cf-4aef-8f69-ada819764841" providerId="ADAL" clId="{6AB89950-CF24-4538-93AF-1A20832D1772}" dt="2026-10-09T18:56:44.785" v="823" actId="1036"/>
+          <ac:spMkLst>
+            <pc:docMk/>
+            <pc:sldMk cId="0" sldId="266"/>
+            <ac:spMk id="37" creationId="{00000000-0000-0000-0000-000000000000}"/>
+          </ac:spMkLst>
+        </pc:spChg>
+        <pc:spChg chg="del">
+          <ac:chgData name="Simon Hong" userId="2f15200c-b3cf-4aef-8f69-ada819764841" providerId="ADAL" clId="{6AB89950-CF24-4538-93AF-1A20832D1772}" dt="2026-10-09T18:56:34.167" v="797" actId="478"/>
+          <ac:spMkLst>
+            <pc:docMk/>
+            <pc:sldMk cId="0" sldId="266"/>
+            <ac:spMk id="41" creationId="{00000000-0000-0000-0000-000000000000}"/>
           </ac:spMkLst>
         </pc:spChg>
       </pc:sldChg>
@@ -5167,7 +5734,7 @@
                 <a:latin typeface="Calibri" panose="020F0502020204030204" pitchFamily="34" charset="0"/>
                 <a:cs typeface="Calibri" panose="020F0502020204030204" pitchFamily="34" charset="0"/>
               </a:rPr>
-              <a:t>(A bad LLM can make a function just to pass the test items in BRD)</a:t>
+              <a:t>(A LLM can make a function just to pass the test items in BRD)</a:t>
             </a:r>
           </a:p>
           <a:p>
@@ -8869,7 +9436,7 @@
                 <a:ea typeface="+mn-ea"/>
                 <a:cs typeface="Courier New" panose="02070309020205020404" pitchFamily="49" charset="0"/>
               </a:rPr>
-              <a:t>  },</a:t>
+              <a:t>  }</a:t>
             </a:r>
           </a:p>
           <a:p>
@@ -9651,7 +10218,9 @@
                 <a:ea typeface="+mn-ea"/>
                 <a:cs typeface="Courier New" panose="02070309020205020404" pitchFamily="49" charset="0"/>
               </a:rPr>
-              <a:t>N_ITEMS_TO_PASS=15</a:t>
+              <a:t>ID_FIELD=incident_id
+EXPECTED_FIELD=expected_word_count
+N_ITEMS_TO_PASS=15</a:t>
             </a:r>
           </a:p>
           <a:p>
@@ -10825,7 +11394,9 @@
                 <a:ea typeface="+mn-ea"/>
                 <a:cs typeface="Courier New" panose="02070309020205020404" pitchFamily="49" charset="0"/>
               </a:rPr>
-              <a:t>N_ITEMS_TO_PASS=15</a:t>
+              <a:t>ID_FIELD=incident_id
+EXPECTED_FIELD=expected_word_count
+N_ITEMS_TO_PASS=15</a:t>
             </a:r>
           </a:p>
           <a:p>
@@ -15381,7 +15952,7 @@
                 <a:latin typeface="Calibri"/>
                 <a:sym typeface="Wingdings" panose="05000000000000000000" pitchFamily="2" charset="2"/>
               </a:rPr>
-              <a:t>function failure (anomaly </a:t>
+              <a:t>correction of failed BRD examples before deployment</a:t>
             </a:r>
             <a:r>
               <a:rPr lang="en-US" sz="4000" dirty="0">
@@ -15391,7 +15962,7 @@
                 <a:latin typeface="Calibri"/>
                 <a:sym typeface="Wingdings" panose="05000000000000000000" pitchFamily="2" charset="2"/>
               </a:rPr>
-              <a:t>monitoring and fixing</a:t>
+              <a:t/>
             </a:r>
             <a:r>
               <a:rPr lang="en-US" sz="4000" dirty="0">
@@ -15401,7 +15972,7 @@
                 <a:latin typeface="Calibri"/>
                 <a:sym typeface="Wingdings" panose="05000000000000000000" pitchFamily="2" charset="2"/>
               </a:rPr>
-              <a:t>)</a:t>
+              <a:t/>
             </a:r>
           </a:p>
           <a:p>
@@ -18256,34 +18827,15 @@
         </p:nvSpPr>
         <p:spPr>
           <a:xfrm>
-            <a:off x="10763735" y="8039100"/>
-            <a:ext cx="14306065" cy="16550376"/>
+            <a:off x="11178657" y="8039100"/>
+            <a:ext cx="13891143" cy="16550376"/>
           </a:xfrm>
           <a:prstGeom prst="roundRect">
             <a:avLst>
               <a:gd name="adj" fmla="val 3647"/>
             </a:avLst>
           </a:prstGeom>
-          <a:gradFill flip="none" rotWithShape="1">
-            <a:gsLst>
-              <a:gs pos="0">
-                <a:srgbClr val="FFFFFF"/>
-              </a:gs>
-              <a:gs pos="92000">
-                <a:srgbClr val="FFFFFF"/>
-              </a:gs>
-              <a:gs pos="100000">
-                <a:srgbClr val="B6D2E3">
-                  <a:lumMod val="20000"/>
-                  <a:lumOff val="80000"/>
-                </a:srgbClr>
-              </a:gs>
-            </a:gsLst>
-            <a:path path="rect">
-              <a:fillToRect l="50000" t="50000" r="50000" b="50000"/>
-            </a:path>
-            <a:tileRect/>
-          </a:gradFill>
+          <a:noFill/>
           <a:ln w="28575" cap="sq" cmpd="sng" algn="ctr">
             <a:solidFill>
               <a:srgbClr val="0000FF"/>
@@ -18750,7 +19302,7 @@
         </p:nvCxnSpPr>
         <p:spPr>
           <a:xfrm>
-            <a:off x="6750990" y="3972742"/>
+            <a:off x="5928030" y="3972742"/>
             <a:ext cx="5334" cy="319298"/>
           </a:xfrm>
           <a:prstGeom prst="straightConnector1">
@@ -18782,7 +19334,7 @@
         <p:spPr>
           <a:xfrm>
             <a:off x="15497248" y="14114340"/>
-            <a:ext cx="8851911" cy="2829646"/>
+            <a:ext cx="8851911" cy="2537689"/>
           </a:xfrm>
           <a:prstGeom prst="roundRect">
             <a:avLst>
@@ -18954,14 +19506,14 @@
           <p:cNvCxnSpPr>
             <a:cxnSpLocks/>
             <a:stCxn id="146" idx="2"/>
-            <a:endCxn id="110" idx="0"/>
+            <a:endCxn id="169" idx="0"/>
           </p:cNvCxnSpPr>
           <p:nvPr/>
         </p:nvCxnSpPr>
         <p:spPr>
           <a:xfrm>
-            <a:off x="18313289" y="16333303"/>
-            <a:ext cx="635" cy="926521"/>
+            <a:off x="18313289" y="16203763"/>
+            <a:ext cx="6240" cy="614475"/>
           </a:xfrm>
           <a:prstGeom prst="straightConnector1">
             <a:avLst/>
@@ -18991,7 +19543,7 @@
         </p:nvSpPr>
         <p:spPr>
           <a:xfrm>
-            <a:off x="20467712" y="15813350"/>
+            <a:off x="20467712" y="15683810"/>
             <a:ext cx="820736" cy="338554"/>
           </a:xfrm>
           <a:prstGeom prst="rect">
@@ -19042,8 +19594,8 @@
         </p:nvSpPr>
         <p:spPr>
           <a:xfrm>
-            <a:off x="17512454" y="16464647"/>
-            <a:ext cx="820736" cy="338554"/>
+            <a:off x="17790024" y="16235804"/>
+            <a:ext cx="529505" cy="276999"/>
           </a:xfrm>
           <a:prstGeom prst="rect">
             <a:avLst/>
@@ -19060,7 +19612,7 @@
               <a:defRPr/>
             </a:pPr>
             <a:r>
-              <a:rPr lang="en-US" sz="1600" dirty="0">
+              <a:rPr lang="en-US" sz="1200" dirty="0">
                 <a:solidFill>
                   <a:prstClr val="black">
                     <a:lumMod val="50000"/>
@@ -19070,7 +19622,7 @@
               </a:rPr>
               <a:t>Yes</a:t>
             </a:r>
-            <a:endParaRPr lang="en-US" sz="1600" dirty="0">
+            <a:endParaRPr lang="en-US" sz="1200" dirty="0">
               <a:solidFill>
                 <a:prstClr val="black"/>
               </a:solidFill>
@@ -19128,8 +19680,8 @@
         </p:nvSpPr>
         <p:spPr>
           <a:xfrm>
-            <a:off x="21324012" y="15636861"/>
-            <a:ext cx="2691924" cy="1066800"/>
+            <a:off x="21324012" y="15654201"/>
+            <a:ext cx="2691924" cy="773040"/>
           </a:xfrm>
           <a:prstGeom prst="diamond">
             <a:avLst/>
@@ -19206,7 +19758,7 @@
         </p:nvCxnSpPr>
         <p:spPr>
           <a:xfrm>
-            <a:off x="19622809" y="16167652"/>
+            <a:off x="19622809" y="16038112"/>
             <a:ext cx="1701203" cy="2609"/>
           </a:xfrm>
           <a:prstGeom prst="straightConnector1">
@@ -19292,8 +19844,8 @@
         </p:nvCxnSpPr>
         <p:spPr>
           <a:xfrm rot="16200000" flipH="1">
-            <a:off x="19646903" y="19726731"/>
-            <a:ext cx="6048085" cy="1943"/>
+            <a:off x="19449624" y="19647590"/>
+            <a:ext cx="6442643" cy="1943"/>
           </a:xfrm>
           <a:prstGeom prst="bentConnector3">
             <a:avLst>
@@ -19329,7 +19881,7 @@
         </p:nvCxnSpPr>
         <p:spPr>
           <a:xfrm flipH="1">
-            <a:off x="6750990" y="8084464"/>
+            <a:off x="5928030" y="8084464"/>
             <a:ext cx="5440" cy="1112107"/>
           </a:xfrm>
           <a:prstGeom prst="straightConnector1">
@@ -19360,7 +19912,7 @@
         </p:nvSpPr>
         <p:spPr>
           <a:xfrm>
-            <a:off x="21945311" y="16591474"/>
+            <a:off x="22329484" y="16325444"/>
             <a:ext cx="2138851" cy="500137"/>
           </a:xfrm>
           <a:prstGeom prst="rect">
@@ -19427,7 +19979,7 @@
         </p:nvGrpSpPr>
         <p:grpSpPr>
           <a:xfrm>
-            <a:off x="4387107" y="12516871"/>
+            <a:off x="3564147" y="12516871"/>
             <a:ext cx="4746562" cy="670280"/>
             <a:chOff x="12799260" y="4501979"/>
             <a:chExt cx="18288000" cy="670280"/>
@@ -19596,7 +20148,7 @@
         </p:nvCxnSpPr>
         <p:spPr>
           <a:xfrm>
-            <a:off x="6759499" y="12161085"/>
+            <a:off x="5936539" y="12161085"/>
             <a:ext cx="889" cy="561274"/>
           </a:xfrm>
           <a:prstGeom prst="straightConnector1">
@@ -19720,7 +20272,7 @@
         <p:spPr>
           <a:xfrm flipH="1" flipV="1">
             <a:off x="22660656" y="15255861"/>
-            <a:ext cx="9318" cy="381000"/>
+            <a:ext cx="9318" cy="398340"/>
           </a:xfrm>
           <a:prstGeom prst="straightConnector1">
             <a:avLst/>
@@ -19755,7 +20307,7 @@
         <p:spPr>
           <a:xfrm flipH="1">
             <a:off x="18313289" y="15207206"/>
-            <a:ext cx="388" cy="794794"/>
+            <a:ext cx="388" cy="665254"/>
           </a:xfrm>
           <a:prstGeom prst="straightConnector1">
             <a:avLst/>
@@ -19785,7 +20337,7 @@
         </p:nvSpPr>
         <p:spPr>
           <a:xfrm>
-            <a:off x="4590855" y="5137538"/>
+            <a:off x="3767895" y="5137538"/>
             <a:ext cx="4330938" cy="449561"/>
           </a:xfrm>
           <a:prstGeom prst="roundRect">
@@ -19951,7 +20503,7 @@
         </p:nvCxnSpPr>
         <p:spPr>
           <a:xfrm>
-            <a:off x="6756324" y="5587099"/>
+            <a:off x="5933364" y="5587099"/>
             <a:ext cx="3174" cy="374528"/>
           </a:xfrm>
           <a:prstGeom prst="straightConnector1">
@@ -20037,8 +20589,8 @@
         </p:nvCxnSpPr>
         <p:spPr>
           <a:xfrm rot="5400000" flipH="1" flipV="1">
-            <a:off x="11475850" y="11430845"/>
-            <a:ext cx="7152810" cy="6341204"/>
+            <a:off x="11351155" y="11555540"/>
+            <a:ext cx="7402200" cy="6341204"/>
           </a:xfrm>
           <a:prstGeom prst="bentConnector2">
             <a:avLst/>
@@ -20068,7 +20620,7 @@
         </p:nvSpPr>
         <p:spPr>
           <a:xfrm>
-            <a:off x="4590855" y="4292040"/>
+            <a:off x="3767895" y="4292040"/>
             <a:ext cx="4330938" cy="449561"/>
           </a:xfrm>
           <a:prstGeom prst="roundRect">
@@ -20160,7 +20712,7 @@
         </p:nvCxnSpPr>
         <p:spPr>
           <a:xfrm>
-            <a:off x="6756324" y="4741601"/>
+            <a:off x="5933364" y="4741601"/>
             <a:ext cx="0" cy="395937"/>
           </a:xfrm>
           <a:prstGeom prst="straightConnector1">
@@ -20191,7 +20743,7 @@
         </p:nvSpPr>
         <p:spPr>
           <a:xfrm>
-            <a:off x="2998794" y="10213852"/>
+            <a:off x="2175834" y="10213852"/>
             <a:ext cx="7525058" cy="593471"/>
           </a:xfrm>
           <a:prstGeom prst="diamond">
@@ -20269,7 +20821,7 @@
         </p:nvCxnSpPr>
         <p:spPr>
           <a:xfrm rot="10800000" flipH="1">
-            <a:off x="2998793" y="4516822"/>
+            <a:off x="2175833" y="4516822"/>
             <a:ext cx="1592061" cy="5993767"/>
           </a:xfrm>
           <a:prstGeom prst="bentConnector3">
@@ -20302,7 +20854,7 @@
         </p:nvSpPr>
         <p:spPr>
           <a:xfrm>
-            <a:off x="6924943" y="12279276"/>
+            <a:off x="6101983" y="12279276"/>
             <a:ext cx="820736" cy="400110"/>
           </a:xfrm>
           <a:prstGeom prst="rect">
@@ -20396,8 +20948,8 @@
         </p:nvGrpSpPr>
         <p:grpSpPr>
           <a:xfrm>
-            <a:off x="20896404" y="22729444"/>
-            <a:ext cx="3551026" cy="1019037"/>
+            <a:off x="20896404" y="22852990"/>
+            <a:ext cx="3551026" cy="771946"/>
             <a:chOff x="39533526" y="17475131"/>
             <a:chExt cx="4330938" cy="1019037"/>
           </a:xfrm>
@@ -20592,7 +21144,7 @@
         </p:nvSpPr>
         <p:spPr>
           <a:xfrm>
-            <a:off x="17060294" y="21174415"/>
+            <a:off x="17060294" y="21423805"/>
             <a:ext cx="2505124" cy="263061"/>
           </a:xfrm>
           <a:prstGeom prst="roundRect">
@@ -20680,7 +21232,7 @@
         </p:nvSpPr>
         <p:spPr>
           <a:xfrm>
-            <a:off x="16786662" y="21831642"/>
+            <a:off x="16786662" y="22081032"/>
             <a:ext cx="3054928" cy="494958"/>
           </a:xfrm>
           <a:prstGeom prst="diamond">
@@ -20758,7 +21310,7 @@
         </p:nvCxnSpPr>
         <p:spPr>
           <a:xfrm>
-            <a:off x="18312856" y="21437476"/>
+            <a:off x="18312856" y="21686866"/>
             <a:ext cx="1270" cy="394166"/>
           </a:xfrm>
           <a:prstGeom prst="straightConnector1">
@@ -20789,7 +21341,7 @@
         </p:nvSpPr>
         <p:spPr>
           <a:xfrm>
-            <a:off x="16522104" y="21788837"/>
+            <a:off x="16522104" y="22038227"/>
             <a:ext cx="463575" cy="276999"/>
           </a:xfrm>
           <a:prstGeom prst="rect">
@@ -20926,8 +21478,8 @@
         </p:nvCxnSpPr>
         <p:spPr>
           <a:xfrm flipH="1" flipV="1">
-            <a:off x="19841590" y="18057413"/>
-            <a:ext cx="135136" cy="5216941"/>
+            <a:off x="19841590" y="18306803"/>
+            <a:ext cx="135136" cy="4967551"/>
           </a:xfrm>
           <a:prstGeom prst="bentConnector3">
             <a:avLst>
@@ -21340,8 +21892,8 @@
         </p:nvCxnSpPr>
         <p:spPr>
           <a:xfrm>
-            <a:off x="10501026" y="7833284"/>
-            <a:ext cx="7812538" cy="332181"/>
+            <a:off x="9678066" y="7833284"/>
+            <a:ext cx="8635498" cy="332181"/>
           </a:xfrm>
           <a:prstGeom prst="bentConnector2">
             <a:avLst/>
@@ -21371,7 +21923,7 @@
         </p:nvGrpSpPr>
         <p:grpSpPr>
           <a:xfrm>
-            <a:off x="5536082" y="7585146"/>
+            <a:off x="4713122" y="7585146"/>
             <a:ext cx="2440696" cy="499318"/>
             <a:chOff x="19780736" y="18469318"/>
             <a:chExt cx="2440696" cy="499318"/>
@@ -21552,7 +22104,7 @@
         </p:nvCxnSpPr>
         <p:spPr>
           <a:xfrm flipH="1">
-            <a:off x="6759499" y="10807323"/>
+            <a:off x="5936539" y="10807323"/>
             <a:ext cx="1824" cy="632155"/>
           </a:xfrm>
           <a:prstGeom prst="straightConnector1">
@@ -21583,7 +22135,7 @@
         </p:nvSpPr>
         <p:spPr>
           <a:xfrm>
-            <a:off x="4808221" y="11439478"/>
+            <a:off x="3985261" y="11439478"/>
             <a:ext cx="3902556" cy="721607"/>
           </a:xfrm>
           <a:prstGeom prst="diamond">
@@ -21675,7 +22227,7 @@
         </p:nvCxnSpPr>
         <p:spPr>
           <a:xfrm rot="10800000">
-            <a:off x="4585521" y="2908636"/>
+            <a:off x="3762561" y="2908636"/>
             <a:ext cx="222700" cy="8891647"/>
           </a:xfrm>
           <a:prstGeom prst="bentConnector3">
@@ -21708,7 +22260,7 @@
         </p:nvSpPr>
         <p:spPr>
           <a:xfrm>
-            <a:off x="3941048" y="11437693"/>
+            <a:off x="3118088" y="11437693"/>
             <a:ext cx="820736" cy="400110"/>
           </a:xfrm>
           <a:prstGeom prst="rect">
@@ -21759,7 +22311,7 @@
         </p:nvSpPr>
         <p:spPr>
           <a:xfrm>
-            <a:off x="3721621" y="5961627"/>
+            <a:off x="2898661" y="5961627"/>
             <a:ext cx="6075754" cy="743086"/>
           </a:xfrm>
           <a:prstGeom prst="diamond">
@@ -21837,7 +22389,7 @@
         </p:nvCxnSpPr>
         <p:spPr>
           <a:xfrm flipH="1">
-            <a:off x="6756430" y="6704713"/>
+            <a:off x="5933470" y="6704713"/>
             <a:ext cx="3068" cy="880433"/>
           </a:xfrm>
           <a:prstGeom prst="straightConnector1">
@@ -21868,7 +22420,7 @@
         </p:nvSpPr>
         <p:spPr>
           <a:xfrm>
-            <a:off x="6842806" y="6801083"/>
+            <a:off x="6019846" y="6801083"/>
             <a:ext cx="820736" cy="400110"/>
           </a:xfrm>
           <a:prstGeom prst="rect">
@@ -21919,7 +22471,7 @@
         </p:nvSpPr>
         <p:spPr>
           <a:xfrm>
-            <a:off x="8915400" y="7162802"/>
+            <a:off x="8092440" y="7162802"/>
             <a:ext cx="1585626" cy="1340964"/>
           </a:xfrm>
           <a:prstGeom prst="roundRect">
@@ -22049,7 +22601,7 @@
         </p:nvCxnSpPr>
         <p:spPr>
           <a:xfrm flipV="1">
-            <a:off x="7976778" y="7833284"/>
+            <a:off x="7153818" y="7833284"/>
             <a:ext cx="938622" cy="1521"/>
           </a:xfrm>
           <a:prstGeom prst="straightConnector1">
@@ -22157,9 +22709,9 @@
           <p:nvPr/>
         </p:nvCxnSpPr>
         <p:spPr>
-          <a:xfrm flipV="1">
-            <a:off x="24447430" y="23250113"/>
-            <a:ext cx="3332397" cy="1"/>
+          <a:xfrm>
+            <a:off x="24447430" y="23247410"/>
+            <a:ext cx="3332397" cy="2703"/>
           </a:xfrm>
           <a:prstGeom prst="straightConnector1">
             <a:avLst/>
@@ -22230,7 +22782,7 @@
         </p:nvCxnSpPr>
         <p:spPr>
           <a:xfrm rot="10800000" flipH="1" flipV="1">
-            <a:off x="3721620" y="6333169"/>
+            <a:off x="2898660" y="6333169"/>
             <a:ext cx="2936195" cy="2956575"/>
           </a:xfrm>
           <a:prstGeom prst="bentConnector3">
@@ -22263,7 +22815,7 @@
         </p:nvSpPr>
         <p:spPr>
           <a:xfrm>
-            <a:off x="3164871" y="5769178"/>
+            <a:off x="2341911" y="5769178"/>
             <a:ext cx="1398261" cy="400110"/>
           </a:xfrm>
           <a:prstGeom prst="rect">
@@ -22314,7 +22866,7 @@
         </p:nvSpPr>
         <p:spPr>
           <a:xfrm>
-            <a:off x="18292969" y="22326600"/>
+            <a:off x="18292969" y="22575990"/>
             <a:ext cx="574900" cy="276999"/>
           </a:xfrm>
           <a:prstGeom prst="rect">
@@ -22365,7 +22917,7 @@
         </p:nvSpPr>
         <p:spPr>
           <a:xfrm>
-            <a:off x="18458252" y="20102959"/>
+            <a:off x="18458252" y="20352349"/>
             <a:ext cx="563717" cy="276999"/>
           </a:xfrm>
           <a:prstGeom prst="rect">
@@ -22420,7 +22972,7 @@
         </p:nvCxnSpPr>
         <p:spPr>
           <a:xfrm flipH="1">
-            <a:off x="18312856" y="20724923"/>
+            <a:off x="18312856" y="20974313"/>
             <a:ext cx="1808" cy="449492"/>
           </a:xfrm>
           <a:prstGeom prst="straightConnector1">
@@ -22451,7 +23003,7 @@
         </p:nvSpPr>
         <p:spPr>
           <a:xfrm>
-            <a:off x="16434418" y="19385918"/>
+            <a:off x="16434418" y="19635308"/>
             <a:ext cx="820736" cy="276999"/>
           </a:xfrm>
           <a:prstGeom prst="rect">
@@ -22506,12 +23058,12 @@
         </p:nvCxnSpPr>
         <p:spPr>
           <a:xfrm rot="10800000" flipV="1">
-            <a:off x="16655336" y="19691670"/>
-            <a:ext cx="431344" cy="3582684"/>
+            <a:off x="16655336" y="19941060"/>
+            <a:ext cx="431344" cy="3333294"/>
           </a:xfrm>
           <a:prstGeom prst="bentConnector3">
             <a:avLst>
-              <a:gd name="adj1" fmla="val 210812"/>
+              <a:gd name="adj1" fmla="val 188328"/>
             </a:avLst>
           </a:prstGeom>
           <a:noFill/>
@@ -22580,8 +23132,8 @@
         </p:nvCxnSpPr>
         <p:spPr>
           <a:xfrm rot="5400000">
-            <a:off x="22518482" y="23890656"/>
-            <a:ext cx="295610" cy="11261"/>
+            <a:off x="22456710" y="23828883"/>
+            <a:ext cx="419155" cy="11261"/>
           </a:xfrm>
           <a:prstGeom prst="bentConnector3">
             <a:avLst>
@@ -23013,7 +23565,7 @@
         </p:nvSpPr>
         <p:spPr>
           <a:xfrm>
-            <a:off x="7610981" y="7097887"/>
+            <a:off x="6788021" y="7097887"/>
             <a:ext cx="1661050" cy="523220"/>
           </a:xfrm>
           <a:prstGeom prst="rect">
@@ -23080,7 +23632,7 @@
         </p:nvSpPr>
         <p:spPr>
           <a:xfrm>
-            <a:off x="2819401" y="10053799"/>
+            <a:off x="1996441" y="10053799"/>
             <a:ext cx="820736" cy="400110"/>
           </a:xfrm>
           <a:prstGeom prst="rect">
@@ -23131,7 +23683,7 @@
         </p:nvSpPr>
         <p:spPr>
           <a:xfrm>
-            <a:off x="6790245" y="10967376"/>
+            <a:off x="5967285" y="10967376"/>
             <a:ext cx="820736" cy="400110"/>
           </a:xfrm>
           <a:prstGeom prst="rect">
@@ -23333,7 +23885,7 @@
                 </a:solidFill>
                 <a:latin typeface="Arial"/>
               </a:rPr>
-              <a:t>Shared runtime tools such as </a:t>
+              <a:t>Generated functions receive narrow wrappers through my_tools; raw GPT client, semaphore, and shared state are not exposed.</a:t>
             </a:r>
             <a:r>
               <a:rPr lang="en-US" sz="1100" kern="0" dirty="0" err="1">
@@ -23344,7 +23896,7 @@
                 </a:solidFill>
                 <a:latin typeface="Arial"/>
               </a:rPr>
-              <a:t>gpt_client</a:t>
+              <a:t/>
             </a:r>
             <a:r>
               <a:rPr lang="en-US" sz="1100" kern="0" dirty="0">
@@ -23355,7 +23907,7 @@
                 </a:solidFill>
                 <a:latin typeface="Arial"/>
               </a:rPr>
-              <a:t>, </a:t>
+              <a:t/>
             </a:r>
             <a:r>
               <a:rPr lang="en-US" sz="1100" kern="0" dirty="0" err="1">
@@ -23366,7 +23918,7 @@
                 </a:solidFill>
                 <a:latin typeface="Arial"/>
               </a:rPr>
-              <a:t>gpt_semaphore</a:t>
+              <a:t/>
             </a:r>
             <a:r>
               <a:rPr lang="en-US" sz="1100" kern="0" dirty="0">
@@ -23377,7 +23929,7 @@
                 </a:solidFill>
                 <a:latin typeface="Arial"/>
               </a:rPr>
-              <a:t>, logging, and shared state are made available through the global </a:t>
+              <a:t/>
             </a:r>
             <a:r>
               <a:rPr lang="en-US" sz="1100" kern="0" dirty="0" err="1">
@@ -23388,7 +23940,7 @@
                 </a:solidFill>
                 <a:latin typeface="Arial"/>
               </a:rPr>
-              <a:t>my_tools</a:t>
+              <a:t/>
             </a:r>
             <a:r>
               <a:rPr lang="en-US" sz="1100" kern="0" dirty="0">
@@ -23399,7 +23951,7 @@
                 </a:solidFill>
                 <a:latin typeface="Arial"/>
               </a:rPr>
-              <a:t> module.  </a:t>
+              <a:t/>
             </a:r>
           </a:p>
           <a:p>
@@ -23842,7 +24394,7 @@
         </p:nvSpPr>
         <p:spPr bwMode="auto">
           <a:xfrm>
-            <a:off x="6657816" y="9196571"/>
+            <a:off x="5834856" y="9196571"/>
             <a:ext cx="186348" cy="186348"/>
           </a:xfrm>
           <a:prstGeom prst="ellipse">
@@ -23936,7 +24488,7 @@
         </p:nvCxnSpPr>
         <p:spPr>
           <a:xfrm>
-            <a:off x="6750990" y="9382919"/>
+            <a:off x="5928030" y="9382919"/>
             <a:ext cx="10333" cy="830933"/>
           </a:xfrm>
           <a:prstGeom prst="straightConnector1">
@@ -24430,7 +24982,7 @@
         </p:nvCxnSpPr>
         <p:spPr>
           <a:xfrm flipH="1">
-            <a:off x="18313394" y="18223064"/>
+            <a:off x="18313394" y="18472454"/>
             <a:ext cx="997" cy="401107"/>
           </a:xfrm>
           <a:prstGeom prst="straightConnector1">
@@ -24461,7 +25013,7 @@
         </p:nvSpPr>
         <p:spPr>
           <a:xfrm>
-            <a:off x="17086680" y="19446443"/>
+            <a:off x="17086680" y="19695833"/>
             <a:ext cx="2453396" cy="490454"/>
           </a:xfrm>
           <a:prstGeom prst="diamond">
@@ -24535,7 +25087,7 @@
         </p:nvSpPr>
         <p:spPr>
           <a:xfrm>
-            <a:off x="17094316" y="20393620"/>
+            <a:off x="17094316" y="20643010"/>
             <a:ext cx="2440696" cy="331303"/>
           </a:xfrm>
           <a:prstGeom prst="roundRect">
@@ -25917,7 +26469,7 @@
         </p:nvSpPr>
         <p:spPr>
           <a:xfrm>
-            <a:off x="17351193" y="17259824"/>
+            <a:off x="17351193" y="17509214"/>
             <a:ext cx="1925462" cy="323814"/>
           </a:xfrm>
           <a:prstGeom prst="roundRect">
@@ -26009,8 +26561,8 @@
         </p:nvCxnSpPr>
         <p:spPr>
           <a:xfrm>
-            <a:off x="18314126" y="22326600"/>
-            <a:ext cx="1905" cy="586950"/>
+            <a:off x="18314126" y="22575990"/>
+            <a:ext cx="1905" cy="337560"/>
           </a:xfrm>
           <a:prstGeom prst="straightConnector1">
             <a:avLst/>
@@ -26922,94 +27474,6 @@
           </a:p>
         </p:txBody>
       </p:sp>
-      <p:sp>
-        <p:nvSpPr>
-          <p:cNvPr id="118" name="Rectangle: Rounded Corners 117">
-            <a:extLst>
-              <a:ext uri="{FF2B5EF4-FFF2-40B4-BE49-F238E27FC236}">
-                <a16:creationId xmlns:a16="http://schemas.microsoft.com/office/drawing/2014/main" id="{EA6F7C5F-6F23-F607-F50F-0828F4266A53}"/>
-              </a:ext>
-            </a:extLst>
-          </p:cNvPr>
-          <p:cNvSpPr/>
-          <p:nvPr/>
-        </p:nvSpPr>
-        <p:spPr>
-          <a:xfrm>
-            <a:off x="10889214" y="20279358"/>
-            <a:ext cx="1988585" cy="741695"/>
-          </a:xfrm>
-          <a:prstGeom prst="roundRect">
-            <a:avLst/>
-          </a:prstGeom>
-          <a:noFill/>
-          <a:ln w="12700" cap="sq" cmpd="sng" algn="ctr">
-            <a:solidFill>
-              <a:srgbClr val="4F5759">
-                <a:lumMod val="50000"/>
-              </a:srgbClr>
-            </a:solidFill>
-            <a:prstDash val="solid"/>
-          </a:ln>
-          <a:effectLst/>
-        </p:spPr>
-        <p:txBody>
-          <a:bodyPr rtlCol="0" anchor="ctr"/>
-          <a:lstStyle/>
-          <a:p>
-            <a:pPr marL="0" marR="0" lvl="0" indent="0" algn="ctr" defTabSz="914400" eaLnBrk="1" fontAlgn="auto" latinLnBrk="0" hangingPunct="1">
-              <a:lnSpc>
-                <a:spcPct val="100000"/>
-              </a:lnSpc>
-              <a:spcBef>
-                <a:spcPts val="0"/>
-              </a:spcBef>
-              <a:spcAft>
-                <a:spcPts val="0"/>
-              </a:spcAft>
-              <a:buClrTx/>
-              <a:buSzTx/>
-              <a:buFontTx/>
-              <a:buNone/>
-              <a:tabLst/>
-              <a:defRPr/>
-            </a:pPr>
-            <a:r>
-              <a:rPr kumimoji="0" lang="en-US" sz="1050" b="0" i="0" u="none" strike="noStrike" kern="0" cap="none" spc="0" normalizeH="0" baseline="0" noProof="0" dirty="0">
-                <a:ln>
-                  <a:noFill/>
-                </a:ln>
-                <a:solidFill>
-                  <a:prstClr val="black">
-                    <a:lumMod val="50000"/>
-                  </a:prstClr>
-                </a:solidFill>
-                <a:effectLst/>
-                <a:uLnTx/>
-                <a:uFillTx/>
-                <a:latin typeface="Arial"/>
-                <a:ea typeface="+mn-ea"/>
-                <a:cs typeface="+mn-cs"/>
-              </a:rPr>
-              <a:t>Make a quarantine note in memory and registry for this crash-causing function for the BRD</a:t>
-            </a:r>
-            <a:endParaRPr kumimoji="0" lang="en-US" sz="1050" b="0" i="0" u="none" strike="noStrike" kern="0" cap="none" spc="0" normalizeH="0" baseline="0" noProof="0" dirty="0">
-              <a:ln>
-                <a:noFill/>
-              </a:ln>
-              <a:solidFill>
-                <a:prstClr val="white"/>
-              </a:solidFill>
-              <a:effectLst/>
-              <a:uLnTx/>
-              <a:uFillTx/>
-              <a:latin typeface="Arial"/>
-              <a:ea typeface="+mn-ea"/>
-              <a:cs typeface="+mn-cs"/>
-            </a:endParaRPr>
-          </a:p>
-        </p:txBody>
-      </p:sp>
       <p:cxnSp>
         <p:nvCxnSpPr>
           <p:cNvPr id="119" name="Connector: Elbow 118">
@@ -27021,15 +27485,15 @@
           </p:cNvPr>
           <p:cNvCxnSpPr>
             <a:cxnSpLocks/>
-            <a:stCxn id="44" idx="1"/>
-            <a:endCxn id="118" idx="2"/>
+            <a:stCxn id="118" idx="3"/>
+            <a:endCxn id="41" idx="0"/>
           </p:cNvCxnSpPr>
           <p:nvPr/>
         </p:nvCxnSpPr>
         <p:spPr>
-          <a:xfrm rot="10800000">
-            <a:off x="11883508" y="21021053"/>
-            <a:ext cx="4903155" cy="1058068"/>
+          <a:xfrm>
+            <a:off x="22300847" y="22327926"/>
+            <a:ext cx="371070" cy="541958"/>
           </a:xfrm>
           <a:prstGeom prst="bentConnector2">
             <a:avLst/>
@@ -27059,7 +27523,7 @@
         </p:nvSpPr>
         <p:spPr bwMode="auto">
           <a:xfrm>
-            <a:off x="11788479" y="18177852"/>
+            <a:off x="11788479" y="18427242"/>
             <a:ext cx="186348" cy="186348"/>
           </a:xfrm>
           <a:prstGeom prst="ellipse">
@@ -27135,41 +27599,6 @@
           </a:p>
         </p:txBody>
       </p:sp>
-      <p:cxnSp>
-        <p:nvCxnSpPr>
-          <p:cNvPr id="121" name="Connector: Elbow 200">
-            <a:extLst>
-              <a:ext uri="{FF2B5EF4-FFF2-40B4-BE49-F238E27FC236}">
-                <a16:creationId xmlns:a16="http://schemas.microsoft.com/office/drawing/2014/main" id="{1D5C3394-70DE-0F89-EC59-E822C95878F7}"/>
-              </a:ext>
-            </a:extLst>
-          </p:cNvPr>
-          <p:cNvCxnSpPr>
-            <a:cxnSpLocks/>
-            <a:stCxn id="118" idx="0"/>
-            <a:endCxn id="120" idx="4"/>
-          </p:cNvCxnSpPr>
-          <p:nvPr/>
-        </p:nvCxnSpPr>
-        <p:spPr>
-          <a:xfrm flipH="1" flipV="1">
-            <a:off x="11881653" y="18364200"/>
-            <a:ext cx="1854" cy="1915158"/>
-          </a:xfrm>
-          <a:prstGeom prst="straightConnector1">
-            <a:avLst/>
-          </a:prstGeom>
-          <a:noFill/>
-          <a:ln w="76200" cap="sq" cmpd="sng" algn="ctr">
-            <a:solidFill>
-              <a:srgbClr val="006297"/>
-            </a:solidFill>
-            <a:prstDash val="solid"/>
-            <a:tailEnd type="triangle"/>
-          </a:ln>
-          <a:effectLst/>
-        </p:spPr>
-      </p:cxnSp>
       <p:sp>
         <p:nvSpPr>
           <p:cNvPr id="122" name="Diamond 121">
@@ -27184,7 +27613,7 @@
         </p:nvSpPr>
         <p:spPr>
           <a:xfrm>
-            <a:off x="17086696" y="18624171"/>
+            <a:off x="17086696" y="18873561"/>
             <a:ext cx="2453396" cy="490454"/>
           </a:xfrm>
           <a:prstGeom prst="diamond">
@@ -27262,7 +27691,7 @@
         </p:nvCxnSpPr>
         <p:spPr>
           <a:xfrm>
-            <a:off x="18313378" y="19936897"/>
+            <a:off x="18313378" y="20186287"/>
             <a:ext cx="1286" cy="456723"/>
           </a:xfrm>
           <a:prstGeom prst="straightConnector1">
@@ -27293,7 +27722,7 @@
         </p:nvSpPr>
         <p:spPr>
           <a:xfrm>
-            <a:off x="18346551" y="19084788"/>
+            <a:off x="18346551" y="19334178"/>
             <a:ext cx="563717" cy="276999"/>
           </a:xfrm>
           <a:prstGeom prst="rect">
@@ -27348,7 +27777,7 @@
         </p:nvCxnSpPr>
         <p:spPr>
           <a:xfrm flipH="1">
-            <a:off x="18313378" y="19114625"/>
+            <a:off x="18313378" y="19364015"/>
             <a:ext cx="16" cy="331818"/>
           </a:xfrm>
           <a:prstGeom prst="straightConnector1">
@@ -27383,7 +27812,7 @@
         </p:nvCxnSpPr>
         <p:spPr>
           <a:xfrm rot="10800000">
-            <a:off x="11881654" y="18364200"/>
+            <a:off x="11881654" y="18613590"/>
             <a:ext cx="5205043" cy="505198"/>
           </a:xfrm>
           <a:prstGeom prst="bentConnector2">
@@ -27414,7 +27843,7 @@
         </p:nvSpPr>
         <p:spPr bwMode="auto">
           <a:xfrm>
-            <a:off x="16787192" y="17891761"/>
+            <a:off x="16787192" y="18141151"/>
             <a:ext cx="3054398" cy="331303"/>
           </a:xfrm>
           <a:prstGeom prst="flowChartPreparation">
@@ -27583,7 +28012,7 @@
         </p:nvSpPr>
         <p:spPr>
           <a:xfrm>
-            <a:off x="16434418" y="18560072"/>
+            <a:off x="16434418" y="18809462"/>
             <a:ext cx="820736" cy="276999"/>
           </a:xfrm>
           <a:prstGeom prst="rect">
@@ -27634,7 +28063,7 @@
         </p:nvSpPr>
         <p:spPr>
           <a:xfrm>
-            <a:off x="4465082" y="1605230"/>
+            <a:off x="3642122" y="1605230"/>
             <a:ext cx="4574118" cy="676459"/>
           </a:xfrm>
           <a:prstGeom prst="roundRect">
@@ -27784,7 +28213,7 @@
         </p:nvSpPr>
         <p:spPr>
           <a:xfrm>
-            <a:off x="4585521" y="3523181"/>
+            <a:off x="3762561" y="3523181"/>
             <a:ext cx="4330938" cy="449561"/>
           </a:xfrm>
           <a:prstGeom prst="roundRect">
@@ -27876,7 +28305,7 @@
         </p:nvCxnSpPr>
         <p:spPr>
           <a:xfrm>
-            <a:off x="6750990" y="3222566"/>
+            <a:off x="5928030" y="3222566"/>
             <a:ext cx="0" cy="300615"/>
           </a:xfrm>
           <a:prstGeom prst="straightConnector1">
@@ -27907,7 +28336,7 @@
         </p:nvSpPr>
         <p:spPr>
           <a:xfrm>
-            <a:off x="4585521" y="2594703"/>
+            <a:off x="3762561" y="2594703"/>
             <a:ext cx="4330938" cy="627863"/>
           </a:xfrm>
           <a:prstGeom prst="roundRect">
@@ -28039,7 +28468,7 @@
         </p:nvCxnSpPr>
         <p:spPr>
           <a:xfrm flipH="1">
-            <a:off x="6750990" y="2281689"/>
+            <a:off x="5928030" y="2281689"/>
             <a:ext cx="1151" cy="313014"/>
           </a:xfrm>
           <a:prstGeom prst="straightConnector1">
@@ -28160,8 +28589,8 @@
         </p:nvSpPr>
         <p:spPr>
           <a:xfrm>
-            <a:off x="17330564" y="15333306"/>
-            <a:ext cx="820736" cy="338554"/>
+            <a:off x="17621794" y="15333306"/>
+            <a:ext cx="529505" cy="276999"/>
           </a:xfrm>
           <a:prstGeom prst="rect">
             <a:avLst/>
@@ -28178,7 +28607,7 @@
               <a:defRPr/>
             </a:pPr>
             <a:r>
-              <a:rPr lang="en-US" sz="1600" dirty="0">
+              <a:rPr lang="en-US" sz="1200" dirty="0">
                 <a:solidFill>
                   <a:prstClr val="black">
                     <a:lumMod val="50000"/>
@@ -28188,7 +28617,7 @@
               </a:rPr>
               <a:t>Yes</a:t>
             </a:r>
-            <a:endParaRPr lang="en-US" sz="1600" dirty="0">
+            <a:endParaRPr lang="en-US" sz="1200" dirty="0">
               <a:solidFill>
                 <a:prstClr val="black"/>
               </a:solidFill>
@@ -28380,7 +28809,7 @@
                 <a:ea typeface="+mn-ea"/>
                 <a:cs typeface="+mn-cs"/>
               </a:rPr>
-              <a:t>  N_ITEMS_TO_PASS</a:t>
+              <a:t>  ID_FIELD, EXPECTED_FIELD, N_ITEMS_TO_PASS</a:t>
             </a:r>
           </a:p>
           <a:p>
@@ -28564,7 +28993,7 @@
         </p:nvCxnSpPr>
         <p:spPr>
           <a:xfrm>
-            <a:off x="18313924" y="17583638"/>
+            <a:off x="18313924" y="17833028"/>
             <a:ext cx="467" cy="308123"/>
           </a:xfrm>
           <a:prstGeom prst="straightConnector1">
@@ -28853,7 +29282,7 @@
         </p:nvSpPr>
         <p:spPr bwMode="auto">
           <a:xfrm>
-            <a:off x="17003769" y="16002000"/>
+            <a:off x="17003769" y="15872460"/>
             <a:ext cx="2619040" cy="331303"/>
           </a:xfrm>
           <a:prstGeom prst="flowChartPreparation">
@@ -28927,7 +29356,7 @@
                 <a:ea typeface="+mn-ea"/>
                 <a:cs typeface="+mn-cs"/>
               </a:rPr>
-              <a:t>: Does it pass the examples + N tests?</a:t>
+              <a:t>: Does it pass the BRD examples test?</a:t>
             </a:r>
           </a:p>
         </p:txBody>
@@ -29377,7 +29806,7 @@
         <p:spPr>
           <a:xfrm rot="10800000" flipH="1" flipV="1">
             <a:off x="12420598" y="11746725"/>
-            <a:ext cx="4366593" cy="6310687"/>
+            <a:ext cx="4366593" cy="6560077"/>
           </a:xfrm>
           <a:prstGeom prst="bentConnector3">
             <a:avLst>
@@ -29504,7 +29933,7 @@
         <p:spPr>
           <a:xfrm rot="10800000" flipH="1" flipV="1">
             <a:off x="13200044" y="13014073"/>
-            <a:ext cx="3587148" cy="5043339"/>
+            <a:ext cx="3587148" cy="5292729"/>
           </a:xfrm>
           <a:prstGeom prst="bentConnector3">
             <a:avLst>
@@ -29700,6 +30129,482 @@
           <a:effectLst/>
         </p:spPr>
       </p:cxnSp>
+      <p:sp>
+        <p:nvSpPr>
+          <p:cNvPr id="169" name="Flowchart: Preparation 168">
+            <a:extLst>
+              <a:ext uri="{FF2B5EF4-FFF2-40B4-BE49-F238E27FC236}">
+                <a16:creationId xmlns:a16="http://schemas.microsoft.com/office/drawing/2014/main" id="{45B5BACE-5E75-DB60-BB3C-CEFD60FA53CF}"/>
+              </a:ext>
+            </a:extLst>
+          </p:cNvPr>
+          <p:cNvSpPr/>
+          <p:nvPr/>
+        </p:nvSpPr>
+        <p:spPr bwMode="auto">
+          <a:xfrm>
+            <a:off x="16786662" y="16818238"/>
+            <a:ext cx="3065734" cy="331303"/>
+          </a:xfrm>
+          <a:prstGeom prst="flowChartPreparation">
+            <a:avLst/>
+          </a:prstGeom>
+          <a:noFill/>
+          <a:ln w="12700" cap="sq" cmpd="sng" algn="ctr">
+            <a:solidFill>
+              <a:srgbClr val="4F5759">
+                <a:lumMod val="50000"/>
+              </a:srgbClr>
+            </a:solidFill>
+            <a:prstDash val="solid"/>
+          </a:ln>
+          <a:effectLst/>
+        </p:spPr>
+        <p:txBody>
+          <a:bodyPr rtlCol="0" anchor="ctr"/>
+          <a:lstStyle/>
+          <a:p>
+            <a:pPr lvl="0" algn="ctr" defTabSz="914400">
+              <a:defRPr/>
+            </a:pPr>
+            <a:r>
+              <a:rPr kumimoji="0" lang="en-US" sz="1000" b="0" i="0" u="none" strike="noStrike" kern="0" cap="none" spc="0" normalizeH="0" baseline="0" noProof="0" dirty="0" err="1">
+                <a:ln>
+                  <a:noFill/>
+                </a:ln>
+                <a:solidFill>
+                  <a:prstClr val="black">
+                    <a:lumMod val="50000"/>
+                  </a:prstClr>
+                </a:solidFill>
+                <a:effectLst/>
+                <a:uLnTx/>
+                <a:uFillTx/>
+                <a:latin typeface="Arial"/>
+                <a:ea typeface="+mn-ea"/>
+                <a:cs typeface="+mn-cs"/>
+              </a:rPr>
+              <a:t>Test_Run</a:t>
+            </a:r>
+            <a:r>
+              <a:rPr kumimoji="0" lang="en-US" sz="1000" b="0" i="0" u="none" strike="noStrike" kern="0" cap="none" spc="0" normalizeH="0" baseline="0" noProof="0" dirty="0">
+                <a:ln>
+                  <a:noFill/>
+                </a:ln>
+                <a:solidFill>
+                  <a:prstClr val="black">
+                    <a:lumMod val="50000"/>
+                  </a:prstClr>
+                </a:solidFill>
+                <a:effectLst/>
+                <a:uLnTx/>
+                <a:uFillTx/>
+                <a:latin typeface="Arial"/>
+                <a:ea typeface="+mn-ea"/>
+                <a:cs typeface="+mn-cs"/>
+              </a:rPr>
+              <a:t>: Does it pass the </a:t>
+            </a:r>
+            <a:r>
+              <a:rPr lang="en-US" sz="1000" kern="0" dirty="0">
+                <a:solidFill>
+                  <a:prstClr val="black">
+                    <a:lumMod val="50000"/>
+                  </a:prstClr>
+                </a:solidFill>
+                <a:latin typeface="Arial"/>
+              </a:rPr>
+              <a:t>N_ITEMS_TO_PASS</a:t>
+            </a:r>
+            <a:r>
+              <a:rPr kumimoji="0" lang="en-US" sz="1000" b="0" i="0" u="none" strike="noStrike" kern="0" cap="none" spc="0" normalizeH="0" baseline="0" noProof="0" dirty="0">
+                <a:ln>
+                  <a:noFill/>
+                </a:ln>
+                <a:solidFill>
+                  <a:prstClr val="black">
+                    <a:lumMod val="50000"/>
+                  </a:prstClr>
+                </a:solidFill>
+                <a:effectLst/>
+                <a:uLnTx/>
+                <a:uFillTx/>
+                <a:latin typeface="Arial"/>
+                <a:ea typeface="+mn-ea"/>
+                <a:cs typeface="+mn-cs"/>
+              </a:rPr>
+              <a:t> test?</a:t>
+            </a:r>
+          </a:p>
+        </p:txBody>
+      </p:sp>
+      <p:cxnSp>
+        <p:nvCxnSpPr>
+          <p:cNvPr id="173" name="Connector: Elbow 87">
+            <a:extLst>
+              <a:ext uri="{FF2B5EF4-FFF2-40B4-BE49-F238E27FC236}">
+                <a16:creationId xmlns:a16="http://schemas.microsoft.com/office/drawing/2014/main" id="{D84BBED4-F848-E6B6-AA6F-C6419EA0C04A}"/>
+              </a:ext>
+            </a:extLst>
+          </p:cNvPr>
+          <p:cNvCxnSpPr>
+            <a:cxnSpLocks/>
+            <a:stCxn id="169" idx="2"/>
+          </p:cNvCxnSpPr>
+          <p:nvPr/>
+        </p:nvCxnSpPr>
+        <p:spPr>
+          <a:xfrm flipH="1">
+            <a:off x="18312856" y="17149541"/>
+            <a:ext cx="6673" cy="392482"/>
+          </a:xfrm>
+          <a:prstGeom prst="straightConnector1">
+            <a:avLst/>
+          </a:prstGeom>
+          <a:noFill/>
+          <a:ln w="76200" cap="sq" cmpd="sng" algn="ctr">
+            <a:solidFill>
+              <a:srgbClr val="006297"/>
+            </a:solidFill>
+            <a:prstDash val="solid"/>
+            <a:tailEnd type="triangle"/>
+          </a:ln>
+          <a:effectLst/>
+        </p:spPr>
+      </p:cxnSp>
+      <p:sp>
+        <p:nvSpPr>
+          <p:cNvPr id="178" name="TextBox 177">
+            <a:extLst>
+              <a:ext uri="{FF2B5EF4-FFF2-40B4-BE49-F238E27FC236}">
+                <a16:creationId xmlns:a16="http://schemas.microsoft.com/office/drawing/2014/main" id="{F836A25F-ECCB-CADD-A312-90E74D438996}"/>
+              </a:ext>
+            </a:extLst>
+          </p:cNvPr>
+          <p:cNvSpPr txBox="1"/>
+          <p:nvPr/>
+        </p:nvSpPr>
+        <p:spPr>
+          <a:xfrm>
+            <a:off x="17738568" y="17171153"/>
+            <a:ext cx="529505" cy="276999"/>
+          </a:xfrm>
+          <a:prstGeom prst="rect">
+            <a:avLst/>
+          </a:prstGeom>
+          <a:noFill/>
+        </p:spPr>
+        <p:txBody>
+          <a:bodyPr wrap="square">
+            <a:spAutoFit/>
+          </a:bodyPr>
+          <a:lstStyle/>
+          <a:p>
+            <a:pPr algn="ctr" defTabSz="914400">
+              <a:defRPr/>
+            </a:pPr>
+            <a:r>
+              <a:rPr lang="en-US" sz="1200" dirty="0">
+                <a:solidFill>
+                  <a:prstClr val="black">
+                    <a:lumMod val="50000"/>
+                  </a:prstClr>
+                </a:solidFill>
+                <a:latin typeface="Arial"/>
+              </a:rPr>
+              <a:t>Yes</a:t>
+            </a:r>
+            <a:endParaRPr lang="en-US" sz="1200" dirty="0">
+              <a:solidFill>
+                <a:prstClr val="black"/>
+              </a:solidFill>
+              <a:latin typeface="Arial"/>
+            </a:endParaRPr>
+          </a:p>
+        </p:txBody>
+      </p:sp>
+      <p:cxnSp>
+        <p:nvCxnSpPr>
+          <p:cNvPr id="180" name="Connector: Elbow 179">
+            <a:extLst>
+              <a:ext uri="{FF2B5EF4-FFF2-40B4-BE49-F238E27FC236}">
+                <a16:creationId xmlns:a16="http://schemas.microsoft.com/office/drawing/2014/main" id="{F963A72C-4A8E-BBFE-0674-5EA1411A3275}"/>
+              </a:ext>
+            </a:extLst>
+          </p:cNvPr>
+          <p:cNvCxnSpPr>
+            <a:cxnSpLocks/>
+            <a:stCxn id="169" idx="3"/>
+            <a:endCxn id="41" idx="0"/>
+          </p:cNvCxnSpPr>
+          <p:nvPr/>
+        </p:nvCxnSpPr>
+        <p:spPr>
+          <a:xfrm>
+            <a:off x="19852396" y="16983890"/>
+            <a:ext cx="2819521" cy="5885994"/>
+          </a:xfrm>
+          <a:prstGeom prst="bentConnector2">
+            <a:avLst/>
+          </a:prstGeom>
+          <a:noFill/>
+          <a:ln w="76200" cap="sq" cmpd="sng" algn="ctr">
+            <a:solidFill>
+              <a:srgbClr val="006297"/>
+            </a:solidFill>
+            <a:prstDash val="solid"/>
+            <a:tailEnd type="triangle"/>
+          </a:ln>
+          <a:effectLst/>
+        </p:spPr>
+      </p:cxnSp>
+      <p:sp>
+        <p:nvSpPr>
+          <p:cNvPr id="183" name="TextBox 182">
+            <a:extLst>
+              <a:ext uri="{FF2B5EF4-FFF2-40B4-BE49-F238E27FC236}">
+                <a16:creationId xmlns:a16="http://schemas.microsoft.com/office/drawing/2014/main" id="{173415F7-DF5F-69E6-5E0A-FE99A5D5C93E}"/>
+              </a:ext>
+            </a:extLst>
+          </p:cNvPr>
+          <p:cNvSpPr txBox="1"/>
+          <p:nvPr/>
+        </p:nvSpPr>
+        <p:spPr>
+          <a:xfrm>
+            <a:off x="19668870" y="16982208"/>
+            <a:ext cx="2487894" cy="830997"/>
+          </a:xfrm>
+          <a:prstGeom prst="rect">
+            <a:avLst/>
+          </a:prstGeom>
+          <a:noFill/>
+        </p:spPr>
+        <p:txBody>
+          <a:bodyPr wrap="square">
+            <a:spAutoFit/>
+          </a:bodyPr>
+          <a:lstStyle/>
+          <a:p>
+            <a:pPr algn="ctr" defTabSz="914400">
+              <a:defRPr/>
+            </a:pPr>
+            <a:r>
+              <a:rPr lang="en-US" sz="1200" dirty="0">
+                <a:solidFill>
+                  <a:prstClr val="black">
+                    <a:lumMod val="50000"/>
+                  </a:prstClr>
+                </a:solidFill>
+                <a:latin typeface="Arial"/>
+              </a:rPr>
+              <a:t>This goes to </a:t>
+            </a:r>
+            <a:r>
+              <a:rPr lang="en-US" sz="1200" dirty="0" err="1">
+                <a:solidFill>
+                  <a:prstClr val="black">
+                    <a:lumMod val="50000"/>
+                  </a:prstClr>
+                </a:solidFill>
+                <a:latin typeface="Arial"/>
+              </a:rPr>
+              <a:t>humnan</a:t>
+            </a:r>
+            <a:r>
+              <a:rPr lang="en-US" sz="1200" dirty="0">
+                <a:solidFill>
+                  <a:prstClr val="black">
+                    <a:lumMod val="50000"/>
+                  </a:prstClr>
+                </a:solidFill>
+                <a:latin typeface="Arial"/>
+              </a:rPr>
+              <a:t> escalation, since either the LLM is cheating or the examples in BRD is not covering all real job cases.</a:t>
+            </a:r>
+            <a:endParaRPr lang="en-US" sz="1200" dirty="0">
+              <a:solidFill>
+                <a:prstClr val="black"/>
+              </a:solidFill>
+              <a:latin typeface="Arial"/>
+            </a:endParaRPr>
+          </a:p>
+        </p:txBody>
+      </p:sp>
+      <p:sp>
+        <p:nvSpPr>
+          <p:cNvPr id="184" name="TextBox 183">
+            <a:extLst>
+              <a:ext uri="{FF2B5EF4-FFF2-40B4-BE49-F238E27FC236}">
+                <a16:creationId xmlns:a16="http://schemas.microsoft.com/office/drawing/2014/main" id="{44B30D09-1C01-3CCA-4C85-1801DD1D151F}"/>
+              </a:ext>
+            </a:extLst>
+          </p:cNvPr>
+          <p:cNvSpPr txBox="1"/>
+          <p:nvPr/>
+        </p:nvSpPr>
+        <p:spPr>
+          <a:xfrm>
+            <a:off x="19751756" y="16682315"/>
+            <a:ext cx="820736" cy="338554"/>
+          </a:xfrm>
+          <a:prstGeom prst="rect">
+            <a:avLst/>
+          </a:prstGeom>
+          <a:noFill/>
+        </p:spPr>
+        <p:txBody>
+          <a:bodyPr wrap="square">
+            <a:spAutoFit/>
+          </a:bodyPr>
+          <a:lstStyle/>
+          <a:p>
+            <a:pPr algn="ctr" defTabSz="914400">
+              <a:defRPr/>
+            </a:pPr>
+            <a:r>
+              <a:rPr lang="en-US" sz="1600" dirty="0">
+                <a:solidFill>
+                  <a:prstClr val="black">
+                    <a:lumMod val="50000"/>
+                  </a:prstClr>
+                </a:solidFill>
+                <a:latin typeface="Arial"/>
+              </a:rPr>
+              <a:t>No</a:t>
+            </a:r>
+            <a:endParaRPr lang="en-US" sz="1600" dirty="0">
+              <a:solidFill>
+                <a:prstClr val="black"/>
+              </a:solidFill>
+              <a:latin typeface="Arial"/>
+            </a:endParaRPr>
+          </a:p>
+        </p:txBody>
+      </p:sp>
+      <p:cxnSp>
+        <p:nvCxnSpPr>
+          <p:cNvPr id="166" name="Connector: Elbow 87">
+            <a:extLst>
+              <a:ext uri="{FF2B5EF4-FFF2-40B4-BE49-F238E27FC236}">
+                <a16:creationId xmlns:a16="http://schemas.microsoft.com/office/drawing/2014/main" id="{29BDAEC3-B0F1-2AD5-D395-42FF5665ADAB}"/>
+              </a:ext>
+            </a:extLst>
+          </p:cNvPr>
+          <p:cNvCxnSpPr>
+            <a:cxnSpLocks/>
+            <a:stCxn id="44" idx="3"/>
+            <a:endCxn id="118" idx="1"/>
+          </p:cNvCxnSpPr>
+          <p:nvPr/>
+        </p:nvCxnSpPr>
+        <p:spPr>
+          <a:xfrm flipV="1">
+            <a:off x="19841590" y="22327926"/>
+            <a:ext cx="696949" cy="585"/>
+          </a:xfrm>
+          <a:prstGeom prst="straightConnector1">
+            <a:avLst/>
+          </a:prstGeom>
+          <a:noFill/>
+          <a:ln w="76200" cap="sq" cmpd="sng" algn="ctr">
+            <a:solidFill>
+              <a:srgbClr val="006297"/>
+            </a:solidFill>
+            <a:prstDash val="solid"/>
+            <a:tailEnd type="triangle"/>
+          </a:ln>
+          <a:effectLst/>
+        </p:spPr>
+      </p:cxnSp>
+      <p:sp>
+        <p:nvSpPr>
+          <p:cNvPr id="118" name="Rectangle: Rounded Corners 117">
+            <a:extLst>
+              <a:ext uri="{FF2B5EF4-FFF2-40B4-BE49-F238E27FC236}">
+                <a16:creationId xmlns:a16="http://schemas.microsoft.com/office/drawing/2014/main" id="{EA6F7C5F-6F23-F607-F50F-0828F4266A53}"/>
+              </a:ext>
+            </a:extLst>
+          </p:cNvPr>
+          <p:cNvSpPr/>
+          <p:nvPr/>
+        </p:nvSpPr>
+        <p:spPr>
+          <a:xfrm>
+            <a:off x="20538539" y="21957078"/>
+            <a:ext cx="1762308" cy="741695"/>
+          </a:xfrm>
+          <a:prstGeom prst="roundRect">
+            <a:avLst/>
+          </a:prstGeom>
+          <a:noFill/>
+          <a:ln w="12700" cap="sq" cmpd="sng" algn="ctr">
+            <a:solidFill>
+              <a:srgbClr val="4F5759">
+                <a:lumMod val="50000"/>
+              </a:srgbClr>
+            </a:solidFill>
+            <a:prstDash val="solid"/>
+          </a:ln>
+          <a:effectLst/>
+        </p:spPr>
+        <p:txBody>
+          <a:bodyPr rtlCol="0" anchor="ctr"/>
+          <a:lstStyle/>
+          <a:p>
+            <a:pPr marL="0" marR="0" lvl="0" indent="0" algn="ctr" defTabSz="914400" eaLnBrk="1" fontAlgn="auto" latinLnBrk="0" hangingPunct="1">
+              <a:lnSpc>
+                <a:spcPct val="100000"/>
+              </a:lnSpc>
+              <a:spcBef>
+                <a:spcPts val="0"/>
+              </a:spcBef>
+              <a:spcAft>
+                <a:spcPts val="0"/>
+              </a:spcAft>
+              <a:buClrTx/>
+              <a:buSzTx/>
+              <a:buFontTx/>
+              <a:buNone/>
+              <a:tabLst/>
+              <a:defRPr/>
+            </a:pPr>
+            <a:r>
+              <a:rPr kumimoji="0" lang="en-US" sz="1050" b="0" i="0" u="none" strike="noStrike" kern="0" cap="none" spc="0" normalizeH="0" baseline="0" noProof="0" dirty="0">
+                <a:ln>
+                  <a:noFill/>
+                </a:ln>
+                <a:solidFill>
+                  <a:prstClr val="black">
+                    <a:lumMod val="50000"/>
+                  </a:prstClr>
+                </a:solidFill>
+                <a:effectLst/>
+                <a:uLnTx/>
+                <a:uFillTx/>
+                <a:latin typeface="Arial"/>
+                <a:ea typeface="+mn-ea"/>
+                <a:cs typeface="+mn-cs"/>
+              </a:rPr>
+              <a:t>Make a quarantine note in memory and registry for this function</a:t>
+            </a:r>
+            <a:endParaRPr kumimoji="0" lang="en-US" sz="1050" b="0" i="0" u="none" strike="noStrike" kern="0" cap="none" spc="0" normalizeH="0" baseline="0" noProof="0" dirty="0">
+              <a:ln>
+                <a:noFill/>
+              </a:ln>
+              <a:solidFill>
+                <a:prstClr val="white"/>
+              </a:solidFill>
+              <a:effectLst/>
+              <a:uLnTx/>
+              <a:uFillTx/>
+              <a:latin typeface="Arial"/>
+              <a:ea typeface="+mn-ea"/>
+              <a:cs typeface="+mn-cs"/>
+            </a:endParaRPr>
+          </a:p>
+        </p:txBody>
+      </p:sp>
     </p:spTree>
     <p:extLst>
       <p:ext uri="{BB962C8B-B14F-4D97-AF65-F5344CB8AC3E}">
@@ -31177,35 +32082,14 @@
           <a:p>
             <a:pPr algn="ctr"/>
             <a:r>
-              <a:rPr lang="en-US" sz="5940" b="1" dirty="0">
-                <a:solidFill>
-                  <a:srgbClr val="2766EC"/>
+              <a:rPr lang="en-US" sz="8000" b="1" dirty="0">
+                <a:solidFill>
+                  <a:srgbClr val="2563EB"/>
                 </a:solidFill>
                 <a:latin typeface="Aptos" pitchFamily="34" charset="0"/>
-                <a:ea typeface="Aptos" pitchFamily="34" charset="-122"/>
-                <a:cs typeface="Aptos" pitchFamily="34" charset="-120"/>
-              </a:rPr>
-              <a:t>Future implementation direction </a:t>
-            </a:r>
-            <a:r>
-              <a:rPr lang="en-US" sz="5940" b="1">
-                <a:solidFill>
-                  <a:srgbClr val="2766EC"/>
-                </a:solidFill>
-                <a:latin typeface="Aptos" pitchFamily="34" charset="0"/>
-                <a:ea typeface="Aptos" pitchFamily="34" charset="-122"/>
-                <a:cs typeface="Aptos" pitchFamily="34" charset="-120"/>
-              </a:rPr>
-              <a:t>– 2</a:t>
-            </a:r>
-            <a:endParaRPr lang="en-US" sz="5940" b="1" dirty="0">
-              <a:solidFill>
-                <a:srgbClr val="2766EC"/>
-              </a:solidFill>
-              <a:latin typeface="Aptos" pitchFamily="34" charset="0"/>
-              <a:ea typeface="Aptos" pitchFamily="34" charset="-122"/>
-              <a:cs typeface="Aptos" pitchFamily="34" charset="-120"/>
-            </a:endParaRPr>
+              </a:rPr>
+              <a:t>Future implementation direction – 2</a:t>
+            </a:r>
           </a:p>
         </p:txBody>
       </p:sp>
@@ -32612,6 +33496,1424 @@
               <a:t>Design rule: BRD-scoped tools control permissions; sandbox isolation contains unexpected code behavior. Both are needed.</a:t>
             </a:r>
             <a:endParaRPr lang="en-US" sz="4158" dirty="0"/>
+          </a:p>
+        </p:txBody>
+      </p:sp>
+    </p:spTree>
+  </p:cSld>
+  <p:clrMapOvr>
+    <a:masterClrMapping/>
+  </p:clrMapOvr>
+</p:sld>
+</file>
+
+<file path=ppt/slides/slide9.xml><?xml version="1.0" encoding="utf-8"?>
+<p:sld xmlns:a="http://schemas.openxmlformats.org/drawingml/2006/main" xmlns:r="http://schemas.openxmlformats.org/officeDocument/2006/relationships" xmlns:p="http://schemas.openxmlformats.org/presentationml/2006/main">
+  <p:cSld>
+    <p:spTree>
+      <p:nvGrpSpPr>
+        <p:cNvPr id="1" name=""/>
+        <p:cNvGrpSpPr/>
+        <p:nvPr/>
+      </p:nvGrpSpPr>
+      <p:grpSpPr>
+        <a:xfrm>
+          <a:off x="0" y="0"/>
+          <a:ext cx="0" cy="0"/>
+          <a:chOff x="0" y="0"/>
+          <a:chExt cx="0" cy="0"/>
+        </a:xfrm>
+      </p:grpSpPr>
+      <p:sp>
+        <p:nvSpPr>
+          <p:cNvPr id="2" name="Shape 0"/>
+          <p:cNvSpPr/>
+          <p:nvPr/>
+        </p:nvSpPr>
+        <p:spPr>
+          <a:xfrm>
+            <a:off x="0" y="0"/>
+            <a:ext cx="43891200" cy="1415491"/>
+          </a:xfrm>
+          <a:prstGeom prst="rect">
+            <a:avLst/>
+          </a:prstGeom>
+          <a:solidFill>
+            <a:srgbClr val="EDFAF7"/>
+          </a:solidFill>
+          <a:ln w="7620">
+            <a:solidFill>
+              <a:srgbClr val="A7B7BC"/>
+            </a:solidFill>
+            <a:prstDash val="solid"/>
+          </a:ln>
+        </p:spPr>
+        <p:txBody>
+          <a:bodyPr/>
+          <a:lstStyle/>
+          <a:p>
+            <a:endParaRPr lang="en-US" sz="6480"/>
+          </a:p>
+        </p:txBody>
+      </p:sp>
+      <p:sp>
+        <p:nvSpPr>
+          <p:cNvPr id="3" name="Text 1"/>
+          <p:cNvSpPr/>
+          <p:nvPr/>
+        </p:nvSpPr>
+        <p:spPr>
+          <a:xfrm>
+            <a:off x="1316736" y="49377"/>
+            <a:ext cx="41257728" cy="1283818"/>
+          </a:xfrm>
+          <a:prstGeom prst="rect">
+            <a:avLst/>
+          </a:prstGeom>
+          <a:noFill/>
+          <a:ln/>
+        </p:spPr>
+        <p:txBody>
+          <a:bodyPr wrap="square" lIns="0" tIns="0" rIns="0" bIns="0" rtlCol="0" anchor="ctr"/>
+          <a:lstStyle/>
+          <a:p>
+            <a:pPr algn="ctr"/>
+            <a:r>
+              <a:rPr lang="en-US" sz="8000" b="1" dirty="0">
+                <a:solidFill>
+                  <a:srgbClr val="2563EB"/>
+                </a:solidFill>
+                <a:latin typeface="Aptos" pitchFamily="34" charset="0"/>
+              </a:rPr>
+              <a:t>Future implementation direction – 3</a:t>
+            </a:r>
+          </a:p>
+        </p:txBody>
+      </p:sp>
+      <p:sp>
+        <p:nvSpPr>
+          <p:cNvPr id="4" name="Text 2"/>
+          <p:cNvSpPr/>
+          <p:nvPr/>
+        </p:nvSpPr>
+        <p:spPr>
+          <a:xfrm>
+            <a:off x="1909267" y="2337206"/>
+            <a:ext cx="40489632" cy="1645920"/>
+          </a:xfrm>
+          <a:prstGeom prst="rect">
+            <a:avLst/>
+          </a:prstGeom>
+          <a:noFill/>
+          <a:ln/>
+        </p:spPr>
+        <p:txBody>
+          <a:bodyPr wrap="square" lIns="0" tIns="0" rIns="0" bIns="0" rtlCol="0" anchor="ctr"/>
+          <a:lstStyle/>
+          <a:p>
+            <a:r>
+              <a:rPr lang="en-US" sz="9648" b="1" dirty="0">
+                <a:solidFill>
+                  <a:srgbClr val="10192D"/>
+                </a:solidFill>
+                <a:latin typeface="Aptos" pitchFamily="34" charset="0"/>
+                <a:ea typeface="Aptos" pitchFamily="34" charset="-122"/>
+                <a:cs typeface="Aptos" pitchFamily="34" charset="-120"/>
+              </a:rPr>
+              <a:t>Defending against deliberately deceptive generated functions</a:t>
+            </a:r>
+            <a:endParaRPr lang="en-US" sz="9648" dirty="0"/>
+          </a:p>
+        </p:txBody>
+      </p:sp>
+      <p:sp>
+        <p:nvSpPr>
+          <p:cNvPr id="5" name="Text 3"/>
+          <p:cNvSpPr/>
+          <p:nvPr/>
+        </p:nvSpPr>
+        <p:spPr>
+          <a:xfrm>
+            <a:off x="1942186" y="4575656"/>
+            <a:ext cx="23340974" cy="1840383"/>
+          </a:xfrm>
+          <a:prstGeom prst="rect">
+            <a:avLst/>
+          </a:prstGeom>
+          <a:noFill/>
+          <a:ln/>
+        </p:spPr>
+        <p:txBody>
+          <a:bodyPr wrap="square" lIns="0" tIns="0" rIns="0" bIns="0" rtlCol="0" anchor="ctr"/>
+          <a:lstStyle/>
+          <a:p>
+            <a:pPr marL="685800" indent="-685800">
+              <a:buFont typeface="Arial" panose="020B0604020202020204" pitchFamily="34" charset="0"/>
+              <a:buChar char="•"/>
+            </a:pPr>
+            <a:r>
+              <a:rPr lang="en-US" sz="4500" dirty="0">
+                <a:solidFill>
+                  <a:srgbClr val="475569"/>
+                </a:solidFill>
+                <a:highlight>
+                  <a:srgbClr val="FFFF00"/>
+                </a:highlight>
+                <a:latin typeface="Aptos" pitchFamily="34" charset="0"/>
+                <a:ea typeface="Aptos" pitchFamily="34" charset="-122"/>
+                <a:cs typeface="Aptos" pitchFamily="34" charset="-120"/>
+              </a:rPr>
+              <a:t>Current program prevents ordinary LLM coding mistakes. </a:t>
+            </a:r>
+          </a:p>
+          <a:p>
+            <a:pPr marL="685800" indent="-685800">
+              <a:buFont typeface="Arial" panose="020B0604020202020204" pitchFamily="34" charset="0"/>
+              <a:buChar char="•"/>
+            </a:pPr>
+            <a:r>
+              <a:rPr lang="en-US" sz="4500" dirty="0">
+                <a:solidFill>
+                  <a:srgbClr val="475569"/>
+                </a:solidFill>
+                <a:highlight>
+                  <a:srgbClr val="FFFF00"/>
+                </a:highlight>
+                <a:latin typeface="Aptos" pitchFamily="34" charset="0"/>
+                <a:ea typeface="Aptos" pitchFamily="34" charset="-122"/>
+                <a:cs typeface="Aptos" pitchFamily="34" charset="-120"/>
+              </a:rPr>
+              <a:t>A future </a:t>
+            </a:r>
+            <a:r>
+              <a:rPr lang="en-US" sz="4500" b="1" dirty="0">
+                <a:solidFill>
+                  <a:srgbClr val="475569"/>
+                </a:solidFill>
+                <a:highlight>
+                  <a:srgbClr val="FFFF00"/>
+                </a:highlight>
+                <a:latin typeface="Aptos" pitchFamily="34" charset="0"/>
+                <a:ea typeface="Aptos" pitchFamily="34" charset="-122"/>
+                <a:cs typeface="Aptos" pitchFamily="34" charset="-120"/>
+              </a:rPr>
+              <a:t>adversarial</a:t>
+            </a:r>
+            <a:r>
+              <a:rPr lang="en-US" sz="4500" dirty="0">
+                <a:solidFill>
+                  <a:srgbClr val="475569"/>
+                </a:solidFill>
+                <a:highlight>
+                  <a:srgbClr val="FFFF00"/>
+                </a:highlight>
+                <a:latin typeface="Aptos" pitchFamily="34" charset="0"/>
+                <a:ea typeface="Aptos" pitchFamily="34" charset="-122"/>
+                <a:cs typeface="Aptos" pitchFamily="34" charset="-120"/>
+              </a:rPr>
+              <a:t> defense must also prevent intentional cheating.</a:t>
+            </a:r>
+            <a:endParaRPr lang="en-US" sz="4500" dirty="0">
+              <a:highlight>
+                <a:srgbClr val="FFFF00"/>
+              </a:highlight>
+            </a:endParaRPr>
+          </a:p>
+        </p:txBody>
+      </p:sp>
+      <p:sp>
+        <p:nvSpPr>
+          <p:cNvPr id="8" name="Text 6"/>
+          <p:cNvSpPr/>
+          <p:nvPr/>
+        </p:nvSpPr>
+        <p:spPr>
+          <a:xfrm>
+            <a:off x="1889760" y="8574634"/>
+            <a:ext cx="39502080" cy="954634"/>
+          </a:xfrm>
+          <a:prstGeom prst="rect">
+            <a:avLst/>
+          </a:prstGeom>
+          <a:noFill/>
+          <a:ln/>
+        </p:spPr>
+        <p:txBody>
+          <a:bodyPr wrap="square" lIns="0" tIns="0" rIns="0" bIns="0" rtlCol="0" anchor="ctr"/>
+          <a:lstStyle/>
+          <a:p>
+            <a:r>
+              <a:rPr lang="en-US" sz="6000" b="1" dirty="0">
+                <a:solidFill>
+                  <a:srgbClr val="2766EC"/>
+                </a:solidFill>
+                <a:latin typeface="Aptos" pitchFamily="34" charset="0"/>
+                <a:ea typeface="Aptos" pitchFamily="34" charset="-122"/>
+                <a:cs typeface="Aptos" pitchFamily="34" charset="-120"/>
+              </a:rPr>
+              <a:t>Hypothetical Cheating Path</a:t>
+            </a:r>
+            <a:endParaRPr lang="en-US" sz="6000" dirty="0"/>
+          </a:p>
+        </p:txBody>
+      </p:sp>
+      <p:sp>
+        <p:nvSpPr>
+          <p:cNvPr id="9" name="Shape 7"/>
+          <p:cNvSpPr/>
+          <p:nvPr/>
+        </p:nvSpPr>
+        <p:spPr>
+          <a:xfrm>
+            <a:off x="1909267" y="10269931"/>
+            <a:ext cx="8460029" cy="5036515"/>
+          </a:xfrm>
+          <a:prstGeom prst="rect">
+            <a:avLst/>
+          </a:prstGeom>
+          <a:solidFill>
+            <a:srgbClr val="DBEAFE"/>
+          </a:solidFill>
+          <a:ln w="13335">
+            <a:solidFill>
+              <a:srgbClr val="3977FF"/>
+            </a:solidFill>
+            <a:prstDash val="solid"/>
+          </a:ln>
+        </p:spPr>
+        <p:txBody>
+          <a:bodyPr/>
+          <a:lstStyle/>
+          <a:p>
+            <a:endParaRPr lang="en-US" sz="6480"/>
+          </a:p>
+        </p:txBody>
+      </p:sp>
+      <p:sp>
+        <p:nvSpPr>
+          <p:cNvPr id="10" name="Text 8"/>
+          <p:cNvSpPr/>
+          <p:nvPr/>
+        </p:nvSpPr>
+        <p:spPr>
+          <a:xfrm>
+            <a:off x="2304288" y="10730789"/>
+            <a:ext cx="7669987" cy="921715"/>
+          </a:xfrm>
+          <a:prstGeom prst="rect">
+            <a:avLst/>
+          </a:prstGeom>
+          <a:noFill/>
+          <a:ln/>
+        </p:spPr>
+        <p:txBody>
+          <a:bodyPr wrap="square" lIns="0" tIns="0" rIns="0" bIns="0" rtlCol="0" anchor="ctr"/>
+          <a:lstStyle/>
+          <a:p>
+            <a:pPr algn="ctr"/>
+            <a:r>
+              <a:rPr lang="en-US" sz="5472" dirty="0">
+                <a:solidFill>
+                  <a:srgbClr val="10192D"/>
+                </a:solidFill>
+                <a:latin typeface="Aptos" pitchFamily="34" charset="0"/>
+                <a:ea typeface="Aptos" pitchFamily="34" charset="-122"/>
+                <a:cs typeface="Aptos" pitchFamily="34" charset="-120"/>
+              </a:rPr>
+              <a:t>1</a:t>
+            </a:r>
+            <a:endParaRPr lang="en-US" sz="5472" dirty="0"/>
+          </a:p>
+        </p:txBody>
+      </p:sp>
+      <p:sp>
+        <p:nvSpPr>
+          <p:cNvPr id="11" name="Text 9"/>
+          <p:cNvSpPr/>
+          <p:nvPr/>
+        </p:nvSpPr>
+        <p:spPr>
+          <a:xfrm>
+            <a:off x="2337207" y="11948769"/>
+            <a:ext cx="7604150" cy="954634"/>
+          </a:xfrm>
+          <a:prstGeom prst="rect">
+            <a:avLst/>
+          </a:prstGeom>
+          <a:noFill/>
+          <a:ln/>
+        </p:spPr>
+        <p:txBody>
+          <a:bodyPr wrap="square" lIns="0" tIns="0" rIns="0" bIns="0" rtlCol="0" anchor="ctr"/>
+          <a:lstStyle/>
+          <a:p>
+            <a:pPr algn="ctr"/>
+            <a:r>
+              <a:rPr lang="en-US" sz="5400" b="1" dirty="0">
+                <a:solidFill>
+                  <a:srgbClr val="10192D"/>
+                </a:solidFill>
+                <a:latin typeface="Aptos" pitchFamily="34" charset="0"/>
+                <a:ea typeface="Aptos" pitchFamily="34" charset="-122"/>
+                <a:cs typeface="Aptos" pitchFamily="34" charset="-120"/>
+              </a:rPr>
+              <a:t>Deceptive code</a:t>
+            </a:r>
+            <a:endParaRPr lang="en-US" sz="5400" dirty="0"/>
+          </a:p>
+        </p:txBody>
+      </p:sp>
+      <p:sp>
+        <p:nvSpPr>
+          <p:cNvPr id="12" name="Text 10"/>
+          <p:cNvSpPr/>
+          <p:nvPr/>
+        </p:nvSpPr>
+        <p:spPr>
+          <a:xfrm>
+            <a:off x="2337207" y="13166751"/>
+            <a:ext cx="7604150" cy="1580083"/>
+          </a:xfrm>
+          <a:prstGeom prst="rect">
+            <a:avLst/>
+          </a:prstGeom>
+          <a:noFill/>
+          <a:ln/>
+        </p:spPr>
+        <p:txBody>
+          <a:bodyPr wrap="square" lIns="0" tIns="0" rIns="0" bIns="0" rtlCol="0" anchor="ctr"/>
+          <a:lstStyle/>
+          <a:p>
+            <a:pPr algn="ctr"/>
+            <a:r>
+              <a:rPr lang="en-US" sz="4572" dirty="0">
+                <a:solidFill>
+                  <a:srgbClr val="10192D"/>
+                </a:solidFill>
+                <a:latin typeface="Aptos" pitchFamily="34" charset="0"/>
+                <a:ea typeface="Aptos" pitchFamily="34" charset="-122"/>
+                <a:cs typeface="Aptos" pitchFamily="34" charset="-120"/>
+              </a:rPr>
+              <a:t>Generated function aims</a:t>
+            </a:r>
+            <a:endParaRPr lang="en-US" sz="4572" dirty="0"/>
+          </a:p>
+          <a:p>
+            <a:pPr algn="ctr"/>
+            <a:r>
+              <a:rPr lang="en-US" sz="4572" dirty="0">
+                <a:solidFill>
+                  <a:srgbClr val="10192D"/>
+                </a:solidFill>
+                <a:latin typeface="Aptos" pitchFamily="34" charset="0"/>
+                <a:ea typeface="Aptos" pitchFamily="34" charset="-122"/>
+                <a:cs typeface="Aptos" pitchFamily="34" charset="-120"/>
+              </a:rPr>
+              <a:t>to game the tests</a:t>
+            </a:r>
+            <a:endParaRPr lang="en-US" sz="4572" dirty="0"/>
+          </a:p>
+        </p:txBody>
+      </p:sp>
+      <p:sp>
+        <p:nvSpPr>
+          <p:cNvPr id="13" name="Shape 11"/>
+          <p:cNvSpPr/>
+          <p:nvPr/>
+        </p:nvSpPr>
+        <p:spPr>
+          <a:xfrm>
+            <a:off x="10451592" y="12788189"/>
+            <a:ext cx="1761134" cy="0"/>
+          </a:xfrm>
+          <a:prstGeom prst="line">
+            <a:avLst/>
+          </a:prstGeom>
+          <a:noFill/>
+          <a:ln w="17780">
+            <a:solidFill>
+              <a:srgbClr val="98A4B7"/>
+            </a:solidFill>
+            <a:prstDash val="solid"/>
+            <a:headEnd type="none"/>
+            <a:tailEnd type="triangle"/>
+          </a:ln>
+        </p:spPr>
+        <p:txBody>
+          <a:bodyPr/>
+          <a:lstStyle/>
+          <a:p>
+            <a:endParaRPr lang="en-US" sz="6480"/>
+          </a:p>
+        </p:txBody>
+      </p:sp>
+      <p:sp>
+        <p:nvSpPr>
+          <p:cNvPr id="14" name="Shape 12"/>
+          <p:cNvSpPr/>
+          <p:nvPr/>
+        </p:nvSpPr>
+        <p:spPr>
+          <a:xfrm>
+            <a:off x="12410237" y="10269931"/>
+            <a:ext cx="8460029" cy="5036515"/>
+          </a:xfrm>
+          <a:prstGeom prst="rect">
+            <a:avLst/>
+          </a:prstGeom>
+          <a:solidFill>
+            <a:srgbClr val="D3F7E5"/>
+          </a:solidFill>
+          <a:ln w="13335">
+            <a:solidFill>
+              <a:srgbClr val="17AD79"/>
+            </a:solidFill>
+            <a:prstDash val="solid"/>
+          </a:ln>
+        </p:spPr>
+        <p:txBody>
+          <a:bodyPr/>
+          <a:lstStyle/>
+          <a:p>
+            <a:endParaRPr lang="en-US" sz="6480"/>
+          </a:p>
+        </p:txBody>
+      </p:sp>
+      <p:sp>
+        <p:nvSpPr>
+          <p:cNvPr id="15" name="Text 13"/>
+          <p:cNvSpPr/>
+          <p:nvPr/>
+        </p:nvSpPr>
+        <p:spPr>
+          <a:xfrm>
+            <a:off x="12805258" y="10730789"/>
+            <a:ext cx="7669987" cy="921715"/>
+          </a:xfrm>
+          <a:prstGeom prst="rect">
+            <a:avLst/>
+          </a:prstGeom>
+          <a:noFill/>
+          <a:ln/>
+        </p:spPr>
+        <p:txBody>
+          <a:bodyPr wrap="square" lIns="0" tIns="0" rIns="0" bIns="0" rtlCol="0" anchor="ctr"/>
+          <a:lstStyle/>
+          <a:p>
+            <a:pPr algn="ctr"/>
+            <a:r>
+              <a:rPr lang="en-US" sz="5472" dirty="0">
+                <a:solidFill>
+                  <a:srgbClr val="10192D"/>
+                </a:solidFill>
+                <a:latin typeface="Aptos" pitchFamily="34" charset="0"/>
+                <a:ea typeface="Aptos" pitchFamily="34" charset="-122"/>
+                <a:cs typeface="Aptos" pitchFamily="34" charset="-120"/>
+              </a:rPr>
+              <a:t>2</a:t>
+            </a:r>
+            <a:endParaRPr lang="en-US" sz="5472" dirty="0"/>
+          </a:p>
+        </p:txBody>
+      </p:sp>
+      <p:sp>
+        <p:nvSpPr>
+          <p:cNvPr id="16" name="Text 14"/>
+          <p:cNvSpPr/>
+          <p:nvPr/>
+        </p:nvSpPr>
+        <p:spPr>
+          <a:xfrm>
+            <a:off x="12838176" y="11948769"/>
+            <a:ext cx="7604150" cy="954634"/>
+          </a:xfrm>
+          <a:prstGeom prst="rect">
+            <a:avLst/>
+          </a:prstGeom>
+          <a:noFill/>
+          <a:ln/>
+        </p:spPr>
+        <p:txBody>
+          <a:bodyPr wrap="square" lIns="0" tIns="0" rIns="0" bIns="0" rtlCol="0" anchor="ctr"/>
+          <a:lstStyle/>
+          <a:p>
+            <a:pPr algn="ctr"/>
+            <a:r>
+              <a:rPr lang="en-US" sz="5400" b="1" dirty="0">
+                <a:solidFill>
+                  <a:srgbClr val="10192D"/>
+                </a:solidFill>
+                <a:latin typeface="Aptos" pitchFamily="34" charset="0"/>
+                <a:ea typeface="Aptos" pitchFamily="34" charset="-122"/>
+                <a:cs typeface="Aptos" pitchFamily="34" charset="-120"/>
+              </a:rPr>
+              <a:t>Answer-key access</a:t>
+            </a:r>
+            <a:endParaRPr lang="en-US" sz="5400" dirty="0"/>
+          </a:p>
+        </p:txBody>
+      </p:sp>
+      <p:sp>
+        <p:nvSpPr>
+          <p:cNvPr id="17" name="Text 15"/>
+          <p:cNvSpPr/>
+          <p:nvPr/>
+        </p:nvSpPr>
+        <p:spPr>
+          <a:xfrm>
+            <a:off x="12838176" y="13166751"/>
+            <a:ext cx="7604150" cy="1580083"/>
+          </a:xfrm>
+          <a:prstGeom prst="rect">
+            <a:avLst/>
+          </a:prstGeom>
+          <a:noFill/>
+          <a:ln/>
+        </p:spPr>
+        <p:txBody>
+          <a:bodyPr wrap="square" lIns="0" tIns="0" rIns="0" bIns="0" rtlCol="0" anchor="ctr"/>
+          <a:lstStyle/>
+          <a:p>
+            <a:pPr algn="ctr"/>
+            <a:r>
+              <a:rPr lang="en-US" sz="4572" dirty="0">
+                <a:solidFill>
+                  <a:srgbClr val="10192D"/>
+                </a:solidFill>
+                <a:latin typeface="Aptos" pitchFamily="34" charset="0"/>
+                <a:ea typeface="Aptos" pitchFamily="34" charset="-122"/>
+                <a:cs typeface="Aptos" pitchFamily="34" charset="-120"/>
+              </a:rPr>
+              <a:t>Uses worker privileges</a:t>
+            </a:r>
+            <a:endParaRPr lang="en-US" sz="4572" dirty="0"/>
+          </a:p>
+          <a:p>
+            <a:pPr algn="ctr"/>
+            <a:r>
+              <a:rPr lang="en-US" sz="4572" dirty="0">
+                <a:solidFill>
+                  <a:srgbClr val="10192D"/>
+                </a:solidFill>
+                <a:latin typeface="Aptos" pitchFamily="34" charset="0"/>
+                <a:ea typeface="Aptos" pitchFamily="34" charset="-122"/>
+                <a:cs typeface="Aptos" pitchFamily="34" charset="-120"/>
+              </a:rPr>
+              <a:t>to read hidden labels</a:t>
+            </a:r>
+            <a:endParaRPr lang="en-US" sz="4572" dirty="0"/>
+          </a:p>
+        </p:txBody>
+      </p:sp>
+      <p:sp>
+        <p:nvSpPr>
+          <p:cNvPr id="18" name="Shape 16"/>
+          <p:cNvSpPr/>
+          <p:nvPr/>
+        </p:nvSpPr>
+        <p:spPr>
+          <a:xfrm>
+            <a:off x="20952562" y="12788189"/>
+            <a:ext cx="1761134" cy="0"/>
+          </a:xfrm>
+          <a:prstGeom prst="line">
+            <a:avLst/>
+          </a:prstGeom>
+          <a:noFill/>
+          <a:ln w="17780">
+            <a:solidFill>
+              <a:srgbClr val="98A4B7"/>
+            </a:solidFill>
+            <a:prstDash val="solid"/>
+            <a:headEnd type="none"/>
+            <a:tailEnd type="triangle"/>
+          </a:ln>
+        </p:spPr>
+        <p:txBody>
+          <a:bodyPr/>
+          <a:lstStyle/>
+          <a:p>
+            <a:endParaRPr lang="en-US" sz="6480"/>
+          </a:p>
+        </p:txBody>
+      </p:sp>
+      <p:sp>
+        <p:nvSpPr>
+          <p:cNvPr id="19" name="Shape 17"/>
+          <p:cNvSpPr/>
+          <p:nvPr/>
+        </p:nvSpPr>
+        <p:spPr>
+          <a:xfrm>
+            <a:off x="22911206" y="10269931"/>
+            <a:ext cx="8460029" cy="5036515"/>
+          </a:xfrm>
+          <a:prstGeom prst="rect">
+            <a:avLst/>
+          </a:prstGeom>
+          <a:solidFill>
+            <a:srgbClr val="FFF2C5"/>
+          </a:solidFill>
+          <a:ln w="13335">
+            <a:solidFill>
+              <a:srgbClr val="F59A15"/>
+            </a:solidFill>
+            <a:prstDash val="solid"/>
+          </a:ln>
+        </p:spPr>
+        <p:txBody>
+          <a:bodyPr/>
+          <a:lstStyle/>
+          <a:p>
+            <a:endParaRPr lang="en-US" sz="6480"/>
+          </a:p>
+        </p:txBody>
+      </p:sp>
+      <p:sp>
+        <p:nvSpPr>
+          <p:cNvPr id="20" name="Text 18"/>
+          <p:cNvSpPr/>
+          <p:nvPr/>
+        </p:nvSpPr>
+        <p:spPr>
+          <a:xfrm>
+            <a:off x="23306227" y="10730789"/>
+            <a:ext cx="7669987" cy="921715"/>
+          </a:xfrm>
+          <a:prstGeom prst="rect">
+            <a:avLst/>
+          </a:prstGeom>
+          <a:noFill/>
+          <a:ln/>
+        </p:spPr>
+        <p:txBody>
+          <a:bodyPr wrap="square" lIns="0" tIns="0" rIns="0" bIns="0" rtlCol="0" anchor="ctr"/>
+          <a:lstStyle/>
+          <a:p>
+            <a:pPr algn="ctr"/>
+            <a:r>
+              <a:rPr lang="en-US" sz="5472" dirty="0">
+                <a:solidFill>
+                  <a:srgbClr val="10192D"/>
+                </a:solidFill>
+                <a:latin typeface="Aptos" pitchFamily="34" charset="0"/>
+                <a:ea typeface="Aptos" pitchFamily="34" charset="-122"/>
+                <a:cs typeface="Aptos" pitchFamily="34" charset="-120"/>
+              </a:rPr>
+              <a:t>3</a:t>
+            </a:r>
+            <a:endParaRPr lang="en-US" sz="5472" dirty="0"/>
+          </a:p>
+        </p:txBody>
+      </p:sp>
+      <p:sp>
+        <p:nvSpPr>
+          <p:cNvPr id="21" name="Text 19"/>
+          <p:cNvSpPr/>
+          <p:nvPr/>
+        </p:nvSpPr>
+        <p:spPr>
+          <a:xfrm>
+            <a:off x="23339146" y="11948769"/>
+            <a:ext cx="7604150" cy="954634"/>
+          </a:xfrm>
+          <a:prstGeom prst="rect">
+            <a:avLst/>
+          </a:prstGeom>
+          <a:noFill/>
+          <a:ln/>
+        </p:spPr>
+        <p:txBody>
+          <a:bodyPr wrap="square" lIns="0" tIns="0" rIns="0" bIns="0" rtlCol="0" anchor="ctr"/>
+          <a:lstStyle/>
+          <a:p>
+            <a:pPr algn="ctr"/>
+            <a:r>
+              <a:rPr lang="en-US" sz="5400" b="1" dirty="0">
+                <a:solidFill>
+                  <a:srgbClr val="10192D"/>
+                </a:solidFill>
+                <a:latin typeface="Aptos" pitchFamily="34" charset="0"/>
+                <a:ea typeface="Aptos" pitchFamily="34" charset="-122"/>
+                <a:cs typeface="Aptos" pitchFamily="34" charset="-120"/>
+              </a:rPr>
+              <a:t>Memorized outputs</a:t>
+            </a:r>
+            <a:endParaRPr lang="en-US" sz="5400" dirty="0"/>
+          </a:p>
+        </p:txBody>
+      </p:sp>
+      <p:sp>
+        <p:nvSpPr>
+          <p:cNvPr id="22" name="Text 20"/>
+          <p:cNvSpPr/>
+          <p:nvPr/>
+        </p:nvSpPr>
+        <p:spPr>
+          <a:xfrm>
+            <a:off x="23339146" y="13166751"/>
+            <a:ext cx="7604150" cy="1580083"/>
+          </a:xfrm>
+          <a:prstGeom prst="rect">
+            <a:avLst/>
+          </a:prstGeom>
+          <a:noFill/>
+          <a:ln/>
+        </p:spPr>
+        <p:txBody>
+          <a:bodyPr wrap="square" lIns="0" tIns="0" rIns="0" bIns="0" rtlCol="0" anchor="ctr"/>
+          <a:lstStyle/>
+          <a:p>
+            <a:pPr algn="ctr"/>
+            <a:r>
+              <a:rPr lang="en-US" sz="4572" dirty="0">
+                <a:solidFill>
+                  <a:srgbClr val="10192D"/>
+                </a:solidFill>
+                <a:latin typeface="Aptos" pitchFamily="34" charset="0"/>
+                <a:ea typeface="Aptos" pitchFamily="34" charset="-122"/>
+                <a:cs typeface="Aptos" pitchFamily="34" charset="-120"/>
+              </a:rPr>
+              <a:t>Returns stored answers</a:t>
+            </a:r>
+            <a:endParaRPr lang="en-US" sz="4572" dirty="0"/>
+          </a:p>
+          <a:p>
+            <a:pPr algn="ctr"/>
+            <a:r>
+              <a:rPr lang="en-US" sz="4572" dirty="0">
+                <a:solidFill>
+                  <a:srgbClr val="10192D"/>
+                </a:solidFill>
+                <a:latin typeface="Aptos" pitchFamily="34" charset="0"/>
+                <a:ea typeface="Aptos" pitchFamily="34" charset="-122"/>
+                <a:cs typeface="Aptos" pitchFamily="34" charset="-120"/>
+              </a:rPr>
+              <a:t>instead of business logic</a:t>
+            </a:r>
+            <a:endParaRPr lang="en-US" sz="4572" dirty="0"/>
+          </a:p>
+        </p:txBody>
+      </p:sp>
+      <p:sp>
+        <p:nvSpPr>
+          <p:cNvPr id="23" name="Shape 21"/>
+          <p:cNvSpPr/>
+          <p:nvPr/>
+        </p:nvSpPr>
+        <p:spPr>
+          <a:xfrm>
+            <a:off x="31453531" y="12788189"/>
+            <a:ext cx="1761134" cy="0"/>
+          </a:xfrm>
+          <a:prstGeom prst="line">
+            <a:avLst/>
+          </a:prstGeom>
+          <a:noFill/>
+          <a:ln w="17780">
+            <a:solidFill>
+              <a:srgbClr val="98A4B7"/>
+            </a:solidFill>
+            <a:prstDash val="solid"/>
+            <a:headEnd type="none"/>
+            <a:tailEnd type="triangle"/>
+          </a:ln>
+        </p:spPr>
+        <p:txBody>
+          <a:bodyPr/>
+          <a:lstStyle/>
+          <a:p>
+            <a:endParaRPr lang="en-US" sz="6480"/>
+          </a:p>
+        </p:txBody>
+      </p:sp>
+      <p:sp>
+        <p:nvSpPr>
+          <p:cNvPr id="24" name="Shape 22"/>
+          <p:cNvSpPr/>
+          <p:nvPr/>
+        </p:nvSpPr>
+        <p:spPr>
+          <a:xfrm>
+            <a:off x="33412176" y="10269931"/>
+            <a:ext cx="8460029" cy="5036515"/>
+          </a:xfrm>
+          <a:prstGeom prst="rect">
+            <a:avLst/>
+          </a:prstGeom>
+          <a:solidFill>
+            <a:srgbClr val="FFE3E2"/>
+          </a:solidFill>
+          <a:ln w="13335">
+            <a:solidFill>
+              <a:srgbClr val="F05252"/>
+            </a:solidFill>
+            <a:prstDash val="solid"/>
+          </a:ln>
+        </p:spPr>
+        <p:txBody>
+          <a:bodyPr/>
+          <a:lstStyle/>
+          <a:p>
+            <a:endParaRPr lang="en-US" sz="6480"/>
+          </a:p>
+        </p:txBody>
+      </p:sp>
+      <p:sp>
+        <p:nvSpPr>
+          <p:cNvPr id="25" name="Text 23"/>
+          <p:cNvSpPr/>
+          <p:nvPr/>
+        </p:nvSpPr>
+        <p:spPr>
+          <a:xfrm>
+            <a:off x="33807197" y="10730789"/>
+            <a:ext cx="7669987" cy="921715"/>
+          </a:xfrm>
+          <a:prstGeom prst="rect">
+            <a:avLst/>
+          </a:prstGeom>
+          <a:noFill/>
+          <a:ln/>
+        </p:spPr>
+        <p:txBody>
+          <a:bodyPr wrap="square" lIns="0" tIns="0" rIns="0" bIns="0" rtlCol="0" anchor="ctr"/>
+          <a:lstStyle/>
+          <a:p>
+            <a:pPr algn="ctr"/>
+            <a:r>
+              <a:rPr lang="en-US" sz="5472" dirty="0">
+                <a:solidFill>
+                  <a:srgbClr val="10192D"/>
+                </a:solidFill>
+                <a:latin typeface="Aptos" pitchFamily="34" charset="0"/>
+                <a:ea typeface="Aptos" pitchFamily="34" charset="-122"/>
+                <a:cs typeface="Aptos" pitchFamily="34" charset="-120"/>
+              </a:rPr>
+              <a:t>4</a:t>
+            </a:r>
+            <a:endParaRPr lang="en-US" sz="5472" dirty="0"/>
+          </a:p>
+        </p:txBody>
+      </p:sp>
+      <p:sp>
+        <p:nvSpPr>
+          <p:cNvPr id="26" name="Text 24"/>
+          <p:cNvSpPr/>
+          <p:nvPr/>
+        </p:nvSpPr>
+        <p:spPr>
+          <a:xfrm>
+            <a:off x="33840115" y="11948769"/>
+            <a:ext cx="7604150" cy="954634"/>
+          </a:xfrm>
+          <a:prstGeom prst="rect">
+            <a:avLst/>
+          </a:prstGeom>
+          <a:noFill/>
+          <a:ln/>
+        </p:spPr>
+        <p:txBody>
+          <a:bodyPr wrap="square" lIns="0" tIns="0" rIns="0" bIns="0" rtlCol="0" anchor="ctr"/>
+          <a:lstStyle/>
+          <a:p>
+            <a:pPr algn="ctr"/>
+            <a:r>
+              <a:rPr lang="en-US" sz="5400" b="1" dirty="0">
+                <a:solidFill>
+                  <a:srgbClr val="10192D"/>
+                </a:solidFill>
+                <a:latin typeface="Aptos" pitchFamily="34" charset="0"/>
+                <a:ea typeface="Aptos" pitchFamily="34" charset="-122"/>
+                <a:cs typeface="Aptos" pitchFamily="34" charset="-120"/>
+              </a:rPr>
+              <a:t>False approval</a:t>
+            </a:r>
+            <a:endParaRPr lang="en-US" sz="5400" dirty="0"/>
+          </a:p>
+        </p:txBody>
+      </p:sp>
+      <p:sp>
+        <p:nvSpPr>
+          <p:cNvPr id="27" name="Text 25"/>
+          <p:cNvSpPr/>
+          <p:nvPr/>
+        </p:nvSpPr>
+        <p:spPr>
+          <a:xfrm>
+            <a:off x="33840115" y="13166751"/>
+            <a:ext cx="7604150" cy="1580083"/>
+          </a:xfrm>
+          <a:prstGeom prst="rect">
+            <a:avLst/>
+          </a:prstGeom>
+          <a:noFill/>
+          <a:ln/>
+        </p:spPr>
+        <p:txBody>
+          <a:bodyPr wrap="square" lIns="0" tIns="0" rIns="0" bIns="0" rtlCol="0" anchor="ctr"/>
+          <a:lstStyle/>
+          <a:p>
+            <a:pPr algn="ctr"/>
+            <a:r>
+              <a:rPr lang="en-US" sz="4572" dirty="0">
+                <a:solidFill>
+                  <a:srgbClr val="10192D"/>
+                </a:solidFill>
+                <a:latin typeface="Aptos" pitchFamily="34" charset="0"/>
+                <a:ea typeface="Aptos" pitchFamily="34" charset="-122"/>
+                <a:cs typeface="Aptos" pitchFamily="34" charset="-120"/>
+              </a:rPr>
+              <a:t>Python sees a match;</a:t>
+            </a:r>
+            <a:endParaRPr lang="en-US" sz="4572" dirty="0"/>
+          </a:p>
+          <a:p>
+            <a:pPr algn="ctr"/>
+            <a:r>
+              <a:rPr lang="en-US" sz="4572" dirty="0">
+                <a:solidFill>
+                  <a:srgbClr val="10192D"/>
+                </a:solidFill>
+                <a:latin typeface="Aptos" pitchFamily="34" charset="0"/>
+                <a:ea typeface="Aptos" pitchFamily="34" charset="-122"/>
+                <a:cs typeface="Aptos" pitchFamily="34" charset="-120"/>
+              </a:rPr>
+              <a:t>the candidate is unsound</a:t>
+            </a:r>
+            <a:endParaRPr lang="en-US" sz="4572" dirty="0"/>
+          </a:p>
+        </p:txBody>
+      </p:sp>
+      <p:sp>
+        <p:nvSpPr>
+          <p:cNvPr id="28" name="Text 26"/>
+          <p:cNvSpPr/>
+          <p:nvPr/>
+        </p:nvSpPr>
+        <p:spPr>
+          <a:xfrm>
+            <a:off x="1909267" y="17643653"/>
+            <a:ext cx="12508992" cy="987552"/>
+          </a:xfrm>
+          <a:prstGeom prst="rect">
+            <a:avLst/>
+          </a:prstGeom>
+          <a:noFill/>
+          <a:ln/>
+        </p:spPr>
+        <p:txBody>
+          <a:bodyPr wrap="square" lIns="0" tIns="0" rIns="0" bIns="0" rtlCol="0" anchor="ctr"/>
+          <a:lstStyle/>
+          <a:p>
+            <a:r>
+              <a:rPr lang="en-US" sz="5940" b="1" dirty="0">
+                <a:solidFill>
+                  <a:srgbClr val="2766EC"/>
+                </a:solidFill>
+                <a:latin typeface="Aptos" pitchFamily="34" charset="0"/>
+                <a:ea typeface="Aptos" pitchFamily="34" charset="-122"/>
+                <a:cs typeface="Aptos" pitchFamily="34" charset="-120"/>
+              </a:rPr>
+              <a:t>Threat model</a:t>
+            </a:r>
+            <a:endParaRPr lang="en-US" sz="5940" dirty="0"/>
+          </a:p>
+        </p:txBody>
+      </p:sp>
+      <p:sp>
+        <p:nvSpPr>
+          <p:cNvPr id="29" name="Text 27"/>
+          <p:cNvSpPr/>
+          <p:nvPr/>
+        </p:nvSpPr>
+        <p:spPr>
+          <a:xfrm>
+            <a:off x="1909267" y="19124981"/>
+            <a:ext cx="13002768" cy="1020470"/>
+          </a:xfrm>
+          <a:prstGeom prst="rect">
+            <a:avLst/>
+          </a:prstGeom>
+          <a:noFill/>
+          <a:ln/>
+        </p:spPr>
+        <p:txBody>
+          <a:bodyPr wrap="square" lIns="0" tIns="0" rIns="0" bIns="0" rtlCol="0" anchor="ctr"/>
+          <a:lstStyle/>
+          <a:p>
+            <a:r>
+              <a:rPr lang="en-US" sz="4446" dirty="0">
+                <a:solidFill>
+                  <a:srgbClr val="10192D"/>
+                </a:solidFill>
+                <a:latin typeface="Aptos" pitchFamily="34" charset="0"/>
+                <a:ea typeface="Aptos" pitchFamily="34" charset="-122"/>
+                <a:cs typeface="Aptos" pitchFamily="34" charset="-120"/>
+              </a:rPr>
+              <a:t>•  Hidden job files or answers are reachable</a:t>
+            </a:r>
+            <a:endParaRPr lang="en-US" sz="4446" dirty="0"/>
+          </a:p>
+        </p:txBody>
+      </p:sp>
+      <p:sp>
+        <p:nvSpPr>
+          <p:cNvPr id="30" name="Text 28"/>
+          <p:cNvSpPr/>
+          <p:nvPr/>
+        </p:nvSpPr>
+        <p:spPr>
+          <a:xfrm>
+            <a:off x="1909267" y="20310043"/>
+            <a:ext cx="13002768" cy="1020470"/>
+          </a:xfrm>
+          <a:prstGeom prst="rect">
+            <a:avLst/>
+          </a:prstGeom>
+          <a:noFill/>
+          <a:ln/>
+        </p:spPr>
+        <p:txBody>
+          <a:bodyPr wrap="square" lIns="0" tIns="0" rIns="0" bIns="0" rtlCol="0" anchor="ctr"/>
+          <a:lstStyle/>
+          <a:p>
+            <a:r>
+              <a:rPr lang="en-US" sz="4446" dirty="0">
+                <a:solidFill>
+                  <a:srgbClr val="10192D"/>
+                </a:solidFill>
+                <a:latin typeface="Aptos" pitchFamily="34" charset="0"/>
+                <a:ea typeface="Aptos" pitchFamily="34" charset="-122"/>
+                <a:cs typeface="Aptos" pitchFamily="34" charset="-120"/>
+              </a:rPr>
+              <a:t>•  Static allowlists can have escape paths</a:t>
+            </a:r>
+            <a:endParaRPr lang="en-US" sz="4446" dirty="0"/>
+          </a:p>
+        </p:txBody>
+      </p:sp>
+      <p:sp>
+        <p:nvSpPr>
+          <p:cNvPr id="31" name="Text 29"/>
+          <p:cNvSpPr/>
+          <p:nvPr/>
+        </p:nvSpPr>
+        <p:spPr>
+          <a:xfrm>
+            <a:off x="1909267" y="21495106"/>
+            <a:ext cx="13002768" cy="1020470"/>
+          </a:xfrm>
+          <a:prstGeom prst="rect">
+            <a:avLst/>
+          </a:prstGeom>
+          <a:noFill/>
+          <a:ln/>
+        </p:spPr>
+        <p:txBody>
+          <a:bodyPr wrap="square" lIns="0" tIns="0" rIns="0" bIns="0" rtlCol="0" anchor="ctr"/>
+          <a:lstStyle/>
+          <a:p>
+            <a:r>
+              <a:rPr lang="en-US" sz="4446" dirty="0">
+                <a:solidFill>
+                  <a:srgbClr val="10192D"/>
+                </a:solidFill>
+                <a:latin typeface="Aptos" pitchFamily="34" charset="0"/>
+                <a:ea typeface="Aptos" pitchFamily="34" charset="-122"/>
+                <a:cs typeface="Aptos" pitchFamily="34" charset="-120"/>
+              </a:rPr>
+              <a:t>•  Passing N jobs does not prove generality</a:t>
+            </a:r>
+            <a:endParaRPr lang="en-US" sz="4446" dirty="0"/>
+          </a:p>
+        </p:txBody>
+      </p:sp>
+      <p:sp>
+        <p:nvSpPr>
+          <p:cNvPr id="32" name="Text 30"/>
+          <p:cNvSpPr/>
+          <p:nvPr/>
+        </p:nvSpPr>
+        <p:spPr>
+          <a:xfrm>
+            <a:off x="15504566" y="17643653"/>
+            <a:ext cx="13167360" cy="987552"/>
+          </a:xfrm>
+          <a:prstGeom prst="rect">
+            <a:avLst/>
+          </a:prstGeom>
+          <a:noFill/>
+          <a:ln/>
+        </p:spPr>
+        <p:txBody>
+          <a:bodyPr wrap="square" lIns="0" tIns="0" rIns="0" bIns="0" rtlCol="0" anchor="ctr"/>
+          <a:lstStyle/>
+          <a:p>
+            <a:r>
+              <a:rPr lang="en-US" sz="5940" b="1" dirty="0">
+                <a:solidFill>
+                  <a:srgbClr val="0A9B73"/>
+                </a:solidFill>
+                <a:latin typeface="Aptos" pitchFamily="34" charset="0"/>
+                <a:ea typeface="Aptos" pitchFamily="34" charset="-122"/>
+                <a:cs typeface="Aptos" pitchFamily="34" charset="-120"/>
+              </a:rPr>
+              <a:t>Future countermeasures</a:t>
+            </a:r>
+            <a:endParaRPr lang="en-US" sz="5940" dirty="0"/>
+          </a:p>
+        </p:txBody>
+      </p:sp>
+      <p:sp>
+        <p:nvSpPr>
+          <p:cNvPr id="33" name="Text 31"/>
+          <p:cNvSpPr/>
+          <p:nvPr/>
+        </p:nvSpPr>
+        <p:spPr>
+          <a:xfrm>
+            <a:off x="15504566" y="19124981"/>
+            <a:ext cx="13002768" cy="1020470"/>
+          </a:xfrm>
+          <a:prstGeom prst="rect">
+            <a:avLst/>
+          </a:prstGeom>
+          <a:noFill/>
+          <a:ln/>
+        </p:spPr>
+        <p:txBody>
+          <a:bodyPr wrap="square" lIns="0" tIns="0" rIns="0" bIns="0" rtlCol="0" anchor="ctr"/>
+          <a:lstStyle/>
+          <a:p>
+            <a:r>
+              <a:rPr lang="en-US" sz="4446" dirty="0">
+                <a:solidFill>
+                  <a:srgbClr val="10192D"/>
+                </a:solidFill>
+                <a:latin typeface="Aptos" pitchFamily="34" charset="0"/>
+                <a:ea typeface="Aptos" pitchFamily="34" charset="-122"/>
+                <a:cs typeface="Aptos" pitchFamily="34" charset="-120"/>
+              </a:rPr>
+              <a:t>•  Sandbox cannot read answers or secrets</a:t>
+            </a:r>
+            <a:endParaRPr lang="en-US" sz="4446" dirty="0"/>
+          </a:p>
+        </p:txBody>
+      </p:sp>
+      <p:sp>
+        <p:nvSpPr>
+          <p:cNvPr id="34" name="Text 32"/>
+          <p:cNvSpPr/>
+          <p:nvPr/>
+        </p:nvSpPr>
+        <p:spPr>
+          <a:xfrm>
+            <a:off x="15504566" y="20310043"/>
+            <a:ext cx="13002768" cy="1020470"/>
+          </a:xfrm>
+          <a:prstGeom prst="rect">
+            <a:avLst/>
+          </a:prstGeom>
+          <a:noFill/>
+          <a:ln/>
+        </p:spPr>
+        <p:txBody>
+          <a:bodyPr wrap="square" lIns="0" tIns="0" rIns="0" bIns="0" rtlCol="0" anchor="ctr"/>
+          <a:lstStyle/>
+          <a:p>
+            <a:r>
+              <a:rPr lang="en-US" sz="4446" dirty="0">
+                <a:solidFill>
+                  <a:srgbClr val="10192D"/>
+                </a:solidFill>
+                <a:latin typeface="Aptos" pitchFamily="34" charset="0"/>
+                <a:ea typeface="Aptos" pitchFamily="34" charset="-122"/>
+                <a:cs typeface="Aptos" pitchFamily="34" charset="-120"/>
+              </a:rPr>
+              <a:t>•  Parent alone compares expected outputs</a:t>
+            </a:r>
+            <a:endParaRPr lang="en-US" sz="4446" dirty="0"/>
+          </a:p>
+        </p:txBody>
+      </p:sp>
+      <p:sp>
+        <p:nvSpPr>
+          <p:cNvPr id="35" name="Text 33"/>
+          <p:cNvSpPr/>
+          <p:nvPr/>
+        </p:nvSpPr>
+        <p:spPr>
+          <a:xfrm>
+            <a:off x="15504566" y="21495106"/>
+            <a:ext cx="13002768" cy="1020470"/>
+          </a:xfrm>
+          <a:prstGeom prst="rect">
+            <a:avLst/>
+          </a:prstGeom>
+          <a:noFill/>
+          <a:ln/>
+        </p:spPr>
+        <p:txBody>
+          <a:bodyPr wrap="square" lIns="0" tIns="0" rIns="0" bIns="0" rtlCol="0" anchor="ctr"/>
+          <a:lstStyle/>
+          <a:p>
+            <a:r>
+              <a:rPr lang="en-US" sz="4446" dirty="0">
+                <a:solidFill>
+                  <a:srgbClr val="10192D"/>
+                </a:solidFill>
+                <a:latin typeface="Aptos" pitchFamily="34" charset="0"/>
+                <a:ea typeface="Aptos" pitchFamily="34" charset="-122"/>
+                <a:cs typeface="Aptos" pitchFamily="34" charset="-120"/>
+              </a:rPr>
+              <a:t>•  BRD-scoped broker limits external tools</a:t>
+            </a:r>
+            <a:endParaRPr lang="en-US" sz="4446" dirty="0"/>
+          </a:p>
+        </p:txBody>
+      </p:sp>
+      <p:sp>
+        <p:nvSpPr>
+          <p:cNvPr id="36" name="Text 34"/>
+          <p:cNvSpPr/>
+          <p:nvPr/>
+        </p:nvSpPr>
+        <p:spPr>
+          <a:xfrm>
+            <a:off x="28770682" y="17643653"/>
+            <a:ext cx="13167360" cy="987552"/>
+          </a:xfrm>
+          <a:prstGeom prst="rect">
+            <a:avLst/>
+          </a:prstGeom>
+          <a:noFill/>
+          <a:ln/>
+        </p:spPr>
+        <p:txBody>
+          <a:bodyPr wrap="square" lIns="0" tIns="0" rIns="0" bIns="0" rtlCol="0" anchor="ctr"/>
+          <a:lstStyle/>
+          <a:p>
+            <a:r>
+              <a:rPr lang="en-US" sz="5940" b="1" dirty="0">
+                <a:solidFill>
+                  <a:srgbClr val="D88404"/>
+                </a:solidFill>
+                <a:latin typeface="Aptos" pitchFamily="34" charset="0"/>
+                <a:ea typeface="Aptos" pitchFamily="34" charset="-122"/>
+                <a:cs typeface="Aptos" pitchFamily="34" charset="-120"/>
+              </a:rPr>
+              <a:t>Adversarial verification</a:t>
+            </a:r>
+            <a:endParaRPr lang="en-US" sz="5940" dirty="0"/>
+          </a:p>
+        </p:txBody>
+      </p:sp>
+      <p:sp>
+        <p:nvSpPr>
+          <p:cNvPr id="37" name="Text 35"/>
+          <p:cNvSpPr/>
+          <p:nvPr/>
+        </p:nvSpPr>
+        <p:spPr>
+          <a:xfrm>
+            <a:off x="28770682" y="19124981"/>
+            <a:ext cx="13002768" cy="1020470"/>
+          </a:xfrm>
+          <a:prstGeom prst="rect">
+            <a:avLst/>
+          </a:prstGeom>
+          <a:noFill/>
+          <a:ln/>
+        </p:spPr>
+        <p:txBody>
+          <a:bodyPr wrap="square" lIns="0" tIns="0" rIns="0" bIns="0" rtlCol="0" anchor="ctr"/>
+          <a:lstStyle/>
+          <a:p>
+            <a:r>
+              <a:rPr lang="en-US" sz="4446" dirty="0">
+                <a:solidFill>
+                  <a:srgbClr val="10192D"/>
+                </a:solidFill>
+                <a:latin typeface="Aptos" pitchFamily="34" charset="0"/>
+                <a:ea typeface="Aptos" pitchFamily="34" charset="-122"/>
+                <a:cs typeface="Aptos" pitchFamily="34" charset="-120"/>
+              </a:rPr>
+              <a:t>•  Test honest and cheating implementations</a:t>
+            </a:r>
+            <a:endParaRPr lang="en-US" sz="4446" dirty="0"/>
+          </a:p>
+        </p:txBody>
+      </p:sp>
+      <p:sp>
+        <p:nvSpPr>
+          <p:cNvPr id="38" name="Text 36"/>
+          <p:cNvSpPr/>
+          <p:nvPr/>
+        </p:nvSpPr>
+        <p:spPr>
+          <a:xfrm>
+            <a:off x="28770682" y="20310043"/>
+            <a:ext cx="13002768" cy="1020470"/>
+          </a:xfrm>
+          <a:prstGeom prst="rect">
+            <a:avLst/>
+          </a:prstGeom>
+          <a:noFill/>
+          <a:ln/>
+        </p:spPr>
+        <p:txBody>
+          <a:bodyPr wrap="square" lIns="0" tIns="0" rIns="0" bIns="0" rtlCol="0" anchor="ctr"/>
+          <a:lstStyle/>
+          <a:p>
+            <a:r>
+              <a:rPr lang="en-US" sz="4446" dirty="0">
+                <a:solidFill>
+                  <a:srgbClr val="10192D"/>
+                </a:solidFill>
+                <a:latin typeface="Aptos" pitchFamily="34" charset="0"/>
+                <a:ea typeface="Aptos" pitchFamily="34" charset="-122"/>
+                <a:cs typeface="Aptos" pitchFamily="34" charset="-120"/>
+              </a:rPr>
+              <a:t>•  Assert holdout data remains inaccessible</a:t>
+            </a:r>
+            <a:endParaRPr lang="en-US" sz="4446" dirty="0"/>
+          </a:p>
+        </p:txBody>
+      </p:sp>
+      <p:sp>
+        <p:nvSpPr>
+          <p:cNvPr id="39" name="Text 37"/>
+          <p:cNvSpPr/>
+          <p:nvPr/>
+        </p:nvSpPr>
+        <p:spPr>
+          <a:xfrm>
+            <a:off x="28770682" y="21495106"/>
+            <a:ext cx="13002768" cy="1020470"/>
+          </a:xfrm>
+          <a:prstGeom prst="rect">
+            <a:avLst/>
+          </a:prstGeom>
+          <a:noFill/>
+          <a:ln/>
+        </p:spPr>
+        <p:txBody>
+          <a:bodyPr wrap="square" lIns="0" tIns="0" rIns="0" bIns="0" rtlCol="0" anchor="ctr"/>
+          <a:lstStyle/>
+          <a:p>
+            <a:r>
+              <a:rPr lang="en-US" sz="4446" dirty="0">
+                <a:solidFill>
+                  <a:srgbClr val="10192D"/>
+                </a:solidFill>
+                <a:latin typeface="Aptos" pitchFamily="34" charset="0"/>
+                <a:ea typeface="Aptos" pitchFamily="34" charset="-122"/>
+                <a:cs typeface="Aptos" pitchFamily="34" charset="-120"/>
+              </a:rPr>
+              <a:t>•  Enforce timeouts; persist blocked hashes</a:t>
+            </a:r>
+            <a:endParaRPr lang="en-US" sz="4446" dirty="0"/>
           </a:p>
         </p:txBody>
       </p:sp>

</xml_diff>